<commit_message>
Split scenario 5 into its own slide and mark the planned automation loop
</commit_message>
<xml_diff>
--- a/slides/sglang_maestro_workflow.pptx
+++ b/slides/sglang_maestro_workflow.pptx
@@ -6,6 +6,7 @@
   </p:sldMasterIdLst>
   <p:sldIdLst>
     <p:sldId id="256" r:id="rId7"/>
+    <p:sldId id="257" r:id="rId8"/>
   </p:sldIdLst>
   <p:sldSz cx="12191695" cy="6858000" type="screen4x3"/>
   <p:notesSz cx="6858000" cy="9144000"/>
@@ -3126,7 +3127,7 @@
         <p:spPr>
           <a:xfrm>
             <a:off x="594360" y="274320"/>
-            <a:ext cx="8229600" cy="548640"/>
+            <a:ext cx="10058400" cy="548640"/>
           </a:xfrm>
           <a:prstGeom prst="rect">
             <a:avLst/>
@@ -3139,10 +3140,13 @@
           </a:bodyPr>
           <a:lstStyle/>
           <a:p>
-            <a:pPr algn="l">
+            <a:pPr algn="l" latinLnBrk="0">
               <a:lnSpc>
                 <a:spcPct val="100000"/>
               </a:lnSpc>
+              <a:spcBef>
+                <a:spcPts val="0"/>
+              </a:spcBef>
               <a:spcAft>
                 <a:spcPts val="0"/>
               </a:spcAft>
@@ -3156,7 +3160,7 @@
                 <a:ea typeface="Microsoft YaHei"/>
                 <a:cs typeface="Microsoft YaHei"/>
               </a:rPr>
-              <a:t>sglang-maestro 工作流程</a:t>
+              <a:t>sglang-maestro 工作流程：适配、分析与调优</a:t>
             </a:r>
           </a:p>
         </p:txBody>
@@ -3183,10 +3187,13 @@
           </a:bodyPr>
           <a:lstStyle/>
           <a:p>
-            <a:pPr algn="l">
+            <a:pPr algn="l" latinLnBrk="0">
               <a:lnSpc>
                 <a:spcPct val="100000"/>
               </a:lnSpc>
+              <a:spcBef>
+                <a:spcPts val="0"/>
+              </a:spcBef>
               <a:spcAft>
                 <a:spcPts val="0"/>
               </a:spcAft>
@@ -3200,7 +3207,7 @@
                 <a:ea typeface="Microsoft YaHei"/>
                 <a:cs typeface="Microsoft YaHei"/>
               </a:rPr>
-              <a:t>输入模型、芯片和业务负载，自动完成适配分析、性能诊断、特性调优和部署规划；真机实测数据回流后校准成本模型、重新规划，形成闭环</a:t>
+              <a:t>输入模型、芯片和业务负载，自动完成适配分析、性能诊断和特性调优；下一步由执行器把方案自动落地到真机，实测数据回流形成闭环</a:t>
             </a:r>
           </a:p>
         </p:txBody>
@@ -3227,10 +3234,13 @@
           </a:bodyPr>
           <a:lstStyle/>
           <a:p>
-            <a:pPr algn="l">
+            <a:pPr algn="l" latinLnBrk="0">
               <a:lnSpc>
                 <a:spcPct val="100000"/>
               </a:lnSpc>
+              <a:spcBef>
+                <a:spcPts val="0"/>
+              </a:spcBef>
               <a:spcAft>
                 <a:spcPts val="0"/>
               </a:spcAft>
@@ -3271,10 +3281,13 @@
           </a:bodyPr>
           <a:lstStyle/>
           <a:p>
-            <a:pPr algn="l">
+            <a:pPr algn="l" latinLnBrk="0">
               <a:lnSpc>
                 <a:spcPct val="100000"/>
               </a:lnSpc>
+              <a:spcBef>
+                <a:spcPts val="0"/>
+              </a:spcBef>
               <a:spcAft>
                 <a:spcPts val="0"/>
               </a:spcAft>
@@ -3326,10 +3339,13 @@
           </a:bodyPr>
           <a:lstStyle/>
           <a:p>
-            <a:pPr algn="l">
+            <a:pPr algn="l" latinLnBrk="0">
               <a:lnSpc>
                 <a:spcPct val="100000"/>
               </a:lnSpc>
+              <a:spcBef>
+                <a:spcPts val="0"/>
+              </a:spcBef>
               <a:spcAft>
                 <a:spcPts val="0"/>
               </a:spcAft>
@@ -3357,7 +3373,7 @@
         <p:spPr>
           <a:xfrm>
             <a:off x="411480" y="1627632"/>
-            <a:ext cx="2011680" cy="592074"/>
+            <a:ext cx="2011680" cy="534924"/>
           </a:xfrm>
           <a:prstGeom prst="rect">
             <a:avLst/>
@@ -3372,15 +3388,18 @@
           </a:ln>
         </p:spPr>
         <p:txBody>
-          <a:bodyPr rtlCol="0" anchor="ctr" wrap="square" lIns="109728" tIns="27432" bIns="27432">
+          <a:bodyPr rtlCol="0" anchor="ctr" wrap="square" lIns="109728" tIns="18288" bIns="18288">
             <a:noAutofit/>
           </a:bodyPr>
           <a:lstStyle/>
           <a:p>
-            <a:pPr algn="l">
+            <a:pPr algn="l" latinLnBrk="0">
               <a:lnSpc>
                 <a:spcPct val="100000"/>
               </a:lnSpc>
+              <a:spcBef>
+                <a:spcPts val="0"/>
+              </a:spcBef>
               <a:spcAft>
                 <a:spcPts val="100"/>
               </a:spcAft>
@@ -3398,10 +3417,13 @@
             </a:r>
           </a:p>
           <a:p>
-            <a:pPr algn="l">
+            <a:pPr algn="l" latinLnBrk="0">
               <a:lnSpc>
                 <a:spcPct val="100000"/>
               </a:lnSpc>
+              <a:spcBef>
+                <a:spcPts val="0"/>
+              </a:spcBef>
               <a:spcAft>
                 <a:spcPts val="0"/>
               </a:spcAft>
@@ -3428,8 +3450,8 @@
         </p:nvSpPr>
         <p:spPr>
           <a:xfrm>
-            <a:off x="411480" y="2329434"/>
-            <a:ext cx="2011680" cy="592074"/>
+            <a:off x="411480" y="2272284"/>
+            <a:ext cx="2011680" cy="534924"/>
           </a:xfrm>
           <a:prstGeom prst="rect">
             <a:avLst/>
@@ -3444,15 +3466,18 @@
           </a:ln>
         </p:spPr>
         <p:txBody>
-          <a:bodyPr rtlCol="0" anchor="ctr" wrap="square" lIns="109728" tIns="27432" bIns="27432">
+          <a:bodyPr rtlCol="0" anchor="ctr" wrap="square" lIns="109728" tIns="18288" bIns="18288">
             <a:noAutofit/>
           </a:bodyPr>
           <a:lstStyle/>
           <a:p>
-            <a:pPr algn="l">
+            <a:pPr algn="l" latinLnBrk="0">
               <a:lnSpc>
                 <a:spcPct val="100000"/>
               </a:lnSpc>
+              <a:spcBef>
+                <a:spcPts val="0"/>
+              </a:spcBef>
               <a:spcAft>
                 <a:spcPts val="100"/>
               </a:spcAft>
@@ -3470,10 +3495,13 @@
             </a:r>
           </a:p>
           <a:p>
-            <a:pPr algn="l">
+            <a:pPr algn="l" latinLnBrk="0">
               <a:lnSpc>
                 <a:spcPct val="100000"/>
               </a:lnSpc>
+              <a:spcBef>
+                <a:spcPts val="0"/>
+              </a:spcBef>
               <a:spcAft>
                 <a:spcPts val="0"/>
               </a:spcAft>
@@ -3500,8 +3528,8 @@
         </p:nvSpPr>
         <p:spPr>
           <a:xfrm>
-            <a:off x="411480" y="3031236"/>
-            <a:ext cx="2011680" cy="592074"/>
+            <a:off x="411480" y="2916936"/>
+            <a:ext cx="2011680" cy="534924"/>
           </a:xfrm>
           <a:prstGeom prst="rect">
             <a:avLst/>
@@ -3516,15 +3544,18 @@
           </a:ln>
         </p:spPr>
         <p:txBody>
-          <a:bodyPr rtlCol="0" anchor="ctr" wrap="square" lIns="109728" tIns="27432" bIns="27432">
+          <a:bodyPr rtlCol="0" anchor="ctr" wrap="square" lIns="109728" tIns="18288" bIns="18288">
             <a:noAutofit/>
           </a:bodyPr>
           <a:lstStyle/>
           <a:p>
-            <a:pPr algn="l">
+            <a:pPr algn="l" latinLnBrk="0">
               <a:lnSpc>
                 <a:spcPct val="100000"/>
               </a:lnSpc>
+              <a:spcBef>
+                <a:spcPts val="0"/>
+              </a:spcBef>
               <a:spcAft>
                 <a:spcPts val="100"/>
               </a:spcAft>
@@ -3542,10 +3573,13 @@
             </a:r>
           </a:p>
           <a:p>
-            <a:pPr algn="l">
+            <a:pPr algn="l" latinLnBrk="0">
               <a:lnSpc>
                 <a:spcPct val="100000"/>
               </a:lnSpc>
+              <a:spcBef>
+                <a:spcPts val="0"/>
+              </a:spcBef>
               <a:spcAft>
                 <a:spcPts val="0"/>
               </a:spcAft>
@@ -3572,8 +3606,8 @@
         </p:nvSpPr>
         <p:spPr>
           <a:xfrm>
-            <a:off x="411480" y="3733038"/>
-            <a:ext cx="2011680" cy="592074"/>
+            <a:off x="411480" y="3561588"/>
+            <a:ext cx="2011680" cy="534924"/>
           </a:xfrm>
           <a:prstGeom prst="rect">
             <a:avLst/>
@@ -3588,15 +3622,18 @@
           </a:ln>
         </p:spPr>
         <p:txBody>
-          <a:bodyPr rtlCol="0" anchor="ctr" wrap="square" lIns="109728" tIns="27432" bIns="27432">
+          <a:bodyPr rtlCol="0" anchor="ctr" wrap="square" lIns="109728" tIns="18288" bIns="18288">
             <a:noAutofit/>
           </a:bodyPr>
           <a:lstStyle/>
           <a:p>
-            <a:pPr algn="l">
+            <a:pPr algn="l" latinLnBrk="0">
               <a:lnSpc>
                 <a:spcPct val="100000"/>
               </a:lnSpc>
+              <a:spcBef>
+                <a:spcPts val="0"/>
+              </a:spcBef>
               <a:spcAft>
                 <a:spcPts val="100"/>
               </a:spcAft>
@@ -3614,10 +3651,13 @@
             </a:r>
           </a:p>
           <a:p>
-            <a:pPr algn="l">
+            <a:pPr algn="l" latinLnBrk="0">
               <a:lnSpc>
                 <a:spcPct val="100000"/>
               </a:lnSpc>
+              <a:spcBef>
+                <a:spcPts val="0"/>
+              </a:spcBef>
               <a:spcAft>
                 <a:spcPts val="0"/>
               </a:spcAft>
@@ -3645,7 +3685,7 @@
         <p:spPr>
           <a:xfrm>
             <a:off x="2715768" y="1627632"/>
-            <a:ext cx="1589455" cy="621792"/>
+            <a:ext cx="2180234" cy="621792"/>
           </a:xfrm>
           <a:prstGeom prst="rect">
             <a:avLst/>
@@ -3663,10 +3703,13 @@
           </a:bodyPr>
           <a:lstStyle/>
           <a:p>
-            <a:pPr algn="l">
+            <a:pPr algn="l" latinLnBrk="0">
               <a:lnSpc>
                 <a:spcPct val="100000"/>
               </a:lnSpc>
+              <a:spcBef>
+                <a:spcPts val="0"/>
+              </a:spcBef>
               <a:spcAft>
                 <a:spcPts val="100"/>
               </a:spcAft>
@@ -3684,10 +3727,13 @@
             </a:r>
           </a:p>
           <a:p>
-            <a:pPr algn="l">
+            <a:pPr algn="l" latinLnBrk="0">
               <a:lnSpc>
                 <a:spcPct val="100000"/>
               </a:lnSpc>
+              <a:spcBef>
+                <a:spcPts val="0"/>
+              </a:spcBef>
               <a:spcAft>
                 <a:spcPts val="0"/>
               </a:spcAft>
@@ -3715,7 +3761,7 @@
         <p:spPr>
           <a:xfrm>
             <a:off x="2715768" y="2249424"/>
-            <a:ext cx="1589455" cy="2075688"/>
+            <a:ext cx="2180234" cy="1847088"/>
           </a:xfrm>
           <a:prstGeom prst="rect">
             <a:avLst/>
@@ -3735,10 +3781,13 @@
           </a:bodyPr>
           <a:lstStyle/>
           <a:p>
-            <a:pPr algn="l" marL="128016" indent="-128016">
+            <a:pPr algn="l" latinLnBrk="0" marL="128016" indent="-128016">
               <a:lnSpc>
                 <a:spcPct val="105000"/>
               </a:lnSpc>
+              <a:spcBef>
+                <a:spcPts val="0"/>
+              </a:spcBef>
               <a:spcAft>
                 <a:spcPts val="700"/>
               </a:spcAft>
@@ -3761,10 +3810,13 @@
             </a:r>
           </a:p>
           <a:p>
-            <a:pPr algn="l" marL="128016" indent="-128016">
+            <a:pPr algn="l" latinLnBrk="0" marL="128016" indent="-128016">
               <a:lnSpc>
                 <a:spcPct val="105000"/>
               </a:lnSpc>
+              <a:spcBef>
+                <a:spcPts val="0"/>
+              </a:spcBef>
               <a:spcAft>
                 <a:spcPts val="700"/>
               </a:spcAft>
@@ -3787,10 +3839,13 @@
             </a:r>
           </a:p>
           <a:p>
-            <a:pPr algn="l" marL="128016" indent="-128016">
+            <a:pPr algn="l" latinLnBrk="0" marL="128016" indent="-128016">
               <a:lnSpc>
                 <a:spcPct val="105000"/>
               </a:lnSpc>
+              <a:spcBef>
+                <a:spcPts val="0"/>
+              </a:spcBef>
               <a:spcAft>
                 <a:spcPts val="700"/>
               </a:spcAft>
@@ -3813,10 +3868,13 @@
             </a:r>
           </a:p>
           <a:p>
-            <a:pPr algn="l" marL="128016" indent="-128016">
+            <a:pPr algn="l" latinLnBrk="0" marL="128016" indent="-128016">
               <a:lnSpc>
                 <a:spcPct val="105000"/>
               </a:lnSpc>
+              <a:spcBef>
+                <a:spcPts val="0"/>
+              </a:spcBef>
               <a:spcAft>
                 <a:spcPts val="700"/>
               </a:spcAft>
@@ -3848,8 +3906,8 @@
         </p:nvCxnSpPr>
         <p:spPr>
           <a:xfrm>
-            <a:off x="4341799" y="2976372"/>
-            <a:ext cx="182880" cy="0"/>
+            <a:off x="4941722" y="2862072"/>
+            <a:ext cx="201168" cy="0"/>
           </a:xfrm>
           <a:prstGeom prst="line">
             <a:avLst/>
@@ -3870,8 +3928,8 @@
         </p:nvSpPr>
         <p:spPr>
           <a:xfrm>
-            <a:off x="4561255" y="1627632"/>
-            <a:ext cx="1589455" cy="621792"/>
+            <a:off x="5188610" y="1627632"/>
+            <a:ext cx="2180234" cy="621792"/>
           </a:xfrm>
           <a:prstGeom prst="rect">
             <a:avLst/>
@@ -3889,10 +3947,13 @@
           </a:bodyPr>
           <a:lstStyle/>
           <a:p>
-            <a:pPr algn="l">
+            <a:pPr algn="l" latinLnBrk="0">
               <a:lnSpc>
                 <a:spcPct val="100000"/>
               </a:lnSpc>
+              <a:spcBef>
+                <a:spcPts val="0"/>
+              </a:spcBef>
               <a:spcAft>
                 <a:spcPts val="100"/>
               </a:spcAft>
@@ -3910,10 +3971,13 @@
             </a:r>
           </a:p>
           <a:p>
-            <a:pPr algn="l">
+            <a:pPr algn="l" latinLnBrk="0">
               <a:lnSpc>
                 <a:spcPct val="100000"/>
               </a:lnSpc>
+              <a:spcBef>
+                <a:spcPts val="0"/>
+              </a:spcBef>
               <a:spcAft>
                 <a:spcPts val="0"/>
               </a:spcAft>
@@ -3940,8 +4004,8 @@
         </p:nvSpPr>
         <p:spPr>
           <a:xfrm>
-            <a:off x="4561255" y="2249424"/>
-            <a:ext cx="1589455" cy="2075688"/>
+            <a:off x="5188610" y="2249424"/>
+            <a:ext cx="2180234" cy="1847088"/>
           </a:xfrm>
           <a:prstGeom prst="rect">
             <a:avLst/>
@@ -3961,10 +4025,13 @@
           </a:bodyPr>
           <a:lstStyle/>
           <a:p>
-            <a:pPr algn="l" marL="128016" indent="-128016">
+            <a:pPr algn="l" latinLnBrk="0" marL="128016" indent="-128016">
               <a:lnSpc>
                 <a:spcPct val="105000"/>
               </a:lnSpc>
+              <a:spcBef>
+                <a:spcPts val="0"/>
+              </a:spcBef>
               <a:spcAft>
                 <a:spcPts val="700"/>
               </a:spcAft>
@@ -3987,10 +4054,13 @@
             </a:r>
           </a:p>
           <a:p>
-            <a:pPr algn="l" marL="128016" indent="-128016">
+            <a:pPr algn="l" latinLnBrk="0" marL="128016" indent="-128016">
               <a:lnSpc>
                 <a:spcPct val="105000"/>
               </a:lnSpc>
+              <a:spcBef>
+                <a:spcPts val="0"/>
+              </a:spcBef>
               <a:spcAft>
                 <a:spcPts val="700"/>
               </a:spcAft>
@@ -4013,10 +4083,13 @@
             </a:r>
           </a:p>
           <a:p>
-            <a:pPr algn="l" marL="128016" indent="-128016">
+            <a:pPr algn="l" latinLnBrk="0" marL="128016" indent="-128016">
               <a:lnSpc>
                 <a:spcPct val="105000"/>
               </a:lnSpc>
+              <a:spcBef>
+                <a:spcPts val="0"/>
+              </a:spcBef>
               <a:spcAft>
                 <a:spcPts val="700"/>
               </a:spcAft>
@@ -4048,8 +4121,8 @@
         </p:nvCxnSpPr>
         <p:spPr>
           <a:xfrm>
-            <a:off x="6187287" y="2976372"/>
-            <a:ext cx="182880" cy="0"/>
+            <a:off x="7414564" y="2862072"/>
+            <a:ext cx="201168" cy="0"/>
           </a:xfrm>
           <a:prstGeom prst="line">
             <a:avLst/>
@@ -4070,8 +4143,8 @@
         </p:nvSpPr>
         <p:spPr>
           <a:xfrm>
-            <a:off x="6406743" y="1627632"/>
-            <a:ext cx="1589455" cy="621792"/>
+            <a:off x="7661452" y="1627632"/>
+            <a:ext cx="2180234" cy="621792"/>
           </a:xfrm>
           <a:prstGeom prst="rect">
             <a:avLst/>
@@ -4089,10 +4162,13 @@
           </a:bodyPr>
           <a:lstStyle/>
           <a:p>
-            <a:pPr algn="l">
+            <a:pPr algn="l" latinLnBrk="0">
               <a:lnSpc>
                 <a:spcPct val="100000"/>
               </a:lnSpc>
+              <a:spcBef>
+                <a:spcPts val="0"/>
+              </a:spcBef>
               <a:spcAft>
                 <a:spcPts val="100"/>
               </a:spcAft>
@@ -4110,10 +4186,13 @@
             </a:r>
           </a:p>
           <a:p>
-            <a:pPr algn="l">
+            <a:pPr algn="l" latinLnBrk="0">
               <a:lnSpc>
                 <a:spcPct val="100000"/>
               </a:lnSpc>
+              <a:spcBef>
+                <a:spcPts val="0"/>
+              </a:spcBef>
               <a:spcAft>
                 <a:spcPts val="0"/>
               </a:spcAft>
@@ -4140,8 +4219,8 @@
         </p:nvSpPr>
         <p:spPr>
           <a:xfrm>
-            <a:off x="6406743" y="2249424"/>
-            <a:ext cx="1589455" cy="2075688"/>
+            <a:off x="7661452" y="2249424"/>
+            <a:ext cx="2180234" cy="1847088"/>
           </a:xfrm>
           <a:prstGeom prst="rect">
             <a:avLst/>
@@ -4161,10 +4240,13 @@
           </a:bodyPr>
           <a:lstStyle/>
           <a:p>
-            <a:pPr algn="l" marL="128016" indent="-128016">
+            <a:pPr algn="l" latinLnBrk="0" marL="128016" indent="-128016">
               <a:lnSpc>
                 <a:spcPct val="105000"/>
               </a:lnSpc>
+              <a:spcBef>
+                <a:spcPts val="0"/>
+              </a:spcBef>
               <a:spcAft>
                 <a:spcPts val="700"/>
               </a:spcAft>
@@ -4183,14 +4265,17 @@
                 <a:ea typeface="Microsoft YaHei"/>
                 <a:cs typeface="Microsoft YaHei"/>
               </a:rPr>
-              <a:t>逐项评估 DP attention、CP、SP、HiCache、EP、TBO、EPLB、投机解码</a:t>
-            </a:r>
-          </a:p>
-          <a:p>
-            <a:pPr algn="l" marL="128016" indent="-128016">
+              <a:t>逐项评估 DP attention / CP / SP / HiCache / EP / TBO / EPLB / 投机解码</a:t>
+            </a:r>
+          </a:p>
+          <a:p>
+            <a:pPr algn="l" latinLnBrk="0" marL="128016" indent="-128016">
               <a:lnSpc>
                 <a:spcPct val="105000"/>
               </a:lnSpc>
+              <a:spcBef>
+                <a:spcPts val="0"/>
+              </a:spcBef>
               <a:spcAft>
                 <a:spcPts val="700"/>
               </a:spcAft>
@@ -4213,10 +4298,13 @@
             </a:r>
           </a:p>
           <a:p>
-            <a:pPr algn="l" marL="128016" indent="-128016">
+            <a:pPr algn="l" latinLnBrk="0" marL="128016" indent="-128016">
               <a:lnSpc>
                 <a:spcPct val="105000"/>
               </a:lnSpc>
+              <a:spcBef>
+                <a:spcPts val="0"/>
+              </a:spcBef>
               <a:spcAft>
                 <a:spcPts val="700"/>
               </a:spcAft>
@@ -4235,7 +4323,7 @@
                 <a:ea typeface="Microsoft YaHei"/>
                 <a:cs typeface="Microsoft YaHei"/>
               </a:rPr>
-              <a:t>合并为组合配置</a:t>
+              <a:t>合并为组合启动配置</a:t>
             </a:r>
           </a:p>
         </p:txBody>
@@ -4248,8 +4336,8 @@
         </p:nvCxnSpPr>
         <p:spPr>
           <a:xfrm>
-            <a:off x="8032775" y="2976372"/>
-            <a:ext cx="182880" cy="0"/>
+            <a:off x="2468880" y="2862072"/>
+            <a:ext cx="201168" cy="0"/>
           </a:xfrm>
           <a:prstGeom prst="line">
             <a:avLst/>
@@ -4262,219 +4350,15 @@
           </a:ln>
         </p:spPr>
       </p:cxnSp>
-      <p:sp>
-        <p:nvSpPr>
-          <p:cNvPr id="21" name="Rectangle 20"/>
-          <p:cNvSpPr/>
-          <p:nvPr/>
-        </p:nvSpPr>
-        <p:spPr>
-          <a:xfrm>
-            <a:off x="8252231" y="1627632"/>
-            <a:ext cx="1589455" cy="621792"/>
-          </a:xfrm>
-          <a:prstGeom prst="rect">
-            <a:avLst/>
-          </a:prstGeom>
-          <a:solidFill>
-            <a:srgbClr val="1D4ED8"/>
-          </a:solidFill>
-          <a:ln>
-            <a:noFill/>
-          </a:ln>
-        </p:spPr>
-        <p:txBody>
-          <a:bodyPr rtlCol="0" anchor="ctr" wrap="square" lIns="128016" tIns="27432" bIns="27432">
-            <a:noAutofit/>
-          </a:bodyPr>
-          <a:lstStyle/>
-          <a:p>
-            <a:pPr algn="l">
-              <a:lnSpc>
-                <a:spcPct val="100000"/>
-              </a:lnSpc>
-              <a:spcAft>
-                <a:spcPts val="100"/>
-              </a:spcAft>
-            </a:pPr>
-            <a:r>
-              <a:rPr sz="900" b="0">
-                <a:solidFill>
-                  <a:srgbClr val="C7D7FE"/>
-                </a:solidFill>
-                <a:latin typeface="Microsoft YaHei"/>
-                <a:ea typeface="Microsoft YaHei"/>
-                <a:cs typeface="Microsoft YaHei"/>
-              </a:rPr>
-              <a:t>场景 5</a:t>
-            </a:r>
-          </a:p>
-          <a:p>
-            <a:pPr algn="l">
-              <a:lnSpc>
-                <a:spcPct val="100000"/>
-              </a:lnSpc>
-              <a:spcAft>
-                <a:spcPts val="0"/>
-              </a:spcAft>
-            </a:pPr>
-            <a:r>
-              <a:rPr sz="1500" b="1">
-                <a:solidFill>
-                  <a:srgbClr val="FFFFFF"/>
-                </a:solidFill>
-                <a:latin typeface="Microsoft YaHei"/>
-                <a:ea typeface="Microsoft YaHei"/>
-                <a:cs typeface="Microsoft YaHei"/>
-              </a:rPr>
-              <a:t>最优部署</a:t>
-            </a:r>
-          </a:p>
-        </p:txBody>
-      </p:sp>
-      <p:sp>
-        <p:nvSpPr>
-          <p:cNvPr id="22" name="Rectangle 21"/>
-          <p:cNvSpPr/>
-          <p:nvPr/>
-        </p:nvSpPr>
-        <p:spPr>
-          <a:xfrm>
-            <a:off x="8252231" y="2249424"/>
-            <a:ext cx="1589455" cy="2075688"/>
-          </a:xfrm>
-          <a:prstGeom prst="rect">
-            <a:avLst/>
-          </a:prstGeom>
-          <a:solidFill>
-            <a:srgbClr val="F5F8FF"/>
-          </a:solidFill>
-          <a:ln w="9525">
-            <a:solidFill>
-              <a:srgbClr val="C9D6F0"/>
-            </a:solidFill>
-          </a:ln>
-        </p:spPr>
-        <p:txBody>
-          <a:bodyPr rtlCol="0" anchor="t" wrap="square" lIns="109728" tIns="128016" bIns="73152">
-            <a:noAutofit/>
-          </a:bodyPr>
-          <a:lstStyle/>
-          <a:p>
-            <a:pPr algn="l" marL="128016" indent="-128016">
-              <a:lnSpc>
-                <a:spcPct val="105000"/>
-              </a:lnSpc>
-              <a:spcAft>
-                <a:spcPts val="700"/>
-              </a:spcAft>
-              <a:buClr>
-                <a:srgbClr val="1D4ED8"/>
-              </a:buClr>
-              <a:buFont typeface="Arial"/>
-              <a:buChar char="•"/>
-            </a:pPr>
-            <a:r>
-              <a:rPr sz="1150" b="0">
-                <a:solidFill>
-                  <a:srgbClr val="374151"/>
-                </a:solidFill>
-                <a:latin typeface="Microsoft YaHei"/>
-                <a:ea typeface="Microsoft YaHei"/>
-                <a:cs typeface="Microsoft YaHei"/>
-              </a:rPr>
-              <a:t>搜索并行布局与实例数</a:t>
-            </a:r>
-          </a:p>
-          <a:p>
-            <a:pPr algn="l" marL="128016" indent="-128016">
-              <a:lnSpc>
-                <a:spcPct val="105000"/>
-              </a:lnSpc>
-              <a:spcAft>
-                <a:spcPts val="700"/>
-              </a:spcAft>
-              <a:buClr>
-                <a:srgbClr val="1D4ED8"/>
-              </a:buClr>
-              <a:buFont typeface="Arial"/>
-              <a:buChar char="•"/>
-            </a:pPr>
-            <a:r>
-              <a:rPr sz="1150" b="0">
-                <a:solidFill>
-                  <a:srgbClr val="374151"/>
-                </a:solidFill>
-                <a:latin typeface="Microsoft YaHei"/>
-                <a:ea typeface="Microsoft YaHei"/>
-                <a:cs typeface="Microsoft YaHei"/>
-              </a:rPr>
-              <a:t>对比 PD 分离与混部</a:t>
-            </a:r>
-          </a:p>
-          <a:p>
-            <a:pPr algn="l" marL="128016" indent="-128016">
-              <a:lnSpc>
-                <a:spcPct val="105000"/>
-              </a:lnSpc>
-              <a:spcAft>
-                <a:spcPts val="700"/>
-              </a:spcAft>
-              <a:buClr>
-                <a:srgbClr val="1D4ED8"/>
-              </a:buClr>
-              <a:buFont typeface="Arial"/>
-              <a:buChar char="•"/>
-            </a:pPr>
-            <a:r>
-              <a:rPr sz="1150" b="0">
-                <a:solidFill>
-                  <a:srgbClr val="374151"/>
-                </a:solidFill>
-                <a:latin typeface="Microsoft YaHei"/>
-                <a:ea typeface="Microsoft YaHei"/>
-                <a:cs typeface="Microsoft YaHei"/>
-              </a:rPr>
-              <a:t>离散事件仿真验证 SLO</a:t>
-            </a:r>
-          </a:p>
-          <a:p>
-            <a:pPr algn="l" marL="128016" indent="-128016">
-              <a:lnSpc>
-                <a:spcPct val="105000"/>
-              </a:lnSpc>
-              <a:spcAft>
-                <a:spcPts val="700"/>
-              </a:spcAft>
-              <a:buClr>
-                <a:srgbClr val="1D4ED8"/>
-              </a:buClr>
-              <a:buFont typeface="Arial"/>
-              <a:buChar char="•"/>
-            </a:pPr>
-            <a:r>
-              <a:rPr sz="1150" b="0">
-                <a:solidFill>
-                  <a:srgbClr val="374151"/>
-                </a:solidFill>
-                <a:latin typeface="Microsoft YaHei"/>
-                <a:ea typeface="Microsoft YaHei"/>
-                <a:cs typeface="Microsoft YaHei"/>
-              </a:rPr>
-              <a:t>生成启动、路由、压测命令</a:t>
-            </a:r>
-          </a:p>
-        </p:txBody>
-      </p:sp>
       <p:cxnSp>
         <p:nvCxnSpPr>
-          <p:cNvPr id="23" name="Connector 22"/>
+          <p:cNvPr id="21" name="Connector 20"/>
           <p:cNvCxnSpPr/>
           <p:nvPr/>
         </p:nvCxnSpPr>
         <p:spPr>
           <a:xfrm>
-            <a:off x="2468880" y="2976372"/>
+            <a:off x="9887407" y="2862072"/>
             <a:ext cx="201168" cy="0"/>
           </a:xfrm>
           <a:prstGeom prst="line">
@@ -4488,38 +4372,16 @@
           </a:ln>
         </p:spPr>
       </p:cxnSp>
-      <p:cxnSp>
-        <p:nvCxnSpPr>
-          <p:cNvPr id="24" name="Connector 23"/>
-          <p:cNvCxnSpPr/>
-          <p:nvPr/>
-        </p:nvCxnSpPr>
-        <p:spPr>
-          <a:xfrm>
-            <a:off x="9887407" y="2976372"/>
-            <a:ext cx="201168" cy="0"/>
-          </a:xfrm>
-          <a:prstGeom prst="line">
-            <a:avLst/>
-          </a:prstGeom>
-          <a:ln w="22225">
-            <a:solidFill>
-              <a:srgbClr val="9CA3AF"/>
-            </a:solidFill>
-            <a:tailEnd type="triangle" w="med" len="med"/>
-          </a:ln>
-        </p:spPr>
-      </p:cxnSp>
-      <p:sp>
-        <p:nvSpPr>
-          <p:cNvPr id="25" name="Rectangle 24"/>
+      <p:sp>
+        <p:nvSpPr>
+          <p:cNvPr id="22" name="Rectangle 21"/>
           <p:cNvSpPr/>
           <p:nvPr/>
         </p:nvSpPr>
         <p:spPr>
           <a:xfrm>
             <a:off x="10134295" y="1627632"/>
-            <a:ext cx="1645920" cy="2697480"/>
+            <a:ext cx="1645920" cy="2468880"/>
           </a:xfrm>
           <a:prstGeom prst="rect">
             <a:avLst/>
@@ -4539,10 +4401,13 @@
           </a:bodyPr>
           <a:lstStyle/>
           <a:p>
-            <a:pPr algn="l">
+            <a:pPr algn="l" latinLnBrk="0">
               <a:lnSpc>
                 <a:spcPct val="100000"/>
               </a:lnSpc>
+              <a:spcBef>
+                <a:spcPts val="0"/>
+              </a:spcBef>
               <a:spcAft>
                 <a:spcPts val="900"/>
               </a:spcAft>
@@ -4556,16 +4421,19 @@
                 <a:ea typeface="Microsoft YaHei"/>
                 <a:cs typeface="Microsoft YaHei"/>
               </a:rPr>
-              <a:t>报告与命令</a:t>
-            </a:r>
-          </a:p>
-          <a:p>
-            <a:pPr algn="l" marL="128016" indent="-128016">
+              <a:t>方案与配置</a:t>
+            </a:r>
+          </a:p>
+          <a:p>
+            <a:pPr algn="l" latinLnBrk="0" marL="128016" indent="-128016">
               <a:lnSpc>
                 <a:spcPct val="105000"/>
               </a:lnSpc>
-              <a:spcAft>
-                <a:spcPts val="700"/>
+              <a:spcBef>
+                <a:spcPts val="0"/>
+              </a:spcBef>
+              <a:spcAft>
+                <a:spcPts val="600"/>
               </a:spcAft>
               <a:buClr>
                 <a:srgbClr val="6B7280"/>
@@ -4574,7 +4442,7 @@
               <a:buChar char="•"/>
             </a:pPr>
             <a:r>
-              <a:rPr sz="1150" b="0">
+              <a:rPr sz="1100" b="0">
                 <a:solidFill>
                   <a:srgbClr val="374151"/>
                 </a:solidFill>
@@ -4582,16 +4450,19 @@
                 <a:ea typeface="Microsoft YaHei"/>
                 <a:cs typeface="Microsoft YaHei"/>
               </a:rPr>
-              <a:t>Markdown / JSON 报告</a:t>
-            </a:r>
-          </a:p>
-          <a:p>
-            <a:pPr algn="l" marL="128016" indent="-128016">
+              <a:t>适配清单与分步计划</a:t>
+            </a:r>
+          </a:p>
+          <a:p>
+            <a:pPr algn="l" latinLnBrk="0" marL="128016" indent="-128016">
               <a:lnSpc>
                 <a:spcPct val="105000"/>
               </a:lnSpc>
-              <a:spcAft>
-                <a:spcPts val="700"/>
+              <a:spcBef>
+                <a:spcPts val="0"/>
+              </a:spcBef>
+              <a:spcAft>
+                <a:spcPts val="600"/>
               </a:spcAft>
               <a:buClr>
                 <a:srgbClr val="6B7280"/>
@@ -4600,7 +4471,7 @@
               <a:buChar char="•"/>
             </a:pPr>
             <a:r>
-              <a:rPr sz="1150" b="0">
+              <a:rPr sz="1100" b="0">
                 <a:solidFill>
                   <a:srgbClr val="374151"/>
                 </a:solidFill>
@@ -4608,16 +4479,19 @@
                 <a:ea typeface="Microsoft YaHei"/>
                 <a:cs typeface="Microsoft YaHei"/>
               </a:rPr>
-              <a:t>每条结论附证据与源码出处</a:t>
-            </a:r>
-          </a:p>
-          <a:p>
-            <a:pPr algn="l" marL="128016" indent="-128016">
+              <a:t>性能诊断与优化建议</a:t>
+            </a:r>
+          </a:p>
+          <a:p>
+            <a:pPr algn="l" latinLnBrk="0" marL="128016" indent="-128016">
               <a:lnSpc>
                 <a:spcPct val="105000"/>
               </a:lnSpc>
-              <a:spcAft>
-                <a:spcPts val="700"/>
+              <a:spcBef>
+                <a:spcPts val="0"/>
+              </a:spcBef>
+              <a:spcAft>
+                <a:spcPts val="600"/>
               </a:spcAft>
               <a:buClr>
                 <a:srgbClr val="6B7280"/>
@@ -4626,7 +4500,7 @@
               <a:buChar char="•"/>
             </a:pPr>
             <a:r>
-              <a:rPr sz="1150" b="0">
+              <a:rPr sz="1100" b="0">
                 <a:solidFill>
                   <a:srgbClr val="374151"/>
                 </a:solidFill>
@@ -4634,16 +4508,19 @@
                 <a:ea typeface="Microsoft YaHei"/>
                 <a:cs typeface="Microsoft YaHei"/>
               </a:rPr>
-              <a:t>启动、路由、压测命令</a:t>
-            </a:r>
-          </a:p>
-          <a:p>
-            <a:pPr algn="l" marL="128016" indent="-128016">
+              <a:t>调优后的启动配置</a:t>
+            </a:r>
+          </a:p>
+          <a:p>
+            <a:pPr algn="l" latinLnBrk="0" marL="128016" indent="-128016">
               <a:lnSpc>
                 <a:spcPct val="105000"/>
               </a:lnSpc>
-              <a:spcAft>
-                <a:spcPts val="700"/>
+              <a:spcBef>
+                <a:spcPts val="0"/>
+              </a:spcBef>
+              <a:spcAft>
+                <a:spcPts val="600"/>
               </a:spcAft>
               <a:buClr>
                 <a:srgbClr val="6B7280"/>
@@ -4652,7 +4529,7 @@
               <a:buChar char="•"/>
             </a:pPr>
             <a:r>
-              <a:rPr sz="1150" b="0">
+              <a:rPr sz="1100" b="0">
                 <a:solidFill>
                   <a:srgbClr val="374151"/>
                 </a:solidFill>
@@ -4660,21 +4537,69 @@
                 <a:ea typeface="Microsoft YaHei"/>
                 <a:cs typeface="Microsoft YaHei"/>
               </a:rPr>
-              <a:t>适配与上线步骤</a:t>
-            </a:r>
-          </a:p>
-        </p:txBody>
-      </p:sp>
-      <p:sp>
-        <p:nvSpPr>
-          <p:cNvPr id="26" name="Rectangle 25"/>
+              <a:t>结论附源码出处</a:t>
+            </a:r>
+          </a:p>
+          <a:p>
+            <a:pPr algn="l" latinLnBrk="0">
+              <a:lnSpc>
+                <a:spcPct val="100000"/>
+              </a:lnSpc>
+              <a:spcBef>
+                <a:spcPts val="800"/>
+              </a:spcBef>
+              <a:spcAft>
+                <a:spcPts val="100"/>
+              </a:spcAft>
+            </a:pPr>
+            <a:r>
+              <a:rPr sz="900" b="0">
+                <a:solidFill>
+                  <a:srgbClr val="6B7280"/>
+                </a:solidFill>
+                <a:latin typeface="Microsoft YaHei"/>
+                <a:ea typeface="Microsoft YaHei"/>
+                <a:cs typeface="Microsoft YaHei"/>
+              </a:rPr>
+              <a:t>下一页</a:t>
+            </a:r>
+          </a:p>
+          <a:p>
+            <a:pPr algn="l" latinLnBrk="0">
+              <a:lnSpc>
+                <a:spcPct val="100000"/>
+              </a:lnSpc>
+              <a:spcBef>
+                <a:spcPts val="0"/>
+              </a:spcBef>
+              <a:spcAft>
+                <a:spcPts val="0"/>
+              </a:spcAft>
+            </a:pPr>
+            <a:r>
+              <a:rPr sz="1000" b="1">
+                <a:solidFill>
+                  <a:srgbClr val="1D4ED8"/>
+                </a:solidFill>
+                <a:latin typeface="Microsoft YaHei"/>
+                <a:ea typeface="Microsoft YaHei"/>
+                <a:cs typeface="Microsoft YaHei"/>
+              </a:rPr>
+              <a:t>场景 5 自动性能测评</a:t>
+            </a:r>
+          </a:p>
+        </p:txBody>
+      </p:sp>
+      <p:sp>
+        <p:nvSpPr>
+          <p:cNvPr id="23" name="Rectangle 22"/>
           <p:cNvSpPr/>
           <p:nvPr/>
         </p:nvSpPr>
         <p:spPr>
           <a:xfrm>
-            <a:off x="2715768" y="4480560"/>
-            <a:ext cx="7125919" cy="603504"/>
+            <a:off x="2715768" y="4224528"/>
+            <a:ext cx="7125919" cy="566928"/>
           </a:xfrm>
           <a:prstGeom prst="rect">
             <a:avLst/>
@@ -4698,14 +4623,14 @@
       </p:sp>
       <p:sp>
         <p:nvSpPr>
-          <p:cNvPr id="27" name="TextBox 26"/>
+          <p:cNvPr id="24" name="TextBox 23"/>
           <p:cNvSpPr txBox="1"/>
           <p:nvPr/>
         </p:nvSpPr>
         <p:spPr>
           <a:xfrm>
-            <a:off x="2715768" y="4480560"/>
-            <a:ext cx="1051560" cy="603504"/>
+            <a:off x="2715768" y="4224528"/>
+            <a:ext cx="1051560" cy="566928"/>
           </a:xfrm>
           <a:prstGeom prst="rect">
             <a:avLst/>
@@ -4718,10 +4643,13 @@
           </a:bodyPr>
           <a:lstStyle/>
           <a:p>
-            <a:pPr algn="l">
+            <a:pPr algn="l" latinLnBrk="0">
               <a:lnSpc>
                 <a:spcPct val="100000"/>
               </a:lnSpc>
+              <a:spcBef>
+                <a:spcPts val="0"/>
+              </a:spcBef>
               <a:spcAft>
                 <a:spcPts val="100"/>
               </a:spcAft>
@@ -4739,10 +4667,13 @@
             </a:r>
           </a:p>
           <a:p>
-            <a:pPr algn="l">
+            <a:pPr algn="l" latinLnBrk="0">
               <a:lnSpc>
                 <a:spcPct val="100000"/>
               </a:lnSpc>
+              <a:spcBef>
+                <a:spcPts val="0"/>
+              </a:spcBef>
               <a:spcAft>
                 <a:spcPts val="0"/>
               </a:spcAft>
@@ -4763,14 +4694,14 @@
       </p:sp>
       <p:cxnSp>
         <p:nvCxnSpPr>
-          <p:cNvPr id="28" name="Connector 27"/>
+          <p:cNvPr id="25" name="Connector 24"/>
           <p:cNvCxnSpPr/>
           <p:nvPr/>
         </p:nvCxnSpPr>
         <p:spPr>
           <a:xfrm>
-            <a:off x="3767328" y="4590288"/>
-            <a:ext cx="0" cy="384048"/>
+            <a:off x="3767328" y="4334256"/>
+            <a:ext cx="0" cy="347472"/>
           </a:xfrm>
           <a:prstGeom prst="line">
             <a:avLst/>
@@ -4784,14 +4715,14 @@
       </p:cxnSp>
       <p:sp>
         <p:nvSpPr>
-          <p:cNvPr id="29" name="TextBox 28"/>
+          <p:cNvPr id="26" name="TextBox 25"/>
           <p:cNvSpPr txBox="1"/>
           <p:nvPr/>
         </p:nvSpPr>
         <p:spPr>
           <a:xfrm>
-            <a:off x="3767328" y="4480560"/>
-            <a:ext cx="2024786" cy="603504"/>
+            <a:off x="3767328" y="4224528"/>
+            <a:ext cx="2024786" cy="566928"/>
           </a:xfrm>
           <a:prstGeom prst="rect">
             <a:avLst/>
@@ -4804,10 +4735,13 @@
           </a:bodyPr>
           <a:lstStyle/>
           <a:p>
-            <a:pPr algn="l">
+            <a:pPr algn="l" latinLnBrk="0">
               <a:lnSpc>
                 <a:spcPct val="100000"/>
               </a:lnSpc>
+              <a:spcBef>
+                <a:spcPts val="0"/>
+              </a:spcBef>
               <a:spcAft>
                 <a:spcPts val="100"/>
               </a:spcAft>
@@ -4825,10 +4759,13 @@
             </a:r>
           </a:p>
           <a:p>
-            <a:pPr algn="l">
+            <a:pPr algn="l" latinLnBrk="0">
               <a:lnSpc>
                 <a:spcPct val="100000"/>
               </a:lnSpc>
+              <a:spcBef>
+                <a:spcPts val="0"/>
+              </a:spcBef>
               <a:spcAft>
                 <a:spcPts val="0"/>
               </a:spcAft>
@@ -4849,14 +4786,14 @@
       </p:sp>
       <p:cxnSp>
         <p:nvCxnSpPr>
-          <p:cNvPr id="30" name="Connector 29"/>
+          <p:cNvPr id="27" name="Connector 26"/>
           <p:cNvCxnSpPr/>
           <p:nvPr/>
         </p:nvCxnSpPr>
         <p:spPr>
           <a:xfrm>
-            <a:off x="5792114" y="4590288"/>
-            <a:ext cx="0" cy="384048"/>
+            <a:off x="5792114" y="4334256"/>
+            <a:ext cx="0" cy="347472"/>
           </a:xfrm>
           <a:prstGeom prst="line">
             <a:avLst/>
@@ -4870,14 +4807,14 @@
       </p:cxnSp>
       <p:sp>
         <p:nvSpPr>
-          <p:cNvPr id="31" name="TextBox 30"/>
+          <p:cNvPr id="28" name="TextBox 27"/>
           <p:cNvSpPr txBox="1"/>
           <p:nvPr/>
         </p:nvSpPr>
         <p:spPr>
           <a:xfrm>
-            <a:off x="5792114" y="4480560"/>
-            <a:ext cx="2024786" cy="603504"/>
+            <a:off x="5792114" y="4224528"/>
+            <a:ext cx="2024786" cy="566928"/>
           </a:xfrm>
           <a:prstGeom prst="rect">
             <a:avLst/>
@@ -4890,10 +4827,13 @@
           </a:bodyPr>
           <a:lstStyle/>
           <a:p>
-            <a:pPr algn="l">
+            <a:pPr algn="l" latinLnBrk="0">
               <a:lnSpc>
                 <a:spcPct val="100000"/>
               </a:lnSpc>
+              <a:spcBef>
+                <a:spcPts val="0"/>
+              </a:spcBef>
               <a:spcAft>
                 <a:spcPts val="100"/>
               </a:spcAft>
@@ -4911,10 +4851,13 @@
             </a:r>
           </a:p>
           <a:p>
-            <a:pPr algn="l">
+            <a:pPr algn="l" latinLnBrk="0">
               <a:lnSpc>
                 <a:spcPct val="100000"/>
               </a:lnSpc>
+              <a:spcBef>
+                <a:spcPts val="0"/>
+              </a:spcBef>
               <a:spcAft>
                 <a:spcPts val="0"/>
               </a:spcAft>
@@ -4935,14 +4878,14 @@
       </p:sp>
       <p:cxnSp>
         <p:nvCxnSpPr>
-          <p:cNvPr id="32" name="Connector 31"/>
+          <p:cNvPr id="29" name="Connector 28"/>
           <p:cNvCxnSpPr/>
           <p:nvPr/>
         </p:nvCxnSpPr>
         <p:spPr>
           <a:xfrm>
-            <a:off x="7816900" y="4590288"/>
-            <a:ext cx="0" cy="384048"/>
+            <a:off x="7816900" y="4334256"/>
+            <a:ext cx="0" cy="347472"/>
           </a:xfrm>
           <a:prstGeom prst="line">
             <a:avLst/>
@@ -4956,14 +4899,14 @@
       </p:cxnSp>
       <p:sp>
         <p:nvSpPr>
-          <p:cNvPr id="33" name="TextBox 32"/>
+          <p:cNvPr id="30" name="TextBox 29"/>
           <p:cNvSpPr txBox="1"/>
           <p:nvPr/>
         </p:nvSpPr>
         <p:spPr>
           <a:xfrm>
-            <a:off x="7816900" y="4480560"/>
-            <a:ext cx="2024786" cy="603504"/>
+            <a:off x="7816900" y="4224528"/>
+            <a:ext cx="2024786" cy="566928"/>
           </a:xfrm>
           <a:prstGeom prst="rect">
             <a:avLst/>
@@ -4976,10 +4919,13 @@
           </a:bodyPr>
           <a:lstStyle/>
           <a:p>
-            <a:pPr algn="l">
+            <a:pPr algn="l" latinLnBrk="0">
               <a:lnSpc>
                 <a:spcPct val="100000"/>
               </a:lnSpc>
+              <a:spcBef>
+                <a:spcPts val="0"/>
+              </a:spcBef>
               <a:spcAft>
                 <a:spcPts val="100"/>
               </a:spcAft>
@@ -4997,10 +4943,13 @@
             </a:r>
           </a:p>
           <a:p>
-            <a:pPr algn="l">
+            <a:pPr algn="l" latinLnBrk="0">
               <a:lnSpc>
                 <a:spcPct val="100000"/>
               </a:lnSpc>
+              <a:spcBef>
+                <a:spcPts val="0"/>
+              </a:spcBef>
               <a:spcAft>
                 <a:spcPts val="0"/>
               </a:spcAft>
@@ -5021,14 +4970,72 @@
       </p:sp>
       <p:sp>
         <p:nvSpPr>
-          <p:cNvPr id="34" name="Rectangle 33"/>
+          <p:cNvPr id="31" name="TextBox 30"/>
+          <p:cNvSpPr txBox="1"/>
+          <p:nvPr/>
+        </p:nvSpPr>
+        <p:spPr>
+          <a:xfrm>
+            <a:off x="2715768" y="4882896"/>
+            <a:ext cx="7125919" cy="274320"/>
+          </a:xfrm>
+          <a:prstGeom prst="rect">
+            <a:avLst/>
+          </a:prstGeom>
+          <a:noFill/>
+        </p:spPr>
+        <p:txBody>
+          <a:bodyPr wrap="square" anchor="ctr" lIns="0" tIns="0" rIns="0" bIns="0">
+            <a:noAutofit/>
+          </a:bodyPr>
+          <a:lstStyle/>
+          <a:p>
+            <a:pPr algn="l" latinLnBrk="0">
+              <a:lnSpc>
+                <a:spcPct val="100000"/>
+              </a:lnSpc>
+              <a:spcBef>
+                <a:spcPts val="0"/>
+              </a:spcBef>
+              <a:spcAft>
+                <a:spcPts val="0"/>
+              </a:spcAft>
+            </a:pPr>
+            <a:r>
+              <a:rPr sz="1100" b="1">
+                <a:solidFill>
+                  <a:srgbClr val="9A3412"/>
+                </a:solidFill>
+                <a:latin typeface="Microsoft YaHei"/>
+                <a:ea typeface="Microsoft YaHei"/>
+                <a:cs typeface="Microsoft YaHei"/>
+              </a:rPr>
+              <a:t>自动落地闭环</a:t>
+            </a:r>
+            <a:r>
+              <a:rPr sz="1000" b="0">
+                <a:solidFill>
+                  <a:srgbClr val="6B7280"/>
+                </a:solidFill>
+                <a:latin typeface="Microsoft YaHei"/>
+                <a:ea typeface="Microsoft YaHei"/>
+                <a:cs typeface="Microsoft YaHei"/>
+              </a:rPr>
+              <a:t>　执行器（规划中）在真机上自动执行：默认只打印命令（dry-run），显式加 --allow-exec 才真正执行</a:t>
+            </a:r>
+          </a:p>
+        </p:txBody>
+      </p:sp>
+      <p:sp>
+        <p:nvSpPr>
+          <p:cNvPr id="32" name="Rectangle 31"/>
           <p:cNvSpPr/>
           <p:nvPr/>
         </p:nvSpPr>
         <p:spPr>
           <a:xfrm>
-            <a:off x="411480" y="5358384"/>
-            <a:ext cx="3545738" cy="658368"/>
+            <a:off x="411480" y="5212080"/>
+            <a:ext cx="3545738" cy="786384"/>
           </a:xfrm>
           <a:prstGeom prst="rect">
             <a:avLst/>
@@ -5043,17 +5050,20 @@
           </a:ln>
         </p:spPr>
         <p:txBody>
-          <a:bodyPr rtlCol="0" anchor="ctr" wrap="square" lIns="146304" tIns="27432" bIns="27432">
+          <a:bodyPr rtlCol="0" anchor="ctr" wrap="square" lIns="146304" tIns="27432" rIns="109728" bIns="27432">
             <a:noAutofit/>
           </a:bodyPr>
           <a:lstStyle/>
           <a:p>
-            <a:pPr algn="l">
+            <a:pPr algn="l" latinLnBrk="0">
               <a:lnSpc>
                 <a:spcPct val="100000"/>
               </a:lnSpc>
-              <a:spcAft>
-                <a:spcPts val="100"/>
+              <a:spcBef>
+                <a:spcPts val="0"/>
+              </a:spcBef>
+              <a:spcAft>
+                <a:spcPts val="200"/>
               </a:spcAft>
             </a:pPr>
             <a:r>
@@ -5065,14 +5075,17 @@
                 <a:ea typeface="Microsoft YaHei"/>
                 <a:cs typeface="Microsoft YaHei"/>
               </a:rPr>
-              <a:t>回流为输入</a:t>
-            </a:r>
-          </a:p>
-          <a:p>
-            <a:pPr algn="l">
-              <a:lnSpc>
-                <a:spcPct val="100000"/>
-              </a:lnSpc>
+              <a:t>实测回流</a:t>
+            </a:r>
+          </a:p>
+          <a:p>
+            <a:pPr algn="l" latinLnBrk="0">
+              <a:lnSpc>
+                <a:spcPct val="105000"/>
+              </a:lnSpc>
+              <a:spcBef>
+                <a:spcPts val="0"/>
+              </a:spcBef>
               <a:spcAft>
                 <a:spcPts val="0"/>
               </a:spcAft>
@@ -5086,21 +5099,21 @@
                 <a:ea typeface="Microsoft YaHei"/>
                 <a:cs typeface="Microsoft YaHei"/>
               </a:rPr>
-              <a:t>诊断真实瓶颈、校准成本模型、重新规划部署</a:t>
-            </a:r>
-          </a:p>
-        </p:txBody>
-      </p:sp>
-      <p:sp>
-        <p:nvSpPr>
-          <p:cNvPr id="35" name="Rectangle 34"/>
+              <a:t>trace、日志、压测结果回到输入：诊断真实瓶颈、校准成本模型</a:t>
+            </a:r>
+          </a:p>
+        </p:txBody>
+      </p:sp>
+      <p:sp>
+        <p:nvSpPr>
+          <p:cNvPr id="33" name="Rectangle 32"/>
           <p:cNvSpPr/>
           <p:nvPr/>
         </p:nvSpPr>
         <p:spPr>
           <a:xfrm>
-            <a:off x="4322978" y="5358384"/>
-            <a:ext cx="3545738" cy="658368"/>
+            <a:off x="4322978" y="5212080"/>
+            <a:ext cx="3545738" cy="786384"/>
           </a:xfrm>
           <a:prstGeom prst="rect">
             <a:avLst/>
@@ -5116,17 +5129,20 @@
           </a:ln>
         </p:spPr>
         <p:txBody>
-          <a:bodyPr rtlCol="0" anchor="ctr" wrap="square" lIns="146304" tIns="27432" bIns="27432">
+          <a:bodyPr rtlCol="0" anchor="ctr" wrap="square" lIns="146304" tIns="27432" rIns="109728" bIns="27432">
             <a:noAutofit/>
           </a:bodyPr>
           <a:lstStyle/>
           <a:p>
-            <a:pPr algn="l">
+            <a:pPr algn="l" latinLnBrk="0">
               <a:lnSpc>
                 <a:spcPct val="100000"/>
               </a:lnSpc>
-              <a:spcAft>
-                <a:spcPts val="100"/>
+              <a:spcBef>
+                <a:spcPts val="0"/>
+              </a:spcBef>
+              <a:spcAft>
+                <a:spcPts val="200"/>
               </a:spcAft>
             </a:pPr>
             <a:r>
@@ -5138,14 +5154,28 @@
                 <a:ea typeface="Microsoft YaHei"/>
                 <a:cs typeface="Microsoft YaHei"/>
               </a:rPr>
-              <a:t>采集实测数据</a:t>
-            </a:r>
-          </a:p>
-          <a:p>
-            <a:pPr algn="l">
-              <a:lnSpc>
-                <a:spcPct val="100000"/>
-              </a:lnSpc>
+              <a:t>自动调优</a:t>
+            </a:r>
+            <a:r>
+              <a:rPr sz="900" b="0">
+                <a:solidFill>
+                  <a:srgbClr val="C2410C"/>
+                </a:solidFill>
+                <a:latin typeface="Microsoft YaHei"/>
+                <a:ea typeface="Microsoft YaHei"/>
+                <a:cs typeface="Microsoft YaHei"/>
+              </a:rPr>
+              <a:t>　规划中</a:t>
+            </a:r>
+          </a:p>
+          <a:p>
+            <a:pPr algn="l" latinLnBrk="0">
+              <a:lnSpc>
+                <a:spcPct val="105000"/>
+              </a:lnSpc>
+              <a:spcBef>
+                <a:spcPts val="0"/>
+              </a:spcBef>
               <a:spcAft>
                 <a:spcPts val="0"/>
               </a:spcAft>
@@ -5159,20 +5189,20 @@
                 <a:ea typeface="Microsoft YaHei"/>
                 <a:cs typeface="Microsoft YaHei"/>
               </a:rPr>
-              <a:t>profiler trace、server 日志、压测结果</a:t>
+              <a:t>候选配置在真机上自动 A/B，按实测选优并回写配置</a:t>
             </a:r>
           </a:p>
         </p:txBody>
       </p:sp>
       <p:cxnSp>
         <p:nvCxnSpPr>
-          <p:cNvPr id="36" name="Connector 35"/>
+          <p:cNvPr id="34" name="Connector 33"/>
           <p:cNvCxnSpPr/>
           <p:nvPr/>
         </p:nvCxnSpPr>
         <p:spPr>
           <a:xfrm flipH="1">
-            <a:off x="4012082" y="5687568"/>
+            <a:off x="4012082" y="5605272"/>
             <a:ext cx="256032" cy="0"/>
           </a:xfrm>
           <a:prstGeom prst="line">
@@ -5188,14 +5218,14 @@
       </p:cxnSp>
       <p:sp>
         <p:nvSpPr>
-          <p:cNvPr id="37" name="Rectangle 36"/>
+          <p:cNvPr id="35" name="Rectangle 34"/>
           <p:cNvSpPr/>
           <p:nvPr/>
         </p:nvSpPr>
         <p:spPr>
           <a:xfrm>
-            <a:off x="8234476" y="5358384"/>
-            <a:ext cx="3545738" cy="658368"/>
+            <a:off x="8234476" y="5212080"/>
+            <a:ext cx="3545738" cy="786384"/>
           </a:xfrm>
           <a:prstGeom prst="rect">
             <a:avLst/>
@@ -5211,17 +5241,20 @@
           </a:ln>
         </p:spPr>
         <p:txBody>
-          <a:bodyPr rtlCol="0" anchor="ctr" wrap="square" lIns="146304" tIns="27432" bIns="27432">
+          <a:bodyPr rtlCol="0" anchor="ctr" wrap="square" lIns="146304" tIns="27432" rIns="109728" bIns="27432">
             <a:noAutofit/>
           </a:bodyPr>
           <a:lstStyle/>
           <a:p>
-            <a:pPr algn="l">
+            <a:pPr algn="l" latinLnBrk="0">
               <a:lnSpc>
                 <a:spcPct val="100000"/>
               </a:lnSpc>
-              <a:spcAft>
-                <a:spcPts val="100"/>
+              <a:spcBef>
+                <a:spcPts val="0"/>
+              </a:spcBef>
+              <a:spcAft>
+                <a:spcPts val="200"/>
               </a:spcAft>
             </a:pPr>
             <a:r>
@@ -5233,14 +5266,28 @@
                 <a:ea typeface="Microsoft YaHei"/>
                 <a:cs typeface="Microsoft YaHei"/>
               </a:rPr>
-              <a:t>真机部署与压测</a:t>
-            </a:r>
-          </a:p>
-          <a:p>
-            <a:pPr algn="l">
-              <a:lnSpc>
-                <a:spcPct val="100000"/>
-              </a:lnSpc>
+              <a:t>自动适配</a:t>
+            </a:r>
+            <a:r>
+              <a:rPr sz="900" b="0">
+                <a:solidFill>
+                  <a:srgbClr val="C2410C"/>
+                </a:solidFill>
+                <a:latin typeface="Microsoft YaHei"/>
+                <a:ea typeface="Microsoft YaHei"/>
+                <a:cs typeface="Microsoft YaHei"/>
+              </a:rPr>
+              <a:t>　规划中</a:t>
+            </a:r>
+          </a:p>
+          <a:p>
+            <a:pPr algn="l" latinLnBrk="0">
+              <a:lnSpc>
+                <a:spcPct val="105000"/>
+              </a:lnSpc>
+              <a:spcBef>
+                <a:spcPts val="0"/>
+              </a:spcBef>
               <a:spcAft>
                 <a:spcPts val="0"/>
               </a:spcAft>
@@ -5254,20 +5301,20 @@
                 <a:ea typeface="Microsoft YaHei"/>
                 <a:cs typeface="Microsoft YaHei"/>
               </a:rPr>
-              <a:t>按输出的命令执行（当前由人操作）</a:t>
+              <a:t>按适配清单生成平台插件骨架、算子注册和 torch 参考实现，自动跑冒烟与精度对比</a:t>
             </a:r>
           </a:p>
         </p:txBody>
       </p:sp>
       <p:cxnSp>
         <p:nvCxnSpPr>
-          <p:cNvPr id="38" name="Connector 37"/>
+          <p:cNvPr id="36" name="Connector 35"/>
           <p:cNvCxnSpPr/>
           <p:nvPr/>
         </p:nvCxnSpPr>
         <p:spPr>
           <a:xfrm flipH="1">
-            <a:off x="7923580" y="5687568"/>
+            <a:off x="7923580" y="5605272"/>
             <a:ext cx="256032" cy="0"/>
           </a:xfrm>
           <a:prstGeom prst="line">
@@ -5283,14 +5330,14 @@
       </p:cxnSp>
       <p:cxnSp>
         <p:nvCxnSpPr>
-          <p:cNvPr id="39" name="Connector 38"/>
+          <p:cNvPr id="37" name="Connector 36"/>
           <p:cNvCxnSpPr/>
           <p:nvPr/>
         </p:nvCxnSpPr>
         <p:spPr>
           <a:xfrm>
-            <a:off x="10957255" y="4370832"/>
-            <a:ext cx="0" cy="941832"/>
+            <a:off x="10957255" y="4142232"/>
+            <a:ext cx="0" cy="1024128"/>
           </a:xfrm>
           <a:prstGeom prst="line">
             <a:avLst/>
@@ -5303,60 +5350,16 @@
           </a:ln>
         </p:spPr>
       </p:cxnSp>
-      <p:sp>
-        <p:nvSpPr>
-          <p:cNvPr id="40" name="TextBox 39"/>
-          <p:cNvSpPr txBox="1"/>
-          <p:nvPr/>
-        </p:nvSpPr>
-        <p:spPr>
-          <a:xfrm>
-            <a:off x="10088575" y="4672584"/>
-            <a:ext cx="777240" cy="274320"/>
-          </a:xfrm>
-          <a:prstGeom prst="rect">
-            <a:avLst/>
-          </a:prstGeom>
-          <a:noFill/>
-        </p:spPr>
-        <p:txBody>
-          <a:bodyPr wrap="square" anchor="ctr" lIns="0" tIns="0" rIns="0" bIns="0">
-            <a:noAutofit/>
-          </a:bodyPr>
-          <a:lstStyle/>
-          <a:p>
-            <a:pPr algn="r">
-              <a:lnSpc>
-                <a:spcPct val="100000"/>
-              </a:lnSpc>
-              <a:spcAft>
-                <a:spcPts val="0"/>
-              </a:spcAft>
-            </a:pPr>
-            <a:r>
-              <a:rPr sz="1000" b="1">
-                <a:solidFill>
-                  <a:srgbClr val="9A3412"/>
-                </a:solidFill>
-                <a:latin typeface="Microsoft YaHei"/>
-                <a:ea typeface="Microsoft YaHei"/>
-                <a:cs typeface="Microsoft YaHei"/>
-              </a:rPr>
-              <a:t>闭环反馈</a:t>
-            </a:r>
-          </a:p>
-        </p:txBody>
-      </p:sp>
       <p:cxnSp>
         <p:nvCxnSpPr>
-          <p:cNvPr id="41" name="Connector 40"/>
+          <p:cNvPr id="38" name="Connector 37"/>
           <p:cNvCxnSpPr/>
           <p:nvPr/>
         </p:nvCxnSpPr>
         <p:spPr>
           <a:xfrm flipV="1">
-            <a:off x="1417320" y="4370832"/>
-            <a:ext cx="0" cy="941832"/>
+            <a:off x="1417320" y="4142232"/>
+            <a:ext cx="0" cy="1024128"/>
           </a:xfrm>
           <a:prstGeom prst="line">
             <a:avLst/>
@@ -5371,14 +5374,14 @@
       </p:cxnSp>
       <p:sp>
         <p:nvSpPr>
-          <p:cNvPr id="42" name="TextBox 41"/>
+          <p:cNvPr id="39" name="TextBox 38"/>
           <p:cNvSpPr txBox="1"/>
           <p:nvPr/>
         </p:nvSpPr>
         <p:spPr>
           <a:xfrm>
             <a:off x="411480" y="6254496"/>
-            <a:ext cx="7680960" cy="292608"/>
+            <a:ext cx="8259775" cy="292608"/>
           </a:xfrm>
           <a:prstGeom prst="rect">
             <a:avLst/>
@@ -5391,10 +5394,13 @@
           </a:bodyPr>
           <a:lstStyle/>
           <a:p>
-            <a:pPr algn="l">
+            <a:pPr algn="l" latinLnBrk="0">
               <a:lnSpc>
                 <a:spcPct val="100000"/>
               </a:lnSpc>
+              <a:spcBef>
+                <a:spcPts val="0"/>
+              </a:spcBef>
               <a:spcAft>
                 <a:spcPts val="0"/>
               </a:spcAft>
@@ -5415,13 +5421,13 @@
       </p:sp>
       <p:sp>
         <p:nvSpPr>
-          <p:cNvPr id="43" name="Rectangle 42"/>
+          <p:cNvPr id="40" name="Rectangle 39"/>
           <p:cNvSpPr/>
           <p:nvPr/>
         </p:nvSpPr>
         <p:spPr>
           <a:xfrm>
-            <a:off x="7939735" y="6327648"/>
+            <a:off x="8854135" y="6327648"/>
             <a:ext cx="274320" cy="146304"/>
           </a:xfrm>
           <a:prstGeom prst="rect">
@@ -5447,14 +5453,14 @@
       </p:sp>
       <p:sp>
         <p:nvSpPr>
-          <p:cNvPr id="44" name="TextBox 43"/>
+          <p:cNvPr id="41" name="TextBox 40"/>
           <p:cNvSpPr txBox="1"/>
           <p:nvPr/>
         </p:nvSpPr>
         <p:spPr>
           <a:xfrm>
-            <a:off x="8287207" y="6254496"/>
-            <a:ext cx="3493008" cy="292608"/>
+            <a:off x="9201607" y="6254496"/>
+            <a:ext cx="2578608" cy="292608"/>
           </a:xfrm>
           <a:prstGeom prst="rect">
             <a:avLst/>
@@ -5467,10 +5473,13 @@
           </a:bodyPr>
           <a:lstStyle/>
           <a:p>
-            <a:pPr algn="l">
+            <a:pPr algn="l" latinLnBrk="0">
               <a:lnSpc>
                 <a:spcPct val="100000"/>
               </a:lnSpc>
+              <a:spcBef>
+                <a:spcPts val="0"/>
+              </a:spcBef>
               <a:spcAft>
                 <a:spcPts val="0"/>
               </a:spcAft>
@@ -5484,7 +5493,2744 @@
                 <a:ea typeface="Microsoft YaHei"/>
                 <a:cs typeface="Microsoft YaHei"/>
               </a:rPr>
-              <a:t>虚线框：在真机上人工执行；其余环节由工具自动完成</a:t>
+              <a:t>虚线框：规划中，目前由人按输出的命令执行</a:t>
+            </a:r>
+          </a:p>
+        </p:txBody>
+      </p:sp>
+    </p:spTree>
+  </p:cSld>
+  <p:clrMapOvr>
+    <a:masterClrMapping/>
+  </p:clrMapOvr>
+</p:sld>
+</file>
+
+<file path=ppt/slides/slide2.xml><?xml version="1.0" encoding="utf-8"?>
+<p:sld xmlns:a="http://schemas.openxmlformats.org/drawingml/2006/main" xmlns:p="http://schemas.openxmlformats.org/presentationml/2006/main" xmlns:r="http://schemas.openxmlformats.org/officeDocument/2006/relationships">
+  <p:cSld>
+    <p:spTree>
+      <p:nvGrpSpPr>
+        <p:cNvPr id="1" name=""/>
+        <p:cNvGrpSpPr/>
+        <p:nvPr/>
+      </p:nvGrpSpPr>
+      <p:grpSpPr/>
+      <p:sp>
+        <p:nvSpPr>
+          <p:cNvPr id="2" name="Rectangle 1"/>
+          <p:cNvSpPr/>
+          <p:nvPr/>
+        </p:nvSpPr>
+        <p:spPr>
+          <a:xfrm>
+            <a:off x="411480" y="365760"/>
+            <a:ext cx="64008" cy="384048"/>
+          </a:xfrm>
+          <a:prstGeom prst="rect">
+            <a:avLst/>
+          </a:prstGeom>
+          <a:solidFill>
+            <a:srgbClr val="1D4ED8"/>
+          </a:solidFill>
+          <a:ln>
+            <a:noFill/>
+          </a:ln>
+        </p:spPr>
+        <p:txBody>
+          <a:bodyPr rtlCol="0" anchor="ctr"/>
+          <a:lstStyle/>
+          <a:p>
+            <a:pPr algn="ctr"/>
+          </a:p>
+        </p:txBody>
+      </p:sp>
+      <p:sp>
+        <p:nvSpPr>
+          <p:cNvPr id="3" name="TextBox 2"/>
+          <p:cNvSpPr txBox="1"/>
+          <p:nvPr/>
+        </p:nvSpPr>
+        <p:spPr>
+          <a:xfrm>
+            <a:off x="594360" y="274320"/>
+            <a:ext cx="10058400" cy="548640"/>
+          </a:xfrm>
+          <a:prstGeom prst="rect">
+            <a:avLst/>
+          </a:prstGeom>
+          <a:noFill/>
+        </p:spPr>
+        <p:txBody>
+          <a:bodyPr wrap="square" anchor="ctr" lIns="0" tIns="0" rIns="0" bIns="0">
+            <a:noAutofit/>
+          </a:bodyPr>
+          <a:lstStyle/>
+          <a:p>
+            <a:pPr algn="l" latinLnBrk="0">
+              <a:lnSpc>
+                <a:spcPct val="100000"/>
+              </a:lnSpc>
+              <a:spcBef>
+                <a:spcPts val="0"/>
+              </a:spcBef>
+              <a:spcAft>
+                <a:spcPts val="0"/>
+              </a:spcAft>
+            </a:pPr>
+            <a:r>
+              <a:rPr sz="2600" b="1">
+                <a:solidFill>
+                  <a:srgbClr val="1F2937"/>
+                </a:solidFill>
+                <a:latin typeface="Microsoft YaHei"/>
+                <a:ea typeface="Microsoft YaHei"/>
+                <a:cs typeface="Microsoft YaHei"/>
+              </a:rPr>
+              <a:t>场景 5：自动性能测评与最优部署</a:t>
+            </a:r>
+          </a:p>
+        </p:txBody>
+      </p:sp>
+      <p:sp>
+        <p:nvSpPr>
+          <p:cNvPr id="4" name="TextBox 3"/>
+          <p:cNvSpPr txBox="1"/>
+          <p:nvPr/>
+        </p:nvSpPr>
+        <p:spPr>
+          <a:xfrm>
+            <a:off x="411480" y="822960"/>
+            <a:ext cx="11368735" cy="365760"/>
+          </a:xfrm>
+          <a:prstGeom prst="rect">
+            <a:avLst/>
+          </a:prstGeom>
+          <a:noFill/>
+        </p:spPr>
+        <p:txBody>
+          <a:bodyPr wrap="square" anchor="ctr" lIns="0" tIns="0" rIns="0" bIns="0">
+            <a:noAutofit/>
+          </a:bodyPr>
+          <a:lstStyle/>
+          <a:p>
+            <a:pPr algn="l" latinLnBrk="0">
+              <a:lnSpc>
+                <a:spcPct val="100000"/>
+              </a:lnSpc>
+              <a:spcBef>
+                <a:spcPts val="0"/>
+              </a:spcBef>
+              <a:spcAft>
+                <a:spcPts val="0"/>
+              </a:spcAft>
+            </a:pPr>
+            <a:r>
+              <a:rPr sz="1350" b="0">
+                <a:solidFill>
+                  <a:srgbClr val="6B7280"/>
+                </a:solidFill>
+                <a:latin typeface="Microsoft YaHei"/>
+                <a:ea typeface="Microsoft YaHei"/>
+                <a:cs typeface="Microsoft YaHei"/>
+              </a:rPr>
+              <a:t>给定业务场景和 SLO，自动生成候选方案、仿真测评、选出最省卡的方案并生成压测脚本；实测结果回来后自动比对、校准并重新选优</a:t>
+            </a:r>
+          </a:p>
+        </p:txBody>
+      </p:sp>
+      <p:sp>
+        <p:nvSpPr>
+          <p:cNvPr id="5" name="TextBox 4"/>
+          <p:cNvSpPr txBox="1"/>
+          <p:nvPr/>
+        </p:nvSpPr>
+        <p:spPr>
+          <a:xfrm>
+            <a:off x="411480" y="1280160"/>
+            <a:ext cx="2011680" cy="274320"/>
+          </a:xfrm>
+          <a:prstGeom prst="rect">
+            <a:avLst/>
+          </a:prstGeom>
+          <a:noFill/>
+        </p:spPr>
+        <p:txBody>
+          <a:bodyPr wrap="square" anchor="ctr" lIns="0" tIns="0" rIns="0" bIns="0">
+            <a:noAutofit/>
+          </a:bodyPr>
+          <a:lstStyle/>
+          <a:p>
+            <a:pPr algn="l" latinLnBrk="0">
+              <a:lnSpc>
+                <a:spcPct val="100000"/>
+              </a:lnSpc>
+              <a:spcBef>
+                <a:spcPts val="0"/>
+              </a:spcBef>
+              <a:spcAft>
+                <a:spcPts val="0"/>
+              </a:spcAft>
+            </a:pPr>
+            <a:r>
+              <a:rPr sz="1100" b="1">
+                <a:solidFill>
+                  <a:srgbClr val="6B7280"/>
+                </a:solidFill>
+                <a:latin typeface="Microsoft YaHei"/>
+                <a:ea typeface="Microsoft YaHei"/>
+                <a:cs typeface="Microsoft YaHei"/>
+              </a:rPr>
+              <a:t>输入</a:t>
+            </a:r>
+          </a:p>
+        </p:txBody>
+      </p:sp>
+      <p:sp>
+        <p:nvSpPr>
+          <p:cNvPr id="6" name="TextBox 5"/>
+          <p:cNvSpPr txBox="1"/>
+          <p:nvPr/>
+        </p:nvSpPr>
+        <p:spPr>
+          <a:xfrm>
+            <a:off x="2715768" y="1280160"/>
+            <a:ext cx="7125919" cy="274320"/>
+          </a:xfrm>
+          <a:prstGeom prst="rect">
+            <a:avLst/>
+          </a:prstGeom>
+          <a:noFill/>
+        </p:spPr>
+        <p:txBody>
+          <a:bodyPr wrap="square" anchor="ctr" lIns="0" tIns="0" rIns="0" bIns="0">
+            <a:noAutofit/>
+          </a:bodyPr>
+          <a:lstStyle/>
+          <a:p>
+            <a:pPr algn="l" latinLnBrk="0">
+              <a:lnSpc>
+                <a:spcPct val="100000"/>
+              </a:lnSpc>
+              <a:spcBef>
+                <a:spcPts val="0"/>
+              </a:spcBef>
+              <a:spcAft>
+                <a:spcPts val="0"/>
+              </a:spcAft>
+            </a:pPr>
+            <a:r>
+              <a:rPr sz="1100" b="1">
+                <a:solidFill>
+                  <a:srgbClr val="1D4ED8"/>
+                </a:solidFill>
+                <a:latin typeface="Microsoft YaHei"/>
+                <a:ea typeface="Microsoft YaHei"/>
+                <a:cs typeface="Microsoft YaHei"/>
+              </a:rPr>
+              <a:t>自动测评与选优</a:t>
+            </a:r>
+            <a:r>
+              <a:rPr sz="1000" b="0">
+                <a:solidFill>
+                  <a:srgbClr val="6B7280"/>
+                </a:solidFill>
+                <a:latin typeface="Microsoft YaHei"/>
+                <a:ea typeface="Microsoft YaHei"/>
+                <a:cs typeface="Microsoft YaHei"/>
+              </a:rPr>
+              <a:t>　对应 sglang-maestro deploy，run 会在场景 3 之后自动执行</a:t>
+            </a:r>
+          </a:p>
+        </p:txBody>
+      </p:sp>
+      <p:sp>
+        <p:nvSpPr>
+          <p:cNvPr id="7" name="TextBox 6"/>
+          <p:cNvSpPr txBox="1"/>
+          <p:nvPr/>
+        </p:nvSpPr>
+        <p:spPr>
+          <a:xfrm>
+            <a:off x="10134295" y="1280160"/>
+            <a:ext cx="1645920" cy="274320"/>
+          </a:xfrm>
+          <a:prstGeom prst="rect">
+            <a:avLst/>
+          </a:prstGeom>
+          <a:noFill/>
+        </p:spPr>
+        <p:txBody>
+          <a:bodyPr wrap="square" anchor="ctr" lIns="0" tIns="0" rIns="0" bIns="0">
+            <a:noAutofit/>
+          </a:bodyPr>
+          <a:lstStyle/>
+          <a:p>
+            <a:pPr algn="l" latinLnBrk="0">
+              <a:lnSpc>
+                <a:spcPct val="100000"/>
+              </a:lnSpc>
+              <a:spcBef>
+                <a:spcPts val="0"/>
+              </a:spcBef>
+              <a:spcAft>
+                <a:spcPts val="0"/>
+              </a:spcAft>
+            </a:pPr>
+            <a:r>
+              <a:rPr sz="1100" b="1">
+                <a:solidFill>
+                  <a:srgbClr val="6B7280"/>
+                </a:solidFill>
+                <a:latin typeface="Microsoft YaHei"/>
+                <a:ea typeface="Microsoft YaHei"/>
+                <a:cs typeface="Microsoft YaHei"/>
+              </a:rPr>
+              <a:t>输出</a:t>
+            </a:r>
+          </a:p>
+        </p:txBody>
+      </p:sp>
+      <p:sp>
+        <p:nvSpPr>
+          <p:cNvPr id="8" name="Rectangle 7"/>
+          <p:cNvSpPr/>
+          <p:nvPr/>
+        </p:nvSpPr>
+        <p:spPr>
+          <a:xfrm>
+            <a:off x="411480" y="1627632"/>
+            <a:ext cx="2011680" cy="534924"/>
+          </a:xfrm>
+          <a:prstGeom prst="rect">
+            <a:avLst/>
+          </a:prstGeom>
+          <a:solidFill>
+            <a:srgbClr val="F3F4F6"/>
+          </a:solidFill>
+          <a:ln w="9525">
+            <a:solidFill>
+              <a:srgbClr val="D1D5DB"/>
+            </a:solidFill>
+          </a:ln>
+        </p:spPr>
+        <p:txBody>
+          <a:bodyPr rtlCol="0" anchor="ctr" wrap="square" lIns="109728" tIns="18288" bIns="18288">
+            <a:noAutofit/>
+          </a:bodyPr>
+          <a:lstStyle/>
+          <a:p>
+            <a:pPr algn="l" latinLnBrk="0">
+              <a:lnSpc>
+                <a:spcPct val="100000"/>
+              </a:lnSpc>
+              <a:spcBef>
+                <a:spcPts val="0"/>
+              </a:spcBef>
+              <a:spcAft>
+                <a:spcPts val="100"/>
+              </a:spcAft>
+            </a:pPr>
+            <a:r>
+              <a:rPr sz="1100" b="1">
+                <a:solidFill>
+                  <a:srgbClr val="1F2937"/>
+                </a:solidFill>
+                <a:latin typeface="Microsoft YaHei"/>
+                <a:ea typeface="Microsoft YaHei"/>
+                <a:cs typeface="Microsoft YaHei"/>
+              </a:rPr>
+              <a:t>模型与调优配置</a:t>
+            </a:r>
+          </a:p>
+          <a:p>
+            <a:pPr algn="l" latinLnBrk="0">
+              <a:lnSpc>
+                <a:spcPct val="100000"/>
+              </a:lnSpc>
+              <a:spcBef>
+                <a:spcPts val="0"/>
+              </a:spcBef>
+              <a:spcAft>
+                <a:spcPts val="0"/>
+              </a:spcAft>
+            </a:pPr>
+            <a:r>
+              <a:rPr sz="900" b="0">
+                <a:solidFill>
+                  <a:srgbClr val="6B7280"/>
+                </a:solidFill>
+                <a:latin typeface="Microsoft YaHei"/>
+                <a:ea typeface="Microsoft YaHei"/>
+                <a:cs typeface="Microsoft YaHei"/>
+              </a:rPr>
+              <a:t>来自场景 1–3 的结论</a:t>
+            </a:r>
+          </a:p>
+        </p:txBody>
+      </p:sp>
+      <p:sp>
+        <p:nvSpPr>
+          <p:cNvPr id="9" name="Rectangle 8"/>
+          <p:cNvSpPr/>
+          <p:nvPr/>
+        </p:nvSpPr>
+        <p:spPr>
+          <a:xfrm>
+            <a:off x="411480" y="2272284"/>
+            <a:ext cx="2011680" cy="534924"/>
+          </a:xfrm>
+          <a:prstGeom prst="rect">
+            <a:avLst/>
+          </a:prstGeom>
+          <a:solidFill>
+            <a:srgbClr val="F3F4F6"/>
+          </a:solidFill>
+          <a:ln w="9525">
+            <a:solidFill>
+              <a:srgbClr val="D1D5DB"/>
+            </a:solidFill>
+          </a:ln>
+        </p:spPr>
+        <p:txBody>
+          <a:bodyPr rtlCol="0" anchor="ctr" wrap="square" lIns="109728" tIns="18288" bIns="18288">
+            <a:noAutofit/>
+          </a:bodyPr>
+          <a:lstStyle/>
+          <a:p>
+            <a:pPr algn="l" latinLnBrk="0">
+              <a:lnSpc>
+                <a:spcPct val="100000"/>
+              </a:lnSpc>
+              <a:spcBef>
+                <a:spcPts val="0"/>
+              </a:spcBef>
+              <a:spcAft>
+                <a:spcPts val="100"/>
+              </a:spcAft>
+            </a:pPr>
+            <a:r>
+              <a:rPr sz="1100" b="1">
+                <a:solidFill>
+                  <a:srgbClr val="1F2937"/>
+                </a:solidFill>
+                <a:latin typeface="Microsoft YaHei"/>
+                <a:ea typeface="Microsoft YaHei"/>
+                <a:cs typeface="Microsoft YaHei"/>
+              </a:rPr>
+              <a:t>芯片与卡数预算</a:t>
+            </a:r>
+          </a:p>
+          <a:p>
+            <a:pPr algn="l" latinLnBrk="0">
+              <a:lnSpc>
+                <a:spcPct val="100000"/>
+              </a:lnSpc>
+              <a:spcBef>
+                <a:spcPts val="0"/>
+              </a:spcBef>
+              <a:spcAft>
+                <a:spcPts val="0"/>
+              </a:spcAft>
+            </a:pPr>
+            <a:r>
+              <a:rPr sz="900" b="0">
+                <a:solidFill>
+                  <a:srgbClr val="6B7280"/>
+                </a:solidFill>
+                <a:latin typeface="Microsoft YaHei"/>
+                <a:ea typeface="Microsoft YaHei"/>
+                <a:cs typeface="Microsoft YaHei"/>
+              </a:rPr>
+              <a:t>芯片规格 YAML、最多可用卡数</a:t>
+            </a:r>
+          </a:p>
+        </p:txBody>
+      </p:sp>
+      <p:sp>
+        <p:nvSpPr>
+          <p:cNvPr id="10" name="Rectangle 9"/>
+          <p:cNvSpPr/>
+          <p:nvPr/>
+        </p:nvSpPr>
+        <p:spPr>
+          <a:xfrm>
+            <a:off x="411480" y="2916936"/>
+            <a:ext cx="2011680" cy="534924"/>
+          </a:xfrm>
+          <a:prstGeom prst="rect">
+            <a:avLst/>
+          </a:prstGeom>
+          <a:solidFill>
+            <a:srgbClr val="F3F4F6"/>
+          </a:solidFill>
+          <a:ln w="9525">
+            <a:solidFill>
+              <a:srgbClr val="D1D5DB"/>
+            </a:solidFill>
+          </a:ln>
+        </p:spPr>
+        <p:txBody>
+          <a:bodyPr rtlCol="0" anchor="ctr" wrap="square" lIns="109728" tIns="18288" bIns="18288">
+            <a:noAutofit/>
+          </a:bodyPr>
+          <a:lstStyle/>
+          <a:p>
+            <a:pPr algn="l" latinLnBrk="0">
+              <a:lnSpc>
+                <a:spcPct val="100000"/>
+              </a:lnSpc>
+              <a:spcBef>
+                <a:spcPts val="0"/>
+              </a:spcBef>
+              <a:spcAft>
+                <a:spcPts val="100"/>
+              </a:spcAft>
+            </a:pPr>
+            <a:r>
+              <a:rPr sz="1100" b="1">
+                <a:solidFill>
+                  <a:srgbClr val="1F2937"/>
+                </a:solidFill>
+                <a:latin typeface="Microsoft YaHei"/>
+                <a:ea typeface="Microsoft YaHei"/>
+                <a:cs typeface="Microsoft YaHei"/>
+              </a:rPr>
+              <a:t>业务场景</a:t>
+            </a:r>
+          </a:p>
+          <a:p>
+            <a:pPr algn="l" latinLnBrk="0">
+              <a:lnSpc>
+                <a:spcPct val="100000"/>
+              </a:lnSpc>
+              <a:spcBef>
+                <a:spcPts val="0"/>
+              </a:spcBef>
+              <a:spcAft>
+                <a:spcPts val="0"/>
+              </a:spcAft>
+            </a:pPr>
+            <a:r>
+              <a:rPr sz="900" b="0">
+                <a:solidFill>
+                  <a:srgbClr val="6B7280"/>
+                </a:solidFill>
+                <a:latin typeface="Microsoft YaHei"/>
+                <a:ea typeface="Microsoft YaHei"/>
+                <a:cs typeface="Microsoft YaHei"/>
+              </a:rPr>
+              <a:t>长度分布、到达率与 SLO</a:t>
+            </a:r>
+          </a:p>
+        </p:txBody>
+      </p:sp>
+      <p:sp>
+        <p:nvSpPr>
+          <p:cNvPr id="11" name="Rectangle 10"/>
+          <p:cNvSpPr/>
+          <p:nvPr/>
+        </p:nvSpPr>
+        <p:spPr>
+          <a:xfrm>
+            <a:off x="411480" y="3561588"/>
+            <a:ext cx="2011680" cy="534924"/>
+          </a:xfrm>
+          <a:prstGeom prst="rect">
+            <a:avLst/>
+          </a:prstGeom>
+          <a:solidFill>
+            <a:srgbClr val="FFF4EC"/>
+          </a:solidFill>
+          <a:ln w="9525">
+            <a:solidFill>
+              <a:srgbClr val="F3B58F"/>
+            </a:solidFill>
+          </a:ln>
+        </p:spPr>
+        <p:txBody>
+          <a:bodyPr rtlCol="0" anchor="ctr" wrap="square" lIns="109728" tIns="18288" bIns="18288">
+            <a:noAutofit/>
+          </a:bodyPr>
+          <a:lstStyle/>
+          <a:p>
+            <a:pPr algn="l" latinLnBrk="0">
+              <a:lnSpc>
+                <a:spcPct val="100000"/>
+              </a:lnSpc>
+              <a:spcBef>
+                <a:spcPts val="0"/>
+              </a:spcBef>
+              <a:spcAft>
+                <a:spcPts val="100"/>
+              </a:spcAft>
+            </a:pPr>
+            <a:r>
+              <a:rPr sz="1100" b="1">
+                <a:solidFill>
+                  <a:srgbClr val="9A3412"/>
+                </a:solidFill>
+                <a:latin typeface="Microsoft YaHei"/>
+                <a:ea typeface="Microsoft YaHei"/>
+                <a:cs typeface="Microsoft YaHei"/>
+              </a:rPr>
+              <a:t>实测结果（可选）</a:t>
+            </a:r>
+          </a:p>
+          <a:p>
+            <a:pPr algn="l" latinLnBrk="0">
+              <a:lnSpc>
+                <a:spcPct val="100000"/>
+              </a:lnSpc>
+              <a:spcBef>
+                <a:spcPts val="0"/>
+              </a:spcBef>
+              <a:spcAft>
+                <a:spcPts val="0"/>
+              </a:spcAft>
+            </a:pPr>
+            <a:r>
+              <a:rPr sz="900" b="0">
+                <a:solidFill>
+                  <a:srgbClr val="6B7280"/>
+                </a:solidFill>
+                <a:latin typeface="Microsoft YaHei"/>
+                <a:ea typeface="Microsoft YaHei"/>
+                <a:cs typeface="Microsoft YaHei"/>
+              </a:rPr>
+              <a:t>server 日志、压测结果</a:t>
+            </a:r>
+          </a:p>
+        </p:txBody>
+      </p:sp>
+      <p:sp>
+        <p:nvSpPr>
+          <p:cNvPr id="12" name="Rectangle 11"/>
+          <p:cNvSpPr/>
+          <p:nvPr/>
+        </p:nvSpPr>
+        <p:spPr>
+          <a:xfrm>
+            <a:off x="2715768" y="1627632"/>
+            <a:ext cx="1589455" cy="621792"/>
+          </a:xfrm>
+          <a:prstGeom prst="rect">
+            <a:avLst/>
+          </a:prstGeom>
+          <a:solidFill>
+            <a:srgbClr val="1D4ED8"/>
+          </a:solidFill>
+          <a:ln>
+            <a:noFill/>
+          </a:ln>
+        </p:spPr>
+        <p:txBody>
+          <a:bodyPr rtlCol="0" anchor="ctr" wrap="square" lIns="128016" tIns="27432" bIns="27432">
+            <a:noAutofit/>
+          </a:bodyPr>
+          <a:lstStyle/>
+          <a:p>
+            <a:pPr algn="l" latinLnBrk="0">
+              <a:lnSpc>
+                <a:spcPct val="100000"/>
+              </a:lnSpc>
+              <a:spcBef>
+                <a:spcPts val="0"/>
+              </a:spcBef>
+              <a:spcAft>
+                <a:spcPts val="100"/>
+              </a:spcAft>
+            </a:pPr>
+            <a:r>
+              <a:rPr sz="900" b="0">
+                <a:solidFill>
+                  <a:srgbClr val="C7D7FE"/>
+                </a:solidFill>
+                <a:latin typeface="Microsoft YaHei"/>
+                <a:ea typeface="Microsoft YaHei"/>
+                <a:cs typeface="Microsoft YaHei"/>
+              </a:rPr>
+              <a:t>步骤 1</a:t>
+            </a:r>
+          </a:p>
+          <a:p>
+            <a:pPr algn="l" latinLnBrk="0">
+              <a:lnSpc>
+                <a:spcPct val="100000"/>
+              </a:lnSpc>
+              <a:spcBef>
+                <a:spcPts val="0"/>
+              </a:spcBef>
+              <a:spcAft>
+                <a:spcPts val="0"/>
+              </a:spcAft>
+            </a:pPr>
+            <a:r>
+              <a:rPr sz="1500" b="1">
+                <a:solidFill>
+                  <a:srgbClr val="FFFFFF"/>
+                </a:solidFill>
+                <a:latin typeface="Microsoft YaHei"/>
+                <a:ea typeface="Microsoft YaHei"/>
+                <a:cs typeface="Microsoft YaHei"/>
+              </a:rPr>
+              <a:t>候选方案</a:t>
+            </a:r>
+          </a:p>
+        </p:txBody>
+      </p:sp>
+      <p:sp>
+        <p:nvSpPr>
+          <p:cNvPr id="13" name="Rectangle 12"/>
+          <p:cNvSpPr/>
+          <p:nvPr/>
+        </p:nvSpPr>
+        <p:spPr>
+          <a:xfrm>
+            <a:off x="2715768" y="2249424"/>
+            <a:ext cx="1589455" cy="1847088"/>
+          </a:xfrm>
+          <a:prstGeom prst="rect">
+            <a:avLst/>
+          </a:prstGeom>
+          <a:solidFill>
+            <a:srgbClr val="F5F8FF"/>
+          </a:solidFill>
+          <a:ln w="9525">
+            <a:solidFill>
+              <a:srgbClr val="C9D6F0"/>
+            </a:solidFill>
+          </a:ln>
+        </p:spPr>
+        <p:txBody>
+          <a:bodyPr rtlCol="0" anchor="t" wrap="square" lIns="109728" tIns="128016" bIns="73152">
+            <a:noAutofit/>
+          </a:bodyPr>
+          <a:lstStyle/>
+          <a:p>
+            <a:pPr algn="l" latinLnBrk="0" marL="128016" indent="-128016">
+              <a:lnSpc>
+                <a:spcPct val="105000"/>
+              </a:lnSpc>
+              <a:spcBef>
+                <a:spcPts val="0"/>
+              </a:spcBef>
+              <a:spcAft>
+                <a:spcPts val="700"/>
+              </a:spcAft>
+              <a:buClr>
+                <a:srgbClr val="1D4ED8"/>
+              </a:buClr>
+              <a:buFont typeface="Arial"/>
+              <a:buChar char="•"/>
+            </a:pPr>
+            <a:r>
+              <a:rPr sz="1100" b="0">
+                <a:solidFill>
+                  <a:srgbClr val="374151"/>
+                </a:solidFill>
+                <a:latin typeface="Microsoft YaHei"/>
+                <a:ea typeface="Microsoft YaHei"/>
+                <a:cs typeface="Microsoft YaHei"/>
+              </a:rPr>
+              <a:t>基于场景 3 的调优配置</a:t>
+            </a:r>
+          </a:p>
+          <a:p>
+            <a:pPr algn="l" latinLnBrk="0" marL="128016" indent="-128016">
+              <a:lnSpc>
+                <a:spcPct val="105000"/>
+              </a:lnSpc>
+              <a:spcBef>
+                <a:spcPts val="0"/>
+              </a:spcBef>
+              <a:spcAft>
+                <a:spcPts val="700"/>
+              </a:spcAft>
+              <a:buClr>
+                <a:srgbClr val="1D4ED8"/>
+              </a:buClr>
+              <a:buFont typeface="Arial"/>
+              <a:buChar char="•"/>
+            </a:pPr>
+            <a:r>
+              <a:rPr sz="1100" b="0">
+                <a:solidFill>
+                  <a:srgbClr val="374151"/>
+                </a:solidFill>
+                <a:latin typeface="Microsoft YaHei"/>
+                <a:ea typeface="Microsoft YaHei"/>
+                <a:cs typeface="Microsoft YaHei"/>
+              </a:rPr>
+              <a:t>枚举实例规格：并行布局与特性组合</a:t>
+            </a:r>
+          </a:p>
+          <a:p>
+            <a:pPr algn="l" latinLnBrk="0" marL="128016" indent="-128016">
+              <a:lnSpc>
+                <a:spcPct val="105000"/>
+              </a:lnSpc>
+              <a:spcBef>
+                <a:spcPts val="0"/>
+              </a:spcBef>
+              <a:spcAft>
+                <a:spcPts val="700"/>
+              </a:spcAft>
+              <a:buClr>
+                <a:srgbClr val="1D4ED8"/>
+              </a:buClr>
+              <a:buFont typeface="Arial"/>
+              <a:buChar char="•"/>
+            </a:pPr>
+            <a:r>
+              <a:rPr sz="1100" b="0">
+                <a:solidFill>
+                  <a:srgbClr val="374151"/>
+                </a:solidFill>
+                <a:latin typeface="Microsoft YaHei"/>
+                <a:ea typeface="Microsoft YaHei"/>
+                <a:cs typeface="Microsoft YaHei"/>
+              </a:rPr>
+              <a:t>混部与 PD 分离两种形态</a:t>
+            </a:r>
+          </a:p>
+        </p:txBody>
+      </p:sp>
+      <p:cxnSp>
+        <p:nvCxnSpPr>
+          <p:cNvPr id="14" name="Connector 13"/>
+          <p:cNvCxnSpPr/>
+          <p:nvPr/>
+        </p:nvCxnSpPr>
+        <p:spPr>
+          <a:xfrm>
+            <a:off x="4350943" y="2862072"/>
+            <a:ext cx="164592" cy="0"/>
+          </a:xfrm>
+          <a:prstGeom prst="line">
+            <a:avLst/>
+          </a:prstGeom>
+          <a:ln w="22225">
+            <a:solidFill>
+              <a:srgbClr val="9CA3AF"/>
+            </a:solidFill>
+            <a:tailEnd type="triangle" w="med" len="med"/>
+          </a:ln>
+        </p:spPr>
+      </p:cxnSp>
+      <p:sp>
+        <p:nvSpPr>
+          <p:cNvPr id="15" name="Rectangle 14"/>
+          <p:cNvSpPr/>
+          <p:nvPr/>
+        </p:nvSpPr>
+        <p:spPr>
+          <a:xfrm>
+            <a:off x="4561255" y="1627632"/>
+            <a:ext cx="1589455" cy="621792"/>
+          </a:xfrm>
+          <a:prstGeom prst="rect">
+            <a:avLst/>
+          </a:prstGeom>
+          <a:solidFill>
+            <a:srgbClr val="1D4ED8"/>
+          </a:solidFill>
+          <a:ln>
+            <a:noFill/>
+          </a:ln>
+        </p:spPr>
+        <p:txBody>
+          <a:bodyPr rtlCol="0" anchor="ctr" wrap="square" lIns="128016" tIns="27432" bIns="27432">
+            <a:noAutofit/>
+          </a:bodyPr>
+          <a:lstStyle/>
+          <a:p>
+            <a:pPr algn="l" latinLnBrk="0">
+              <a:lnSpc>
+                <a:spcPct val="100000"/>
+              </a:lnSpc>
+              <a:spcBef>
+                <a:spcPts val="0"/>
+              </a:spcBef>
+              <a:spcAft>
+                <a:spcPts val="100"/>
+              </a:spcAft>
+            </a:pPr>
+            <a:r>
+              <a:rPr sz="900" b="0">
+                <a:solidFill>
+                  <a:srgbClr val="C7D7FE"/>
+                </a:solidFill>
+                <a:latin typeface="Microsoft YaHei"/>
+                <a:ea typeface="Microsoft YaHei"/>
+                <a:cs typeface="Microsoft YaHei"/>
+              </a:rPr>
+              <a:t>步骤 2</a:t>
+            </a:r>
+          </a:p>
+          <a:p>
+            <a:pPr algn="l" latinLnBrk="0">
+              <a:lnSpc>
+                <a:spcPct val="100000"/>
+              </a:lnSpc>
+              <a:spcBef>
+                <a:spcPts val="0"/>
+              </a:spcBef>
+              <a:spcAft>
+                <a:spcPts val="0"/>
+              </a:spcAft>
+            </a:pPr>
+            <a:r>
+              <a:rPr sz="1500" b="1">
+                <a:solidFill>
+                  <a:srgbClr val="FFFFFF"/>
+                </a:solidFill>
+                <a:latin typeface="Microsoft YaHei"/>
+                <a:ea typeface="Microsoft YaHei"/>
+                <a:cs typeface="Microsoft YaHei"/>
+              </a:rPr>
+              <a:t>仿真测评</a:t>
+            </a:r>
+          </a:p>
+        </p:txBody>
+      </p:sp>
+      <p:sp>
+        <p:nvSpPr>
+          <p:cNvPr id="16" name="Rectangle 15"/>
+          <p:cNvSpPr/>
+          <p:nvPr/>
+        </p:nvSpPr>
+        <p:spPr>
+          <a:xfrm>
+            <a:off x="4561255" y="2249424"/>
+            <a:ext cx="1589455" cy="1847088"/>
+          </a:xfrm>
+          <a:prstGeom prst="rect">
+            <a:avLst/>
+          </a:prstGeom>
+          <a:solidFill>
+            <a:srgbClr val="F5F8FF"/>
+          </a:solidFill>
+          <a:ln w="9525">
+            <a:solidFill>
+              <a:srgbClr val="C9D6F0"/>
+            </a:solidFill>
+          </a:ln>
+        </p:spPr>
+        <p:txBody>
+          <a:bodyPr rtlCol="0" anchor="t" wrap="square" lIns="109728" tIns="128016" bIns="73152">
+            <a:noAutofit/>
+          </a:bodyPr>
+          <a:lstStyle/>
+          <a:p>
+            <a:pPr algn="l" latinLnBrk="0" marL="128016" indent="-128016">
+              <a:lnSpc>
+                <a:spcPct val="105000"/>
+              </a:lnSpc>
+              <a:spcBef>
+                <a:spcPts val="0"/>
+              </a:spcBef>
+              <a:spcAft>
+                <a:spcPts val="700"/>
+              </a:spcAft>
+              <a:buClr>
+                <a:srgbClr val="1D4ED8"/>
+              </a:buClr>
+              <a:buFont typeface="Arial"/>
+              <a:buChar char="•"/>
+            </a:pPr>
+            <a:r>
+              <a:rPr sz="1100" b="0">
+                <a:solidFill>
+                  <a:srgbClr val="374151"/>
+                </a:solidFill>
+                <a:latin typeface="Microsoft YaHei"/>
+                <a:ea typeface="Microsoft YaHei"/>
+                <a:cs typeface="Microsoft YaHei"/>
+              </a:rPr>
+              <a:t>成本模型算 prefill / decode 单步耗时</a:t>
+            </a:r>
+          </a:p>
+          <a:p>
+            <a:pPr algn="l" latinLnBrk="0" marL="128016" indent="-128016">
+              <a:lnSpc>
+                <a:spcPct val="105000"/>
+              </a:lnSpc>
+              <a:spcBef>
+                <a:spcPts val="0"/>
+              </a:spcBef>
+              <a:spcAft>
+                <a:spcPts val="700"/>
+              </a:spcAft>
+              <a:buClr>
+                <a:srgbClr val="1D4ED8"/>
+              </a:buClr>
+              <a:buFont typeface="Arial"/>
+              <a:buChar char="•"/>
+            </a:pPr>
+            <a:r>
+              <a:rPr sz="1100" b="0">
+                <a:solidFill>
+                  <a:srgbClr val="374151"/>
+                </a:solidFill>
+                <a:latin typeface="Microsoft YaHei"/>
+                <a:ea typeface="Microsoft YaHei"/>
+                <a:cs typeface="Microsoft YaHei"/>
+              </a:rPr>
+              <a:t>离散事件仿真请求排队、批处理与路由</a:t>
+            </a:r>
+          </a:p>
+          <a:p>
+            <a:pPr algn="l" latinLnBrk="0" marL="128016" indent="-128016">
+              <a:lnSpc>
+                <a:spcPct val="105000"/>
+              </a:lnSpc>
+              <a:spcBef>
+                <a:spcPts val="0"/>
+              </a:spcBef>
+              <a:spcAft>
+                <a:spcPts val="700"/>
+              </a:spcAft>
+              <a:buClr>
+                <a:srgbClr val="1D4ED8"/>
+              </a:buClr>
+              <a:buFont typeface="Arial"/>
+              <a:buChar char="•"/>
+            </a:pPr>
+            <a:r>
+              <a:rPr sz="1100" b="0">
+                <a:solidFill>
+                  <a:srgbClr val="374151"/>
+                </a:solidFill>
+                <a:latin typeface="Microsoft YaHei"/>
+                <a:ea typeface="Microsoft YaHei"/>
+                <a:cs typeface="Microsoft YaHei"/>
+              </a:rPr>
+              <a:t>二分求单实例达标的最高到达率</a:t>
+            </a:r>
+          </a:p>
+        </p:txBody>
+      </p:sp>
+      <p:cxnSp>
+        <p:nvCxnSpPr>
+          <p:cNvPr id="17" name="Connector 16"/>
+          <p:cNvCxnSpPr/>
+          <p:nvPr/>
+        </p:nvCxnSpPr>
+        <p:spPr>
+          <a:xfrm>
+            <a:off x="6196431" y="2862072"/>
+            <a:ext cx="164592" cy="0"/>
+          </a:xfrm>
+          <a:prstGeom prst="line">
+            <a:avLst/>
+          </a:prstGeom>
+          <a:ln w="22225">
+            <a:solidFill>
+              <a:srgbClr val="9CA3AF"/>
+            </a:solidFill>
+            <a:tailEnd type="triangle" w="med" len="med"/>
+          </a:ln>
+        </p:spPr>
+      </p:cxnSp>
+      <p:sp>
+        <p:nvSpPr>
+          <p:cNvPr id="18" name="Rectangle 17"/>
+          <p:cNvSpPr/>
+          <p:nvPr/>
+        </p:nvSpPr>
+        <p:spPr>
+          <a:xfrm>
+            <a:off x="6406743" y="1627632"/>
+            <a:ext cx="1589455" cy="621792"/>
+          </a:xfrm>
+          <a:prstGeom prst="rect">
+            <a:avLst/>
+          </a:prstGeom>
+          <a:solidFill>
+            <a:srgbClr val="1D4ED8"/>
+          </a:solidFill>
+          <a:ln>
+            <a:noFill/>
+          </a:ln>
+        </p:spPr>
+        <p:txBody>
+          <a:bodyPr rtlCol="0" anchor="ctr" wrap="square" lIns="128016" tIns="27432" bIns="27432">
+            <a:noAutofit/>
+          </a:bodyPr>
+          <a:lstStyle/>
+          <a:p>
+            <a:pPr algn="l" latinLnBrk="0">
+              <a:lnSpc>
+                <a:spcPct val="100000"/>
+              </a:lnSpc>
+              <a:spcBef>
+                <a:spcPts val="0"/>
+              </a:spcBef>
+              <a:spcAft>
+                <a:spcPts val="100"/>
+              </a:spcAft>
+            </a:pPr>
+            <a:r>
+              <a:rPr sz="900" b="0">
+                <a:solidFill>
+                  <a:srgbClr val="C7D7FE"/>
+                </a:solidFill>
+                <a:latin typeface="Microsoft YaHei"/>
+                <a:ea typeface="Microsoft YaHei"/>
+                <a:cs typeface="Microsoft YaHei"/>
+              </a:rPr>
+              <a:t>步骤 3</a:t>
+            </a:r>
+          </a:p>
+          <a:p>
+            <a:pPr algn="l" latinLnBrk="0">
+              <a:lnSpc>
+                <a:spcPct val="100000"/>
+              </a:lnSpc>
+              <a:spcBef>
+                <a:spcPts val="0"/>
+              </a:spcBef>
+              <a:spcAft>
+                <a:spcPts val="0"/>
+              </a:spcAft>
+            </a:pPr>
+            <a:r>
+              <a:rPr sz="1500" b="1">
+                <a:solidFill>
+                  <a:srgbClr val="FFFFFF"/>
+                </a:solidFill>
+                <a:latin typeface="Microsoft YaHei"/>
+                <a:ea typeface="Microsoft YaHei"/>
+                <a:cs typeface="Microsoft YaHei"/>
+              </a:rPr>
+              <a:t>选优</a:t>
+            </a:r>
+          </a:p>
+        </p:txBody>
+      </p:sp>
+      <p:sp>
+        <p:nvSpPr>
+          <p:cNvPr id="19" name="Rectangle 18"/>
+          <p:cNvSpPr/>
+          <p:nvPr/>
+        </p:nvSpPr>
+        <p:spPr>
+          <a:xfrm>
+            <a:off x="6406743" y="2249424"/>
+            <a:ext cx="1589455" cy="1847088"/>
+          </a:xfrm>
+          <a:prstGeom prst="rect">
+            <a:avLst/>
+          </a:prstGeom>
+          <a:solidFill>
+            <a:srgbClr val="F5F8FF"/>
+          </a:solidFill>
+          <a:ln w="9525">
+            <a:solidFill>
+              <a:srgbClr val="C9D6F0"/>
+            </a:solidFill>
+          </a:ln>
+        </p:spPr>
+        <p:txBody>
+          <a:bodyPr rtlCol="0" anchor="t" wrap="square" lIns="109728" tIns="128016" bIns="73152">
+            <a:noAutofit/>
+          </a:bodyPr>
+          <a:lstStyle/>
+          <a:p>
+            <a:pPr algn="l" latinLnBrk="0" marL="128016" indent="-128016">
+              <a:lnSpc>
+                <a:spcPct val="105000"/>
+              </a:lnSpc>
+              <a:spcBef>
+                <a:spcPts val="0"/>
+              </a:spcBef>
+              <a:spcAft>
+                <a:spcPts val="700"/>
+              </a:spcAft>
+              <a:buClr>
+                <a:srgbClr val="1D4ED8"/>
+              </a:buClr>
+              <a:buFont typeface="Arial"/>
+              <a:buChar char="•"/>
+            </a:pPr>
+            <a:r>
+              <a:rPr sz="1100" b="0">
+                <a:solidFill>
+                  <a:srgbClr val="374151"/>
+                </a:solidFill>
+                <a:latin typeface="Microsoft YaHei"/>
+                <a:ea typeface="Microsoft YaHei"/>
+                <a:cs typeface="Microsoft YaHei"/>
+              </a:rPr>
+              <a:t>给定到达率：满足 SLO 且卡数最少</a:t>
+            </a:r>
+          </a:p>
+          <a:p>
+            <a:pPr algn="l" latinLnBrk="0" marL="128016" indent="-128016">
+              <a:lnSpc>
+                <a:spcPct val="105000"/>
+              </a:lnSpc>
+              <a:spcBef>
+                <a:spcPts val="0"/>
+              </a:spcBef>
+              <a:spcAft>
+                <a:spcPts val="700"/>
+              </a:spcAft>
+              <a:buClr>
+                <a:srgbClr val="1D4ED8"/>
+              </a:buClr>
+              <a:buFont typeface="Arial"/>
+              <a:buChar char="•"/>
+            </a:pPr>
+            <a:r>
+              <a:rPr sz="1100" b="0">
+                <a:solidFill>
+                  <a:srgbClr val="374151"/>
+                </a:solidFill>
+                <a:latin typeface="Microsoft YaHei"/>
+                <a:ea typeface="Microsoft YaHei"/>
+                <a:cs typeface="Microsoft YaHei"/>
+              </a:rPr>
+              <a:t>不给到达率：预算内每卡吞吐最高</a:t>
+            </a:r>
+          </a:p>
+          <a:p>
+            <a:pPr algn="l" latinLnBrk="0" marL="128016" indent="-128016">
+              <a:lnSpc>
+                <a:spcPct val="105000"/>
+              </a:lnSpc>
+              <a:spcBef>
+                <a:spcPts val="0"/>
+              </a:spcBef>
+              <a:spcAft>
+                <a:spcPts val="700"/>
+              </a:spcAft>
+              <a:buClr>
+                <a:srgbClr val="1D4ED8"/>
+              </a:buClr>
+              <a:buFont typeface="Arial"/>
+              <a:buChar char="•"/>
+            </a:pPr>
+            <a:r>
+              <a:rPr sz="1100" b="0">
+                <a:solidFill>
+                  <a:srgbClr val="374151"/>
+                </a:solidFill>
+                <a:latin typeface="Microsoft YaHei"/>
+                <a:ea typeface="Microsoft YaHei"/>
+                <a:cs typeface="Microsoft YaHei"/>
+              </a:rPr>
+              <a:t>PD 分离省卡 10% 以上才选</a:t>
+            </a:r>
+          </a:p>
+        </p:txBody>
+      </p:sp>
+      <p:cxnSp>
+        <p:nvCxnSpPr>
+          <p:cNvPr id="20" name="Connector 19"/>
+          <p:cNvCxnSpPr/>
+          <p:nvPr/>
+        </p:nvCxnSpPr>
+        <p:spPr>
+          <a:xfrm>
+            <a:off x="8041919" y="2862072"/>
+            <a:ext cx="164592" cy="0"/>
+          </a:xfrm>
+          <a:prstGeom prst="line">
+            <a:avLst/>
+          </a:prstGeom>
+          <a:ln w="22225">
+            <a:solidFill>
+              <a:srgbClr val="9CA3AF"/>
+            </a:solidFill>
+            <a:tailEnd type="triangle" w="med" len="med"/>
+          </a:ln>
+        </p:spPr>
+      </p:cxnSp>
+      <p:sp>
+        <p:nvSpPr>
+          <p:cNvPr id="21" name="Rectangle 20"/>
+          <p:cNvSpPr/>
+          <p:nvPr/>
+        </p:nvSpPr>
+        <p:spPr>
+          <a:xfrm>
+            <a:off x="8252231" y="1627632"/>
+            <a:ext cx="1589455" cy="621792"/>
+          </a:xfrm>
+          <a:prstGeom prst="rect">
+            <a:avLst/>
+          </a:prstGeom>
+          <a:solidFill>
+            <a:srgbClr val="1D4ED8"/>
+          </a:solidFill>
+          <a:ln>
+            <a:noFill/>
+          </a:ln>
+        </p:spPr>
+        <p:txBody>
+          <a:bodyPr rtlCol="0" anchor="ctr" wrap="square" lIns="128016" tIns="27432" bIns="27432">
+            <a:noAutofit/>
+          </a:bodyPr>
+          <a:lstStyle/>
+          <a:p>
+            <a:pPr algn="l" latinLnBrk="0">
+              <a:lnSpc>
+                <a:spcPct val="100000"/>
+              </a:lnSpc>
+              <a:spcBef>
+                <a:spcPts val="0"/>
+              </a:spcBef>
+              <a:spcAft>
+                <a:spcPts val="100"/>
+              </a:spcAft>
+            </a:pPr>
+            <a:r>
+              <a:rPr sz="900" b="0">
+                <a:solidFill>
+                  <a:srgbClr val="C7D7FE"/>
+                </a:solidFill>
+                <a:latin typeface="Microsoft YaHei"/>
+                <a:ea typeface="Microsoft YaHei"/>
+                <a:cs typeface="Microsoft YaHei"/>
+              </a:rPr>
+              <a:t>步骤 4</a:t>
+            </a:r>
+          </a:p>
+          <a:p>
+            <a:pPr algn="l" latinLnBrk="0">
+              <a:lnSpc>
+                <a:spcPct val="100000"/>
+              </a:lnSpc>
+              <a:spcBef>
+                <a:spcPts val="0"/>
+              </a:spcBef>
+              <a:spcAft>
+                <a:spcPts val="0"/>
+              </a:spcAft>
+            </a:pPr>
+            <a:r>
+              <a:rPr sz="1500" b="1">
+                <a:solidFill>
+                  <a:srgbClr val="FFFFFF"/>
+                </a:solidFill>
+                <a:latin typeface="Microsoft YaHei"/>
+                <a:ea typeface="Microsoft YaHei"/>
+                <a:cs typeface="Microsoft YaHei"/>
+              </a:rPr>
+              <a:t>测评脚本</a:t>
+            </a:r>
+          </a:p>
+        </p:txBody>
+      </p:sp>
+      <p:sp>
+        <p:nvSpPr>
+          <p:cNvPr id="22" name="Rectangle 21"/>
+          <p:cNvSpPr/>
+          <p:nvPr/>
+        </p:nvSpPr>
+        <p:spPr>
+          <a:xfrm>
+            <a:off x="8252231" y="2249424"/>
+            <a:ext cx="1589455" cy="1847088"/>
+          </a:xfrm>
+          <a:prstGeom prst="rect">
+            <a:avLst/>
+          </a:prstGeom>
+          <a:solidFill>
+            <a:srgbClr val="F5F8FF"/>
+          </a:solidFill>
+          <a:ln w="9525">
+            <a:solidFill>
+              <a:srgbClr val="C9D6F0"/>
+            </a:solidFill>
+          </a:ln>
+        </p:spPr>
+        <p:txBody>
+          <a:bodyPr rtlCol="0" anchor="t" wrap="square" lIns="109728" tIns="128016" bIns="73152">
+            <a:noAutofit/>
+          </a:bodyPr>
+          <a:lstStyle/>
+          <a:p>
+            <a:pPr algn="l" latinLnBrk="0" marL="128016" indent="-128016">
+              <a:lnSpc>
+                <a:spcPct val="105000"/>
+              </a:lnSpc>
+              <a:spcBef>
+                <a:spcPts val="0"/>
+              </a:spcBef>
+              <a:spcAft>
+                <a:spcPts val="700"/>
+              </a:spcAft>
+              <a:buClr>
+                <a:srgbClr val="1D4ED8"/>
+              </a:buClr>
+              <a:buFont typeface="Arial"/>
+              <a:buChar char="•"/>
+            </a:pPr>
+            <a:r>
+              <a:rPr sz="1100" b="0">
+                <a:solidFill>
+                  <a:srgbClr val="374151"/>
+                </a:solidFill>
+                <a:latin typeface="Microsoft YaHei"/>
+                <a:ea typeface="Microsoft YaHei"/>
+                <a:cs typeface="Microsoft YaHei"/>
+              </a:rPr>
+              <a:t>把实例放置到各台机器</a:t>
+            </a:r>
+          </a:p>
+          <a:p>
+            <a:pPr algn="l" latinLnBrk="0" marL="128016" indent="-128016">
+              <a:lnSpc>
+                <a:spcPct val="105000"/>
+              </a:lnSpc>
+              <a:spcBef>
+                <a:spcPts val="0"/>
+              </a:spcBef>
+              <a:spcAft>
+                <a:spcPts val="700"/>
+              </a:spcAft>
+              <a:buClr>
+                <a:srgbClr val="1D4ED8"/>
+              </a:buClr>
+              <a:buFont typeface="Arial"/>
+              <a:buChar char="•"/>
+            </a:pPr>
+            <a:r>
+              <a:rPr sz="1100" b="0">
+                <a:solidFill>
+                  <a:srgbClr val="374151"/>
+                </a:solidFill>
+                <a:latin typeface="Microsoft YaHei"/>
+                <a:ea typeface="Microsoft YaHei"/>
+                <a:cs typeface="Microsoft YaHei"/>
+              </a:rPr>
+              <a:t>生成启动、路由、健康检查命令</a:t>
+            </a:r>
+          </a:p>
+          <a:p>
+            <a:pPr algn="l" latinLnBrk="0" marL="128016" indent="-128016">
+              <a:lnSpc>
+                <a:spcPct val="105000"/>
+              </a:lnSpc>
+              <a:spcBef>
+                <a:spcPts val="0"/>
+              </a:spcBef>
+              <a:spcAft>
+                <a:spcPts val="700"/>
+              </a:spcAft>
+              <a:buClr>
+                <a:srgbClr val="1D4ED8"/>
+              </a:buClr>
+              <a:buFont typeface="Arial"/>
+              <a:buChar char="•"/>
+            </a:pPr>
+            <a:r>
+              <a:rPr sz="1100" b="0">
+                <a:solidFill>
+                  <a:srgbClr val="374151"/>
+                </a:solidFill>
+                <a:latin typeface="Microsoft YaHei"/>
+                <a:ea typeface="Microsoft YaHei"/>
+                <a:cs typeface="Microsoft YaHei"/>
+              </a:rPr>
+              <a:t>压测命令按业务场景重放请求</a:t>
+            </a:r>
+          </a:p>
+        </p:txBody>
+      </p:sp>
+      <p:cxnSp>
+        <p:nvCxnSpPr>
+          <p:cNvPr id="23" name="Connector 22"/>
+          <p:cNvCxnSpPr/>
+          <p:nvPr/>
+        </p:nvCxnSpPr>
+        <p:spPr>
+          <a:xfrm>
+            <a:off x="2468880" y="2862072"/>
+            <a:ext cx="201168" cy="0"/>
+          </a:xfrm>
+          <a:prstGeom prst="line">
+            <a:avLst/>
+          </a:prstGeom>
+          <a:ln w="22225">
+            <a:solidFill>
+              <a:srgbClr val="9CA3AF"/>
+            </a:solidFill>
+            <a:tailEnd type="triangle" w="med" len="med"/>
+          </a:ln>
+        </p:spPr>
+      </p:cxnSp>
+      <p:cxnSp>
+        <p:nvCxnSpPr>
+          <p:cNvPr id="24" name="Connector 23"/>
+          <p:cNvCxnSpPr/>
+          <p:nvPr/>
+        </p:nvCxnSpPr>
+        <p:spPr>
+          <a:xfrm>
+            <a:off x="9887407" y="2862072"/>
+            <a:ext cx="201168" cy="0"/>
+          </a:xfrm>
+          <a:prstGeom prst="line">
+            <a:avLst/>
+          </a:prstGeom>
+          <a:ln w="22225">
+            <a:solidFill>
+              <a:srgbClr val="9CA3AF"/>
+            </a:solidFill>
+            <a:tailEnd type="triangle" w="med" len="med"/>
+          </a:ln>
+        </p:spPr>
+      </p:cxnSp>
+      <p:sp>
+        <p:nvSpPr>
+          <p:cNvPr id="25" name="Rectangle 24"/>
+          <p:cNvSpPr/>
+          <p:nvPr/>
+        </p:nvSpPr>
+        <p:spPr>
+          <a:xfrm>
+            <a:off x="10134295" y="1627632"/>
+            <a:ext cx="1645920" cy="2468880"/>
+          </a:xfrm>
+          <a:prstGeom prst="rect">
+            <a:avLst/>
+          </a:prstGeom>
+          <a:solidFill>
+            <a:srgbClr val="F3F4F6"/>
+          </a:solidFill>
+          <a:ln w="9525">
+            <a:solidFill>
+              <a:srgbClr val="D1D5DB"/>
+            </a:solidFill>
+          </a:ln>
+        </p:spPr>
+        <p:txBody>
+          <a:bodyPr rtlCol="0" anchor="t" wrap="square" lIns="128016" tIns="146304" bIns="73152">
+            <a:noAutofit/>
+          </a:bodyPr>
+          <a:lstStyle/>
+          <a:p>
+            <a:pPr algn="l" latinLnBrk="0">
+              <a:lnSpc>
+                <a:spcPct val="100000"/>
+              </a:lnSpc>
+              <a:spcBef>
+                <a:spcPts val="0"/>
+              </a:spcBef>
+              <a:spcAft>
+                <a:spcPts val="900"/>
+              </a:spcAft>
+            </a:pPr>
+            <a:r>
+              <a:rPr sz="1300" b="1">
+                <a:solidFill>
+                  <a:srgbClr val="1F2937"/>
+                </a:solidFill>
+                <a:latin typeface="Microsoft YaHei"/>
+                <a:ea typeface="Microsoft YaHei"/>
+                <a:cs typeface="Microsoft YaHei"/>
+              </a:rPr>
+              <a:t>测评报告与方案</a:t>
+            </a:r>
+          </a:p>
+          <a:p>
+            <a:pPr algn="l" latinLnBrk="0" marL="128016" indent="-128016">
+              <a:lnSpc>
+                <a:spcPct val="105000"/>
+              </a:lnSpc>
+              <a:spcBef>
+                <a:spcPts val="0"/>
+              </a:spcBef>
+              <a:spcAft>
+                <a:spcPts val="600"/>
+              </a:spcAft>
+              <a:buClr>
+                <a:srgbClr val="6B7280"/>
+              </a:buClr>
+              <a:buFont typeface="Arial"/>
+              <a:buChar char="•"/>
+            </a:pPr>
+            <a:r>
+              <a:rPr sz="1100" b="0">
+                <a:solidFill>
+                  <a:srgbClr val="374151"/>
+                </a:solidFill>
+                <a:latin typeface="Microsoft YaHei"/>
+                <a:ea typeface="Microsoft YaHei"/>
+                <a:cs typeface="Microsoft YaHei"/>
+              </a:rPr>
+              <a:t>各项指标的预测值</a:t>
+            </a:r>
+          </a:p>
+          <a:p>
+            <a:pPr algn="l" latinLnBrk="0" marL="128016" indent="-128016">
+              <a:lnSpc>
+                <a:spcPct val="105000"/>
+              </a:lnSpc>
+              <a:spcBef>
+                <a:spcPts val="0"/>
+              </a:spcBef>
+              <a:spcAft>
+                <a:spcPts val="600"/>
+              </a:spcAft>
+              <a:buClr>
+                <a:srgbClr val="6B7280"/>
+              </a:buClr>
+              <a:buFont typeface="Arial"/>
+              <a:buChar char="•"/>
+            </a:pPr>
+            <a:r>
+              <a:rPr sz="1100" b="0">
+                <a:solidFill>
+                  <a:srgbClr val="374151"/>
+                </a:solidFill>
+                <a:latin typeface="Microsoft YaHei"/>
+                <a:ea typeface="Microsoft YaHei"/>
+                <a:cs typeface="Microsoft YaHei"/>
+              </a:rPr>
+              <a:t>候选方案对比与选择理由</a:t>
+            </a:r>
+          </a:p>
+          <a:p>
+            <a:pPr algn="l" latinLnBrk="0" marL="128016" indent="-128016">
+              <a:lnSpc>
+                <a:spcPct val="105000"/>
+              </a:lnSpc>
+              <a:spcBef>
+                <a:spcPts val="0"/>
+              </a:spcBef>
+              <a:spcAft>
+                <a:spcPts val="600"/>
+              </a:spcAft>
+              <a:buClr>
+                <a:srgbClr val="6B7280"/>
+              </a:buClr>
+              <a:buFont typeface="Arial"/>
+              <a:buChar char="•"/>
+            </a:pPr>
+            <a:r>
+              <a:rPr sz="1100" b="0">
+                <a:solidFill>
+                  <a:srgbClr val="374151"/>
+                </a:solidFill>
+                <a:latin typeface="Microsoft YaHei"/>
+                <a:ea typeface="Microsoft YaHei"/>
+                <a:cs typeface="Microsoft YaHei"/>
+              </a:rPr>
+              <a:t>部署命令与上线步骤</a:t>
+            </a:r>
+          </a:p>
+          <a:p>
+            <a:pPr algn="l" latinLnBrk="0" marL="128016" indent="-128016">
+              <a:lnSpc>
+                <a:spcPct val="105000"/>
+              </a:lnSpc>
+              <a:spcBef>
+                <a:spcPts val="0"/>
+              </a:spcBef>
+              <a:spcAft>
+                <a:spcPts val="600"/>
+              </a:spcAft>
+              <a:buClr>
+                <a:srgbClr val="6B7280"/>
+              </a:buClr>
+              <a:buFont typeface="Arial"/>
+              <a:buChar char="•"/>
+            </a:pPr>
+            <a:r>
+              <a:rPr sz="1100" b="0">
+                <a:solidFill>
+                  <a:srgbClr val="374151"/>
+                </a:solidFill>
+                <a:latin typeface="Microsoft YaHei"/>
+                <a:ea typeface="Microsoft YaHei"/>
+                <a:cs typeface="Microsoft YaHei"/>
+              </a:rPr>
+              <a:t>有实测时：实测与预测偏差表</a:t>
+            </a:r>
+          </a:p>
+        </p:txBody>
+      </p:sp>
+      <p:sp>
+        <p:nvSpPr>
+          <p:cNvPr id="26" name="Rectangle 25"/>
+          <p:cNvSpPr/>
+          <p:nvPr/>
+        </p:nvSpPr>
+        <p:spPr>
+          <a:xfrm>
+            <a:off x="2715768" y="4224528"/>
+            <a:ext cx="7125919" cy="566928"/>
+          </a:xfrm>
+          <a:prstGeom prst="rect">
+            <a:avLst/>
+          </a:prstGeom>
+          <a:solidFill>
+            <a:srgbClr val="F9FAFB"/>
+          </a:solidFill>
+          <a:ln w="9525">
+            <a:solidFill>
+              <a:srgbClr val="D1D5DB"/>
+            </a:solidFill>
+          </a:ln>
+        </p:spPr>
+        <p:txBody>
+          <a:bodyPr rtlCol="0" anchor="ctr"/>
+          <a:lstStyle/>
+          <a:p>
+            <a:pPr algn="ctr"/>
+          </a:p>
+        </p:txBody>
+      </p:sp>
+      <p:sp>
+        <p:nvSpPr>
+          <p:cNvPr id="27" name="TextBox 26"/>
+          <p:cNvSpPr txBox="1"/>
+          <p:nvPr/>
+        </p:nvSpPr>
+        <p:spPr>
+          <a:xfrm>
+            <a:off x="2715768" y="4224528"/>
+            <a:ext cx="1051560" cy="566928"/>
+          </a:xfrm>
+          <a:prstGeom prst="rect">
+            <a:avLst/>
+          </a:prstGeom>
+          <a:noFill/>
+        </p:spPr>
+        <p:txBody>
+          <a:bodyPr wrap="square" anchor="ctr" lIns="128016" tIns="0" rIns="45720" bIns="0">
+            <a:noAutofit/>
+          </a:bodyPr>
+          <a:lstStyle/>
+          <a:p>
+            <a:pPr algn="l" latinLnBrk="0">
+              <a:lnSpc>
+                <a:spcPct val="100000"/>
+              </a:lnSpc>
+              <a:spcBef>
+                <a:spcPts val="0"/>
+              </a:spcBef>
+              <a:spcAft>
+                <a:spcPts val="100"/>
+              </a:spcAft>
+            </a:pPr>
+            <a:r>
+              <a:rPr sz="1100" b="1">
+                <a:solidFill>
+                  <a:srgbClr val="1F2937"/>
+                </a:solidFill>
+                <a:latin typeface="Microsoft YaHei"/>
+                <a:ea typeface="Microsoft YaHei"/>
+                <a:cs typeface="Microsoft YaHei"/>
+              </a:rPr>
+              <a:t>测评指标</a:t>
+            </a:r>
+          </a:p>
+          <a:p>
+            <a:pPr algn="l" latinLnBrk="0">
+              <a:lnSpc>
+                <a:spcPct val="100000"/>
+              </a:lnSpc>
+              <a:spcBef>
+                <a:spcPts val="0"/>
+              </a:spcBef>
+              <a:spcAft>
+                <a:spcPts val="0"/>
+              </a:spcAft>
+            </a:pPr>
+            <a:r>
+              <a:rPr sz="900" b="0">
+                <a:solidFill>
+                  <a:srgbClr val="6B7280"/>
+                </a:solidFill>
+                <a:latin typeface="Microsoft YaHei"/>
+                <a:ea typeface="Microsoft YaHei"/>
+                <a:cs typeface="Microsoft YaHei"/>
+              </a:rPr>
+              <a:t>预测值与实测值</a:t>
+            </a:r>
+          </a:p>
+        </p:txBody>
+      </p:sp>
+      <p:cxnSp>
+        <p:nvCxnSpPr>
+          <p:cNvPr id="28" name="Connector 27"/>
+          <p:cNvCxnSpPr/>
+          <p:nvPr/>
+        </p:nvCxnSpPr>
+        <p:spPr>
+          <a:xfrm>
+            <a:off x="3767328" y="4334256"/>
+            <a:ext cx="0" cy="347472"/>
+          </a:xfrm>
+          <a:prstGeom prst="line">
+            <a:avLst/>
+          </a:prstGeom>
+          <a:ln w="9525">
+            <a:solidFill>
+              <a:srgbClr val="D1D5DB"/>
+            </a:solidFill>
+          </a:ln>
+        </p:spPr>
+      </p:cxnSp>
+      <p:sp>
+        <p:nvSpPr>
+          <p:cNvPr id="29" name="TextBox 28"/>
+          <p:cNvSpPr txBox="1"/>
+          <p:nvPr/>
+        </p:nvSpPr>
+        <p:spPr>
+          <a:xfrm>
+            <a:off x="3767328" y="4224528"/>
+            <a:ext cx="1214871" cy="566928"/>
+          </a:xfrm>
+          <a:prstGeom prst="rect">
+            <a:avLst/>
+          </a:prstGeom>
+          <a:noFill/>
+        </p:spPr>
+        <p:txBody>
+          <a:bodyPr wrap="square" anchor="ctr" lIns="128016" tIns="18288" rIns="73152" bIns="18288">
+            <a:noAutofit/>
+          </a:bodyPr>
+          <a:lstStyle/>
+          <a:p>
+            <a:pPr algn="l" latinLnBrk="0">
+              <a:lnSpc>
+                <a:spcPct val="100000"/>
+              </a:lnSpc>
+              <a:spcBef>
+                <a:spcPts val="0"/>
+              </a:spcBef>
+              <a:spcAft>
+                <a:spcPts val="100"/>
+              </a:spcAft>
+            </a:pPr>
+            <a:r>
+              <a:rPr sz="1000" b="1">
+                <a:solidFill>
+                  <a:srgbClr val="374151"/>
+                </a:solidFill>
+                <a:latin typeface="Microsoft YaHei"/>
+                <a:ea typeface="Microsoft YaHei"/>
+                <a:cs typeface="Microsoft YaHei"/>
+              </a:rPr>
+              <a:t>TTFT</a:t>
+            </a:r>
+          </a:p>
+          <a:p>
+            <a:pPr algn="l" latinLnBrk="0">
+              <a:lnSpc>
+                <a:spcPct val="100000"/>
+              </a:lnSpc>
+              <a:spcBef>
+                <a:spcPts val="0"/>
+              </a:spcBef>
+              <a:spcAft>
+                <a:spcPts val="0"/>
+              </a:spcAft>
+            </a:pPr>
+            <a:r>
+              <a:rPr sz="900" b="0">
+                <a:solidFill>
+                  <a:srgbClr val="6B7280"/>
+                </a:solidFill>
+                <a:latin typeface="Microsoft YaHei"/>
+                <a:ea typeface="Microsoft YaHei"/>
+                <a:cs typeface="Microsoft YaHei"/>
+              </a:rPr>
+              <a:t>P50 / P90 / P99</a:t>
+            </a:r>
+          </a:p>
+        </p:txBody>
+      </p:sp>
+      <p:cxnSp>
+        <p:nvCxnSpPr>
+          <p:cNvPr id="30" name="Connector 29"/>
+          <p:cNvCxnSpPr/>
+          <p:nvPr/>
+        </p:nvCxnSpPr>
+        <p:spPr>
+          <a:xfrm>
+            <a:off x="4982199" y="4334256"/>
+            <a:ext cx="0" cy="347472"/>
+          </a:xfrm>
+          <a:prstGeom prst="line">
+            <a:avLst/>
+          </a:prstGeom>
+          <a:ln w="9525">
+            <a:solidFill>
+              <a:srgbClr val="D1D5DB"/>
+            </a:solidFill>
+          </a:ln>
+        </p:spPr>
+      </p:cxnSp>
+      <p:sp>
+        <p:nvSpPr>
+          <p:cNvPr id="31" name="TextBox 30"/>
+          <p:cNvSpPr txBox="1"/>
+          <p:nvPr/>
+        </p:nvSpPr>
+        <p:spPr>
+          <a:xfrm>
+            <a:off x="4982199" y="4224528"/>
+            <a:ext cx="1214871" cy="566928"/>
+          </a:xfrm>
+          <a:prstGeom prst="rect">
+            <a:avLst/>
+          </a:prstGeom>
+          <a:noFill/>
+        </p:spPr>
+        <p:txBody>
+          <a:bodyPr wrap="square" anchor="ctr" lIns="128016" tIns="18288" rIns="73152" bIns="18288">
+            <a:noAutofit/>
+          </a:bodyPr>
+          <a:lstStyle/>
+          <a:p>
+            <a:pPr algn="l" latinLnBrk="0">
+              <a:lnSpc>
+                <a:spcPct val="100000"/>
+              </a:lnSpc>
+              <a:spcBef>
+                <a:spcPts val="0"/>
+              </a:spcBef>
+              <a:spcAft>
+                <a:spcPts val="100"/>
+              </a:spcAft>
+            </a:pPr>
+            <a:r>
+              <a:rPr sz="1000" b="1">
+                <a:solidFill>
+                  <a:srgbClr val="374151"/>
+                </a:solidFill>
+                <a:latin typeface="Microsoft YaHei"/>
+                <a:ea typeface="Microsoft YaHei"/>
+                <a:cs typeface="Microsoft YaHei"/>
+              </a:rPr>
+              <a:t>TPOT</a:t>
+            </a:r>
+          </a:p>
+          <a:p>
+            <a:pPr algn="l" latinLnBrk="0">
+              <a:lnSpc>
+                <a:spcPct val="100000"/>
+              </a:lnSpc>
+              <a:spcBef>
+                <a:spcPts val="0"/>
+              </a:spcBef>
+              <a:spcAft>
+                <a:spcPts val="0"/>
+              </a:spcAft>
+            </a:pPr>
+            <a:r>
+              <a:rPr sz="900" b="0">
+                <a:solidFill>
+                  <a:srgbClr val="6B7280"/>
+                </a:solidFill>
+                <a:latin typeface="Microsoft YaHei"/>
+                <a:ea typeface="Microsoft YaHei"/>
+                <a:cs typeface="Microsoft YaHei"/>
+              </a:rPr>
+              <a:t>P50 / P90 / P99</a:t>
+            </a:r>
+          </a:p>
+        </p:txBody>
+      </p:sp>
+      <p:cxnSp>
+        <p:nvCxnSpPr>
+          <p:cNvPr id="32" name="Connector 31"/>
+          <p:cNvCxnSpPr/>
+          <p:nvPr/>
+        </p:nvCxnSpPr>
+        <p:spPr>
+          <a:xfrm>
+            <a:off x="6197071" y="4334256"/>
+            <a:ext cx="0" cy="347472"/>
+          </a:xfrm>
+          <a:prstGeom prst="line">
+            <a:avLst/>
+          </a:prstGeom>
+          <a:ln w="9525">
+            <a:solidFill>
+              <a:srgbClr val="D1D5DB"/>
+            </a:solidFill>
+          </a:ln>
+        </p:spPr>
+      </p:cxnSp>
+      <p:sp>
+        <p:nvSpPr>
+          <p:cNvPr id="33" name="TextBox 32"/>
+          <p:cNvSpPr txBox="1"/>
+          <p:nvPr/>
+        </p:nvSpPr>
+        <p:spPr>
+          <a:xfrm>
+            <a:off x="6197071" y="4224528"/>
+            <a:ext cx="1214871" cy="566928"/>
+          </a:xfrm>
+          <a:prstGeom prst="rect">
+            <a:avLst/>
+          </a:prstGeom>
+          <a:noFill/>
+        </p:spPr>
+        <p:txBody>
+          <a:bodyPr wrap="square" anchor="ctr" lIns="128016" tIns="18288" rIns="73152" bIns="18288">
+            <a:noAutofit/>
+          </a:bodyPr>
+          <a:lstStyle/>
+          <a:p>
+            <a:pPr algn="l" latinLnBrk="0">
+              <a:lnSpc>
+                <a:spcPct val="100000"/>
+              </a:lnSpc>
+              <a:spcBef>
+                <a:spcPts val="0"/>
+              </a:spcBef>
+              <a:spcAft>
+                <a:spcPts val="100"/>
+              </a:spcAft>
+            </a:pPr>
+            <a:r>
+              <a:rPr sz="1000" b="1">
+                <a:solidFill>
+                  <a:srgbClr val="374151"/>
+                </a:solidFill>
+                <a:latin typeface="Microsoft YaHei"/>
+                <a:ea typeface="Microsoft YaHei"/>
+                <a:cs typeface="Microsoft YaHei"/>
+              </a:rPr>
+              <a:t>输出吞吐</a:t>
+            </a:r>
+          </a:p>
+          <a:p>
+            <a:pPr algn="l" latinLnBrk="0">
+              <a:lnSpc>
+                <a:spcPct val="100000"/>
+              </a:lnSpc>
+              <a:spcBef>
+                <a:spcPts val="0"/>
+              </a:spcBef>
+              <a:spcAft>
+                <a:spcPts val="0"/>
+              </a:spcAft>
+            </a:pPr>
+            <a:r>
+              <a:rPr sz="900" b="0">
+                <a:solidFill>
+                  <a:srgbClr val="6B7280"/>
+                </a:solidFill>
+                <a:latin typeface="Microsoft YaHei"/>
+                <a:ea typeface="Microsoft YaHei"/>
+                <a:cs typeface="Microsoft YaHei"/>
+              </a:rPr>
+              <a:t>总量与每卡</a:t>
+            </a:r>
+          </a:p>
+        </p:txBody>
+      </p:sp>
+      <p:cxnSp>
+        <p:nvCxnSpPr>
+          <p:cNvPr id="34" name="Connector 33"/>
+          <p:cNvCxnSpPr/>
+          <p:nvPr/>
+        </p:nvCxnSpPr>
+        <p:spPr>
+          <a:xfrm>
+            <a:off x="7411943" y="4334256"/>
+            <a:ext cx="0" cy="347472"/>
+          </a:xfrm>
+          <a:prstGeom prst="line">
+            <a:avLst/>
+          </a:prstGeom>
+          <a:ln w="9525">
+            <a:solidFill>
+              <a:srgbClr val="D1D5DB"/>
+            </a:solidFill>
+          </a:ln>
+        </p:spPr>
+      </p:cxnSp>
+      <p:sp>
+        <p:nvSpPr>
+          <p:cNvPr id="35" name="TextBox 34"/>
+          <p:cNvSpPr txBox="1"/>
+          <p:nvPr/>
+        </p:nvSpPr>
+        <p:spPr>
+          <a:xfrm>
+            <a:off x="7411943" y="4224528"/>
+            <a:ext cx="1214871" cy="566928"/>
+          </a:xfrm>
+          <a:prstGeom prst="rect">
+            <a:avLst/>
+          </a:prstGeom>
+          <a:noFill/>
+        </p:spPr>
+        <p:txBody>
+          <a:bodyPr wrap="square" anchor="ctr" lIns="128016" tIns="18288" rIns="73152" bIns="18288">
+            <a:noAutofit/>
+          </a:bodyPr>
+          <a:lstStyle/>
+          <a:p>
+            <a:pPr algn="l" latinLnBrk="0">
+              <a:lnSpc>
+                <a:spcPct val="100000"/>
+              </a:lnSpc>
+              <a:spcBef>
+                <a:spcPts val="0"/>
+              </a:spcBef>
+              <a:spcAft>
+                <a:spcPts val="100"/>
+              </a:spcAft>
+            </a:pPr>
+            <a:r>
+              <a:rPr sz="1000" b="1">
+                <a:solidFill>
+                  <a:srgbClr val="374151"/>
+                </a:solidFill>
+                <a:latin typeface="Microsoft YaHei"/>
+                <a:ea typeface="Microsoft YaHei"/>
+                <a:cs typeface="Microsoft YaHei"/>
+              </a:rPr>
+              <a:t>SLO 达成率</a:t>
+            </a:r>
+          </a:p>
+          <a:p>
+            <a:pPr algn="l" latinLnBrk="0">
+              <a:lnSpc>
+                <a:spcPct val="100000"/>
+              </a:lnSpc>
+              <a:spcBef>
+                <a:spcPts val="0"/>
+              </a:spcBef>
+              <a:spcAft>
+                <a:spcPts val="0"/>
+              </a:spcAft>
+            </a:pPr>
+            <a:r>
+              <a:rPr sz="900" b="0">
+                <a:solidFill>
+                  <a:srgbClr val="6B7280"/>
+                </a:solidFill>
+                <a:latin typeface="Microsoft YaHei"/>
+                <a:ea typeface="Microsoft YaHei"/>
+                <a:cs typeface="Microsoft YaHei"/>
+              </a:rPr>
+              <a:t>达标请求占比</a:t>
+            </a:r>
+          </a:p>
+        </p:txBody>
+      </p:sp>
+      <p:cxnSp>
+        <p:nvCxnSpPr>
+          <p:cNvPr id="36" name="Connector 35"/>
+          <p:cNvCxnSpPr/>
+          <p:nvPr/>
+        </p:nvCxnSpPr>
+        <p:spPr>
+          <a:xfrm>
+            <a:off x="8626815" y="4334256"/>
+            <a:ext cx="0" cy="347472"/>
+          </a:xfrm>
+          <a:prstGeom prst="line">
+            <a:avLst/>
+          </a:prstGeom>
+          <a:ln w="9525">
+            <a:solidFill>
+              <a:srgbClr val="D1D5DB"/>
+            </a:solidFill>
+          </a:ln>
+        </p:spPr>
+      </p:cxnSp>
+      <p:sp>
+        <p:nvSpPr>
+          <p:cNvPr id="37" name="TextBox 36"/>
+          <p:cNvSpPr txBox="1"/>
+          <p:nvPr/>
+        </p:nvSpPr>
+        <p:spPr>
+          <a:xfrm>
+            <a:off x="8626815" y="4224528"/>
+            <a:ext cx="1214871" cy="566928"/>
+          </a:xfrm>
+          <a:prstGeom prst="rect">
+            <a:avLst/>
+          </a:prstGeom>
+          <a:noFill/>
+        </p:spPr>
+        <p:txBody>
+          <a:bodyPr wrap="square" anchor="ctr" lIns="128016" tIns="18288" rIns="73152" bIns="18288">
+            <a:noAutofit/>
+          </a:bodyPr>
+          <a:lstStyle/>
+          <a:p>
+            <a:pPr algn="l" latinLnBrk="0">
+              <a:lnSpc>
+                <a:spcPct val="100000"/>
+              </a:lnSpc>
+              <a:spcBef>
+                <a:spcPts val="0"/>
+              </a:spcBef>
+              <a:spcAft>
+                <a:spcPts val="100"/>
+              </a:spcAft>
+            </a:pPr>
+            <a:r>
+              <a:rPr sz="1000" b="1">
+                <a:solidFill>
+                  <a:srgbClr val="374151"/>
+                </a:solidFill>
+                <a:latin typeface="Microsoft YaHei"/>
+                <a:ea typeface="Microsoft YaHei"/>
+                <a:cs typeface="Microsoft YaHei"/>
+              </a:rPr>
+              <a:t>资源</a:t>
+            </a:r>
+          </a:p>
+          <a:p>
+            <a:pPr algn="l" latinLnBrk="0">
+              <a:lnSpc>
+                <a:spcPct val="100000"/>
+              </a:lnSpc>
+              <a:spcBef>
+                <a:spcPts val="0"/>
+              </a:spcBef>
+              <a:spcAft>
+                <a:spcPts val="0"/>
+              </a:spcAft>
+            </a:pPr>
+            <a:r>
+              <a:rPr sz="900" b="0">
+                <a:solidFill>
+                  <a:srgbClr val="6B7280"/>
+                </a:solidFill>
+                <a:latin typeface="Microsoft YaHei"/>
+                <a:ea typeface="Microsoft YaHei"/>
+                <a:cs typeface="Microsoft YaHei"/>
+              </a:rPr>
+              <a:t>卡数与实例数</a:t>
+            </a:r>
+          </a:p>
+        </p:txBody>
+      </p:sp>
+      <p:sp>
+        <p:nvSpPr>
+          <p:cNvPr id="38" name="TextBox 37"/>
+          <p:cNvSpPr txBox="1"/>
+          <p:nvPr/>
+        </p:nvSpPr>
+        <p:spPr>
+          <a:xfrm>
+            <a:off x="2715768" y="4882896"/>
+            <a:ext cx="7125919" cy="274320"/>
+          </a:xfrm>
+          <a:prstGeom prst="rect">
+            <a:avLst/>
+          </a:prstGeom>
+          <a:noFill/>
+        </p:spPr>
+        <p:txBody>
+          <a:bodyPr wrap="square" anchor="ctr" lIns="0" tIns="0" rIns="0" bIns="0">
+            <a:noAutofit/>
+          </a:bodyPr>
+          <a:lstStyle/>
+          <a:p>
+            <a:pPr algn="l" latinLnBrk="0">
+              <a:lnSpc>
+                <a:spcPct val="100000"/>
+              </a:lnSpc>
+              <a:spcBef>
+                <a:spcPts val="0"/>
+              </a:spcBef>
+              <a:spcAft>
+                <a:spcPts val="0"/>
+              </a:spcAft>
+            </a:pPr>
+            <a:r>
+              <a:rPr sz="1100" b="1">
+                <a:solidFill>
+                  <a:srgbClr val="9A3412"/>
+                </a:solidFill>
+                <a:latin typeface="Microsoft YaHei"/>
+                <a:ea typeface="Microsoft YaHei"/>
+                <a:cs typeface="Microsoft YaHei"/>
+              </a:rPr>
+              <a:t>实测闭环</a:t>
+            </a:r>
+            <a:r>
+              <a:rPr sz="1000" b="0">
+                <a:solidFill>
+                  <a:srgbClr val="6B7280"/>
+                </a:solidFill>
+                <a:latin typeface="Microsoft YaHei"/>
+                <a:ea typeface="Microsoft YaHei"/>
+                <a:cs typeface="Microsoft YaHei"/>
+              </a:rPr>
+              <a:t>　预测与实测对不上时，自动校准成本模型并重新选优</a:t>
+            </a:r>
+          </a:p>
+        </p:txBody>
+      </p:sp>
+      <p:sp>
+        <p:nvSpPr>
+          <p:cNvPr id="39" name="Rectangle 38"/>
+          <p:cNvSpPr/>
+          <p:nvPr/>
+        </p:nvSpPr>
+        <p:spPr>
+          <a:xfrm>
+            <a:off x="411480" y="5212080"/>
+            <a:ext cx="3545738" cy="786384"/>
+          </a:xfrm>
+          <a:prstGeom prst="rect">
+            <a:avLst/>
+          </a:prstGeom>
+          <a:solidFill>
+            <a:srgbClr val="FFF4EC"/>
+          </a:solidFill>
+          <a:ln w="12700">
+            <a:solidFill>
+              <a:srgbClr val="F3B58F"/>
+            </a:solidFill>
+          </a:ln>
+        </p:spPr>
+        <p:txBody>
+          <a:bodyPr rtlCol="0" anchor="ctr" wrap="square" lIns="146304" tIns="27432" rIns="109728" bIns="27432">
+            <a:noAutofit/>
+          </a:bodyPr>
+          <a:lstStyle/>
+          <a:p>
+            <a:pPr algn="l" latinLnBrk="0">
+              <a:lnSpc>
+                <a:spcPct val="100000"/>
+              </a:lnSpc>
+              <a:spcBef>
+                <a:spcPts val="0"/>
+              </a:spcBef>
+              <a:spcAft>
+                <a:spcPts val="200"/>
+              </a:spcAft>
+            </a:pPr>
+            <a:r>
+              <a:rPr sz="1100" b="1">
+                <a:solidFill>
+                  <a:srgbClr val="9A3412"/>
+                </a:solidFill>
+                <a:latin typeface="Microsoft YaHei"/>
+                <a:ea typeface="Microsoft YaHei"/>
+                <a:cs typeface="Microsoft YaHei"/>
+              </a:rPr>
+              <a:t>校准并重新选优</a:t>
+            </a:r>
+          </a:p>
+          <a:p>
+            <a:pPr algn="l" latinLnBrk="0">
+              <a:lnSpc>
+                <a:spcPct val="105000"/>
+              </a:lnSpc>
+              <a:spcBef>
+                <a:spcPts val="0"/>
+              </a:spcBef>
+              <a:spcAft>
+                <a:spcPts val="0"/>
+              </a:spcAft>
+            </a:pPr>
+            <a:r>
+              <a:rPr sz="950" b="0">
+                <a:solidFill>
+                  <a:srgbClr val="374151"/>
+                </a:solidFill>
+                <a:latin typeface="Microsoft YaHei"/>
+                <a:ea typeface="Microsoft YaHei"/>
+                <a:cs typeface="Microsoft YaHei"/>
+              </a:rPr>
+              <a:t>拟合 prefill / decode 系数，带校准重新规划部署</a:t>
+            </a:r>
+          </a:p>
+        </p:txBody>
+      </p:sp>
+      <p:sp>
+        <p:nvSpPr>
+          <p:cNvPr id="40" name="Rectangle 39"/>
+          <p:cNvSpPr/>
+          <p:nvPr/>
+        </p:nvSpPr>
+        <p:spPr>
+          <a:xfrm>
+            <a:off x="4322978" y="5212080"/>
+            <a:ext cx="3545738" cy="786384"/>
+          </a:xfrm>
+          <a:prstGeom prst="rect">
+            <a:avLst/>
+          </a:prstGeom>
+          <a:solidFill>
+            <a:srgbClr val="FFF4EC"/>
+          </a:solidFill>
+          <a:ln w="12700">
+            <a:solidFill>
+              <a:srgbClr val="F3B58F"/>
+            </a:solidFill>
+          </a:ln>
+        </p:spPr>
+        <p:txBody>
+          <a:bodyPr rtlCol="0" anchor="ctr" wrap="square" lIns="146304" tIns="27432" rIns="109728" bIns="27432">
+            <a:noAutofit/>
+          </a:bodyPr>
+          <a:lstStyle/>
+          <a:p>
+            <a:pPr algn="l" latinLnBrk="0">
+              <a:lnSpc>
+                <a:spcPct val="100000"/>
+              </a:lnSpc>
+              <a:spcBef>
+                <a:spcPts val="0"/>
+              </a:spcBef>
+              <a:spcAft>
+                <a:spcPts val="200"/>
+              </a:spcAft>
+            </a:pPr>
+            <a:r>
+              <a:rPr sz="1100" b="1">
+                <a:solidFill>
+                  <a:srgbClr val="9A3412"/>
+                </a:solidFill>
+                <a:latin typeface="Microsoft YaHei"/>
+                <a:ea typeface="Microsoft YaHei"/>
+                <a:cs typeface="Microsoft YaHei"/>
+              </a:rPr>
+              <a:t>自动比对</a:t>
+            </a:r>
+          </a:p>
+          <a:p>
+            <a:pPr algn="l" latinLnBrk="0">
+              <a:lnSpc>
+                <a:spcPct val="105000"/>
+              </a:lnSpc>
+              <a:spcBef>
+                <a:spcPts val="0"/>
+              </a:spcBef>
+              <a:spcAft>
+                <a:spcPts val="0"/>
+              </a:spcAft>
+            </a:pPr>
+            <a:r>
+              <a:rPr sz="950" b="0">
+                <a:solidFill>
+                  <a:srgbClr val="374151"/>
+                </a:solidFill>
+                <a:latin typeface="Microsoft YaHei"/>
+                <a:ea typeface="Microsoft YaHei"/>
+                <a:cs typeface="Microsoft YaHei"/>
+              </a:rPr>
+              <a:t>实测与预测逐项比对，超出 ±20% 判为偏差</a:t>
+            </a:r>
+          </a:p>
+        </p:txBody>
+      </p:sp>
+      <p:cxnSp>
+        <p:nvCxnSpPr>
+          <p:cNvPr id="41" name="Connector 40"/>
+          <p:cNvCxnSpPr/>
+          <p:nvPr/>
+        </p:nvCxnSpPr>
+        <p:spPr>
+          <a:xfrm flipH="1">
+            <a:off x="4012082" y="5605272"/>
+            <a:ext cx="256032" cy="0"/>
+          </a:xfrm>
+          <a:prstGeom prst="line">
+            <a:avLst/>
+          </a:prstGeom>
+          <a:ln w="22225">
+            <a:solidFill>
+              <a:srgbClr val="C2410C"/>
+            </a:solidFill>
+            <a:tailEnd type="triangle" w="med" len="med"/>
+          </a:ln>
+        </p:spPr>
+      </p:cxnSp>
+      <p:sp>
+        <p:nvSpPr>
+          <p:cNvPr id="42" name="Rectangle 41"/>
+          <p:cNvSpPr/>
+          <p:nvPr/>
+        </p:nvSpPr>
+        <p:spPr>
+          <a:xfrm>
+            <a:off x="8234476" y="5212080"/>
+            <a:ext cx="3545738" cy="786384"/>
+          </a:xfrm>
+          <a:prstGeom prst="rect">
+            <a:avLst/>
+          </a:prstGeom>
+          <a:solidFill>
+            <a:srgbClr val="FFFFFF"/>
+          </a:solidFill>
+          <a:ln w="12700">
+            <a:solidFill>
+              <a:srgbClr val="C2410C"/>
+            </a:solidFill>
+            <a:prstDash val="dash"/>
+          </a:ln>
+        </p:spPr>
+        <p:txBody>
+          <a:bodyPr rtlCol="0" anchor="ctr" wrap="square" lIns="146304" tIns="27432" rIns="109728" bIns="27432">
+            <a:noAutofit/>
+          </a:bodyPr>
+          <a:lstStyle/>
+          <a:p>
+            <a:pPr algn="l" latinLnBrk="0">
+              <a:lnSpc>
+                <a:spcPct val="100000"/>
+              </a:lnSpc>
+              <a:spcBef>
+                <a:spcPts val="0"/>
+              </a:spcBef>
+              <a:spcAft>
+                <a:spcPts val="200"/>
+              </a:spcAft>
+            </a:pPr>
+            <a:r>
+              <a:rPr sz="1100" b="1">
+                <a:solidFill>
+                  <a:srgbClr val="9A3412"/>
+                </a:solidFill>
+                <a:latin typeface="Microsoft YaHei"/>
+                <a:ea typeface="Microsoft YaHei"/>
+                <a:cs typeface="Microsoft YaHei"/>
+              </a:rPr>
+              <a:t>真机压测</a:t>
+            </a:r>
+            <a:r>
+              <a:rPr sz="900" b="0">
+                <a:solidFill>
+                  <a:srgbClr val="C2410C"/>
+                </a:solidFill>
+                <a:latin typeface="Microsoft YaHei"/>
+                <a:ea typeface="Microsoft YaHei"/>
+                <a:cs typeface="Microsoft YaHei"/>
+              </a:rPr>
+              <a:t>　规划中</a:t>
+            </a:r>
+          </a:p>
+          <a:p>
+            <a:pPr algn="l" latinLnBrk="0">
+              <a:lnSpc>
+                <a:spcPct val="105000"/>
+              </a:lnSpc>
+              <a:spcBef>
+                <a:spcPts val="0"/>
+              </a:spcBef>
+              <a:spcAft>
+                <a:spcPts val="0"/>
+              </a:spcAft>
+            </a:pPr>
+            <a:r>
+              <a:rPr sz="950" b="0">
+                <a:solidFill>
+                  <a:srgbClr val="374151"/>
+                </a:solidFill>
+                <a:latin typeface="Microsoft YaHei"/>
+                <a:ea typeface="Microsoft YaHei"/>
+                <a:cs typeface="Microsoft YaHei"/>
+              </a:rPr>
+              <a:t>执行器自动启动服务、跑压测、收集日志；目前由人按生成的命令执行</a:t>
+            </a:r>
+          </a:p>
+        </p:txBody>
+      </p:sp>
+      <p:cxnSp>
+        <p:nvCxnSpPr>
+          <p:cNvPr id="43" name="Connector 42"/>
+          <p:cNvCxnSpPr/>
+          <p:nvPr/>
+        </p:nvCxnSpPr>
+        <p:spPr>
+          <a:xfrm flipH="1">
+            <a:off x="7923580" y="5605272"/>
+            <a:ext cx="256032" cy="0"/>
+          </a:xfrm>
+          <a:prstGeom prst="line">
+            <a:avLst/>
+          </a:prstGeom>
+          <a:ln w="22225">
+            <a:solidFill>
+              <a:srgbClr val="C2410C"/>
+            </a:solidFill>
+            <a:tailEnd type="triangle" w="med" len="med"/>
+          </a:ln>
+        </p:spPr>
+      </p:cxnSp>
+      <p:cxnSp>
+        <p:nvCxnSpPr>
+          <p:cNvPr id="44" name="Connector 43"/>
+          <p:cNvCxnSpPr/>
+          <p:nvPr/>
+        </p:nvCxnSpPr>
+        <p:spPr>
+          <a:xfrm>
+            <a:off x="10957255" y="4142232"/>
+            <a:ext cx="0" cy="1024128"/>
+          </a:xfrm>
+          <a:prstGeom prst="line">
+            <a:avLst/>
+          </a:prstGeom>
+          <a:ln w="22225">
+            <a:solidFill>
+              <a:srgbClr val="C2410C"/>
+            </a:solidFill>
+            <a:tailEnd type="triangle" w="med" len="med"/>
+          </a:ln>
+        </p:spPr>
+      </p:cxnSp>
+      <p:cxnSp>
+        <p:nvCxnSpPr>
+          <p:cNvPr id="45" name="Connector 44"/>
+          <p:cNvCxnSpPr/>
+          <p:nvPr/>
+        </p:nvCxnSpPr>
+        <p:spPr>
+          <a:xfrm flipV="1">
+            <a:off x="1417320" y="4142232"/>
+            <a:ext cx="0" cy="1024128"/>
+          </a:xfrm>
+          <a:prstGeom prst="line">
+            <a:avLst/>
+          </a:prstGeom>
+          <a:ln w="22225">
+            <a:solidFill>
+              <a:srgbClr val="C2410C"/>
+            </a:solidFill>
+            <a:tailEnd type="triangle" w="med" len="med"/>
+          </a:ln>
+        </p:spPr>
+      </p:cxnSp>
+      <p:sp>
+        <p:nvSpPr>
+          <p:cNvPr id="46" name="TextBox 45"/>
+          <p:cNvSpPr txBox="1"/>
+          <p:nvPr/>
+        </p:nvSpPr>
+        <p:spPr>
+          <a:xfrm>
+            <a:off x="411480" y="6254496"/>
+            <a:ext cx="8259775" cy="292608"/>
+          </a:xfrm>
+          <a:prstGeom prst="rect">
+            <a:avLst/>
+          </a:prstGeom>
+          <a:noFill/>
+        </p:spPr>
+        <p:txBody>
+          <a:bodyPr wrap="square" anchor="ctr" lIns="0" tIns="0" rIns="0" bIns="0">
+            <a:noAutofit/>
+          </a:bodyPr>
+          <a:lstStyle/>
+          <a:p>
+            <a:pPr algn="l" latinLnBrk="0">
+              <a:lnSpc>
+                <a:spcPct val="100000"/>
+              </a:lnSpc>
+              <a:spcBef>
+                <a:spcPts val="0"/>
+              </a:spcBef>
+              <a:spcAft>
+                <a:spcPts val="0"/>
+              </a:spcAft>
+            </a:pPr>
+            <a:r>
+              <a:rPr sz="950" b="0">
+                <a:solidFill>
+                  <a:srgbClr val="6B7280"/>
+                </a:solidFill>
+                <a:latin typeface="Microsoft YaHei"/>
+                <a:ea typeface="Microsoft YaHei"/>
+                <a:cs typeface="Microsoft YaHei"/>
+              </a:rPr>
+              <a:t>命令：sglang-maestro deploy --model &lt;模型&gt; --hardware &lt;芯片&gt; --workload &lt;业务场景&gt; [--calibration &lt;校准文件&gt;]</a:t>
+            </a:r>
+          </a:p>
+        </p:txBody>
+      </p:sp>
+      <p:sp>
+        <p:nvSpPr>
+          <p:cNvPr id="47" name="Rectangle 46"/>
+          <p:cNvSpPr/>
+          <p:nvPr/>
+        </p:nvSpPr>
+        <p:spPr>
+          <a:xfrm>
+            <a:off x="8854135" y="6327648"/>
+            <a:ext cx="274320" cy="146304"/>
+          </a:xfrm>
+          <a:prstGeom prst="rect">
+            <a:avLst/>
+          </a:prstGeom>
+          <a:solidFill>
+            <a:srgbClr val="FFFFFF"/>
+          </a:solidFill>
+          <a:ln w="12700">
+            <a:solidFill>
+              <a:srgbClr val="C2410C"/>
+            </a:solidFill>
+            <a:prstDash val="dash"/>
+          </a:ln>
+        </p:spPr>
+        <p:txBody>
+          <a:bodyPr rtlCol="0" anchor="ctr"/>
+          <a:lstStyle/>
+          <a:p>
+            <a:pPr algn="ctr"/>
+          </a:p>
+        </p:txBody>
+      </p:sp>
+      <p:sp>
+        <p:nvSpPr>
+          <p:cNvPr id="48" name="TextBox 47"/>
+          <p:cNvSpPr txBox="1"/>
+          <p:nvPr/>
+        </p:nvSpPr>
+        <p:spPr>
+          <a:xfrm>
+            <a:off x="9201607" y="6254496"/>
+            <a:ext cx="2578608" cy="292608"/>
+          </a:xfrm>
+          <a:prstGeom prst="rect">
+            <a:avLst/>
+          </a:prstGeom>
+          <a:noFill/>
+        </p:spPr>
+        <p:txBody>
+          <a:bodyPr wrap="square" anchor="ctr" lIns="0" tIns="0" rIns="0" bIns="0">
+            <a:noAutofit/>
+          </a:bodyPr>
+          <a:lstStyle/>
+          <a:p>
+            <a:pPr algn="l" latinLnBrk="0">
+              <a:lnSpc>
+                <a:spcPct val="100000"/>
+              </a:lnSpc>
+              <a:spcBef>
+                <a:spcPts val="0"/>
+              </a:spcBef>
+              <a:spcAft>
+                <a:spcPts val="0"/>
+              </a:spcAft>
+            </a:pPr>
+            <a:r>
+              <a:rPr sz="900" b="0">
+                <a:solidFill>
+                  <a:srgbClr val="6B7280"/>
+                </a:solidFill>
+                <a:latin typeface="Microsoft YaHei"/>
+                <a:ea typeface="Microsoft YaHei"/>
+                <a:cs typeface="Microsoft YaHei"/>
+              </a:rPr>
+              <a:t>虚线框：规划中，目前由人按输出的命令执行</a:t>
             </a:r>
           </a:p>
         </p:txBody>

</xml_diff>

<commit_message>
Drop PD disaggregation from the evaluation slide
</commit_message>
<xml_diff>
--- a/slides/sglang_maestro_workflow.pptx
+++ b/slides/sglang_maestro_workflow.pptx
@@ -6291,7 +6291,7 @@
                 <a:ea typeface="Microsoft YaHei"/>
                 <a:cs typeface="Microsoft YaHei"/>
               </a:rPr>
-              <a:t>混部与 PD 分离两种形态</a:t>
+              <a:t>TPOT 超标时自动试更小的 chunk</a:t>
             </a:r>
           </a:p>
         </p:txBody>
@@ -6721,7 +6721,7 @@
                 <a:ea typeface="Microsoft YaHei"/>
                 <a:cs typeface="Microsoft YaHei"/>
               </a:rPr>
-              <a:t>PD 分离省卡 10% 以上才选</a:t>
+              <a:t>整集群带路由仿真，不达标加实例</a:t>
             </a:r>
           </a:p>
         </p:txBody>
@@ -8151,7 +8151,7 @@
                 <a:ea typeface="Microsoft YaHei"/>
                 <a:cs typeface="Microsoft YaHei"/>
               </a:rPr>
-              <a:t>命令：sglang-maestro deploy --model &lt;模型&gt; --hardware &lt;芯片&gt; --workload &lt;业务场景&gt; [--calibration &lt;校准文件&gt;]</a:t>
+              <a:t>命令：sglang-maestro deploy --model &lt;模型&gt; --hardware &lt;芯片&gt; --workload &lt;业务场景&gt; --no-pd [--calibration &lt;校准文件&gt;]</a:t>
             </a:r>
           </a:p>
         </p:txBody>

</xml_diff>

<commit_message>
Restyle the evaluation slide as a vertical step layout
</commit_message>
<xml_diff>
--- a/slides/sglang_maestro_workflow.pptx
+++ b/slides/sglang_maestro_workflow.pptx
@@ -5647,8 +5647,8 @@
         </p:nvSpPr>
         <p:spPr>
           <a:xfrm>
-            <a:off x="411480" y="1280160"/>
-            <a:ext cx="2011680" cy="274320"/>
+            <a:off x="411480" y="1325880"/>
+            <a:ext cx="402336" cy="530352"/>
           </a:xfrm>
           <a:prstGeom prst="rect">
             <a:avLst/>
@@ -5661,7 +5661,7 @@
           </a:bodyPr>
           <a:lstStyle/>
           <a:p>
-            <a:pPr algn="l" latinLnBrk="0">
+            <a:pPr algn="ctr" latinLnBrk="0">
               <a:lnSpc>
                 <a:spcPct val="100000"/>
               </a:lnSpc>
@@ -5688,122 +5688,19 @@
       </p:sp>
       <p:sp>
         <p:nvSpPr>
-          <p:cNvPr id="6" name="TextBox 5"/>
-          <p:cNvSpPr txBox="1"/>
-          <p:nvPr/>
-        </p:nvSpPr>
-        <p:spPr>
-          <a:xfrm>
-            <a:off x="2715768" y="1280160"/>
-            <a:ext cx="7125919" cy="274320"/>
-          </a:xfrm>
-          <a:prstGeom prst="rect">
-            <a:avLst/>
-          </a:prstGeom>
-          <a:noFill/>
-        </p:spPr>
-        <p:txBody>
-          <a:bodyPr wrap="square" anchor="ctr" lIns="0" tIns="0" rIns="0" bIns="0">
-            <a:noAutofit/>
-          </a:bodyPr>
-          <a:lstStyle/>
-          <a:p>
-            <a:pPr algn="l" latinLnBrk="0">
-              <a:lnSpc>
-                <a:spcPct val="100000"/>
-              </a:lnSpc>
-              <a:spcBef>
-                <a:spcPts val="0"/>
-              </a:spcBef>
-              <a:spcAft>
-                <a:spcPts val="0"/>
-              </a:spcAft>
-            </a:pPr>
-            <a:r>
-              <a:rPr sz="1100" b="1">
-                <a:solidFill>
-                  <a:srgbClr val="1D4ED8"/>
-                </a:solidFill>
-                <a:latin typeface="Microsoft YaHei"/>
-                <a:ea typeface="Microsoft YaHei"/>
-                <a:cs typeface="Microsoft YaHei"/>
-              </a:rPr>
-              <a:t>自动测评与选优</a:t>
-            </a:r>
-            <a:r>
-              <a:rPr sz="1000" b="0">
-                <a:solidFill>
-                  <a:srgbClr val="6B7280"/>
-                </a:solidFill>
-                <a:latin typeface="Microsoft YaHei"/>
-                <a:ea typeface="Microsoft YaHei"/>
-                <a:cs typeface="Microsoft YaHei"/>
-              </a:rPr>
-              <a:t>　对应 sglang-maestro deploy，run 会在场景 3 之后自动执行</a:t>
-            </a:r>
-          </a:p>
-        </p:txBody>
-      </p:sp>
-      <p:sp>
-        <p:nvSpPr>
-          <p:cNvPr id="7" name="TextBox 6"/>
-          <p:cNvSpPr txBox="1"/>
-          <p:nvPr/>
-        </p:nvSpPr>
-        <p:spPr>
-          <a:xfrm>
-            <a:off x="10134295" y="1280160"/>
-            <a:ext cx="1645920" cy="274320"/>
-          </a:xfrm>
-          <a:prstGeom prst="rect">
-            <a:avLst/>
-          </a:prstGeom>
-          <a:noFill/>
-        </p:spPr>
-        <p:txBody>
-          <a:bodyPr wrap="square" anchor="ctr" lIns="0" tIns="0" rIns="0" bIns="0">
-            <a:noAutofit/>
-          </a:bodyPr>
-          <a:lstStyle/>
-          <a:p>
-            <a:pPr algn="l" latinLnBrk="0">
-              <a:lnSpc>
-                <a:spcPct val="100000"/>
-              </a:lnSpc>
-              <a:spcBef>
-                <a:spcPts val="0"/>
-              </a:spcBef>
-              <a:spcAft>
-                <a:spcPts val="0"/>
-              </a:spcAft>
-            </a:pPr>
-            <a:r>
-              <a:rPr sz="1100" b="1">
-                <a:solidFill>
-                  <a:srgbClr val="6B7280"/>
-                </a:solidFill>
-                <a:latin typeface="Microsoft YaHei"/>
-                <a:ea typeface="Microsoft YaHei"/>
-                <a:cs typeface="Microsoft YaHei"/>
-              </a:rPr>
-              <a:t>输出</a:t>
-            </a:r>
-          </a:p>
-        </p:txBody>
-      </p:sp>
-      <p:sp>
-        <p:nvSpPr>
-          <p:cNvPr id="8" name="Rectangle 7"/>
+          <p:cNvPr id="6" name="Rounded Rectangle 5"/>
           <p:cNvSpPr/>
           <p:nvPr/>
         </p:nvSpPr>
         <p:spPr>
           <a:xfrm>
-            <a:off x="411480" y="1627632"/>
-            <a:ext cx="2011680" cy="534924"/>
-          </a:xfrm>
-          <a:prstGeom prst="rect">
-            <a:avLst/>
+            <a:off x="914400" y="1325880"/>
+            <a:ext cx="2620441" cy="530352"/>
+          </a:xfrm>
+          <a:prstGeom prst="roundRect">
+            <a:avLst>
+              <a:gd name="adj" fmla="val 20000"/>
+            </a:avLst>
           </a:prstGeom>
           <a:solidFill>
             <a:srgbClr val="F3F4F6"/>
@@ -5815,7 +5712,7 @@
           </a:ln>
         </p:spPr>
         <p:txBody>
-          <a:bodyPr rtlCol="0" anchor="ctr" wrap="square" lIns="109728" tIns="18288" bIns="18288">
+          <a:bodyPr rtlCol="0" anchor="ctr" wrap="square" lIns="164592" tIns="18288" bIns="18288">
             <a:noAutofit/>
           </a:bodyPr>
           <a:lstStyle/>
@@ -5871,17 +5768,19 @@
       </p:sp>
       <p:sp>
         <p:nvSpPr>
-          <p:cNvPr id="9" name="Rectangle 8"/>
+          <p:cNvPr id="7" name="Rounded Rectangle 6"/>
           <p:cNvSpPr/>
           <p:nvPr/>
         </p:nvSpPr>
         <p:spPr>
           <a:xfrm>
-            <a:off x="411480" y="2272284"/>
-            <a:ext cx="2011680" cy="534924"/>
-          </a:xfrm>
-          <a:prstGeom prst="rect">
-            <a:avLst/>
+            <a:off x="3662857" y="1325880"/>
+            <a:ext cx="2620441" cy="530352"/>
+          </a:xfrm>
+          <a:prstGeom prst="roundRect">
+            <a:avLst>
+              <a:gd name="adj" fmla="val 20000"/>
+            </a:avLst>
           </a:prstGeom>
           <a:solidFill>
             <a:srgbClr val="F3F4F6"/>
@@ -5893,7 +5792,7 @@
           </a:ln>
         </p:spPr>
         <p:txBody>
-          <a:bodyPr rtlCol="0" anchor="ctr" wrap="square" lIns="109728" tIns="18288" bIns="18288">
+          <a:bodyPr rtlCol="0" anchor="ctr" wrap="square" lIns="164592" tIns="18288" bIns="18288">
             <a:noAutofit/>
           </a:bodyPr>
           <a:lstStyle/>
@@ -5949,17 +5848,19 @@
       </p:sp>
       <p:sp>
         <p:nvSpPr>
-          <p:cNvPr id="10" name="Rectangle 9"/>
+          <p:cNvPr id="8" name="Rounded Rectangle 7"/>
           <p:cNvSpPr/>
           <p:nvPr/>
         </p:nvSpPr>
         <p:spPr>
           <a:xfrm>
-            <a:off x="411480" y="2916936"/>
-            <a:ext cx="2011680" cy="534924"/>
-          </a:xfrm>
-          <a:prstGeom prst="rect">
-            <a:avLst/>
+            <a:off x="6411315" y="1325880"/>
+            <a:ext cx="2620441" cy="530352"/>
+          </a:xfrm>
+          <a:prstGeom prst="roundRect">
+            <a:avLst>
+              <a:gd name="adj" fmla="val 20000"/>
+            </a:avLst>
           </a:prstGeom>
           <a:solidFill>
             <a:srgbClr val="F3F4F6"/>
@@ -5971,7 +5872,7 @@
           </a:ln>
         </p:spPr>
         <p:txBody>
-          <a:bodyPr rtlCol="0" anchor="ctr" wrap="square" lIns="109728" tIns="18288" bIns="18288">
+          <a:bodyPr rtlCol="0" anchor="ctr" wrap="square" lIns="164592" tIns="18288" bIns="18288">
             <a:noAutofit/>
           </a:bodyPr>
           <a:lstStyle/>
@@ -6027,17 +5928,19 @@
       </p:sp>
       <p:sp>
         <p:nvSpPr>
-          <p:cNvPr id="11" name="Rectangle 10"/>
+          <p:cNvPr id="9" name="Rounded Rectangle 8"/>
           <p:cNvSpPr/>
           <p:nvPr/>
         </p:nvSpPr>
         <p:spPr>
           <a:xfrm>
-            <a:off x="411480" y="3561588"/>
-            <a:ext cx="2011680" cy="534924"/>
-          </a:xfrm>
-          <a:prstGeom prst="rect">
-            <a:avLst/>
+            <a:off x="9159773" y="1325880"/>
+            <a:ext cx="2620441" cy="530352"/>
+          </a:xfrm>
+          <a:prstGeom prst="roundRect">
+            <a:avLst>
+              <a:gd name="adj" fmla="val 20000"/>
+            </a:avLst>
           </a:prstGeom>
           <a:solidFill>
             <a:srgbClr val="FFF4EC"/>
@@ -6049,7 +5952,7 @@
           </a:ln>
         </p:spPr>
         <p:txBody>
-          <a:bodyPr rtlCol="0" anchor="ctr" wrap="square" lIns="109728" tIns="18288" bIns="18288">
+          <a:bodyPr rtlCol="0" anchor="ctr" wrap="square" lIns="164592" tIns="18288" bIns="18288">
             <a:noAutofit/>
           </a:bodyPr>
           <a:lstStyle/>
@@ -6105,16 +6008,195 @@
       </p:sp>
       <p:sp>
         <p:nvSpPr>
-          <p:cNvPr id="12" name="Rectangle 11"/>
+          <p:cNvPr id="10" name="TextBox 9"/>
+          <p:cNvSpPr txBox="1"/>
+          <p:nvPr/>
+        </p:nvSpPr>
+        <p:spPr>
+          <a:xfrm>
+            <a:off x="914400" y="1975104"/>
+            <a:ext cx="6858000" cy="274320"/>
+          </a:xfrm>
+          <a:prstGeom prst="rect">
+            <a:avLst/>
+          </a:prstGeom>
+          <a:noFill/>
+        </p:spPr>
+        <p:txBody>
+          <a:bodyPr wrap="square" anchor="ctr" lIns="0" tIns="0" rIns="0" bIns="0">
+            <a:noAutofit/>
+          </a:bodyPr>
+          <a:lstStyle/>
+          <a:p>
+            <a:pPr algn="l" latinLnBrk="0">
+              <a:lnSpc>
+                <a:spcPct val="100000"/>
+              </a:lnSpc>
+              <a:spcBef>
+                <a:spcPts val="0"/>
+              </a:spcBef>
+              <a:spcAft>
+                <a:spcPts val="0"/>
+              </a:spcAft>
+            </a:pPr>
+            <a:r>
+              <a:rPr sz="1100" b="1">
+                <a:solidFill>
+                  <a:srgbClr val="1D4ED8"/>
+                </a:solidFill>
+                <a:latin typeface="Microsoft YaHei"/>
+                <a:ea typeface="Microsoft YaHei"/>
+                <a:cs typeface="Microsoft YaHei"/>
+              </a:rPr>
+              <a:t>自动测评与选优</a:t>
+            </a:r>
+            <a:r>
+              <a:rPr sz="1000" b="0">
+                <a:solidFill>
+                  <a:srgbClr val="6B7280"/>
+                </a:solidFill>
+                <a:latin typeface="Microsoft YaHei"/>
+                <a:ea typeface="Microsoft YaHei"/>
+                <a:cs typeface="Microsoft YaHei"/>
+              </a:rPr>
+              <a:t>　对应 sglang-maestro deploy，run 会在场景 3 之后自动执行</a:t>
+            </a:r>
+          </a:p>
+        </p:txBody>
+      </p:sp>
+      <p:sp>
+        <p:nvSpPr>
+          <p:cNvPr id="11" name="TextBox 10"/>
+          <p:cNvSpPr txBox="1"/>
+          <p:nvPr/>
+        </p:nvSpPr>
+        <p:spPr>
+          <a:xfrm>
+            <a:off x="8412480" y="1975104"/>
+            <a:ext cx="3367735" cy="274320"/>
+          </a:xfrm>
+          <a:prstGeom prst="rect">
+            <a:avLst/>
+          </a:prstGeom>
+          <a:noFill/>
+        </p:spPr>
+        <p:txBody>
+          <a:bodyPr wrap="square" anchor="ctr" lIns="0" tIns="0" rIns="0" bIns="0">
+            <a:noAutofit/>
+          </a:bodyPr>
+          <a:lstStyle/>
+          <a:p>
+            <a:pPr algn="l" latinLnBrk="0">
+              <a:lnSpc>
+                <a:spcPct val="100000"/>
+              </a:lnSpc>
+              <a:spcBef>
+                <a:spcPts val="0"/>
+              </a:spcBef>
+              <a:spcAft>
+                <a:spcPts val="0"/>
+              </a:spcAft>
+            </a:pPr>
+            <a:r>
+              <a:rPr sz="1100" b="1">
+                <a:solidFill>
+                  <a:srgbClr val="6B7280"/>
+                </a:solidFill>
+                <a:latin typeface="Microsoft YaHei"/>
+                <a:ea typeface="Microsoft YaHei"/>
+                <a:cs typeface="Microsoft YaHei"/>
+              </a:rPr>
+              <a:t>输出</a:t>
+            </a:r>
+          </a:p>
+        </p:txBody>
+      </p:sp>
+      <p:cxnSp>
+        <p:nvCxnSpPr>
+          <p:cNvPr id="12" name="Connector 11"/>
+          <p:cNvCxnSpPr/>
+          <p:nvPr/>
+        </p:nvCxnSpPr>
+        <p:spPr>
+          <a:xfrm>
+            <a:off x="612648" y="1892807"/>
+            <a:ext cx="0" cy="466345"/>
+          </a:xfrm>
+          <a:prstGeom prst="line">
+            <a:avLst/>
+          </a:prstGeom>
+          <a:ln w="22225">
+            <a:solidFill>
+              <a:srgbClr val="9CA3AF"/>
+            </a:solidFill>
+            <a:tailEnd type="triangle" w="med" len="med"/>
+          </a:ln>
+        </p:spPr>
+      </p:cxnSp>
+      <p:cxnSp>
+        <p:nvCxnSpPr>
+          <p:cNvPr id="13" name="Connector 12"/>
+          <p:cNvCxnSpPr/>
+          <p:nvPr/>
+        </p:nvCxnSpPr>
+        <p:spPr>
+          <a:xfrm>
+            <a:off x="612648" y="2587752"/>
+            <a:ext cx="0" cy="1892807"/>
+          </a:xfrm>
+          <a:prstGeom prst="line">
+            <a:avLst/>
+          </a:prstGeom>
+          <a:ln w="25400">
+            <a:solidFill>
+              <a:srgbClr val="C7D7FE"/>
+            </a:solidFill>
+          </a:ln>
+        </p:spPr>
+      </p:cxnSp>
+      <p:sp>
+        <p:nvSpPr>
+          <p:cNvPr id="14" name="Rounded Rectangle 13"/>
           <p:cNvSpPr/>
           <p:nvPr/>
         </p:nvSpPr>
         <p:spPr>
           <a:xfrm>
-            <a:off x="2715768" y="1627632"/>
-            <a:ext cx="1589455" cy="621792"/>
-          </a:xfrm>
-          <a:prstGeom prst="rect">
+            <a:off x="914400" y="2304288"/>
+            <a:ext cx="6858000" cy="566928"/>
+          </a:xfrm>
+          <a:prstGeom prst="roundRect">
+            <a:avLst>
+              <a:gd name="adj" fmla="val 14000"/>
+            </a:avLst>
+          </a:prstGeom>
+          <a:solidFill>
+            <a:srgbClr val="F5F8FF"/>
+          </a:solidFill>
+          <a:ln>
+            <a:noFill/>
+          </a:ln>
+        </p:spPr>
+        <p:txBody>
+          <a:bodyPr rtlCol="0" anchor="ctr"/>
+          <a:lstStyle/>
+          <a:p>
+            <a:pPr algn="ctr"/>
+          </a:p>
+        </p:txBody>
+      </p:sp>
+      <p:sp>
+        <p:nvSpPr>
+          <p:cNvPr id="15" name="Oval 14"/>
+          <p:cNvSpPr/>
+          <p:nvPr/>
+        </p:nvSpPr>
+        <p:spPr>
+          <a:xfrm>
+            <a:off x="411480" y="2386584"/>
+            <a:ext cx="402336" cy="402336"/>
+          </a:xfrm>
+          <a:prstGeom prst="ellipse">
             <a:avLst/>
           </a:prstGeom>
           <a:solidFill>
@@ -6125,11 +6207,58 @@
           </a:ln>
         </p:spPr>
         <p:txBody>
-          <a:bodyPr rtlCol="0" anchor="ctr" wrap="square" lIns="128016" tIns="27432" bIns="27432">
+          <a:bodyPr rtlCol="0" anchor="ctr" wrap="square" lIns="0" tIns="0" rIns="0" bIns="0">
             <a:noAutofit/>
           </a:bodyPr>
           <a:lstStyle/>
           <a:p>
+            <a:pPr algn="ctr" latinLnBrk="0">
+              <a:lnSpc>
+                <a:spcPct val="100000"/>
+              </a:lnSpc>
+              <a:spcBef>
+                <a:spcPts val="0"/>
+              </a:spcBef>
+              <a:spcAft>
+                <a:spcPts val="0"/>
+              </a:spcAft>
+            </a:pPr>
+            <a:r>
+              <a:rPr sz="1400" b="1">
+                <a:solidFill>
+                  <a:srgbClr val="FFFFFF"/>
+                </a:solidFill>
+                <a:latin typeface="Microsoft YaHei"/>
+                <a:ea typeface="Microsoft YaHei"/>
+                <a:cs typeface="Microsoft YaHei"/>
+              </a:rPr>
+              <a:t>1</a:t>
+            </a:r>
+          </a:p>
+        </p:txBody>
+      </p:sp>
+      <p:sp>
+        <p:nvSpPr>
+          <p:cNvPr id="16" name="TextBox 15"/>
+          <p:cNvSpPr txBox="1"/>
+          <p:nvPr/>
+        </p:nvSpPr>
+        <p:spPr>
+          <a:xfrm>
+            <a:off x="1097280" y="2304288"/>
+            <a:ext cx="960120" cy="566928"/>
+          </a:xfrm>
+          <a:prstGeom prst="rect">
+            <a:avLst/>
+          </a:prstGeom>
+          <a:noFill/>
+        </p:spPr>
+        <p:txBody>
+          <a:bodyPr wrap="square" anchor="ctr" lIns="0" tIns="0" rIns="0" bIns="0">
+            <a:noAutofit/>
+          </a:bodyPr>
+          <a:lstStyle/>
+          <a:p>
             <a:pPr algn="l" latinLnBrk="0">
               <a:lnSpc>
                 <a:spcPct val="100000"/>
@@ -6138,37 +6267,13 @@
                 <a:spcPts val="0"/>
               </a:spcBef>
               <a:spcAft>
-                <a:spcPts val="100"/>
-              </a:spcAft>
-            </a:pPr>
-            <a:r>
-              <a:rPr sz="900" b="0">
-                <a:solidFill>
-                  <a:srgbClr val="C7D7FE"/>
-                </a:solidFill>
-                <a:latin typeface="Microsoft YaHei"/>
-                <a:ea typeface="Microsoft YaHei"/>
-                <a:cs typeface="Microsoft YaHei"/>
-              </a:rPr>
-              <a:t>步骤 1</a:t>
-            </a:r>
-          </a:p>
-          <a:p>
-            <a:pPr algn="l" latinLnBrk="0">
-              <a:lnSpc>
-                <a:spcPct val="100000"/>
-              </a:lnSpc>
-              <a:spcBef>
-                <a:spcPts val="0"/>
-              </a:spcBef>
-              <a:spcAft>
-                <a:spcPts val="0"/>
-              </a:spcAft>
-            </a:pPr>
-            <a:r>
-              <a:rPr sz="1500" b="1">
-                <a:solidFill>
-                  <a:srgbClr val="FFFFFF"/>
+                <a:spcPts val="0"/>
+              </a:spcAft>
+            </a:pPr>
+            <a:r>
+              <a:rPr sz="1400" b="1">
+                <a:solidFill>
+                  <a:srgbClr val="1F2937"/>
                 </a:solidFill>
                 <a:latin typeface="Microsoft YaHei"/>
                 <a:ea typeface="Microsoft YaHei"/>
@@ -6179,31 +6284,45 @@
           </a:p>
         </p:txBody>
       </p:sp>
-      <p:sp>
-        <p:nvSpPr>
-          <p:cNvPr id="13" name="Rectangle 12"/>
-          <p:cNvSpPr/>
-          <p:nvPr/>
-        </p:nvSpPr>
-        <p:spPr>
-          <a:xfrm>
-            <a:off x="2715768" y="2249424"/>
-            <a:ext cx="1589455" cy="1847088"/>
-          </a:xfrm>
-          <a:prstGeom prst="rect">
-            <a:avLst/>
-          </a:prstGeom>
-          <a:solidFill>
-            <a:srgbClr val="F5F8FF"/>
-          </a:solidFill>
-          <a:ln w="9525">
+      <p:cxnSp>
+        <p:nvCxnSpPr>
+          <p:cNvPr id="17" name="Connector 16"/>
+          <p:cNvCxnSpPr/>
+          <p:nvPr/>
+        </p:nvCxnSpPr>
+        <p:spPr>
+          <a:xfrm>
+            <a:off x="2148840" y="2432304"/>
+            <a:ext cx="0" cy="310896"/>
+          </a:xfrm>
+          <a:prstGeom prst="line">
+            <a:avLst/>
+          </a:prstGeom>
+          <a:ln w="12700">
             <a:solidFill>
               <a:srgbClr val="C9D6F0"/>
             </a:solidFill>
           </a:ln>
         </p:spPr>
-        <p:txBody>
-          <a:bodyPr rtlCol="0" anchor="t" wrap="square" lIns="109728" tIns="128016" bIns="73152">
+      </p:cxnSp>
+      <p:sp>
+        <p:nvSpPr>
+          <p:cNvPr id="18" name="TextBox 17"/>
+          <p:cNvSpPr txBox="1"/>
+          <p:nvPr/>
+        </p:nvSpPr>
+        <p:spPr>
+          <a:xfrm>
+            <a:off x="2276856" y="2304288"/>
+            <a:ext cx="1740407" cy="566928"/>
+          </a:xfrm>
+          <a:prstGeom prst="rect">
+            <a:avLst/>
+          </a:prstGeom>
+          <a:noFill/>
+        </p:spPr>
+        <p:txBody>
+          <a:bodyPr wrap="square" anchor="ctr" lIns="0" tIns="0" rIns="0" bIns="0">
             <a:noAutofit/>
           </a:bodyPr>
           <a:lstStyle/>
@@ -6216,7 +6335,7 @@
                 <a:spcPts val="0"/>
               </a:spcBef>
               <a:spcAft>
-                <a:spcPts val="700"/>
+                <a:spcPts val="0"/>
               </a:spcAft>
               <a:buClr>
                 <a:srgbClr val="1D4ED8"/>
@@ -6236,6 +6355,29 @@
               <a:t>基于场景 3 的调优配置</a:t>
             </a:r>
           </a:p>
+        </p:txBody>
+      </p:sp>
+      <p:sp>
+        <p:nvSpPr>
+          <p:cNvPr id="19" name="TextBox 18"/>
+          <p:cNvSpPr txBox="1"/>
+          <p:nvPr/>
+        </p:nvSpPr>
+        <p:spPr>
+          <a:xfrm>
+            <a:off x="4126992" y="2304288"/>
+            <a:ext cx="1740407" cy="566928"/>
+          </a:xfrm>
+          <a:prstGeom prst="rect">
+            <a:avLst/>
+          </a:prstGeom>
+          <a:noFill/>
+        </p:spPr>
+        <p:txBody>
+          <a:bodyPr wrap="square" anchor="ctr" lIns="0" tIns="0" rIns="0" bIns="0">
+            <a:noAutofit/>
+          </a:bodyPr>
+          <a:lstStyle/>
           <a:p>
             <a:pPr algn="l" latinLnBrk="0" marL="128016" indent="-128016">
               <a:lnSpc>
@@ -6245,7 +6387,7 @@
                 <a:spcPts val="0"/>
               </a:spcBef>
               <a:spcAft>
-                <a:spcPts val="700"/>
+                <a:spcPts val="0"/>
               </a:spcAft>
               <a:buClr>
                 <a:srgbClr val="1D4ED8"/>
@@ -6265,6 +6407,29 @@
               <a:t>枚举实例规格：并行布局与特性组合</a:t>
             </a:r>
           </a:p>
+        </p:txBody>
+      </p:sp>
+      <p:sp>
+        <p:nvSpPr>
+          <p:cNvPr id="20" name="TextBox 19"/>
+          <p:cNvSpPr txBox="1"/>
+          <p:nvPr/>
+        </p:nvSpPr>
+        <p:spPr>
+          <a:xfrm>
+            <a:off x="5977128" y="2304288"/>
+            <a:ext cx="1740407" cy="566928"/>
+          </a:xfrm>
+          <a:prstGeom prst="rect">
+            <a:avLst/>
+          </a:prstGeom>
+          <a:noFill/>
+        </p:spPr>
+        <p:txBody>
+          <a:bodyPr wrap="square" anchor="ctr" lIns="0" tIns="0" rIns="0" bIns="0">
+            <a:noAutofit/>
+          </a:bodyPr>
+          <a:lstStyle/>
           <a:p>
             <a:pPr algn="l" latinLnBrk="0" marL="128016" indent="-128016">
               <a:lnSpc>
@@ -6274,7 +6439,7 @@
                 <a:spcPts val="0"/>
               </a:spcBef>
               <a:spcAft>
-                <a:spcPts val="700"/>
+                <a:spcPts val="0"/>
               </a:spcAft>
               <a:buClr>
                 <a:srgbClr val="1D4ED8"/>
@@ -6296,40 +6461,49 @@
           </a:p>
         </p:txBody>
       </p:sp>
-      <p:cxnSp>
-        <p:nvCxnSpPr>
-          <p:cNvPr id="14" name="Connector 13"/>
-          <p:cNvCxnSpPr/>
-          <p:nvPr/>
-        </p:nvCxnSpPr>
-        <p:spPr>
-          <a:xfrm>
-            <a:off x="4350943" y="2862072"/>
-            <a:ext cx="164592" cy="0"/>
-          </a:xfrm>
-          <a:prstGeom prst="line">
-            <a:avLst/>
-          </a:prstGeom>
-          <a:ln w="22225">
-            <a:solidFill>
-              <a:srgbClr val="9CA3AF"/>
-            </a:solidFill>
-            <a:tailEnd type="triangle" w="med" len="med"/>
+      <p:sp>
+        <p:nvSpPr>
+          <p:cNvPr id="21" name="Rounded Rectangle 20"/>
+          <p:cNvSpPr/>
+          <p:nvPr/>
+        </p:nvSpPr>
+        <p:spPr>
+          <a:xfrm>
+            <a:off x="914400" y="2935224"/>
+            <a:ext cx="6858000" cy="566928"/>
+          </a:xfrm>
+          <a:prstGeom prst="roundRect">
+            <a:avLst>
+              <a:gd name="adj" fmla="val 14000"/>
+            </a:avLst>
+          </a:prstGeom>
+          <a:solidFill>
+            <a:srgbClr val="F5F8FF"/>
+          </a:solidFill>
+          <a:ln>
+            <a:noFill/>
           </a:ln>
         </p:spPr>
-      </p:cxnSp>
-      <p:sp>
-        <p:nvSpPr>
-          <p:cNvPr id="15" name="Rectangle 14"/>
+        <p:txBody>
+          <a:bodyPr rtlCol="0" anchor="ctr"/>
+          <a:lstStyle/>
+          <a:p>
+            <a:pPr algn="ctr"/>
+          </a:p>
+        </p:txBody>
+      </p:sp>
+      <p:sp>
+        <p:nvSpPr>
+          <p:cNvPr id="22" name="Oval 21"/>
           <p:cNvSpPr/>
           <p:nvPr/>
         </p:nvSpPr>
         <p:spPr>
           <a:xfrm>
-            <a:off x="4561255" y="1627632"/>
-            <a:ext cx="1589455" cy="621792"/>
-          </a:xfrm>
-          <a:prstGeom prst="rect">
+            <a:off x="411480" y="3017520"/>
+            <a:ext cx="402336" cy="402336"/>
+          </a:xfrm>
+          <a:prstGeom prst="ellipse">
             <a:avLst/>
           </a:prstGeom>
           <a:solidFill>
@@ -6340,11 +6514,58 @@
           </a:ln>
         </p:spPr>
         <p:txBody>
-          <a:bodyPr rtlCol="0" anchor="ctr" wrap="square" lIns="128016" tIns="27432" bIns="27432">
+          <a:bodyPr rtlCol="0" anchor="ctr" wrap="square" lIns="0" tIns="0" rIns="0" bIns="0">
             <a:noAutofit/>
           </a:bodyPr>
           <a:lstStyle/>
           <a:p>
+            <a:pPr algn="ctr" latinLnBrk="0">
+              <a:lnSpc>
+                <a:spcPct val="100000"/>
+              </a:lnSpc>
+              <a:spcBef>
+                <a:spcPts val="0"/>
+              </a:spcBef>
+              <a:spcAft>
+                <a:spcPts val="0"/>
+              </a:spcAft>
+            </a:pPr>
+            <a:r>
+              <a:rPr sz="1400" b="1">
+                <a:solidFill>
+                  <a:srgbClr val="FFFFFF"/>
+                </a:solidFill>
+                <a:latin typeface="Microsoft YaHei"/>
+                <a:ea typeface="Microsoft YaHei"/>
+                <a:cs typeface="Microsoft YaHei"/>
+              </a:rPr>
+              <a:t>2</a:t>
+            </a:r>
+          </a:p>
+        </p:txBody>
+      </p:sp>
+      <p:sp>
+        <p:nvSpPr>
+          <p:cNvPr id="23" name="TextBox 22"/>
+          <p:cNvSpPr txBox="1"/>
+          <p:nvPr/>
+        </p:nvSpPr>
+        <p:spPr>
+          <a:xfrm>
+            <a:off x="1097280" y="2935224"/>
+            <a:ext cx="960120" cy="566928"/>
+          </a:xfrm>
+          <a:prstGeom prst="rect">
+            <a:avLst/>
+          </a:prstGeom>
+          <a:noFill/>
+        </p:spPr>
+        <p:txBody>
+          <a:bodyPr wrap="square" anchor="ctr" lIns="0" tIns="0" rIns="0" bIns="0">
+            <a:noAutofit/>
+          </a:bodyPr>
+          <a:lstStyle/>
+          <a:p>
             <a:pPr algn="l" latinLnBrk="0">
               <a:lnSpc>
                 <a:spcPct val="100000"/>
@@ -6353,37 +6574,13 @@
                 <a:spcPts val="0"/>
               </a:spcBef>
               <a:spcAft>
-                <a:spcPts val="100"/>
-              </a:spcAft>
-            </a:pPr>
-            <a:r>
-              <a:rPr sz="900" b="0">
-                <a:solidFill>
-                  <a:srgbClr val="C7D7FE"/>
-                </a:solidFill>
-                <a:latin typeface="Microsoft YaHei"/>
-                <a:ea typeface="Microsoft YaHei"/>
-                <a:cs typeface="Microsoft YaHei"/>
-              </a:rPr>
-              <a:t>步骤 2</a:t>
-            </a:r>
-          </a:p>
-          <a:p>
-            <a:pPr algn="l" latinLnBrk="0">
-              <a:lnSpc>
-                <a:spcPct val="100000"/>
-              </a:lnSpc>
-              <a:spcBef>
-                <a:spcPts val="0"/>
-              </a:spcBef>
-              <a:spcAft>
-                <a:spcPts val="0"/>
-              </a:spcAft>
-            </a:pPr>
-            <a:r>
-              <a:rPr sz="1500" b="1">
-                <a:solidFill>
-                  <a:srgbClr val="FFFFFF"/>
+                <a:spcPts val="0"/>
+              </a:spcAft>
+            </a:pPr>
+            <a:r>
+              <a:rPr sz="1400" b="1">
+                <a:solidFill>
+                  <a:srgbClr val="1F2937"/>
                 </a:solidFill>
                 <a:latin typeface="Microsoft YaHei"/>
                 <a:ea typeface="Microsoft YaHei"/>
@@ -6394,31 +6591,45 @@
           </a:p>
         </p:txBody>
       </p:sp>
-      <p:sp>
-        <p:nvSpPr>
-          <p:cNvPr id="16" name="Rectangle 15"/>
-          <p:cNvSpPr/>
-          <p:nvPr/>
-        </p:nvSpPr>
-        <p:spPr>
-          <a:xfrm>
-            <a:off x="4561255" y="2249424"/>
-            <a:ext cx="1589455" cy="1847088"/>
-          </a:xfrm>
-          <a:prstGeom prst="rect">
-            <a:avLst/>
-          </a:prstGeom>
-          <a:solidFill>
-            <a:srgbClr val="F5F8FF"/>
-          </a:solidFill>
-          <a:ln w="9525">
+      <p:cxnSp>
+        <p:nvCxnSpPr>
+          <p:cNvPr id="24" name="Connector 23"/>
+          <p:cNvCxnSpPr/>
+          <p:nvPr/>
+        </p:nvCxnSpPr>
+        <p:spPr>
+          <a:xfrm>
+            <a:off x="2148840" y="3063240"/>
+            <a:ext cx="0" cy="310896"/>
+          </a:xfrm>
+          <a:prstGeom prst="line">
+            <a:avLst/>
+          </a:prstGeom>
+          <a:ln w="12700">
             <a:solidFill>
               <a:srgbClr val="C9D6F0"/>
             </a:solidFill>
           </a:ln>
         </p:spPr>
-        <p:txBody>
-          <a:bodyPr rtlCol="0" anchor="t" wrap="square" lIns="109728" tIns="128016" bIns="73152">
+      </p:cxnSp>
+      <p:sp>
+        <p:nvSpPr>
+          <p:cNvPr id="25" name="TextBox 24"/>
+          <p:cNvSpPr txBox="1"/>
+          <p:nvPr/>
+        </p:nvSpPr>
+        <p:spPr>
+          <a:xfrm>
+            <a:off x="2276856" y="2935224"/>
+            <a:ext cx="1740407" cy="566928"/>
+          </a:xfrm>
+          <a:prstGeom prst="rect">
+            <a:avLst/>
+          </a:prstGeom>
+          <a:noFill/>
+        </p:spPr>
+        <p:txBody>
+          <a:bodyPr wrap="square" anchor="ctr" lIns="0" tIns="0" rIns="0" bIns="0">
             <a:noAutofit/>
           </a:bodyPr>
           <a:lstStyle/>
@@ -6431,7 +6642,7 @@
                 <a:spcPts val="0"/>
               </a:spcBef>
               <a:spcAft>
-                <a:spcPts val="700"/>
+                <a:spcPts val="0"/>
               </a:spcAft>
               <a:buClr>
                 <a:srgbClr val="1D4ED8"/>
@@ -6451,6 +6662,29 @@
               <a:t>成本模型算 prefill / decode 单步耗时</a:t>
             </a:r>
           </a:p>
+        </p:txBody>
+      </p:sp>
+      <p:sp>
+        <p:nvSpPr>
+          <p:cNvPr id="26" name="TextBox 25"/>
+          <p:cNvSpPr txBox="1"/>
+          <p:nvPr/>
+        </p:nvSpPr>
+        <p:spPr>
+          <a:xfrm>
+            <a:off x="4126992" y="2935224"/>
+            <a:ext cx="1740407" cy="566928"/>
+          </a:xfrm>
+          <a:prstGeom prst="rect">
+            <a:avLst/>
+          </a:prstGeom>
+          <a:noFill/>
+        </p:spPr>
+        <p:txBody>
+          <a:bodyPr wrap="square" anchor="ctr" lIns="0" tIns="0" rIns="0" bIns="0">
+            <a:noAutofit/>
+          </a:bodyPr>
+          <a:lstStyle/>
           <a:p>
             <a:pPr algn="l" latinLnBrk="0" marL="128016" indent="-128016">
               <a:lnSpc>
@@ -6460,7 +6694,7 @@
                 <a:spcPts val="0"/>
               </a:spcBef>
               <a:spcAft>
-                <a:spcPts val="700"/>
+                <a:spcPts val="0"/>
               </a:spcAft>
               <a:buClr>
                 <a:srgbClr val="1D4ED8"/>
@@ -6480,6 +6714,29 @@
               <a:t>离散事件仿真请求排队、批处理与路由</a:t>
             </a:r>
           </a:p>
+        </p:txBody>
+      </p:sp>
+      <p:sp>
+        <p:nvSpPr>
+          <p:cNvPr id="27" name="TextBox 26"/>
+          <p:cNvSpPr txBox="1"/>
+          <p:nvPr/>
+        </p:nvSpPr>
+        <p:spPr>
+          <a:xfrm>
+            <a:off x="5977128" y="2935224"/>
+            <a:ext cx="1740407" cy="566928"/>
+          </a:xfrm>
+          <a:prstGeom prst="rect">
+            <a:avLst/>
+          </a:prstGeom>
+          <a:noFill/>
+        </p:spPr>
+        <p:txBody>
+          <a:bodyPr wrap="square" anchor="ctr" lIns="0" tIns="0" rIns="0" bIns="0">
+            <a:noAutofit/>
+          </a:bodyPr>
+          <a:lstStyle/>
           <a:p>
             <a:pPr algn="l" latinLnBrk="0" marL="128016" indent="-128016">
               <a:lnSpc>
@@ -6489,7 +6746,7 @@
                 <a:spcPts val="0"/>
               </a:spcBef>
               <a:spcAft>
-                <a:spcPts val="700"/>
+                <a:spcPts val="0"/>
               </a:spcAft>
               <a:buClr>
                 <a:srgbClr val="1D4ED8"/>
@@ -6511,40 +6768,49 @@
           </a:p>
         </p:txBody>
       </p:sp>
-      <p:cxnSp>
-        <p:nvCxnSpPr>
-          <p:cNvPr id="17" name="Connector 16"/>
-          <p:cNvCxnSpPr/>
-          <p:nvPr/>
-        </p:nvCxnSpPr>
-        <p:spPr>
-          <a:xfrm>
-            <a:off x="6196431" y="2862072"/>
-            <a:ext cx="164592" cy="0"/>
-          </a:xfrm>
-          <a:prstGeom prst="line">
-            <a:avLst/>
-          </a:prstGeom>
-          <a:ln w="22225">
-            <a:solidFill>
-              <a:srgbClr val="9CA3AF"/>
-            </a:solidFill>
-            <a:tailEnd type="triangle" w="med" len="med"/>
+      <p:sp>
+        <p:nvSpPr>
+          <p:cNvPr id="28" name="Rounded Rectangle 27"/>
+          <p:cNvSpPr/>
+          <p:nvPr/>
+        </p:nvSpPr>
+        <p:spPr>
+          <a:xfrm>
+            <a:off x="914400" y="3566160"/>
+            <a:ext cx="6858000" cy="566928"/>
+          </a:xfrm>
+          <a:prstGeom prst="roundRect">
+            <a:avLst>
+              <a:gd name="adj" fmla="val 14000"/>
+            </a:avLst>
+          </a:prstGeom>
+          <a:solidFill>
+            <a:srgbClr val="F5F8FF"/>
+          </a:solidFill>
+          <a:ln>
+            <a:noFill/>
           </a:ln>
         </p:spPr>
-      </p:cxnSp>
-      <p:sp>
-        <p:nvSpPr>
-          <p:cNvPr id="18" name="Rectangle 17"/>
+        <p:txBody>
+          <a:bodyPr rtlCol="0" anchor="ctr"/>
+          <a:lstStyle/>
+          <a:p>
+            <a:pPr algn="ctr"/>
+          </a:p>
+        </p:txBody>
+      </p:sp>
+      <p:sp>
+        <p:nvSpPr>
+          <p:cNvPr id="29" name="Oval 28"/>
           <p:cNvSpPr/>
           <p:nvPr/>
         </p:nvSpPr>
         <p:spPr>
           <a:xfrm>
-            <a:off x="6406743" y="1627632"/>
-            <a:ext cx="1589455" cy="621792"/>
-          </a:xfrm>
-          <a:prstGeom prst="rect">
+            <a:off x="411480" y="3648456"/>
+            <a:ext cx="402336" cy="402336"/>
+          </a:xfrm>
+          <a:prstGeom prst="ellipse">
             <a:avLst/>
           </a:prstGeom>
           <a:solidFill>
@@ -6555,11 +6821,58 @@
           </a:ln>
         </p:spPr>
         <p:txBody>
-          <a:bodyPr rtlCol="0" anchor="ctr" wrap="square" lIns="128016" tIns="27432" bIns="27432">
+          <a:bodyPr rtlCol="0" anchor="ctr" wrap="square" lIns="0" tIns="0" rIns="0" bIns="0">
             <a:noAutofit/>
           </a:bodyPr>
           <a:lstStyle/>
           <a:p>
+            <a:pPr algn="ctr" latinLnBrk="0">
+              <a:lnSpc>
+                <a:spcPct val="100000"/>
+              </a:lnSpc>
+              <a:spcBef>
+                <a:spcPts val="0"/>
+              </a:spcBef>
+              <a:spcAft>
+                <a:spcPts val="0"/>
+              </a:spcAft>
+            </a:pPr>
+            <a:r>
+              <a:rPr sz="1400" b="1">
+                <a:solidFill>
+                  <a:srgbClr val="FFFFFF"/>
+                </a:solidFill>
+                <a:latin typeface="Microsoft YaHei"/>
+                <a:ea typeface="Microsoft YaHei"/>
+                <a:cs typeface="Microsoft YaHei"/>
+              </a:rPr>
+              <a:t>3</a:t>
+            </a:r>
+          </a:p>
+        </p:txBody>
+      </p:sp>
+      <p:sp>
+        <p:nvSpPr>
+          <p:cNvPr id="30" name="TextBox 29"/>
+          <p:cNvSpPr txBox="1"/>
+          <p:nvPr/>
+        </p:nvSpPr>
+        <p:spPr>
+          <a:xfrm>
+            <a:off x="1097280" y="3566160"/>
+            <a:ext cx="960120" cy="566928"/>
+          </a:xfrm>
+          <a:prstGeom prst="rect">
+            <a:avLst/>
+          </a:prstGeom>
+          <a:noFill/>
+        </p:spPr>
+        <p:txBody>
+          <a:bodyPr wrap="square" anchor="ctr" lIns="0" tIns="0" rIns="0" bIns="0">
+            <a:noAutofit/>
+          </a:bodyPr>
+          <a:lstStyle/>
+          <a:p>
             <a:pPr algn="l" latinLnBrk="0">
               <a:lnSpc>
                 <a:spcPct val="100000"/>
@@ -6568,37 +6881,13 @@
                 <a:spcPts val="0"/>
               </a:spcBef>
               <a:spcAft>
-                <a:spcPts val="100"/>
-              </a:spcAft>
-            </a:pPr>
-            <a:r>
-              <a:rPr sz="900" b="0">
-                <a:solidFill>
-                  <a:srgbClr val="C7D7FE"/>
-                </a:solidFill>
-                <a:latin typeface="Microsoft YaHei"/>
-                <a:ea typeface="Microsoft YaHei"/>
-                <a:cs typeface="Microsoft YaHei"/>
-              </a:rPr>
-              <a:t>步骤 3</a:t>
-            </a:r>
-          </a:p>
-          <a:p>
-            <a:pPr algn="l" latinLnBrk="0">
-              <a:lnSpc>
-                <a:spcPct val="100000"/>
-              </a:lnSpc>
-              <a:spcBef>
-                <a:spcPts val="0"/>
-              </a:spcBef>
-              <a:spcAft>
-                <a:spcPts val="0"/>
-              </a:spcAft>
-            </a:pPr>
-            <a:r>
-              <a:rPr sz="1500" b="1">
-                <a:solidFill>
-                  <a:srgbClr val="FFFFFF"/>
+                <a:spcPts val="0"/>
+              </a:spcAft>
+            </a:pPr>
+            <a:r>
+              <a:rPr sz="1400" b="1">
+                <a:solidFill>
+                  <a:srgbClr val="1F2937"/>
                 </a:solidFill>
                 <a:latin typeface="Microsoft YaHei"/>
                 <a:ea typeface="Microsoft YaHei"/>
@@ -6609,31 +6898,45 @@
           </a:p>
         </p:txBody>
       </p:sp>
-      <p:sp>
-        <p:nvSpPr>
-          <p:cNvPr id="19" name="Rectangle 18"/>
-          <p:cNvSpPr/>
-          <p:nvPr/>
-        </p:nvSpPr>
-        <p:spPr>
-          <a:xfrm>
-            <a:off x="6406743" y="2249424"/>
-            <a:ext cx="1589455" cy="1847088"/>
-          </a:xfrm>
-          <a:prstGeom prst="rect">
-            <a:avLst/>
-          </a:prstGeom>
-          <a:solidFill>
-            <a:srgbClr val="F5F8FF"/>
-          </a:solidFill>
-          <a:ln w="9525">
+      <p:cxnSp>
+        <p:nvCxnSpPr>
+          <p:cNvPr id="31" name="Connector 30"/>
+          <p:cNvCxnSpPr/>
+          <p:nvPr/>
+        </p:nvCxnSpPr>
+        <p:spPr>
+          <a:xfrm>
+            <a:off x="2148840" y="3694176"/>
+            <a:ext cx="0" cy="310896"/>
+          </a:xfrm>
+          <a:prstGeom prst="line">
+            <a:avLst/>
+          </a:prstGeom>
+          <a:ln w="12700">
             <a:solidFill>
               <a:srgbClr val="C9D6F0"/>
             </a:solidFill>
           </a:ln>
         </p:spPr>
-        <p:txBody>
-          <a:bodyPr rtlCol="0" anchor="t" wrap="square" lIns="109728" tIns="128016" bIns="73152">
+      </p:cxnSp>
+      <p:sp>
+        <p:nvSpPr>
+          <p:cNvPr id="32" name="TextBox 31"/>
+          <p:cNvSpPr txBox="1"/>
+          <p:nvPr/>
+        </p:nvSpPr>
+        <p:spPr>
+          <a:xfrm>
+            <a:off x="2276856" y="3566160"/>
+            <a:ext cx="1740407" cy="566928"/>
+          </a:xfrm>
+          <a:prstGeom prst="rect">
+            <a:avLst/>
+          </a:prstGeom>
+          <a:noFill/>
+        </p:spPr>
+        <p:txBody>
+          <a:bodyPr wrap="square" anchor="ctr" lIns="0" tIns="0" rIns="0" bIns="0">
             <a:noAutofit/>
           </a:bodyPr>
           <a:lstStyle/>
@@ -6646,7 +6949,7 @@
                 <a:spcPts val="0"/>
               </a:spcBef>
               <a:spcAft>
-                <a:spcPts val="700"/>
+                <a:spcPts val="0"/>
               </a:spcAft>
               <a:buClr>
                 <a:srgbClr val="1D4ED8"/>
@@ -6666,6 +6969,29 @@
               <a:t>给定到达率：满足 SLO 且卡数最少</a:t>
             </a:r>
           </a:p>
+        </p:txBody>
+      </p:sp>
+      <p:sp>
+        <p:nvSpPr>
+          <p:cNvPr id="33" name="TextBox 32"/>
+          <p:cNvSpPr txBox="1"/>
+          <p:nvPr/>
+        </p:nvSpPr>
+        <p:spPr>
+          <a:xfrm>
+            <a:off x="4126992" y="3566160"/>
+            <a:ext cx="1740407" cy="566928"/>
+          </a:xfrm>
+          <a:prstGeom prst="rect">
+            <a:avLst/>
+          </a:prstGeom>
+          <a:noFill/>
+        </p:spPr>
+        <p:txBody>
+          <a:bodyPr wrap="square" anchor="ctr" lIns="0" tIns="0" rIns="0" bIns="0">
+            <a:noAutofit/>
+          </a:bodyPr>
+          <a:lstStyle/>
           <a:p>
             <a:pPr algn="l" latinLnBrk="0" marL="128016" indent="-128016">
               <a:lnSpc>
@@ -6675,7 +7001,7 @@
                 <a:spcPts val="0"/>
               </a:spcBef>
               <a:spcAft>
-                <a:spcPts val="700"/>
+                <a:spcPts val="0"/>
               </a:spcAft>
               <a:buClr>
                 <a:srgbClr val="1D4ED8"/>
@@ -6695,6 +7021,29 @@
               <a:t>不给到达率：预算内每卡吞吐最高</a:t>
             </a:r>
           </a:p>
+        </p:txBody>
+      </p:sp>
+      <p:sp>
+        <p:nvSpPr>
+          <p:cNvPr id="34" name="TextBox 33"/>
+          <p:cNvSpPr txBox="1"/>
+          <p:nvPr/>
+        </p:nvSpPr>
+        <p:spPr>
+          <a:xfrm>
+            <a:off x="5977128" y="3566160"/>
+            <a:ext cx="1740407" cy="566928"/>
+          </a:xfrm>
+          <a:prstGeom prst="rect">
+            <a:avLst/>
+          </a:prstGeom>
+          <a:noFill/>
+        </p:spPr>
+        <p:txBody>
+          <a:bodyPr wrap="square" anchor="ctr" lIns="0" tIns="0" rIns="0" bIns="0">
+            <a:noAutofit/>
+          </a:bodyPr>
+          <a:lstStyle/>
           <a:p>
             <a:pPr algn="l" latinLnBrk="0" marL="128016" indent="-128016">
               <a:lnSpc>
@@ -6704,7 +7053,7 @@
                 <a:spcPts val="0"/>
               </a:spcBef>
               <a:spcAft>
-                <a:spcPts val="700"/>
+                <a:spcPts val="0"/>
               </a:spcAft>
               <a:buClr>
                 <a:srgbClr val="1D4ED8"/>
@@ -6726,40 +7075,49 @@
           </a:p>
         </p:txBody>
       </p:sp>
-      <p:cxnSp>
-        <p:nvCxnSpPr>
-          <p:cNvPr id="20" name="Connector 19"/>
-          <p:cNvCxnSpPr/>
-          <p:nvPr/>
-        </p:nvCxnSpPr>
-        <p:spPr>
-          <a:xfrm>
-            <a:off x="8041919" y="2862072"/>
-            <a:ext cx="164592" cy="0"/>
-          </a:xfrm>
-          <a:prstGeom prst="line">
-            <a:avLst/>
-          </a:prstGeom>
-          <a:ln w="22225">
-            <a:solidFill>
-              <a:srgbClr val="9CA3AF"/>
-            </a:solidFill>
-            <a:tailEnd type="triangle" w="med" len="med"/>
+      <p:sp>
+        <p:nvSpPr>
+          <p:cNvPr id="35" name="Rounded Rectangle 34"/>
+          <p:cNvSpPr/>
+          <p:nvPr/>
+        </p:nvSpPr>
+        <p:spPr>
+          <a:xfrm>
+            <a:off x="914400" y="4197096"/>
+            <a:ext cx="6858000" cy="566928"/>
+          </a:xfrm>
+          <a:prstGeom prst="roundRect">
+            <a:avLst>
+              <a:gd name="adj" fmla="val 14000"/>
+            </a:avLst>
+          </a:prstGeom>
+          <a:solidFill>
+            <a:srgbClr val="F5F8FF"/>
+          </a:solidFill>
+          <a:ln>
+            <a:noFill/>
           </a:ln>
         </p:spPr>
-      </p:cxnSp>
-      <p:sp>
-        <p:nvSpPr>
-          <p:cNvPr id="21" name="Rectangle 20"/>
+        <p:txBody>
+          <a:bodyPr rtlCol="0" anchor="ctr"/>
+          <a:lstStyle/>
+          <a:p>
+            <a:pPr algn="ctr"/>
+          </a:p>
+        </p:txBody>
+      </p:sp>
+      <p:sp>
+        <p:nvSpPr>
+          <p:cNvPr id="36" name="Oval 35"/>
           <p:cNvSpPr/>
           <p:nvPr/>
         </p:nvSpPr>
         <p:spPr>
           <a:xfrm>
-            <a:off x="8252231" y="1627632"/>
-            <a:ext cx="1589455" cy="621792"/>
-          </a:xfrm>
-          <a:prstGeom prst="rect">
+            <a:off x="411480" y="4279392"/>
+            <a:ext cx="402336" cy="402336"/>
+          </a:xfrm>
+          <a:prstGeom prst="ellipse">
             <a:avLst/>
           </a:prstGeom>
           <a:solidFill>
@@ -6770,11 +7128,58 @@
           </a:ln>
         </p:spPr>
         <p:txBody>
-          <a:bodyPr rtlCol="0" anchor="ctr" wrap="square" lIns="128016" tIns="27432" bIns="27432">
+          <a:bodyPr rtlCol="0" anchor="ctr" wrap="square" lIns="0" tIns="0" rIns="0" bIns="0">
             <a:noAutofit/>
           </a:bodyPr>
           <a:lstStyle/>
           <a:p>
+            <a:pPr algn="ctr" latinLnBrk="0">
+              <a:lnSpc>
+                <a:spcPct val="100000"/>
+              </a:lnSpc>
+              <a:spcBef>
+                <a:spcPts val="0"/>
+              </a:spcBef>
+              <a:spcAft>
+                <a:spcPts val="0"/>
+              </a:spcAft>
+            </a:pPr>
+            <a:r>
+              <a:rPr sz="1400" b="1">
+                <a:solidFill>
+                  <a:srgbClr val="FFFFFF"/>
+                </a:solidFill>
+                <a:latin typeface="Microsoft YaHei"/>
+                <a:ea typeface="Microsoft YaHei"/>
+                <a:cs typeface="Microsoft YaHei"/>
+              </a:rPr>
+              <a:t>4</a:t>
+            </a:r>
+          </a:p>
+        </p:txBody>
+      </p:sp>
+      <p:sp>
+        <p:nvSpPr>
+          <p:cNvPr id="37" name="TextBox 36"/>
+          <p:cNvSpPr txBox="1"/>
+          <p:nvPr/>
+        </p:nvSpPr>
+        <p:spPr>
+          <a:xfrm>
+            <a:off x="1097280" y="4197096"/>
+            <a:ext cx="960120" cy="566928"/>
+          </a:xfrm>
+          <a:prstGeom prst="rect">
+            <a:avLst/>
+          </a:prstGeom>
+          <a:noFill/>
+        </p:spPr>
+        <p:txBody>
+          <a:bodyPr wrap="square" anchor="ctr" lIns="0" tIns="0" rIns="0" bIns="0">
+            <a:noAutofit/>
+          </a:bodyPr>
+          <a:lstStyle/>
+          <a:p>
             <a:pPr algn="l" latinLnBrk="0">
               <a:lnSpc>
                 <a:spcPct val="100000"/>
@@ -6783,37 +7188,13 @@
                 <a:spcPts val="0"/>
               </a:spcBef>
               <a:spcAft>
-                <a:spcPts val="100"/>
-              </a:spcAft>
-            </a:pPr>
-            <a:r>
-              <a:rPr sz="900" b="0">
-                <a:solidFill>
-                  <a:srgbClr val="C7D7FE"/>
-                </a:solidFill>
-                <a:latin typeface="Microsoft YaHei"/>
-                <a:ea typeface="Microsoft YaHei"/>
-                <a:cs typeface="Microsoft YaHei"/>
-              </a:rPr>
-              <a:t>步骤 4</a:t>
-            </a:r>
-          </a:p>
-          <a:p>
-            <a:pPr algn="l" latinLnBrk="0">
-              <a:lnSpc>
-                <a:spcPct val="100000"/>
-              </a:lnSpc>
-              <a:spcBef>
-                <a:spcPts val="0"/>
-              </a:spcBef>
-              <a:spcAft>
-                <a:spcPts val="0"/>
-              </a:spcAft>
-            </a:pPr>
-            <a:r>
-              <a:rPr sz="1500" b="1">
-                <a:solidFill>
-                  <a:srgbClr val="FFFFFF"/>
+                <a:spcPts val="0"/>
+              </a:spcAft>
+            </a:pPr>
+            <a:r>
+              <a:rPr sz="1400" b="1">
+                <a:solidFill>
+                  <a:srgbClr val="1F2937"/>
                 </a:solidFill>
                 <a:latin typeface="Microsoft YaHei"/>
                 <a:ea typeface="Microsoft YaHei"/>
@@ -6824,31 +7205,45 @@
           </a:p>
         </p:txBody>
       </p:sp>
-      <p:sp>
-        <p:nvSpPr>
-          <p:cNvPr id="22" name="Rectangle 21"/>
-          <p:cNvSpPr/>
-          <p:nvPr/>
-        </p:nvSpPr>
-        <p:spPr>
-          <a:xfrm>
-            <a:off x="8252231" y="2249424"/>
-            <a:ext cx="1589455" cy="1847088"/>
-          </a:xfrm>
-          <a:prstGeom prst="rect">
-            <a:avLst/>
-          </a:prstGeom>
-          <a:solidFill>
-            <a:srgbClr val="F5F8FF"/>
-          </a:solidFill>
-          <a:ln w="9525">
+      <p:cxnSp>
+        <p:nvCxnSpPr>
+          <p:cNvPr id="38" name="Connector 37"/>
+          <p:cNvCxnSpPr/>
+          <p:nvPr/>
+        </p:nvCxnSpPr>
+        <p:spPr>
+          <a:xfrm>
+            <a:off x="2148840" y="4325112"/>
+            <a:ext cx="0" cy="310896"/>
+          </a:xfrm>
+          <a:prstGeom prst="line">
+            <a:avLst/>
+          </a:prstGeom>
+          <a:ln w="12700">
             <a:solidFill>
               <a:srgbClr val="C9D6F0"/>
             </a:solidFill>
           </a:ln>
         </p:spPr>
-        <p:txBody>
-          <a:bodyPr rtlCol="0" anchor="t" wrap="square" lIns="109728" tIns="128016" bIns="73152">
+      </p:cxnSp>
+      <p:sp>
+        <p:nvSpPr>
+          <p:cNvPr id="39" name="TextBox 38"/>
+          <p:cNvSpPr txBox="1"/>
+          <p:nvPr/>
+        </p:nvSpPr>
+        <p:spPr>
+          <a:xfrm>
+            <a:off x="2276856" y="4197096"/>
+            <a:ext cx="1740407" cy="566928"/>
+          </a:xfrm>
+          <a:prstGeom prst="rect">
+            <a:avLst/>
+          </a:prstGeom>
+          <a:noFill/>
+        </p:spPr>
+        <p:txBody>
+          <a:bodyPr wrap="square" anchor="ctr" lIns="0" tIns="0" rIns="0" bIns="0">
             <a:noAutofit/>
           </a:bodyPr>
           <a:lstStyle/>
@@ -6861,7 +7256,7 @@
                 <a:spcPts val="0"/>
               </a:spcBef>
               <a:spcAft>
-                <a:spcPts val="700"/>
+                <a:spcPts val="0"/>
               </a:spcAft>
               <a:buClr>
                 <a:srgbClr val="1D4ED8"/>
@@ -6881,6 +7276,29 @@
               <a:t>把实例放置到各台机器</a:t>
             </a:r>
           </a:p>
+        </p:txBody>
+      </p:sp>
+      <p:sp>
+        <p:nvSpPr>
+          <p:cNvPr id="40" name="TextBox 39"/>
+          <p:cNvSpPr txBox="1"/>
+          <p:nvPr/>
+        </p:nvSpPr>
+        <p:spPr>
+          <a:xfrm>
+            <a:off x="4126992" y="4197096"/>
+            <a:ext cx="1740407" cy="566928"/>
+          </a:xfrm>
+          <a:prstGeom prst="rect">
+            <a:avLst/>
+          </a:prstGeom>
+          <a:noFill/>
+        </p:spPr>
+        <p:txBody>
+          <a:bodyPr wrap="square" anchor="ctr" lIns="0" tIns="0" rIns="0" bIns="0">
+            <a:noAutofit/>
+          </a:bodyPr>
+          <a:lstStyle/>
           <a:p>
             <a:pPr algn="l" latinLnBrk="0" marL="128016" indent="-128016">
               <a:lnSpc>
@@ -6890,7 +7308,7 @@
                 <a:spcPts val="0"/>
               </a:spcBef>
               <a:spcAft>
-                <a:spcPts val="700"/>
+                <a:spcPts val="0"/>
               </a:spcAft>
               <a:buClr>
                 <a:srgbClr val="1D4ED8"/>
@@ -6910,6 +7328,29 @@
               <a:t>生成启动、路由、健康检查命令</a:t>
             </a:r>
           </a:p>
+        </p:txBody>
+      </p:sp>
+      <p:sp>
+        <p:nvSpPr>
+          <p:cNvPr id="41" name="TextBox 40"/>
+          <p:cNvSpPr txBox="1"/>
+          <p:nvPr/>
+        </p:nvSpPr>
+        <p:spPr>
+          <a:xfrm>
+            <a:off x="5977128" y="4197096"/>
+            <a:ext cx="1740407" cy="566928"/>
+          </a:xfrm>
+          <a:prstGeom prst="rect">
+            <a:avLst/>
+          </a:prstGeom>
+          <a:noFill/>
+        </p:spPr>
+        <p:txBody>
+          <a:bodyPr wrap="square" anchor="ctr" lIns="0" tIns="0" rIns="0" bIns="0">
+            <a:noAutofit/>
+          </a:bodyPr>
+          <a:lstStyle/>
           <a:p>
             <a:pPr algn="l" latinLnBrk="0" marL="128016" indent="-128016">
               <a:lnSpc>
@@ -6919,7 +7360,7 @@
                 <a:spcPts val="0"/>
               </a:spcBef>
               <a:spcAft>
-                <a:spcPts val="700"/>
+                <a:spcPts val="0"/>
               </a:spcAft>
               <a:buClr>
                 <a:srgbClr val="1D4ED8"/>
@@ -6941,66 +7382,22 @@
           </a:p>
         </p:txBody>
       </p:sp>
-      <p:cxnSp>
-        <p:nvCxnSpPr>
-          <p:cNvPr id="23" name="Connector 22"/>
-          <p:cNvCxnSpPr/>
-          <p:nvPr/>
-        </p:nvCxnSpPr>
-        <p:spPr>
-          <a:xfrm>
-            <a:off x="2468880" y="2862072"/>
-            <a:ext cx="201168" cy="0"/>
-          </a:xfrm>
-          <a:prstGeom prst="line">
-            <a:avLst/>
-          </a:prstGeom>
-          <a:ln w="22225">
-            <a:solidFill>
-              <a:srgbClr val="9CA3AF"/>
-            </a:solidFill>
-            <a:tailEnd type="triangle" w="med" len="med"/>
-          </a:ln>
-        </p:spPr>
-      </p:cxnSp>
-      <p:cxnSp>
-        <p:nvCxnSpPr>
-          <p:cNvPr id="24" name="Connector 23"/>
-          <p:cNvCxnSpPr/>
-          <p:nvPr/>
-        </p:nvCxnSpPr>
-        <p:spPr>
-          <a:xfrm>
-            <a:off x="9887407" y="2862072"/>
-            <a:ext cx="201168" cy="0"/>
-          </a:xfrm>
-          <a:prstGeom prst="line">
-            <a:avLst/>
-          </a:prstGeom>
-          <a:ln w="22225">
-            <a:solidFill>
-              <a:srgbClr val="9CA3AF"/>
-            </a:solidFill>
-            <a:tailEnd type="triangle" w="med" len="med"/>
-          </a:ln>
-        </p:spPr>
-      </p:cxnSp>
-      <p:sp>
-        <p:nvSpPr>
-          <p:cNvPr id="25" name="Rectangle 24"/>
+      <p:sp>
+        <p:nvSpPr>
+          <p:cNvPr id="42" name="Rectangle 41"/>
           <p:cNvSpPr/>
           <p:nvPr/>
         </p:nvSpPr>
         <p:spPr>
           <a:xfrm>
-            <a:off x="10134295" y="1627632"/>
-            <a:ext cx="1645920" cy="2468880"/>
+            <a:off x="8412480" y="2304288"/>
+            <a:ext cx="3367735" cy="1444752"/>
           </a:xfrm>
           <a:prstGeom prst="rect">
             <a:avLst/>
           </a:prstGeom>
           <a:solidFill>
-            <a:srgbClr val="F3F4F6"/>
+            <a:srgbClr val="FFFFFF"/>
           </a:solidFill>
           <a:ln w="9525">
             <a:solidFill>
@@ -7009,7 +7406,60 @@
           </a:ln>
         </p:spPr>
         <p:txBody>
-          <a:bodyPr rtlCol="0" anchor="t" wrap="square" lIns="128016" tIns="146304" bIns="73152">
+          <a:bodyPr rtlCol="0" anchor="ctr"/>
+          <a:lstStyle/>
+          <a:p>
+            <a:pPr algn="ctr"/>
+          </a:p>
+        </p:txBody>
+      </p:sp>
+      <p:sp>
+        <p:nvSpPr>
+          <p:cNvPr id="43" name="Rectangle 42"/>
+          <p:cNvSpPr/>
+          <p:nvPr/>
+        </p:nvSpPr>
+        <p:spPr>
+          <a:xfrm>
+            <a:off x="8412480" y="2304288"/>
+            <a:ext cx="3367735" cy="54864"/>
+          </a:xfrm>
+          <a:prstGeom prst="rect">
+            <a:avLst/>
+          </a:prstGeom>
+          <a:solidFill>
+            <a:srgbClr val="1D4ED8"/>
+          </a:solidFill>
+          <a:ln>
+            <a:noFill/>
+          </a:ln>
+        </p:spPr>
+        <p:txBody>
+          <a:bodyPr rtlCol="0" anchor="ctr"/>
+          <a:lstStyle/>
+          <a:p>
+            <a:pPr algn="ctr"/>
+          </a:p>
+        </p:txBody>
+      </p:sp>
+      <p:sp>
+        <p:nvSpPr>
+          <p:cNvPr id="44" name="TextBox 43"/>
+          <p:cNvSpPr txBox="1"/>
+          <p:nvPr/>
+        </p:nvSpPr>
+        <p:spPr>
+          <a:xfrm>
+            <a:off x="8412480" y="2359152"/>
+            <a:ext cx="3367735" cy="1389888"/>
+          </a:xfrm>
+          <a:prstGeom prst="rect">
+            <a:avLst/>
+          </a:prstGeom>
+          <a:noFill/>
+        </p:spPr>
+        <p:txBody>
+          <a:bodyPr wrap="square" anchor="t" lIns="164592" tIns="128016" rIns="109728" bIns="54864">
             <a:noAutofit/>
           </a:bodyPr>
           <a:lstStyle/>
@@ -7022,7 +7472,7 @@
                 <a:spcPts val="0"/>
               </a:spcBef>
               <a:spcAft>
-                <a:spcPts val="900"/>
+                <a:spcPts val="800"/>
               </a:spcAft>
             </a:pPr>
             <a:r>
@@ -7046,7 +7496,7 @@
                 <a:spcPts val="0"/>
               </a:spcBef>
               <a:spcAft>
-                <a:spcPts val="600"/>
+                <a:spcPts val="500"/>
               </a:spcAft>
               <a:buClr>
                 <a:srgbClr val="6B7280"/>
@@ -7055,7 +7505,7 @@
               <a:buChar char="•"/>
             </a:pPr>
             <a:r>
-              <a:rPr sz="1100" b="0">
+              <a:rPr sz="1050" b="0">
                 <a:solidFill>
                   <a:srgbClr val="374151"/>
                 </a:solidFill>
@@ -7075,7 +7525,7 @@
                 <a:spcPts val="0"/>
               </a:spcBef>
               <a:spcAft>
-                <a:spcPts val="600"/>
+                <a:spcPts val="500"/>
               </a:spcAft>
               <a:buClr>
                 <a:srgbClr val="6B7280"/>
@@ -7084,7 +7534,7 @@
               <a:buChar char="•"/>
             </a:pPr>
             <a:r>
-              <a:rPr sz="1100" b="0">
+              <a:rPr sz="1050" b="0">
                 <a:solidFill>
                   <a:srgbClr val="374151"/>
                 </a:solidFill>
@@ -7104,7 +7554,7 @@
                 <a:spcPts val="0"/>
               </a:spcBef>
               <a:spcAft>
-                <a:spcPts val="600"/>
+                <a:spcPts val="500"/>
               </a:spcAft>
               <a:buClr>
                 <a:srgbClr val="6B7280"/>
@@ -7113,7 +7563,7 @@
               <a:buChar char="•"/>
             </a:pPr>
             <a:r>
-              <a:rPr sz="1100" b="0">
+              <a:rPr sz="1050" b="0">
                 <a:solidFill>
                   <a:srgbClr val="374151"/>
                 </a:solidFill>
@@ -7133,7 +7583,7 @@
                 <a:spcPts val="0"/>
               </a:spcBef>
               <a:spcAft>
-                <a:spcPts val="600"/>
+                <a:spcPts val="500"/>
               </a:spcAft>
               <a:buClr>
                 <a:srgbClr val="6B7280"/>
@@ -7142,7 +7592,7 @@
               <a:buChar char="•"/>
             </a:pPr>
             <a:r>
-              <a:rPr sz="1100" b="0">
+              <a:rPr sz="1050" b="0">
                 <a:solidFill>
                   <a:srgbClr val="374151"/>
                 </a:solidFill>
@@ -7157,14 +7607,14 @@
       </p:sp>
       <p:sp>
         <p:nvSpPr>
-          <p:cNvPr id="26" name="Rectangle 25"/>
+          <p:cNvPr id="45" name="Rectangle 44"/>
           <p:cNvSpPr/>
           <p:nvPr/>
         </p:nvSpPr>
         <p:spPr>
           <a:xfrm>
-            <a:off x="2715768" y="4224528"/>
-            <a:ext cx="7125919" cy="566928"/>
+            <a:off x="8412480" y="3877055"/>
+            <a:ext cx="3367735" cy="2103120"/>
           </a:xfrm>
           <a:prstGeom prst="rect">
             <a:avLst/>
@@ -7188,14 +7638,14 @@
       </p:sp>
       <p:sp>
         <p:nvSpPr>
-          <p:cNvPr id="27" name="TextBox 26"/>
+          <p:cNvPr id="46" name="TextBox 45"/>
           <p:cNvSpPr txBox="1"/>
           <p:nvPr/>
         </p:nvSpPr>
         <p:spPr>
           <a:xfrm>
-            <a:off x="2715768" y="4224528"/>
-            <a:ext cx="1051560" cy="566928"/>
+            <a:off x="8412480" y="3877055"/>
+            <a:ext cx="3367735" cy="402336"/>
           </a:xfrm>
           <a:prstGeom prst="rect">
             <a:avLst/>
@@ -7203,7 +7653,7 @@
           <a:noFill/>
         </p:spPr>
         <p:txBody>
-          <a:bodyPr wrap="square" anchor="ctr" lIns="128016" tIns="0" rIns="45720" bIns="0">
+          <a:bodyPr wrap="square" anchor="ctr" lIns="164592" tIns="54864" rIns="109728" bIns="0">
             <a:noAutofit/>
           </a:bodyPr>
           <a:lstStyle/>
@@ -7216,11 +7666,11 @@
                 <a:spcPts val="0"/>
               </a:spcBef>
               <a:spcAft>
-                <a:spcPts val="100"/>
-              </a:spcAft>
-            </a:pPr>
-            <a:r>
-              <a:rPr sz="1100" b="1">
+                <a:spcPts val="0"/>
+              </a:spcAft>
+            </a:pPr>
+            <a:r>
+              <a:rPr sz="1300" b="1">
                 <a:solidFill>
                   <a:srgbClr val="1F2937"/>
                 </a:solidFill>
@@ -7230,21 +7680,8 @@
               </a:rPr>
               <a:t>测评指标</a:t>
             </a:r>
-          </a:p>
-          <a:p>
-            <a:pPr algn="l" latinLnBrk="0">
-              <a:lnSpc>
-                <a:spcPct val="100000"/>
-              </a:lnSpc>
-              <a:spcBef>
-                <a:spcPts val="0"/>
-              </a:spcBef>
-              <a:spcAft>
-                <a:spcPts val="0"/>
-              </a:spcAft>
-            </a:pPr>
-            <a:r>
-              <a:rPr sz="900" b="0">
+            <a:r>
+              <a:rPr sz="950" b="0">
                 <a:solidFill>
                   <a:srgbClr val="6B7280"/>
                 </a:solidFill>
@@ -7252,21 +7689,21 @@
                 <a:ea typeface="Microsoft YaHei"/>
                 <a:cs typeface="Microsoft YaHei"/>
               </a:rPr>
-              <a:t>预测值与实测值</a:t>
+              <a:t>　预测值与实测值</a:t>
             </a:r>
           </a:p>
         </p:txBody>
       </p:sp>
       <p:cxnSp>
         <p:nvCxnSpPr>
-          <p:cNvPr id="28" name="Connector 27"/>
+          <p:cNvPr id="47" name="Connector 46"/>
           <p:cNvCxnSpPr/>
           <p:nvPr/>
         </p:nvCxnSpPr>
         <p:spPr>
           <a:xfrm>
-            <a:off x="3767328" y="4334256"/>
-            <a:ext cx="0" cy="347472"/>
+            <a:off x="8577072" y="4279392"/>
+            <a:ext cx="3038551" cy="0"/>
           </a:xfrm>
           <a:prstGeom prst="line">
             <a:avLst/>
@@ -7280,14 +7717,14 @@
       </p:cxnSp>
       <p:sp>
         <p:nvSpPr>
-          <p:cNvPr id="29" name="TextBox 28"/>
+          <p:cNvPr id="48" name="TextBox 47"/>
           <p:cNvSpPr txBox="1"/>
           <p:nvPr/>
         </p:nvSpPr>
         <p:spPr>
           <a:xfrm>
-            <a:off x="3767328" y="4224528"/>
-            <a:ext cx="1214871" cy="566928"/>
+            <a:off x="8412480" y="4279392"/>
+            <a:ext cx="1325880" cy="325526"/>
           </a:xfrm>
           <a:prstGeom prst="rect">
             <a:avLst/>
@@ -7295,7 +7732,7 @@
           <a:noFill/>
         </p:spPr>
         <p:txBody>
-          <a:bodyPr wrap="square" anchor="ctr" lIns="128016" tIns="18288" rIns="73152" bIns="18288">
+          <a:bodyPr wrap="square" anchor="ctr" lIns="164592" tIns="0" rIns="36576" bIns="0">
             <a:noAutofit/>
           </a:bodyPr>
           <a:lstStyle/>
@@ -7308,37 +7745,60 @@
                 <a:spcPts val="0"/>
               </a:spcBef>
               <a:spcAft>
-                <a:spcPts val="100"/>
-              </a:spcAft>
-            </a:pPr>
-            <a:r>
-              <a:rPr sz="1000" b="1">
+                <a:spcPts val="0"/>
+              </a:spcAft>
+            </a:pPr>
+            <a:r>
+              <a:rPr sz="1100" b="1">
+                <a:solidFill>
+                  <a:srgbClr val="1D4ED8"/>
+                </a:solidFill>
+                <a:latin typeface="Microsoft YaHei"/>
+                <a:ea typeface="Microsoft YaHei"/>
+                <a:cs typeface="Microsoft YaHei"/>
+              </a:rPr>
+              <a:t>TTFT</a:t>
+            </a:r>
+          </a:p>
+        </p:txBody>
+      </p:sp>
+      <p:sp>
+        <p:nvSpPr>
+          <p:cNvPr id="49" name="TextBox 48"/>
+          <p:cNvSpPr txBox="1"/>
+          <p:nvPr/>
+        </p:nvSpPr>
+        <p:spPr>
+          <a:xfrm>
+            <a:off x="9738359" y="4279392"/>
+            <a:ext cx="2041855" cy="325526"/>
+          </a:xfrm>
+          <a:prstGeom prst="rect">
+            <a:avLst/>
+          </a:prstGeom>
+          <a:noFill/>
+        </p:spPr>
+        <p:txBody>
+          <a:bodyPr wrap="square" anchor="ctr" lIns="36576" tIns="0" rIns="164592" bIns="0">
+            <a:noAutofit/>
+          </a:bodyPr>
+          <a:lstStyle/>
+          <a:p>
+            <a:pPr algn="r" latinLnBrk="0">
+              <a:lnSpc>
+                <a:spcPct val="100000"/>
+              </a:lnSpc>
+              <a:spcBef>
+                <a:spcPts val="0"/>
+              </a:spcBef>
+              <a:spcAft>
+                <a:spcPts val="0"/>
+              </a:spcAft>
+            </a:pPr>
+            <a:r>
+              <a:rPr sz="1000" b="0">
                 <a:solidFill>
                   <a:srgbClr val="374151"/>
-                </a:solidFill>
-                <a:latin typeface="Microsoft YaHei"/>
-                <a:ea typeface="Microsoft YaHei"/>
-                <a:cs typeface="Microsoft YaHei"/>
-              </a:rPr>
-              <a:t>TTFT</a:t>
-            </a:r>
-          </a:p>
-          <a:p>
-            <a:pPr algn="l" latinLnBrk="0">
-              <a:lnSpc>
-                <a:spcPct val="100000"/>
-              </a:lnSpc>
-              <a:spcBef>
-                <a:spcPts val="0"/>
-              </a:spcBef>
-              <a:spcAft>
-                <a:spcPts val="0"/>
-              </a:spcAft>
-            </a:pPr>
-            <a:r>
-              <a:rPr sz="900" b="0">
-                <a:solidFill>
-                  <a:srgbClr val="6B7280"/>
                 </a:solidFill>
                 <a:latin typeface="Microsoft YaHei"/>
                 <a:ea typeface="Microsoft YaHei"/>
@@ -7351,14 +7811,14 @@
       </p:sp>
       <p:cxnSp>
         <p:nvCxnSpPr>
-          <p:cNvPr id="30" name="Connector 29"/>
+          <p:cNvPr id="50" name="Connector 49"/>
           <p:cNvCxnSpPr/>
           <p:nvPr/>
         </p:nvCxnSpPr>
         <p:spPr>
           <a:xfrm>
-            <a:off x="4982199" y="4334256"/>
-            <a:ext cx="0" cy="347472"/>
+            <a:off x="8577072" y="4604918"/>
+            <a:ext cx="3038551" cy="0"/>
           </a:xfrm>
           <a:prstGeom prst="line">
             <a:avLst/>
@@ -7372,14 +7832,14 @@
       </p:cxnSp>
       <p:sp>
         <p:nvSpPr>
-          <p:cNvPr id="31" name="TextBox 30"/>
+          <p:cNvPr id="51" name="TextBox 50"/>
           <p:cNvSpPr txBox="1"/>
           <p:nvPr/>
         </p:nvSpPr>
         <p:spPr>
           <a:xfrm>
-            <a:off x="4982199" y="4224528"/>
-            <a:ext cx="1214871" cy="566928"/>
+            <a:off x="8412480" y="4604918"/>
+            <a:ext cx="1325880" cy="325526"/>
           </a:xfrm>
           <a:prstGeom prst="rect">
             <a:avLst/>
@@ -7387,7 +7847,7 @@
           <a:noFill/>
         </p:spPr>
         <p:txBody>
-          <a:bodyPr wrap="square" anchor="ctr" lIns="128016" tIns="18288" rIns="73152" bIns="18288">
+          <a:bodyPr wrap="square" anchor="ctr" lIns="164592" tIns="0" rIns="36576" bIns="0">
             <a:noAutofit/>
           </a:bodyPr>
           <a:lstStyle/>
@@ -7400,37 +7860,60 @@
                 <a:spcPts val="0"/>
               </a:spcBef>
               <a:spcAft>
-                <a:spcPts val="100"/>
-              </a:spcAft>
-            </a:pPr>
-            <a:r>
-              <a:rPr sz="1000" b="1">
+                <a:spcPts val="0"/>
+              </a:spcAft>
+            </a:pPr>
+            <a:r>
+              <a:rPr sz="1100" b="1">
+                <a:solidFill>
+                  <a:srgbClr val="1D4ED8"/>
+                </a:solidFill>
+                <a:latin typeface="Microsoft YaHei"/>
+                <a:ea typeface="Microsoft YaHei"/>
+                <a:cs typeface="Microsoft YaHei"/>
+              </a:rPr>
+              <a:t>TPOT</a:t>
+            </a:r>
+          </a:p>
+        </p:txBody>
+      </p:sp>
+      <p:sp>
+        <p:nvSpPr>
+          <p:cNvPr id="52" name="TextBox 51"/>
+          <p:cNvSpPr txBox="1"/>
+          <p:nvPr/>
+        </p:nvSpPr>
+        <p:spPr>
+          <a:xfrm>
+            <a:off x="9738359" y="4604918"/>
+            <a:ext cx="2041855" cy="325526"/>
+          </a:xfrm>
+          <a:prstGeom prst="rect">
+            <a:avLst/>
+          </a:prstGeom>
+          <a:noFill/>
+        </p:spPr>
+        <p:txBody>
+          <a:bodyPr wrap="square" anchor="ctr" lIns="36576" tIns="0" rIns="164592" bIns="0">
+            <a:noAutofit/>
+          </a:bodyPr>
+          <a:lstStyle/>
+          <a:p>
+            <a:pPr algn="r" latinLnBrk="0">
+              <a:lnSpc>
+                <a:spcPct val="100000"/>
+              </a:lnSpc>
+              <a:spcBef>
+                <a:spcPts val="0"/>
+              </a:spcBef>
+              <a:spcAft>
+                <a:spcPts val="0"/>
+              </a:spcAft>
+            </a:pPr>
+            <a:r>
+              <a:rPr sz="1000" b="0">
                 <a:solidFill>
                   <a:srgbClr val="374151"/>
-                </a:solidFill>
-                <a:latin typeface="Microsoft YaHei"/>
-                <a:ea typeface="Microsoft YaHei"/>
-                <a:cs typeface="Microsoft YaHei"/>
-              </a:rPr>
-              <a:t>TPOT</a:t>
-            </a:r>
-          </a:p>
-          <a:p>
-            <a:pPr algn="l" latinLnBrk="0">
-              <a:lnSpc>
-                <a:spcPct val="100000"/>
-              </a:lnSpc>
-              <a:spcBef>
-                <a:spcPts val="0"/>
-              </a:spcBef>
-              <a:spcAft>
-                <a:spcPts val="0"/>
-              </a:spcAft>
-            </a:pPr>
-            <a:r>
-              <a:rPr sz="900" b="0">
-                <a:solidFill>
-                  <a:srgbClr val="6B7280"/>
                 </a:solidFill>
                 <a:latin typeface="Microsoft YaHei"/>
                 <a:ea typeface="Microsoft YaHei"/>
@@ -7443,14 +7926,14 @@
       </p:sp>
       <p:cxnSp>
         <p:nvCxnSpPr>
-          <p:cNvPr id="32" name="Connector 31"/>
+          <p:cNvPr id="53" name="Connector 52"/>
           <p:cNvCxnSpPr/>
           <p:nvPr/>
         </p:nvCxnSpPr>
         <p:spPr>
           <a:xfrm>
-            <a:off x="6197071" y="4334256"/>
-            <a:ext cx="0" cy="347472"/>
+            <a:off x="8577072" y="4930444"/>
+            <a:ext cx="3038551" cy="0"/>
           </a:xfrm>
           <a:prstGeom prst="line">
             <a:avLst/>
@@ -7464,14 +7947,14 @@
       </p:cxnSp>
       <p:sp>
         <p:nvSpPr>
-          <p:cNvPr id="33" name="TextBox 32"/>
+          <p:cNvPr id="54" name="TextBox 53"/>
           <p:cNvSpPr txBox="1"/>
           <p:nvPr/>
         </p:nvSpPr>
         <p:spPr>
           <a:xfrm>
-            <a:off x="6197071" y="4224528"/>
-            <a:ext cx="1214871" cy="566928"/>
+            <a:off x="8412480" y="4930444"/>
+            <a:ext cx="1325880" cy="325526"/>
           </a:xfrm>
           <a:prstGeom prst="rect">
             <a:avLst/>
@@ -7479,7 +7962,7 @@
           <a:noFill/>
         </p:spPr>
         <p:txBody>
-          <a:bodyPr wrap="square" anchor="ctr" lIns="128016" tIns="18288" rIns="73152" bIns="18288">
+          <a:bodyPr wrap="square" anchor="ctr" lIns="164592" tIns="0" rIns="36576" bIns="0">
             <a:noAutofit/>
           </a:bodyPr>
           <a:lstStyle/>
@@ -7492,37 +7975,60 @@
                 <a:spcPts val="0"/>
               </a:spcBef>
               <a:spcAft>
-                <a:spcPts val="100"/>
-              </a:spcAft>
-            </a:pPr>
-            <a:r>
-              <a:rPr sz="1000" b="1">
+                <a:spcPts val="0"/>
+              </a:spcAft>
+            </a:pPr>
+            <a:r>
+              <a:rPr sz="1100" b="1">
+                <a:solidFill>
+                  <a:srgbClr val="1D4ED8"/>
+                </a:solidFill>
+                <a:latin typeface="Microsoft YaHei"/>
+                <a:ea typeface="Microsoft YaHei"/>
+                <a:cs typeface="Microsoft YaHei"/>
+              </a:rPr>
+              <a:t>输出吞吐</a:t>
+            </a:r>
+          </a:p>
+        </p:txBody>
+      </p:sp>
+      <p:sp>
+        <p:nvSpPr>
+          <p:cNvPr id="55" name="TextBox 54"/>
+          <p:cNvSpPr txBox="1"/>
+          <p:nvPr/>
+        </p:nvSpPr>
+        <p:spPr>
+          <a:xfrm>
+            <a:off x="9738359" y="4930444"/>
+            <a:ext cx="2041855" cy="325526"/>
+          </a:xfrm>
+          <a:prstGeom prst="rect">
+            <a:avLst/>
+          </a:prstGeom>
+          <a:noFill/>
+        </p:spPr>
+        <p:txBody>
+          <a:bodyPr wrap="square" anchor="ctr" lIns="36576" tIns="0" rIns="164592" bIns="0">
+            <a:noAutofit/>
+          </a:bodyPr>
+          <a:lstStyle/>
+          <a:p>
+            <a:pPr algn="r" latinLnBrk="0">
+              <a:lnSpc>
+                <a:spcPct val="100000"/>
+              </a:lnSpc>
+              <a:spcBef>
+                <a:spcPts val="0"/>
+              </a:spcBef>
+              <a:spcAft>
+                <a:spcPts val="0"/>
+              </a:spcAft>
+            </a:pPr>
+            <a:r>
+              <a:rPr sz="1000" b="0">
                 <a:solidFill>
                   <a:srgbClr val="374151"/>
-                </a:solidFill>
-                <a:latin typeface="Microsoft YaHei"/>
-                <a:ea typeface="Microsoft YaHei"/>
-                <a:cs typeface="Microsoft YaHei"/>
-              </a:rPr>
-              <a:t>输出吞吐</a:t>
-            </a:r>
-          </a:p>
-          <a:p>
-            <a:pPr algn="l" latinLnBrk="0">
-              <a:lnSpc>
-                <a:spcPct val="100000"/>
-              </a:lnSpc>
-              <a:spcBef>
-                <a:spcPts val="0"/>
-              </a:spcBef>
-              <a:spcAft>
-                <a:spcPts val="0"/>
-              </a:spcAft>
-            </a:pPr>
-            <a:r>
-              <a:rPr sz="900" b="0">
-                <a:solidFill>
-                  <a:srgbClr val="6B7280"/>
                 </a:solidFill>
                 <a:latin typeface="Microsoft YaHei"/>
                 <a:ea typeface="Microsoft YaHei"/>
@@ -7535,14 +8041,14 @@
       </p:sp>
       <p:cxnSp>
         <p:nvCxnSpPr>
-          <p:cNvPr id="34" name="Connector 33"/>
+          <p:cNvPr id="56" name="Connector 55"/>
           <p:cNvCxnSpPr/>
           <p:nvPr/>
         </p:nvCxnSpPr>
         <p:spPr>
           <a:xfrm>
-            <a:off x="7411943" y="4334256"/>
-            <a:ext cx="0" cy="347472"/>
+            <a:off x="8577072" y="5255971"/>
+            <a:ext cx="3038551" cy="0"/>
           </a:xfrm>
           <a:prstGeom prst="line">
             <a:avLst/>
@@ -7556,14 +8062,14 @@
       </p:cxnSp>
       <p:sp>
         <p:nvSpPr>
-          <p:cNvPr id="35" name="TextBox 34"/>
+          <p:cNvPr id="57" name="TextBox 56"/>
           <p:cNvSpPr txBox="1"/>
           <p:nvPr/>
         </p:nvSpPr>
         <p:spPr>
           <a:xfrm>
-            <a:off x="7411943" y="4224528"/>
-            <a:ext cx="1214871" cy="566928"/>
+            <a:off x="8412480" y="5255971"/>
+            <a:ext cx="1325880" cy="325526"/>
           </a:xfrm>
           <a:prstGeom prst="rect">
             <a:avLst/>
@@ -7571,7 +8077,7 @@
           <a:noFill/>
         </p:spPr>
         <p:txBody>
-          <a:bodyPr wrap="square" anchor="ctr" lIns="128016" tIns="18288" rIns="73152" bIns="18288">
+          <a:bodyPr wrap="square" anchor="ctr" lIns="164592" tIns="0" rIns="36576" bIns="0">
             <a:noAutofit/>
           </a:bodyPr>
           <a:lstStyle/>
@@ -7584,37 +8090,60 @@
                 <a:spcPts val="0"/>
               </a:spcBef>
               <a:spcAft>
-                <a:spcPts val="100"/>
-              </a:spcAft>
-            </a:pPr>
-            <a:r>
-              <a:rPr sz="1000" b="1">
+                <a:spcPts val="0"/>
+              </a:spcAft>
+            </a:pPr>
+            <a:r>
+              <a:rPr sz="1100" b="1">
+                <a:solidFill>
+                  <a:srgbClr val="1D4ED8"/>
+                </a:solidFill>
+                <a:latin typeface="Microsoft YaHei"/>
+                <a:ea typeface="Microsoft YaHei"/>
+                <a:cs typeface="Microsoft YaHei"/>
+              </a:rPr>
+              <a:t>SLO 达成率</a:t>
+            </a:r>
+          </a:p>
+        </p:txBody>
+      </p:sp>
+      <p:sp>
+        <p:nvSpPr>
+          <p:cNvPr id="58" name="TextBox 57"/>
+          <p:cNvSpPr txBox="1"/>
+          <p:nvPr/>
+        </p:nvSpPr>
+        <p:spPr>
+          <a:xfrm>
+            <a:off x="9738359" y="5255971"/>
+            <a:ext cx="2041855" cy="325526"/>
+          </a:xfrm>
+          <a:prstGeom prst="rect">
+            <a:avLst/>
+          </a:prstGeom>
+          <a:noFill/>
+        </p:spPr>
+        <p:txBody>
+          <a:bodyPr wrap="square" anchor="ctr" lIns="36576" tIns="0" rIns="164592" bIns="0">
+            <a:noAutofit/>
+          </a:bodyPr>
+          <a:lstStyle/>
+          <a:p>
+            <a:pPr algn="r" latinLnBrk="0">
+              <a:lnSpc>
+                <a:spcPct val="100000"/>
+              </a:lnSpc>
+              <a:spcBef>
+                <a:spcPts val="0"/>
+              </a:spcBef>
+              <a:spcAft>
+                <a:spcPts val="0"/>
+              </a:spcAft>
+            </a:pPr>
+            <a:r>
+              <a:rPr sz="1000" b="0">
                 <a:solidFill>
                   <a:srgbClr val="374151"/>
-                </a:solidFill>
-                <a:latin typeface="Microsoft YaHei"/>
-                <a:ea typeface="Microsoft YaHei"/>
-                <a:cs typeface="Microsoft YaHei"/>
-              </a:rPr>
-              <a:t>SLO 达成率</a:t>
-            </a:r>
-          </a:p>
-          <a:p>
-            <a:pPr algn="l" latinLnBrk="0">
-              <a:lnSpc>
-                <a:spcPct val="100000"/>
-              </a:lnSpc>
-              <a:spcBef>
-                <a:spcPts val="0"/>
-              </a:spcBef>
-              <a:spcAft>
-                <a:spcPts val="0"/>
-              </a:spcAft>
-            </a:pPr>
-            <a:r>
-              <a:rPr sz="900" b="0">
-                <a:solidFill>
-                  <a:srgbClr val="6B7280"/>
                 </a:solidFill>
                 <a:latin typeface="Microsoft YaHei"/>
                 <a:ea typeface="Microsoft YaHei"/>
@@ -7627,14 +8156,14 @@
       </p:sp>
       <p:cxnSp>
         <p:nvCxnSpPr>
-          <p:cNvPr id="36" name="Connector 35"/>
+          <p:cNvPr id="59" name="Connector 58"/>
           <p:cNvCxnSpPr/>
           <p:nvPr/>
         </p:nvCxnSpPr>
         <p:spPr>
           <a:xfrm>
-            <a:off x="8626815" y="4334256"/>
-            <a:ext cx="0" cy="347472"/>
+            <a:off x="8577072" y="5581497"/>
+            <a:ext cx="3038551" cy="0"/>
           </a:xfrm>
           <a:prstGeom prst="line">
             <a:avLst/>
@@ -7648,14 +8177,14 @@
       </p:cxnSp>
       <p:sp>
         <p:nvSpPr>
-          <p:cNvPr id="37" name="TextBox 36"/>
+          <p:cNvPr id="60" name="TextBox 59"/>
           <p:cNvSpPr txBox="1"/>
           <p:nvPr/>
         </p:nvSpPr>
         <p:spPr>
           <a:xfrm>
-            <a:off x="8626815" y="4224528"/>
-            <a:ext cx="1214871" cy="566928"/>
+            <a:off x="8412480" y="5581497"/>
+            <a:ext cx="1325880" cy="325526"/>
           </a:xfrm>
           <a:prstGeom prst="rect">
             <a:avLst/>
@@ -7663,7 +8192,7 @@
           <a:noFill/>
         </p:spPr>
         <p:txBody>
-          <a:bodyPr wrap="square" anchor="ctr" lIns="128016" tIns="18288" rIns="73152" bIns="18288">
+          <a:bodyPr wrap="square" anchor="ctr" lIns="164592" tIns="0" rIns="36576" bIns="0">
             <a:noAutofit/>
           </a:bodyPr>
           <a:lstStyle/>
@@ -7676,11 +8205,58 @@
                 <a:spcPts val="0"/>
               </a:spcBef>
               <a:spcAft>
-                <a:spcPts val="100"/>
-              </a:spcAft>
-            </a:pPr>
-            <a:r>
-              <a:rPr sz="1000" b="1">
+                <a:spcPts val="0"/>
+              </a:spcAft>
+            </a:pPr>
+            <a:r>
+              <a:rPr sz="1100" b="1">
+                <a:solidFill>
+                  <a:srgbClr val="1D4ED8"/>
+                </a:solidFill>
+                <a:latin typeface="Microsoft YaHei"/>
+                <a:ea typeface="Microsoft YaHei"/>
+                <a:cs typeface="Microsoft YaHei"/>
+              </a:rPr>
+              <a:t>资源</a:t>
+            </a:r>
+          </a:p>
+        </p:txBody>
+      </p:sp>
+      <p:sp>
+        <p:nvSpPr>
+          <p:cNvPr id="61" name="TextBox 60"/>
+          <p:cNvSpPr txBox="1"/>
+          <p:nvPr/>
+        </p:nvSpPr>
+        <p:spPr>
+          <a:xfrm>
+            <a:off x="9738359" y="5581497"/>
+            <a:ext cx="2041855" cy="325526"/>
+          </a:xfrm>
+          <a:prstGeom prst="rect">
+            <a:avLst/>
+          </a:prstGeom>
+          <a:noFill/>
+        </p:spPr>
+        <p:txBody>
+          <a:bodyPr wrap="square" anchor="ctr" lIns="36576" tIns="0" rIns="164592" bIns="0">
+            <a:noAutofit/>
+          </a:bodyPr>
+          <a:lstStyle/>
+          <a:p>
+            <a:pPr algn="r" latinLnBrk="0">
+              <a:lnSpc>
+                <a:spcPct val="100000"/>
+              </a:lnSpc>
+              <a:spcBef>
+                <a:spcPts val="0"/>
+              </a:spcBef>
+              <a:spcAft>
+                <a:spcPts val="0"/>
+              </a:spcAft>
+            </a:pPr>
+            <a:r>
+              <a:rPr sz="1000" b="0">
                 <a:solidFill>
                   <a:srgbClr val="374151"/>
                 </a:solidFill>
@@ -7688,30 +8264,6 @@
                 <a:ea typeface="Microsoft YaHei"/>
                 <a:cs typeface="Microsoft YaHei"/>
               </a:rPr>
-              <a:t>资源</a:t>
-            </a:r>
-          </a:p>
-          <a:p>
-            <a:pPr algn="l" latinLnBrk="0">
-              <a:lnSpc>
-                <a:spcPct val="100000"/>
-              </a:lnSpc>
-              <a:spcBef>
-                <a:spcPts val="0"/>
-              </a:spcBef>
-              <a:spcAft>
-                <a:spcPts val="0"/>
-              </a:spcAft>
-            </a:pPr>
-            <a:r>
-              <a:rPr sz="900" b="0">
-                <a:solidFill>
-                  <a:srgbClr val="6B7280"/>
-                </a:solidFill>
-                <a:latin typeface="Microsoft YaHei"/>
-                <a:ea typeface="Microsoft YaHei"/>
-                <a:cs typeface="Microsoft YaHei"/>
-              </a:rPr>
               <a:t>卡数与实例数</a:t>
             </a:r>
           </a:p>
@@ -7719,14 +8271,14 @@
       </p:sp>
       <p:sp>
         <p:nvSpPr>
-          <p:cNvPr id="38" name="TextBox 37"/>
+          <p:cNvPr id="62" name="TextBox 61"/>
           <p:cNvSpPr txBox="1"/>
           <p:nvPr/>
         </p:nvSpPr>
         <p:spPr>
           <a:xfrm>
-            <a:off x="2715768" y="4882896"/>
-            <a:ext cx="7125919" cy="274320"/>
+            <a:off x="914400" y="4873752"/>
+            <a:ext cx="6858000" cy="274320"/>
           </a:xfrm>
           <a:prstGeom prst="rect">
             <a:avLst/>
@@ -7777,195 +8329,19 @@
       </p:sp>
       <p:sp>
         <p:nvSpPr>
-          <p:cNvPr id="39" name="Rectangle 38"/>
+          <p:cNvPr id="63" name="Rounded Rectangle 62"/>
           <p:cNvSpPr/>
           <p:nvPr/>
         </p:nvSpPr>
         <p:spPr>
           <a:xfrm>
             <a:off x="411480" y="5212080"/>
-            <a:ext cx="3545738" cy="786384"/>
-          </a:xfrm>
-          <a:prstGeom prst="rect">
-            <a:avLst/>
-          </a:prstGeom>
-          <a:solidFill>
-            <a:srgbClr val="FFF4EC"/>
-          </a:solidFill>
-          <a:ln w="12700">
-            <a:solidFill>
-              <a:srgbClr val="F3B58F"/>
-            </a:solidFill>
-          </a:ln>
-        </p:spPr>
-        <p:txBody>
-          <a:bodyPr rtlCol="0" anchor="ctr" wrap="square" lIns="146304" tIns="27432" rIns="109728" bIns="27432">
-            <a:noAutofit/>
-          </a:bodyPr>
-          <a:lstStyle/>
-          <a:p>
-            <a:pPr algn="l" latinLnBrk="0">
-              <a:lnSpc>
-                <a:spcPct val="100000"/>
-              </a:lnSpc>
-              <a:spcBef>
-                <a:spcPts val="0"/>
-              </a:spcBef>
-              <a:spcAft>
-                <a:spcPts val="200"/>
-              </a:spcAft>
-            </a:pPr>
-            <a:r>
-              <a:rPr sz="1100" b="1">
-                <a:solidFill>
-                  <a:srgbClr val="9A3412"/>
-                </a:solidFill>
-                <a:latin typeface="Microsoft YaHei"/>
-                <a:ea typeface="Microsoft YaHei"/>
-                <a:cs typeface="Microsoft YaHei"/>
-              </a:rPr>
-              <a:t>校准并重新选优</a:t>
-            </a:r>
-          </a:p>
-          <a:p>
-            <a:pPr algn="l" latinLnBrk="0">
-              <a:lnSpc>
-                <a:spcPct val="105000"/>
-              </a:lnSpc>
-              <a:spcBef>
-                <a:spcPts val="0"/>
-              </a:spcBef>
-              <a:spcAft>
-                <a:spcPts val="0"/>
-              </a:spcAft>
-            </a:pPr>
-            <a:r>
-              <a:rPr sz="950" b="0">
-                <a:solidFill>
-                  <a:srgbClr val="374151"/>
-                </a:solidFill>
-                <a:latin typeface="Microsoft YaHei"/>
-                <a:ea typeface="Microsoft YaHei"/>
-                <a:cs typeface="Microsoft YaHei"/>
-              </a:rPr>
-              <a:t>拟合 prefill / decode 系数，带校准重新规划部署</a:t>
-            </a:r>
-          </a:p>
-        </p:txBody>
-      </p:sp>
-      <p:sp>
-        <p:nvSpPr>
-          <p:cNvPr id="40" name="Rectangle 39"/>
-          <p:cNvSpPr/>
-          <p:nvPr/>
-        </p:nvSpPr>
-        <p:spPr>
-          <a:xfrm>
-            <a:off x="4322978" y="5212080"/>
-            <a:ext cx="3545738" cy="786384"/>
-          </a:xfrm>
-          <a:prstGeom prst="rect">
-            <a:avLst/>
-          </a:prstGeom>
-          <a:solidFill>
-            <a:srgbClr val="FFF4EC"/>
-          </a:solidFill>
-          <a:ln w="12700">
-            <a:solidFill>
-              <a:srgbClr val="F3B58F"/>
-            </a:solidFill>
-          </a:ln>
-        </p:spPr>
-        <p:txBody>
-          <a:bodyPr rtlCol="0" anchor="ctr" wrap="square" lIns="146304" tIns="27432" rIns="109728" bIns="27432">
-            <a:noAutofit/>
-          </a:bodyPr>
-          <a:lstStyle/>
-          <a:p>
-            <a:pPr algn="l" latinLnBrk="0">
-              <a:lnSpc>
-                <a:spcPct val="100000"/>
-              </a:lnSpc>
-              <a:spcBef>
-                <a:spcPts val="0"/>
-              </a:spcBef>
-              <a:spcAft>
-                <a:spcPts val="200"/>
-              </a:spcAft>
-            </a:pPr>
-            <a:r>
-              <a:rPr sz="1100" b="1">
-                <a:solidFill>
-                  <a:srgbClr val="9A3412"/>
-                </a:solidFill>
-                <a:latin typeface="Microsoft YaHei"/>
-                <a:ea typeface="Microsoft YaHei"/>
-                <a:cs typeface="Microsoft YaHei"/>
-              </a:rPr>
-              <a:t>自动比对</a:t>
-            </a:r>
-          </a:p>
-          <a:p>
-            <a:pPr algn="l" latinLnBrk="0">
-              <a:lnSpc>
-                <a:spcPct val="105000"/>
-              </a:lnSpc>
-              <a:spcBef>
-                <a:spcPts val="0"/>
-              </a:spcBef>
-              <a:spcAft>
-                <a:spcPts val="0"/>
-              </a:spcAft>
-            </a:pPr>
-            <a:r>
-              <a:rPr sz="950" b="0">
-                <a:solidFill>
-                  <a:srgbClr val="374151"/>
-                </a:solidFill>
-                <a:latin typeface="Microsoft YaHei"/>
-                <a:ea typeface="Microsoft YaHei"/>
-                <a:cs typeface="Microsoft YaHei"/>
-              </a:rPr>
-              <a:t>实测与预测逐项比对，超出 ±20% 判为偏差</a:t>
-            </a:r>
-          </a:p>
-        </p:txBody>
-      </p:sp>
-      <p:cxnSp>
-        <p:nvCxnSpPr>
-          <p:cNvPr id="41" name="Connector 40"/>
-          <p:cNvCxnSpPr/>
-          <p:nvPr/>
-        </p:nvCxnSpPr>
-        <p:spPr>
-          <a:xfrm flipH="1">
-            <a:off x="4012082" y="5605272"/>
-            <a:ext cx="256032" cy="0"/>
-          </a:xfrm>
-          <a:prstGeom prst="line">
-            <a:avLst/>
-          </a:prstGeom>
-          <a:ln w="22225">
-            <a:solidFill>
-              <a:srgbClr val="C2410C"/>
-            </a:solidFill>
-            <a:tailEnd type="triangle" w="med" len="med"/>
-          </a:ln>
-        </p:spPr>
-      </p:cxnSp>
-      <p:sp>
-        <p:nvSpPr>
-          <p:cNvPr id="42" name="Rectangle 41"/>
-          <p:cNvSpPr/>
-          <p:nvPr/>
-        </p:nvSpPr>
-        <p:spPr>
-          <a:xfrm>
-            <a:off x="8234476" y="5212080"/>
-            <a:ext cx="3545738" cy="786384"/>
-          </a:xfrm>
-          <a:prstGeom prst="rect">
-            <a:avLst/>
+            <a:ext cx="2650292" cy="768096"/>
+          </a:xfrm>
+          <a:prstGeom prst="roundRect">
+            <a:avLst>
+              <a:gd name="adj" fmla="val 12000"/>
+            </a:avLst>
           </a:prstGeom>
           <a:solidFill>
             <a:srgbClr val="FFFFFF"/>
@@ -8045,14 +8421,14 @@
       </p:sp>
       <p:cxnSp>
         <p:nvCxnSpPr>
-          <p:cNvPr id="43" name="Connector 42"/>
+          <p:cNvPr id="64" name="Connector 63"/>
           <p:cNvCxnSpPr/>
           <p:nvPr/>
         </p:nvCxnSpPr>
         <p:spPr>
-          <a:xfrm flipH="1">
-            <a:off x="7923580" y="5605272"/>
-            <a:ext cx="256032" cy="0"/>
+          <a:xfrm>
+            <a:off x="3116636" y="5596128"/>
+            <a:ext cx="219456" cy="0"/>
           </a:xfrm>
           <a:prstGeom prst="line">
             <a:avLst/>
@@ -8065,16 +8441,96 @@
           </a:ln>
         </p:spPr>
       </p:cxnSp>
+      <p:sp>
+        <p:nvSpPr>
+          <p:cNvPr id="65" name="Rounded Rectangle 64"/>
+          <p:cNvSpPr/>
+          <p:nvPr/>
+        </p:nvSpPr>
+        <p:spPr>
+          <a:xfrm>
+            <a:off x="3390956" y="5212080"/>
+            <a:ext cx="1920502" cy="768096"/>
+          </a:xfrm>
+          <a:prstGeom prst="roundRect">
+            <a:avLst>
+              <a:gd name="adj" fmla="val 12000"/>
+            </a:avLst>
+          </a:prstGeom>
+          <a:solidFill>
+            <a:srgbClr val="FFF4EC"/>
+          </a:solidFill>
+          <a:ln w="12700">
+            <a:solidFill>
+              <a:srgbClr val="F3B58F"/>
+            </a:solidFill>
+          </a:ln>
+        </p:spPr>
+        <p:txBody>
+          <a:bodyPr rtlCol="0" anchor="ctr" wrap="square" lIns="146304" tIns="27432" rIns="109728" bIns="27432">
+            <a:noAutofit/>
+          </a:bodyPr>
+          <a:lstStyle/>
+          <a:p>
+            <a:pPr algn="l" latinLnBrk="0">
+              <a:lnSpc>
+                <a:spcPct val="100000"/>
+              </a:lnSpc>
+              <a:spcBef>
+                <a:spcPts val="0"/>
+              </a:spcBef>
+              <a:spcAft>
+                <a:spcPts val="200"/>
+              </a:spcAft>
+            </a:pPr>
+            <a:r>
+              <a:rPr sz="1100" b="1">
+                <a:solidFill>
+                  <a:srgbClr val="9A3412"/>
+                </a:solidFill>
+                <a:latin typeface="Microsoft YaHei"/>
+                <a:ea typeface="Microsoft YaHei"/>
+                <a:cs typeface="Microsoft YaHei"/>
+              </a:rPr>
+              <a:t>自动比对</a:t>
+            </a:r>
+          </a:p>
+          <a:p>
+            <a:pPr algn="l" latinLnBrk="0">
+              <a:lnSpc>
+                <a:spcPct val="105000"/>
+              </a:lnSpc>
+              <a:spcBef>
+                <a:spcPts val="0"/>
+              </a:spcBef>
+              <a:spcAft>
+                <a:spcPts val="0"/>
+              </a:spcAft>
+            </a:pPr>
+            <a:r>
+              <a:rPr sz="950" b="0">
+                <a:solidFill>
+                  <a:srgbClr val="374151"/>
+                </a:solidFill>
+                <a:latin typeface="Microsoft YaHei"/>
+                <a:ea typeface="Microsoft YaHei"/>
+                <a:cs typeface="Microsoft YaHei"/>
+              </a:rPr>
+              <a:t>实测与预测逐项比对，超出 ±20% 判为偏差</a:t>
+            </a:r>
+          </a:p>
+        </p:txBody>
+      </p:sp>
       <p:cxnSp>
         <p:nvCxnSpPr>
-          <p:cNvPr id="44" name="Connector 43"/>
+          <p:cNvPr id="66" name="Connector 65"/>
           <p:cNvCxnSpPr/>
           <p:nvPr/>
         </p:nvCxnSpPr>
         <p:spPr>
           <a:xfrm>
-            <a:off x="10957255" y="4142232"/>
-            <a:ext cx="0" cy="1024128"/>
+            <a:off x="5366322" y="5596128"/>
+            <a:ext cx="219456" cy="0"/>
           </a:xfrm>
           <a:prstGeom prst="line">
             <a:avLst/>
@@ -8087,16 +8543,96 @@
           </a:ln>
         </p:spPr>
       </p:cxnSp>
+      <p:sp>
+        <p:nvSpPr>
+          <p:cNvPr id="67" name="Rounded Rectangle 66"/>
+          <p:cNvSpPr/>
+          <p:nvPr/>
+        </p:nvSpPr>
+        <p:spPr>
+          <a:xfrm>
+            <a:off x="5640642" y="5212080"/>
+            <a:ext cx="2131757" cy="768096"/>
+          </a:xfrm>
+          <a:prstGeom prst="roundRect">
+            <a:avLst>
+              <a:gd name="adj" fmla="val 12000"/>
+            </a:avLst>
+          </a:prstGeom>
+          <a:solidFill>
+            <a:srgbClr val="FFF4EC"/>
+          </a:solidFill>
+          <a:ln w="12700">
+            <a:solidFill>
+              <a:srgbClr val="F3B58F"/>
+            </a:solidFill>
+          </a:ln>
+        </p:spPr>
+        <p:txBody>
+          <a:bodyPr rtlCol="0" anchor="ctr" wrap="square" lIns="146304" tIns="27432" rIns="109728" bIns="27432">
+            <a:noAutofit/>
+          </a:bodyPr>
+          <a:lstStyle/>
+          <a:p>
+            <a:pPr algn="l" latinLnBrk="0">
+              <a:lnSpc>
+                <a:spcPct val="100000"/>
+              </a:lnSpc>
+              <a:spcBef>
+                <a:spcPts val="0"/>
+              </a:spcBef>
+              <a:spcAft>
+                <a:spcPts val="200"/>
+              </a:spcAft>
+            </a:pPr>
+            <a:r>
+              <a:rPr sz="1100" b="1">
+                <a:solidFill>
+                  <a:srgbClr val="9A3412"/>
+                </a:solidFill>
+                <a:latin typeface="Microsoft YaHei"/>
+                <a:ea typeface="Microsoft YaHei"/>
+                <a:cs typeface="Microsoft YaHei"/>
+              </a:rPr>
+              <a:t>校准并重新选优</a:t>
+            </a:r>
+          </a:p>
+          <a:p>
+            <a:pPr algn="l" latinLnBrk="0">
+              <a:lnSpc>
+                <a:spcPct val="105000"/>
+              </a:lnSpc>
+              <a:spcBef>
+                <a:spcPts val="0"/>
+              </a:spcBef>
+              <a:spcAft>
+                <a:spcPts val="0"/>
+              </a:spcAft>
+            </a:pPr>
+            <a:r>
+              <a:rPr sz="950" b="0">
+                <a:solidFill>
+                  <a:srgbClr val="374151"/>
+                </a:solidFill>
+                <a:latin typeface="Microsoft YaHei"/>
+                <a:ea typeface="Microsoft YaHei"/>
+                <a:cs typeface="Microsoft YaHei"/>
+              </a:rPr>
+              <a:t>拟合 prefill / decode 系数，带校准重新规划部署</a:t>
+            </a:r>
+          </a:p>
+        </p:txBody>
+      </p:sp>
       <p:cxnSp>
         <p:nvCxnSpPr>
-          <p:cNvPr id="45" name="Connector 44"/>
+          <p:cNvPr id="68" name="Connector 67"/>
           <p:cNvCxnSpPr/>
           <p:nvPr/>
         </p:nvCxnSpPr>
         <p:spPr>
-          <a:xfrm flipV="1">
-            <a:off x="1417320" y="4142232"/>
-            <a:ext cx="0" cy="1024128"/>
+          <a:xfrm>
+            <a:off x="612648" y="4709159"/>
+            <a:ext cx="0" cy="466345"/>
           </a:xfrm>
           <a:prstGeom prst="line">
             <a:avLst/>
@@ -8111,7 +8647,57 @@
       </p:cxnSp>
       <p:sp>
         <p:nvSpPr>
-          <p:cNvPr id="46" name="TextBox 45"/>
+          <p:cNvPr id="69" name="Freeform 68"/>
+          <p:cNvSpPr/>
+          <p:nvPr/>
+        </p:nvSpPr>
+        <p:spPr>
+          <a:xfrm>
+            <a:off x="7808975" y="2587752"/>
+            <a:ext cx="283465" cy="3008376"/>
+          </a:xfrm>
+          <a:custGeom>
+            <a:avLst/>
+            <a:gdLst/>
+            <a:ahLst/>
+            <a:cxnLst/>
+            <a:rect l="l" t="t" r="r" b="b"/>
+            <a:pathLst>
+              <a:path w="283465" h="3008376">
+                <a:moveTo>
+                  <a:pt x="0" y="3008376"/>
+                </a:moveTo>
+                <a:lnTo>
+                  <a:pt x="283465" y="3008376"/>
+                </a:lnTo>
+                <a:lnTo>
+                  <a:pt x="283465" y="0"/>
+                </a:lnTo>
+                <a:lnTo>
+                  <a:pt x="18289" y="0"/>
+                </a:lnTo>
+              </a:path>
+            </a:pathLst>
+          </a:custGeom>
+          <a:noFill/>
+          <a:ln w="22225">
+            <a:solidFill>
+              <a:srgbClr val="C2410C"/>
+            </a:solidFill>
+            <a:tailEnd type="triangle" w="med" len="med"/>
+          </a:ln>
+        </p:spPr>
+        <p:txBody>
+          <a:bodyPr rtlCol="0" anchor="ctr"/>
+          <a:lstStyle/>
+          <a:p>
+            <a:pPr algn="ctr"/>
+          </a:p>
+        </p:txBody>
+      </p:sp>
+      <p:sp>
+        <p:nvSpPr>
+          <p:cNvPr id="70" name="TextBox 69"/>
           <p:cNvSpPr txBox="1"/>
           <p:nvPr/>
         </p:nvSpPr>
@@ -8158,7 +8744,7 @@
       </p:sp>
       <p:sp>
         <p:nvSpPr>
-          <p:cNvPr id="47" name="Rectangle 46"/>
+          <p:cNvPr id="71" name="Rectangle 70"/>
           <p:cNvSpPr/>
           <p:nvPr/>
         </p:nvSpPr>
@@ -8190,7 +8776,7 @@
       </p:sp>
       <p:sp>
         <p:nvSpPr>
-          <p:cNvPr id="48" name="TextBox 47"/>
+          <p:cNvPr id="72" name="TextBox 71"/>
           <p:cNvSpPr txBox="1"/>
           <p:nvPr/>
         </p:nvSpPr>

</xml_diff>

<commit_message>
Add an operator performance optimization slide
</commit_message>
<xml_diff>
--- a/slides/sglang_maestro_workflow.pptx
+++ b/slides/sglang_maestro_workflow.pptx
@@ -7,6 +7,7 @@
   <p:sldIdLst>
     <p:sldId id="256" r:id="rId7"/>
     <p:sldId id="257" r:id="rId8"/>
+    <p:sldId id="258" r:id="rId9"/>
   </p:sldIdLst>
   <p:sldSz cx="12191695" cy="6858000" type="screen4x3"/>
   <p:notesSz cx="6858000" cy="9144000"/>
@@ -8817,6 +8818,4586 @@
                 <a:cs typeface="Microsoft YaHei"/>
               </a:rPr>
               <a:t>虚线框：规划中，目前由人按输出的命令执行</a:t>
+            </a:r>
+          </a:p>
+        </p:txBody>
+      </p:sp>
+    </p:spTree>
+  </p:cSld>
+  <p:clrMapOvr>
+    <a:masterClrMapping/>
+  </p:clrMapOvr>
+</p:sld>
+</file>
+
+<file path=ppt/slides/slide3.xml><?xml version="1.0" encoding="utf-8"?>
+<p:sld xmlns:a="http://schemas.openxmlformats.org/drawingml/2006/main" xmlns:p="http://schemas.openxmlformats.org/presentationml/2006/main" xmlns:r="http://schemas.openxmlformats.org/officeDocument/2006/relationships">
+  <p:cSld>
+    <p:spTree>
+      <p:nvGrpSpPr>
+        <p:cNvPr id="1" name=""/>
+        <p:cNvGrpSpPr/>
+        <p:nvPr/>
+      </p:nvGrpSpPr>
+      <p:grpSpPr/>
+      <p:sp>
+        <p:nvSpPr>
+          <p:cNvPr id="2" name="Rectangle 1"/>
+          <p:cNvSpPr/>
+          <p:nvPr/>
+        </p:nvSpPr>
+        <p:spPr>
+          <a:xfrm>
+            <a:off x="411480" y="365760"/>
+            <a:ext cx="64008" cy="384048"/>
+          </a:xfrm>
+          <a:prstGeom prst="rect">
+            <a:avLst/>
+          </a:prstGeom>
+          <a:solidFill>
+            <a:srgbClr val="1D4ED8"/>
+          </a:solidFill>
+          <a:ln>
+            <a:noFill/>
+          </a:ln>
+        </p:spPr>
+        <p:txBody>
+          <a:bodyPr rtlCol="0" anchor="ctr"/>
+          <a:lstStyle/>
+          <a:p>
+            <a:pPr algn="ctr"/>
+          </a:p>
+        </p:txBody>
+      </p:sp>
+      <p:sp>
+        <p:nvSpPr>
+          <p:cNvPr id="3" name="TextBox 2"/>
+          <p:cNvSpPr txBox="1"/>
+          <p:nvPr/>
+        </p:nvSpPr>
+        <p:spPr>
+          <a:xfrm>
+            <a:off x="594360" y="274320"/>
+            <a:ext cx="10058400" cy="548640"/>
+          </a:xfrm>
+          <a:prstGeom prst="rect">
+            <a:avLst/>
+          </a:prstGeom>
+          <a:noFill/>
+        </p:spPr>
+        <p:txBody>
+          <a:bodyPr wrap="square" anchor="ctr" lIns="0" tIns="0" rIns="0" bIns="0">
+            <a:noAutofit/>
+          </a:bodyPr>
+          <a:lstStyle/>
+          <a:p>
+            <a:pPr algn="l" latinLnBrk="0">
+              <a:lnSpc>
+                <a:spcPct val="100000"/>
+              </a:lnSpc>
+              <a:spcBef>
+                <a:spcPts val="0"/>
+              </a:spcBef>
+              <a:spcAft>
+                <a:spcPts val="0"/>
+              </a:spcAft>
+            </a:pPr>
+            <a:r>
+              <a:rPr sz="2600" b="1">
+                <a:solidFill>
+                  <a:srgbClr val="1F2937"/>
+                </a:solidFill>
+                <a:latin typeface="Microsoft YaHei"/>
+                <a:ea typeface="Microsoft YaHei"/>
+                <a:cs typeface="Microsoft YaHei"/>
+              </a:rPr>
+              <a:t>场景 2 深入：Agent 算子性能优化</a:t>
+            </a:r>
+          </a:p>
+        </p:txBody>
+      </p:sp>
+      <p:sp>
+        <p:nvSpPr>
+          <p:cNvPr id="4" name="TextBox 3"/>
+          <p:cNvSpPr txBox="1"/>
+          <p:nvPr/>
+        </p:nvSpPr>
+        <p:spPr>
+          <a:xfrm>
+            <a:off x="411480" y="822960"/>
+            <a:ext cx="11368735" cy="365760"/>
+          </a:xfrm>
+          <a:prstGeom prst="rect">
+            <a:avLst/>
+          </a:prstGeom>
+          <a:noFill/>
+        </p:spPr>
+        <p:txBody>
+          <a:bodyPr wrap="square" anchor="ctr" lIns="0" tIns="0" rIns="0" bIns="0">
+            <a:noAutofit/>
+          </a:bodyPr>
+          <a:lstStyle/>
+          <a:p>
+            <a:pPr algn="l" latinLnBrk="0">
+              <a:lnSpc>
+                <a:spcPct val="100000"/>
+              </a:lnSpc>
+              <a:spcBef>
+                <a:spcPts val="0"/>
+              </a:spcBef>
+              <a:spcAft>
+                <a:spcPts val="0"/>
+              </a:spcAft>
+            </a:pPr>
+            <a:r>
+              <a:rPr sz="1350" b="0">
+                <a:solidFill>
+                  <a:srgbClr val="6B7280"/>
+                </a:solidFill>
+                <a:latin typeface="Microsoft YaHei"/>
+                <a:ea typeface="Microsoft YaHei"/>
+                <a:cs typeface="Microsoft YaHei"/>
+              </a:rPr>
+              <a:t>每轮自动抓 trace、排热点、判瓶颈，结合芯片特性选择优化手段并预估收益；精度和收益都验证通过才保留，然后进入下一轮</a:t>
+            </a:r>
+          </a:p>
+        </p:txBody>
+      </p:sp>
+      <p:sp>
+        <p:nvSpPr>
+          <p:cNvPr id="5" name="TextBox 4"/>
+          <p:cNvSpPr txBox="1"/>
+          <p:nvPr/>
+        </p:nvSpPr>
+        <p:spPr>
+          <a:xfrm>
+            <a:off x="411480" y="1325880"/>
+            <a:ext cx="4480559" cy="274320"/>
+          </a:xfrm>
+          <a:prstGeom prst="rect">
+            <a:avLst/>
+          </a:prstGeom>
+          <a:noFill/>
+        </p:spPr>
+        <p:txBody>
+          <a:bodyPr wrap="square" anchor="ctr" lIns="0" tIns="0" rIns="0" bIns="0">
+            <a:noAutofit/>
+          </a:bodyPr>
+          <a:lstStyle/>
+          <a:p>
+            <a:pPr algn="l" latinLnBrk="0">
+              <a:lnSpc>
+                <a:spcPct val="100000"/>
+              </a:lnSpc>
+              <a:spcBef>
+                <a:spcPts val="0"/>
+              </a:spcBef>
+              <a:spcAft>
+                <a:spcPts val="0"/>
+              </a:spcAft>
+            </a:pPr>
+            <a:r>
+              <a:rPr sz="1100" b="1">
+                <a:solidFill>
+                  <a:srgbClr val="1D4ED8"/>
+                </a:solidFill>
+                <a:latin typeface="Microsoft YaHei"/>
+                <a:ea typeface="Microsoft YaHei"/>
+                <a:cs typeface="Microsoft YaHei"/>
+              </a:rPr>
+              <a:t>Agent 怎么做</a:t>
+            </a:r>
+            <a:r>
+              <a:rPr sz="1000" b="0">
+                <a:solidFill>
+                  <a:srgbClr val="6B7280"/>
+                </a:solidFill>
+                <a:latin typeface="Microsoft YaHei"/>
+                <a:ea typeface="Microsoft YaHei"/>
+                <a:cs typeface="Microsoft YaHei"/>
+              </a:rPr>
+              <a:t>　六个环节，循环推进</a:t>
+            </a:r>
+          </a:p>
+        </p:txBody>
+      </p:sp>
+      <p:sp>
+        <p:nvSpPr>
+          <p:cNvPr id="6" name="Oval 5"/>
+          <p:cNvSpPr/>
+          <p:nvPr/>
+        </p:nvSpPr>
+        <p:spPr>
+          <a:xfrm>
+            <a:off x="1051560" y="2139696"/>
+            <a:ext cx="3200400" cy="3255264"/>
+          </a:xfrm>
+          <a:prstGeom prst="ellipse">
+            <a:avLst/>
+          </a:prstGeom>
+          <a:noFill/>
+          <a:ln w="25400">
+            <a:solidFill>
+              <a:srgbClr val="C7D7FE"/>
+            </a:solidFill>
+          </a:ln>
+        </p:spPr>
+        <p:txBody>
+          <a:bodyPr rtlCol="0" anchor="ctr"/>
+          <a:lstStyle/>
+          <a:p>
+            <a:pPr algn="ctr"/>
+          </a:p>
+        </p:txBody>
+      </p:sp>
+      <p:sp>
+        <p:nvSpPr>
+          <p:cNvPr id="7" name="Oval 6"/>
+          <p:cNvSpPr/>
+          <p:nvPr/>
+        </p:nvSpPr>
+        <p:spPr>
+          <a:xfrm>
+            <a:off x="2011680" y="3127248"/>
+            <a:ext cx="1280160" cy="1280160"/>
+          </a:xfrm>
+          <a:prstGeom prst="ellipse">
+            <a:avLst/>
+          </a:prstGeom>
+          <a:solidFill>
+            <a:srgbClr val="F5F8FF"/>
+          </a:solidFill>
+          <a:ln>
+            <a:noFill/>
+          </a:ln>
+        </p:spPr>
+        <p:txBody>
+          <a:bodyPr rtlCol="0" anchor="ctr"/>
+          <a:lstStyle/>
+          <a:p>
+            <a:pPr algn="ctr"/>
+          </a:p>
+        </p:txBody>
+      </p:sp>
+      <p:sp>
+        <p:nvSpPr>
+          <p:cNvPr id="8" name="TextBox 7"/>
+          <p:cNvSpPr txBox="1"/>
+          <p:nvPr/>
+        </p:nvSpPr>
+        <p:spPr>
+          <a:xfrm>
+            <a:off x="2011680" y="3127248"/>
+            <a:ext cx="1280160" cy="1280160"/>
+          </a:xfrm>
+          <a:prstGeom prst="rect">
+            <a:avLst/>
+          </a:prstGeom>
+          <a:noFill/>
+        </p:spPr>
+        <p:txBody>
+          <a:bodyPr wrap="square" anchor="ctr" lIns="0" tIns="0" rIns="0" bIns="0">
+            <a:noAutofit/>
+          </a:bodyPr>
+          <a:lstStyle/>
+          <a:p>
+            <a:pPr algn="ctr" latinLnBrk="0">
+              <a:lnSpc>
+                <a:spcPct val="100000"/>
+              </a:lnSpc>
+              <a:spcBef>
+                <a:spcPts val="0"/>
+              </a:spcBef>
+              <a:spcAft>
+                <a:spcPts val="300"/>
+              </a:spcAft>
+            </a:pPr>
+            <a:r>
+              <a:rPr sz="1250" b="1">
+                <a:solidFill>
+                  <a:srgbClr val="1D4ED8"/>
+                </a:solidFill>
+                <a:latin typeface="Microsoft YaHei"/>
+                <a:ea typeface="Microsoft YaHei"/>
+                <a:cs typeface="Microsoft YaHei"/>
+              </a:rPr>
+              <a:t>算子优化闭环</a:t>
+            </a:r>
+          </a:p>
+          <a:p>
+            <a:pPr algn="ctr" latinLnBrk="0">
+              <a:lnSpc>
+                <a:spcPct val="100000"/>
+              </a:lnSpc>
+              <a:spcBef>
+                <a:spcPts val="0"/>
+              </a:spcBef>
+              <a:spcAft>
+                <a:spcPts val="0"/>
+              </a:spcAft>
+            </a:pPr>
+            <a:r>
+              <a:rPr sz="950" b="0">
+                <a:solidFill>
+                  <a:srgbClr val="6B7280"/>
+                </a:solidFill>
+                <a:latin typeface="Microsoft YaHei"/>
+                <a:ea typeface="Microsoft YaHei"/>
+                <a:cs typeface="Microsoft YaHei"/>
+              </a:rPr>
+              <a:t>每轮只攻</a:t>
+            </a:r>
+          </a:p>
+          <a:p>
+            <a:pPr algn="ctr" latinLnBrk="0">
+              <a:lnSpc>
+                <a:spcPct val="100000"/>
+              </a:lnSpc>
+              <a:spcBef>
+                <a:spcPts val="0"/>
+              </a:spcBef>
+              <a:spcAft>
+                <a:spcPts val="0"/>
+              </a:spcAft>
+            </a:pPr>
+            <a:r>
+              <a:rPr sz="950" b="0">
+                <a:solidFill>
+                  <a:srgbClr val="6B7280"/>
+                </a:solidFill>
+                <a:latin typeface="Microsoft YaHei"/>
+                <a:ea typeface="Microsoft YaHei"/>
+                <a:cs typeface="Microsoft YaHei"/>
+              </a:rPr>
+              <a:t>当前最大瓶颈</a:t>
+            </a:r>
+          </a:p>
+        </p:txBody>
+      </p:sp>
+      <p:sp>
+        <p:nvSpPr>
+          <p:cNvPr id="9" name="Rounded Rectangle 8"/>
+          <p:cNvSpPr/>
+          <p:nvPr/>
+        </p:nvSpPr>
+        <p:spPr>
+          <a:xfrm>
+            <a:off x="1920239" y="1847088"/>
+            <a:ext cx="1463040" cy="585216"/>
+          </a:xfrm>
+          <a:prstGeom prst="roundRect">
+            <a:avLst>
+              <a:gd name="adj" fmla="val 50000"/>
+            </a:avLst>
+          </a:prstGeom>
+          <a:solidFill>
+            <a:srgbClr val="FFFFFF"/>
+          </a:solidFill>
+          <a:ln w="15875">
+            <a:solidFill>
+              <a:srgbClr val="1D4ED8"/>
+            </a:solidFill>
+          </a:ln>
+        </p:spPr>
+        <p:txBody>
+          <a:bodyPr rtlCol="0" anchor="ctr" wrap="square" lIns="54864" tIns="18288" rIns="54864" bIns="18288">
+            <a:noAutofit/>
+          </a:bodyPr>
+          <a:lstStyle/>
+          <a:p>
+            <a:pPr algn="ctr" latinLnBrk="0">
+              <a:lnSpc>
+                <a:spcPct val="100000"/>
+              </a:lnSpc>
+              <a:spcBef>
+                <a:spcPts val="0"/>
+              </a:spcBef>
+              <a:spcAft>
+                <a:spcPts val="100"/>
+              </a:spcAft>
+            </a:pPr>
+            <a:r>
+              <a:rPr sz="1200" b="1">
+                <a:solidFill>
+                  <a:srgbClr val="1D4ED8"/>
+                </a:solidFill>
+                <a:latin typeface="Microsoft YaHei"/>
+                <a:ea typeface="Microsoft YaHei"/>
+                <a:cs typeface="Microsoft YaHei"/>
+              </a:rPr>
+              <a:t>1</a:t>
+            </a:r>
+            <a:r>
+              <a:rPr sz="1200" b="1">
+                <a:solidFill>
+                  <a:srgbClr val="1F2937"/>
+                </a:solidFill>
+                <a:latin typeface="Microsoft YaHei"/>
+                <a:ea typeface="Microsoft YaHei"/>
+                <a:cs typeface="Microsoft YaHei"/>
+              </a:rPr>
+              <a:t>  采集</a:t>
+            </a:r>
+          </a:p>
+          <a:p>
+            <a:pPr algn="ctr" latinLnBrk="0">
+              <a:lnSpc>
+                <a:spcPct val="100000"/>
+              </a:lnSpc>
+              <a:spcBef>
+                <a:spcPts val="0"/>
+              </a:spcBef>
+              <a:spcAft>
+                <a:spcPts val="0"/>
+              </a:spcAft>
+            </a:pPr>
+            <a:r>
+              <a:rPr sz="900" b="0">
+                <a:solidFill>
+                  <a:srgbClr val="6B7280"/>
+                </a:solidFill>
+                <a:latin typeface="Microsoft YaHei"/>
+                <a:ea typeface="Microsoft YaHei"/>
+                <a:cs typeface="Microsoft YaHei"/>
+              </a:rPr>
+              <a:t>抓 kernel 级 trace</a:t>
+            </a:r>
+          </a:p>
+        </p:txBody>
+      </p:sp>
+      <p:sp>
+        <p:nvSpPr>
+          <p:cNvPr id="10" name="Rounded Rectangle 9"/>
+          <p:cNvSpPr/>
+          <p:nvPr/>
+        </p:nvSpPr>
+        <p:spPr>
+          <a:xfrm>
+            <a:off x="3306053" y="2660904"/>
+            <a:ext cx="1463040" cy="585216"/>
+          </a:xfrm>
+          <a:prstGeom prst="roundRect">
+            <a:avLst>
+              <a:gd name="adj" fmla="val 50000"/>
+            </a:avLst>
+          </a:prstGeom>
+          <a:solidFill>
+            <a:srgbClr val="FFFFFF"/>
+          </a:solidFill>
+          <a:ln w="15875">
+            <a:solidFill>
+              <a:srgbClr val="1D4ED8"/>
+            </a:solidFill>
+          </a:ln>
+        </p:spPr>
+        <p:txBody>
+          <a:bodyPr rtlCol="0" anchor="ctr" wrap="square" lIns="54864" tIns="18288" rIns="54864" bIns="18288">
+            <a:noAutofit/>
+          </a:bodyPr>
+          <a:lstStyle/>
+          <a:p>
+            <a:pPr algn="ctr" latinLnBrk="0">
+              <a:lnSpc>
+                <a:spcPct val="100000"/>
+              </a:lnSpc>
+              <a:spcBef>
+                <a:spcPts val="0"/>
+              </a:spcBef>
+              <a:spcAft>
+                <a:spcPts val="100"/>
+              </a:spcAft>
+            </a:pPr>
+            <a:r>
+              <a:rPr sz="1200" b="1">
+                <a:solidFill>
+                  <a:srgbClr val="1D4ED8"/>
+                </a:solidFill>
+                <a:latin typeface="Microsoft YaHei"/>
+                <a:ea typeface="Microsoft YaHei"/>
+                <a:cs typeface="Microsoft YaHei"/>
+              </a:rPr>
+              <a:t>2</a:t>
+            </a:r>
+            <a:r>
+              <a:rPr sz="1200" b="1">
+                <a:solidFill>
+                  <a:srgbClr val="1F2937"/>
+                </a:solidFill>
+                <a:latin typeface="Microsoft YaHei"/>
+                <a:ea typeface="Microsoft YaHei"/>
+                <a:cs typeface="Microsoft YaHei"/>
+              </a:rPr>
+              <a:t>  定位</a:t>
+            </a:r>
+          </a:p>
+          <a:p>
+            <a:pPr algn="ctr" latinLnBrk="0">
+              <a:lnSpc>
+                <a:spcPct val="100000"/>
+              </a:lnSpc>
+              <a:spcBef>
+                <a:spcPts val="0"/>
+              </a:spcBef>
+              <a:spcAft>
+                <a:spcPts val="0"/>
+              </a:spcAft>
+            </a:pPr>
+            <a:r>
+              <a:rPr sz="900" b="0">
+                <a:solidFill>
+                  <a:srgbClr val="6B7280"/>
+                </a:solidFill>
+                <a:latin typeface="Microsoft YaHei"/>
+                <a:ea typeface="Microsoft YaHei"/>
+                <a:cs typeface="Microsoft YaHei"/>
+              </a:rPr>
+              <a:t>按耗时排出热点算子</a:t>
+            </a:r>
+          </a:p>
+        </p:txBody>
+      </p:sp>
+      <p:sp>
+        <p:nvSpPr>
+          <p:cNvPr id="11" name="Rounded Rectangle 10"/>
+          <p:cNvSpPr/>
+          <p:nvPr/>
+        </p:nvSpPr>
+        <p:spPr>
+          <a:xfrm>
+            <a:off x="3306053" y="4288536"/>
+            <a:ext cx="1463040" cy="585216"/>
+          </a:xfrm>
+          <a:prstGeom prst="roundRect">
+            <a:avLst>
+              <a:gd name="adj" fmla="val 50000"/>
+            </a:avLst>
+          </a:prstGeom>
+          <a:solidFill>
+            <a:srgbClr val="FFFFFF"/>
+          </a:solidFill>
+          <a:ln w="15875">
+            <a:solidFill>
+              <a:srgbClr val="1D4ED8"/>
+            </a:solidFill>
+          </a:ln>
+        </p:spPr>
+        <p:txBody>
+          <a:bodyPr rtlCol="0" anchor="ctr" wrap="square" lIns="54864" tIns="18288" rIns="54864" bIns="18288">
+            <a:noAutofit/>
+          </a:bodyPr>
+          <a:lstStyle/>
+          <a:p>
+            <a:pPr algn="ctr" latinLnBrk="0">
+              <a:lnSpc>
+                <a:spcPct val="100000"/>
+              </a:lnSpc>
+              <a:spcBef>
+                <a:spcPts val="0"/>
+              </a:spcBef>
+              <a:spcAft>
+                <a:spcPts val="100"/>
+              </a:spcAft>
+            </a:pPr>
+            <a:r>
+              <a:rPr sz="1200" b="1">
+                <a:solidFill>
+                  <a:srgbClr val="1D4ED8"/>
+                </a:solidFill>
+                <a:latin typeface="Microsoft YaHei"/>
+                <a:ea typeface="Microsoft YaHei"/>
+                <a:cs typeface="Microsoft YaHei"/>
+              </a:rPr>
+              <a:t>3</a:t>
+            </a:r>
+            <a:r>
+              <a:rPr sz="1200" b="1">
+                <a:solidFill>
+                  <a:srgbClr val="1F2937"/>
+                </a:solidFill>
+                <a:latin typeface="Microsoft YaHei"/>
+                <a:ea typeface="Microsoft YaHei"/>
+                <a:cs typeface="Microsoft YaHei"/>
+              </a:rPr>
+              <a:t>  诊断</a:t>
+            </a:r>
+          </a:p>
+          <a:p>
+            <a:pPr algn="ctr" latinLnBrk="0">
+              <a:lnSpc>
+                <a:spcPct val="100000"/>
+              </a:lnSpc>
+              <a:spcBef>
+                <a:spcPts val="0"/>
+              </a:spcBef>
+              <a:spcAft>
+                <a:spcPts val="0"/>
+              </a:spcAft>
+            </a:pPr>
+            <a:r>
+              <a:rPr sz="900" b="0">
+                <a:solidFill>
+                  <a:srgbClr val="6B7280"/>
+                </a:solidFill>
+                <a:latin typeface="Microsoft YaHei"/>
+                <a:ea typeface="Microsoft YaHei"/>
+                <a:cs typeface="Microsoft YaHei"/>
+              </a:rPr>
+              <a:t>判瓶颈、找异常</a:t>
+            </a:r>
+          </a:p>
+        </p:txBody>
+      </p:sp>
+      <p:sp>
+        <p:nvSpPr>
+          <p:cNvPr id="12" name="Rounded Rectangle 11"/>
+          <p:cNvSpPr/>
+          <p:nvPr/>
+        </p:nvSpPr>
+        <p:spPr>
+          <a:xfrm>
+            <a:off x="1920239" y="5102352"/>
+            <a:ext cx="1463040" cy="585216"/>
+          </a:xfrm>
+          <a:prstGeom prst="roundRect">
+            <a:avLst>
+              <a:gd name="adj" fmla="val 50000"/>
+            </a:avLst>
+          </a:prstGeom>
+          <a:solidFill>
+            <a:srgbClr val="FFFFFF"/>
+          </a:solidFill>
+          <a:ln w="15875">
+            <a:solidFill>
+              <a:srgbClr val="1D4ED8"/>
+            </a:solidFill>
+          </a:ln>
+        </p:spPr>
+        <p:txBody>
+          <a:bodyPr rtlCol="0" anchor="ctr" wrap="square" lIns="54864" tIns="18288" rIns="54864" bIns="18288">
+            <a:noAutofit/>
+          </a:bodyPr>
+          <a:lstStyle/>
+          <a:p>
+            <a:pPr algn="ctr" latinLnBrk="0">
+              <a:lnSpc>
+                <a:spcPct val="100000"/>
+              </a:lnSpc>
+              <a:spcBef>
+                <a:spcPts val="0"/>
+              </a:spcBef>
+              <a:spcAft>
+                <a:spcPts val="100"/>
+              </a:spcAft>
+            </a:pPr>
+            <a:r>
+              <a:rPr sz="1200" b="1">
+                <a:solidFill>
+                  <a:srgbClr val="1D4ED8"/>
+                </a:solidFill>
+                <a:latin typeface="Microsoft YaHei"/>
+                <a:ea typeface="Microsoft YaHei"/>
+                <a:cs typeface="Microsoft YaHei"/>
+              </a:rPr>
+              <a:t>4</a:t>
+            </a:r>
+            <a:r>
+              <a:rPr sz="1200" b="1">
+                <a:solidFill>
+                  <a:srgbClr val="1F2937"/>
+                </a:solidFill>
+                <a:latin typeface="Microsoft YaHei"/>
+                <a:ea typeface="Microsoft YaHei"/>
+                <a:cs typeface="Microsoft YaHei"/>
+              </a:rPr>
+              <a:t>  优化</a:t>
+            </a:r>
+          </a:p>
+          <a:p>
+            <a:pPr algn="ctr" latinLnBrk="0">
+              <a:lnSpc>
+                <a:spcPct val="100000"/>
+              </a:lnSpc>
+              <a:spcBef>
+                <a:spcPts val="0"/>
+              </a:spcBef>
+              <a:spcAft>
+                <a:spcPts val="0"/>
+              </a:spcAft>
+            </a:pPr>
+            <a:r>
+              <a:rPr sz="900" b="0">
+                <a:solidFill>
+                  <a:srgbClr val="6B7280"/>
+                </a:solidFill>
+                <a:latin typeface="Microsoft YaHei"/>
+                <a:ea typeface="Microsoft YaHei"/>
+                <a:cs typeface="Microsoft YaHei"/>
+              </a:rPr>
+              <a:t>对症选手段、估收益</a:t>
+            </a:r>
+          </a:p>
+        </p:txBody>
+      </p:sp>
+      <p:sp>
+        <p:nvSpPr>
+          <p:cNvPr id="13" name="Rounded Rectangle 12"/>
+          <p:cNvSpPr/>
+          <p:nvPr/>
+        </p:nvSpPr>
+        <p:spPr>
+          <a:xfrm>
+            <a:off x="534426" y="4288536"/>
+            <a:ext cx="1463040" cy="585216"/>
+          </a:xfrm>
+          <a:prstGeom prst="roundRect">
+            <a:avLst>
+              <a:gd name="adj" fmla="val 50000"/>
+            </a:avLst>
+          </a:prstGeom>
+          <a:solidFill>
+            <a:srgbClr val="FFFFFF"/>
+          </a:solidFill>
+          <a:ln w="15875">
+            <a:solidFill>
+              <a:srgbClr val="1D4ED8"/>
+            </a:solidFill>
+          </a:ln>
+        </p:spPr>
+        <p:txBody>
+          <a:bodyPr rtlCol="0" anchor="ctr" wrap="square" lIns="54864" tIns="18288" rIns="54864" bIns="18288">
+            <a:noAutofit/>
+          </a:bodyPr>
+          <a:lstStyle/>
+          <a:p>
+            <a:pPr algn="ctr" latinLnBrk="0">
+              <a:lnSpc>
+                <a:spcPct val="100000"/>
+              </a:lnSpc>
+              <a:spcBef>
+                <a:spcPts val="0"/>
+              </a:spcBef>
+              <a:spcAft>
+                <a:spcPts val="100"/>
+              </a:spcAft>
+            </a:pPr>
+            <a:r>
+              <a:rPr sz="1200" b="1">
+                <a:solidFill>
+                  <a:srgbClr val="1D4ED8"/>
+                </a:solidFill>
+                <a:latin typeface="Microsoft YaHei"/>
+                <a:ea typeface="Microsoft YaHei"/>
+                <a:cs typeface="Microsoft YaHei"/>
+              </a:rPr>
+              <a:t>5</a:t>
+            </a:r>
+            <a:r>
+              <a:rPr sz="1200" b="1">
+                <a:solidFill>
+                  <a:srgbClr val="1F2937"/>
+                </a:solidFill>
+                <a:latin typeface="Microsoft YaHei"/>
+                <a:ea typeface="Microsoft YaHei"/>
+                <a:cs typeface="Microsoft YaHei"/>
+              </a:rPr>
+              <a:t>  验证</a:t>
+            </a:r>
+          </a:p>
+          <a:p>
+            <a:pPr algn="ctr" latinLnBrk="0">
+              <a:lnSpc>
+                <a:spcPct val="100000"/>
+              </a:lnSpc>
+              <a:spcBef>
+                <a:spcPts val="0"/>
+              </a:spcBef>
+              <a:spcAft>
+                <a:spcPts val="0"/>
+              </a:spcAft>
+            </a:pPr>
+            <a:r>
+              <a:rPr sz="900" b="0">
+                <a:solidFill>
+                  <a:srgbClr val="6B7280"/>
+                </a:solidFill>
+                <a:latin typeface="Microsoft YaHei"/>
+                <a:ea typeface="Microsoft YaHei"/>
+                <a:cs typeface="Microsoft YaHei"/>
+              </a:rPr>
+              <a:t>精度和收益双验证</a:t>
+            </a:r>
+          </a:p>
+        </p:txBody>
+      </p:sp>
+      <p:sp>
+        <p:nvSpPr>
+          <p:cNvPr id="14" name="Rounded Rectangle 13"/>
+          <p:cNvSpPr/>
+          <p:nvPr/>
+        </p:nvSpPr>
+        <p:spPr>
+          <a:xfrm>
+            <a:off x="534426" y="2660904"/>
+            <a:ext cx="1463040" cy="585216"/>
+          </a:xfrm>
+          <a:prstGeom prst="roundRect">
+            <a:avLst>
+              <a:gd name="adj" fmla="val 50000"/>
+            </a:avLst>
+          </a:prstGeom>
+          <a:solidFill>
+            <a:srgbClr val="FFFFFF"/>
+          </a:solidFill>
+          <a:ln w="15875">
+            <a:solidFill>
+              <a:srgbClr val="1D4ED8"/>
+            </a:solidFill>
+          </a:ln>
+        </p:spPr>
+        <p:txBody>
+          <a:bodyPr rtlCol="0" anchor="ctr" wrap="square" lIns="54864" tIns="18288" rIns="54864" bIns="18288">
+            <a:noAutofit/>
+          </a:bodyPr>
+          <a:lstStyle/>
+          <a:p>
+            <a:pPr algn="ctr" latinLnBrk="0">
+              <a:lnSpc>
+                <a:spcPct val="100000"/>
+              </a:lnSpc>
+              <a:spcBef>
+                <a:spcPts val="0"/>
+              </a:spcBef>
+              <a:spcAft>
+                <a:spcPts val="100"/>
+              </a:spcAft>
+            </a:pPr>
+            <a:r>
+              <a:rPr sz="1200" b="1">
+                <a:solidFill>
+                  <a:srgbClr val="1D4ED8"/>
+                </a:solidFill>
+                <a:latin typeface="Microsoft YaHei"/>
+                <a:ea typeface="Microsoft YaHei"/>
+                <a:cs typeface="Microsoft YaHei"/>
+              </a:rPr>
+              <a:t>6</a:t>
+            </a:r>
+            <a:r>
+              <a:rPr sz="1200" b="1">
+                <a:solidFill>
+                  <a:srgbClr val="1F2937"/>
+                </a:solidFill>
+                <a:latin typeface="Microsoft YaHei"/>
+                <a:ea typeface="Microsoft YaHei"/>
+                <a:cs typeface="Microsoft YaHei"/>
+              </a:rPr>
+              <a:t>  沉淀</a:t>
+            </a:r>
+          </a:p>
+          <a:p>
+            <a:pPr algn="ctr" latinLnBrk="0">
+              <a:lnSpc>
+                <a:spcPct val="100000"/>
+              </a:lnSpc>
+              <a:spcBef>
+                <a:spcPts val="0"/>
+              </a:spcBef>
+              <a:spcAft>
+                <a:spcPts val="0"/>
+              </a:spcAft>
+            </a:pPr>
+            <a:r>
+              <a:rPr sz="900" b="0">
+                <a:solidFill>
+                  <a:srgbClr val="6B7280"/>
+                </a:solidFill>
+                <a:latin typeface="Microsoft YaHei"/>
+                <a:ea typeface="Microsoft YaHei"/>
+                <a:cs typeface="Microsoft YaHei"/>
+              </a:rPr>
+              <a:t>写回配置和规则库</a:t>
+            </a:r>
+          </a:p>
+        </p:txBody>
+      </p:sp>
+      <p:sp>
+        <p:nvSpPr>
+          <p:cNvPr id="15" name="Isosceles Triangle 14"/>
+          <p:cNvSpPr/>
+          <p:nvPr/>
+        </p:nvSpPr>
+        <p:spPr>
+          <a:xfrm rot="7660204">
+            <a:off x="3550659" y="2402290"/>
+            <a:ext cx="137160" cy="137160"/>
+          </a:xfrm>
+          <a:prstGeom prst="triangle">
+            <a:avLst/>
+          </a:prstGeom>
+          <a:solidFill>
+            <a:srgbClr val="1D4ED8"/>
+          </a:solidFill>
+          <a:ln>
+            <a:noFill/>
+          </a:ln>
+        </p:spPr>
+        <p:txBody>
+          <a:bodyPr rtlCol="0" anchor="ctr"/>
+          <a:lstStyle/>
+          <a:p>
+            <a:pPr algn="ctr"/>
+          </a:p>
+        </p:txBody>
+      </p:sp>
+      <p:sp>
+        <p:nvSpPr>
+          <p:cNvPr id="16" name="Isosceles Triangle 15"/>
+          <p:cNvSpPr/>
+          <p:nvPr/>
+        </p:nvSpPr>
+        <p:spPr>
+          <a:xfrm rot="10800000">
+            <a:off x="4183380" y="3698748"/>
+            <a:ext cx="137160" cy="137160"/>
+          </a:xfrm>
+          <a:prstGeom prst="triangle">
+            <a:avLst/>
+          </a:prstGeom>
+          <a:solidFill>
+            <a:srgbClr val="1D4ED8"/>
+          </a:solidFill>
+          <a:ln>
+            <a:noFill/>
+          </a:ln>
+        </p:spPr>
+        <p:txBody>
+          <a:bodyPr rtlCol="0" anchor="ctr"/>
+          <a:lstStyle/>
+          <a:p>
+            <a:pPr algn="ctr"/>
+          </a:p>
+        </p:txBody>
+      </p:sp>
+      <p:sp>
+        <p:nvSpPr>
+          <p:cNvPr id="17" name="Isosceles Triangle 16"/>
+          <p:cNvSpPr/>
+          <p:nvPr/>
+        </p:nvSpPr>
+        <p:spPr>
+          <a:xfrm rot="13975963">
+            <a:off x="3537259" y="5005439"/>
+            <a:ext cx="137160" cy="137160"/>
+          </a:xfrm>
+          <a:prstGeom prst="triangle">
+            <a:avLst/>
+          </a:prstGeom>
+          <a:solidFill>
+            <a:srgbClr val="1D4ED8"/>
+          </a:solidFill>
+          <a:ln>
+            <a:noFill/>
+          </a:ln>
+        </p:spPr>
+        <p:txBody>
+          <a:bodyPr rtlCol="0" anchor="ctr"/>
+          <a:lstStyle/>
+          <a:p>
+            <a:pPr algn="ctr"/>
+          </a:p>
+        </p:txBody>
+      </p:sp>
+      <p:sp>
+        <p:nvSpPr>
+          <p:cNvPr id="18" name="Isosceles Triangle 17"/>
+          <p:cNvSpPr/>
+          <p:nvPr/>
+        </p:nvSpPr>
+        <p:spPr>
+          <a:xfrm rot="18460204">
+            <a:off x="1615700" y="4995205"/>
+            <a:ext cx="137160" cy="137160"/>
+          </a:xfrm>
+          <a:prstGeom prst="triangle">
+            <a:avLst/>
+          </a:prstGeom>
+          <a:solidFill>
+            <a:srgbClr val="1D4ED8"/>
+          </a:solidFill>
+          <a:ln>
+            <a:noFill/>
+          </a:ln>
+        </p:spPr>
+        <p:txBody>
+          <a:bodyPr rtlCol="0" anchor="ctr"/>
+          <a:lstStyle/>
+          <a:p>
+            <a:pPr algn="ctr"/>
+          </a:p>
+        </p:txBody>
+      </p:sp>
+      <p:sp>
+        <p:nvSpPr>
+          <p:cNvPr id="19" name="Isosceles Triangle 18"/>
+          <p:cNvSpPr/>
+          <p:nvPr/>
+        </p:nvSpPr>
+        <p:spPr>
+          <a:xfrm rot="0">
+            <a:off x="982980" y="3698748"/>
+            <a:ext cx="137160" cy="137160"/>
+          </a:xfrm>
+          <a:prstGeom prst="triangle">
+            <a:avLst/>
+          </a:prstGeom>
+          <a:solidFill>
+            <a:srgbClr val="1D4ED8"/>
+          </a:solidFill>
+          <a:ln>
+            <a:noFill/>
+          </a:ln>
+        </p:spPr>
+        <p:txBody>
+          <a:bodyPr rtlCol="0" anchor="ctr"/>
+          <a:lstStyle/>
+          <a:p>
+            <a:pPr algn="ctr"/>
+          </a:p>
+        </p:txBody>
+      </p:sp>
+      <p:sp>
+        <p:nvSpPr>
+          <p:cNvPr id="20" name="Isosceles Triangle 19"/>
+          <p:cNvSpPr/>
+          <p:nvPr/>
+        </p:nvSpPr>
+        <p:spPr>
+          <a:xfrm rot="3175963">
+            <a:off x="1629100" y="2392056"/>
+            <a:ext cx="137160" cy="137160"/>
+          </a:xfrm>
+          <a:prstGeom prst="triangle">
+            <a:avLst/>
+          </a:prstGeom>
+          <a:solidFill>
+            <a:srgbClr val="1D4ED8"/>
+          </a:solidFill>
+          <a:ln>
+            <a:noFill/>
+          </a:ln>
+        </p:spPr>
+        <p:txBody>
+          <a:bodyPr rtlCol="0" anchor="ctr"/>
+          <a:lstStyle/>
+          <a:p>
+            <a:pPr algn="ctr"/>
+          </a:p>
+        </p:txBody>
+      </p:sp>
+      <p:sp>
+        <p:nvSpPr>
+          <p:cNvPr id="21" name="TextBox 20"/>
+          <p:cNvSpPr txBox="1"/>
+          <p:nvPr/>
+        </p:nvSpPr>
+        <p:spPr>
+          <a:xfrm>
+            <a:off x="5166360" y="1325880"/>
+            <a:ext cx="3291840" cy="274320"/>
+          </a:xfrm>
+          <a:prstGeom prst="rect">
+            <a:avLst/>
+          </a:prstGeom>
+          <a:noFill/>
+        </p:spPr>
+        <p:txBody>
+          <a:bodyPr wrap="square" anchor="ctr" lIns="0" tIns="0" rIns="0" bIns="0">
+            <a:noAutofit/>
+          </a:bodyPr>
+          <a:lstStyle/>
+          <a:p>
+            <a:pPr algn="l" latinLnBrk="0">
+              <a:lnSpc>
+                <a:spcPct val="100000"/>
+              </a:lnSpc>
+              <a:spcBef>
+                <a:spcPts val="0"/>
+              </a:spcBef>
+              <a:spcAft>
+                <a:spcPts val="0"/>
+              </a:spcAft>
+            </a:pPr>
+            <a:r>
+              <a:rPr sz="1100" b="1">
+                <a:solidFill>
+                  <a:srgbClr val="1D4ED8"/>
+                </a:solidFill>
+                <a:latin typeface="Microsoft YaHei"/>
+                <a:ea typeface="Microsoft YaHei"/>
+                <a:cs typeface="Microsoft YaHei"/>
+              </a:rPr>
+              <a:t>优化手段</a:t>
+            </a:r>
+            <a:r>
+              <a:rPr sz="1000" b="0">
+                <a:solidFill>
+                  <a:srgbClr val="6B7280"/>
+                </a:solidFill>
+                <a:latin typeface="Microsoft YaHei"/>
+                <a:ea typeface="Microsoft YaHei"/>
+                <a:cs typeface="Microsoft YaHei"/>
+              </a:rPr>
+              <a:t>　看瓶颈类型和芯片特性选择</a:t>
+            </a:r>
+          </a:p>
+        </p:txBody>
+      </p:sp>
+      <p:sp>
+        <p:nvSpPr>
+          <p:cNvPr id="22" name="TextBox 21"/>
+          <p:cNvSpPr txBox="1"/>
+          <p:nvPr/>
+        </p:nvSpPr>
+        <p:spPr>
+          <a:xfrm>
+            <a:off x="7857439" y="1325880"/>
+            <a:ext cx="1417319" cy="274320"/>
+          </a:xfrm>
+          <a:prstGeom prst="rect">
+            <a:avLst/>
+          </a:prstGeom>
+          <a:noFill/>
+        </p:spPr>
+        <p:txBody>
+          <a:bodyPr wrap="square" anchor="ctr" lIns="0" tIns="0" rIns="0" bIns="0">
+            <a:noAutofit/>
+          </a:bodyPr>
+          <a:lstStyle/>
+          <a:p>
+            <a:pPr algn="l" latinLnBrk="0">
+              <a:lnSpc>
+                <a:spcPct val="100000"/>
+              </a:lnSpc>
+              <a:spcBef>
+                <a:spcPts val="0"/>
+              </a:spcBef>
+              <a:spcAft>
+                <a:spcPts val="0"/>
+              </a:spcAft>
+            </a:pPr>
+            <a:r>
+              <a:rPr sz="900" b="0">
+                <a:solidFill>
+                  <a:srgbClr val="6B7280"/>
+                </a:solidFill>
+                <a:latin typeface="Microsoft YaHei"/>
+                <a:ea typeface="Microsoft YaHei"/>
+                <a:cs typeface="Microsoft YaHei"/>
+              </a:rPr>
+              <a:t>示意图，横轴为时间</a:t>
+            </a:r>
+          </a:p>
+        </p:txBody>
+      </p:sp>
+      <p:sp>
+        <p:nvSpPr>
+          <p:cNvPr id="23" name="Rectangle 22"/>
+          <p:cNvSpPr/>
+          <p:nvPr/>
+        </p:nvSpPr>
+        <p:spPr>
+          <a:xfrm>
+            <a:off x="9274759" y="1403604"/>
+            <a:ext cx="146304" cy="118872"/>
+          </a:xfrm>
+          <a:prstGeom prst="rect">
+            <a:avLst/>
+          </a:prstGeom>
+          <a:solidFill>
+            <a:srgbClr val="2563EB"/>
+          </a:solidFill>
+          <a:ln>
+            <a:noFill/>
+          </a:ln>
+        </p:spPr>
+        <p:txBody>
+          <a:bodyPr rtlCol="0" anchor="ctr"/>
+          <a:lstStyle/>
+          <a:p>
+            <a:pPr algn="ctr"/>
+          </a:p>
+        </p:txBody>
+      </p:sp>
+      <p:sp>
+        <p:nvSpPr>
+          <p:cNvPr id="24" name="TextBox 23"/>
+          <p:cNvSpPr txBox="1"/>
+          <p:nvPr/>
+        </p:nvSpPr>
+        <p:spPr>
+          <a:xfrm>
+            <a:off x="9475927" y="1325880"/>
+            <a:ext cx="329184" cy="274320"/>
+          </a:xfrm>
+          <a:prstGeom prst="rect">
+            <a:avLst/>
+          </a:prstGeom>
+          <a:noFill/>
+        </p:spPr>
+        <p:txBody>
+          <a:bodyPr wrap="square" anchor="ctr" lIns="0" tIns="0" rIns="0" bIns="0">
+            <a:noAutofit/>
+          </a:bodyPr>
+          <a:lstStyle/>
+          <a:p>
+            <a:pPr algn="l" latinLnBrk="0">
+              <a:lnSpc>
+                <a:spcPct val="100000"/>
+              </a:lnSpc>
+              <a:spcBef>
+                <a:spcPts val="0"/>
+              </a:spcBef>
+              <a:spcAft>
+                <a:spcPts val="0"/>
+              </a:spcAft>
+            </a:pPr>
+            <a:r>
+              <a:rPr sz="900" b="0">
+                <a:solidFill>
+                  <a:srgbClr val="374151"/>
+                </a:solidFill>
+                <a:latin typeface="Microsoft YaHei"/>
+                <a:ea typeface="Microsoft YaHei"/>
+                <a:cs typeface="Microsoft YaHei"/>
+              </a:rPr>
+              <a:t>计算</a:t>
+            </a:r>
+          </a:p>
+        </p:txBody>
+      </p:sp>
+      <p:sp>
+        <p:nvSpPr>
+          <p:cNvPr id="25" name="Rectangle 24"/>
+          <p:cNvSpPr/>
+          <p:nvPr/>
+        </p:nvSpPr>
+        <p:spPr>
+          <a:xfrm>
+            <a:off x="9805111" y="1403604"/>
+            <a:ext cx="146304" cy="118872"/>
+          </a:xfrm>
+          <a:prstGeom prst="rect">
+            <a:avLst/>
+          </a:prstGeom>
+          <a:solidFill>
+            <a:srgbClr val="0D9488"/>
+          </a:solidFill>
+          <a:ln>
+            <a:noFill/>
+          </a:ln>
+        </p:spPr>
+        <p:txBody>
+          <a:bodyPr rtlCol="0" anchor="ctr"/>
+          <a:lstStyle/>
+          <a:p>
+            <a:pPr algn="ctr"/>
+          </a:p>
+        </p:txBody>
+      </p:sp>
+      <p:sp>
+        <p:nvSpPr>
+          <p:cNvPr id="26" name="TextBox 25"/>
+          <p:cNvSpPr txBox="1"/>
+          <p:nvPr/>
+        </p:nvSpPr>
+        <p:spPr>
+          <a:xfrm>
+            <a:off x="10006279" y="1325880"/>
+            <a:ext cx="329184" cy="274320"/>
+          </a:xfrm>
+          <a:prstGeom prst="rect">
+            <a:avLst/>
+          </a:prstGeom>
+          <a:noFill/>
+        </p:spPr>
+        <p:txBody>
+          <a:bodyPr wrap="square" anchor="ctr" lIns="0" tIns="0" rIns="0" bIns="0">
+            <a:noAutofit/>
+          </a:bodyPr>
+          <a:lstStyle/>
+          <a:p>
+            <a:pPr algn="l" latinLnBrk="0">
+              <a:lnSpc>
+                <a:spcPct val="100000"/>
+              </a:lnSpc>
+              <a:spcBef>
+                <a:spcPts val="0"/>
+              </a:spcBef>
+              <a:spcAft>
+                <a:spcPts val="0"/>
+              </a:spcAft>
+            </a:pPr>
+            <a:r>
+              <a:rPr sz="900" b="0">
+                <a:solidFill>
+                  <a:srgbClr val="374151"/>
+                </a:solidFill>
+                <a:latin typeface="Microsoft YaHei"/>
+                <a:ea typeface="Microsoft YaHei"/>
+                <a:cs typeface="Microsoft YaHei"/>
+              </a:rPr>
+              <a:t>访存</a:t>
+            </a:r>
+          </a:p>
+        </p:txBody>
+      </p:sp>
+      <p:sp>
+        <p:nvSpPr>
+          <p:cNvPr id="27" name="Rectangle 26"/>
+          <p:cNvSpPr/>
+          <p:nvPr/>
+        </p:nvSpPr>
+        <p:spPr>
+          <a:xfrm>
+            <a:off x="10335463" y="1403604"/>
+            <a:ext cx="146304" cy="118872"/>
+          </a:xfrm>
+          <a:prstGeom prst="rect">
+            <a:avLst/>
+          </a:prstGeom>
+          <a:solidFill>
+            <a:srgbClr val="D97706"/>
+          </a:solidFill>
+          <a:ln>
+            <a:noFill/>
+          </a:ln>
+        </p:spPr>
+        <p:txBody>
+          <a:bodyPr rtlCol="0" anchor="ctr"/>
+          <a:lstStyle/>
+          <a:p>
+            <a:pPr algn="ctr"/>
+          </a:p>
+        </p:txBody>
+      </p:sp>
+      <p:sp>
+        <p:nvSpPr>
+          <p:cNvPr id="28" name="TextBox 27"/>
+          <p:cNvSpPr txBox="1"/>
+          <p:nvPr/>
+        </p:nvSpPr>
+        <p:spPr>
+          <a:xfrm>
+            <a:off x="10536631" y="1325880"/>
+            <a:ext cx="329184" cy="274320"/>
+          </a:xfrm>
+          <a:prstGeom prst="rect">
+            <a:avLst/>
+          </a:prstGeom>
+          <a:noFill/>
+        </p:spPr>
+        <p:txBody>
+          <a:bodyPr wrap="square" anchor="ctr" lIns="0" tIns="0" rIns="0" bIns="0">
+            <a:noAutofit/>
+          </a:bodyPr>
+          <a:lstStyle/>
+          <a:p>
+            <a:pPr algn="l" latinLnBrk="0">
+              <a:lnSpc>
+                <a:spcPct val="100000"/>
+              </a:lnSpc>
+              <a:spcBef>
+                <a:spcPts val="0"/>
+              </a:spcBef>
+              <a:spcAft>
+                <a:spcPts val="0"/>
+              </a:spcAft>
+            </a:pPr>
+            <a:r>
+              <a:rPr sz="900" b="0">
+                <a:solidFill>
+                  <a:srgbClr val="374151"/>
+                </a:solidFill>
+                <a:latin typeface="Microsoft YaHei"/>
+                <a:ea typeface="Microsoft YaHei"/>
+                <a:cs typeface="Microsoft YaHei"/>
+              </a:rPr>
+              <a:t>通信</a:t>
+            </a:r>
+          </a:p>
+        </p:txBody>
+      </p:sp>
+      <p:sp>
+        <p:nvSpPr>
+          <p:cNvPr id="29" name="Rectangle 28"/>
+          <p:cNvSpPr/>
+          <p:nvPr/>
+        </p:nvSpPr>
+        <p:spPr>
+          <a:xfrm>
+            <a:off x="10865815" y="1403604"/>
+            <a:ext cx="146304" cy="118872"/>
+          </a:xfrm>
+          <a:prstGeom prst="rect">
+            <a:avLst/>
+          </a:prstGeom>
+          <a:solidFill>
+            <a:srgbClr val="F0FDF4"/>
+          </a:solidFill>
+          <a:ln w="12700">
+            <a:solidFill>
+              <a:srgbClr val="15803D"/>
+            </a:solidFill>
+            <a:prstDash val="dash"/>
+          </a:ln>
+        </p:spPr>
+        <p:txBody>
+          <a:bodyPr rtlCol="0" anchor="ctr"/>
+          <a:lstStyle/>
+          <a:p>
+            <a:pPr algn="ctr"/>
+          </a:p>
+        </p:txBody>
+      </p:sp>
+      <p:sp>
+        <p:nvSpPr>
+          <p:cNvPr id="30" name="TextBox 29"/>
+          <p:cNvSpPr txBox="1"/>
+          <p:nvPr/>
+        </p:nvSpPr>
+        <p:spPr>
+          <a:xfrm>
+            <a:off x="11066983" y="1325880"/>
+            <a:ext cx="713232" cy="274320"/>
+          </a:xfrm>
+          <a:prstGeom prst="rect">
+            <a:avLst/>
+          </a:prstGeom>
+          <a:noFill/>
+        </p:spPr>
+        <p:txBody>
+          <a:bodyPr wrap="square" anchor="ctr" lIns="0" tIns="0" rIns="0" bIns="0">
+            <a:noAutofit/>
+          </a:bodyPr>
+          <a:lstStyle/>
+          <a:p>
+            <a:pPr algn="l" latinLnBrk="0">
+              <a:lnSpc>
+                <a:spcPct val="100000"/>
+              </a:lnSpc>
+              <a:spcBef>
+                <a:spcPts val="0"/>
+              </a:spcBef>
+              <a:spcAft>
+                <a:spcPts val="0"/>
+              </a:spcAft>
+            </a:pPr>
+            <a:r>
+              <a:rPr sz="900" b="0">
+                <a:solidFill>
+                  <a:srgbClr val="374151"/>
+                </a:solidFill>
+                <a:latin typeface="Microsoft YaHei"/>
+                <a:ea typeface="Microsoft YaHei"/>
+                <a:cs typeface="Microsoft YaHei"/>
+              </a:rPr>
+              <a:t>节省的时间</a:t>
+            </a:r>
+          </a:p>
+        </p:txBody>
+      </p:sp>
+      <p:sp>
+        <p:nvSpPr>
+          <p:cNvPr id="31" name="Rounded Rectangle 30"/>
+          <p:cNvSpPr/>
+          <p:nvPr/>
+        </p:nvSpPr>
+        <p:spPr>
+          <a:xfrm>
+            <a:off x="5166360" y="1691640"/>
+            <a:ext cx="3224631" cy="1554480"/>
+          </a:xfrm>
+          <a:prstGeom prst="roundRect">
+            <a:avLst>
+              <a:gd name="adj" fmla="val 5000"/>
+            </a:avLst>
+          </a:prstGeom>
+          <a:solidFill>
+            <a:srgbClr val="FFFFFF"/>
+          </a:solidFill>
+          <a:ln w="9525">
+            <a:solidFill>
+              <a:srgbClr val="D1D5DB"/>
+            </a:solidFill>
+          </a:ln>
+        </p:spPr>
+        <p:txBody>
+          <a:bodyPr rtlCol="0" anchor="ctr"/>
+          <a:lstStyle/>
+          <a:p>
+            <a:pPr algn="ctr"/>
+          </a:p>
+        </p:txBody>
+      </p:sp>
+      <p:sp>
+        <p:nvSpPr>
+          <p:cNvPr id="32" name="TextBox 31"/>
+          <p:cNvSpPr txBox="1"/>
+          <p:nvPr/>
+        </p:nvSpPr>
+        <p:spPr>
+          <a:xfrm>
+            <a:off x="5312664" y="1764792"/>
+            <a:ext cx="2950311" cy="310896"/>
+          </a:xfrm>
+          <a:prstGeom prst="rect">
+            <a:avLst/>
+          </a:prstGeom>
+          <a:noFill/>
+        </p:spPr>
+        <p:txBody>
+          <a:bodyPr wrap="square" anchor="ctr" lIns="0" tIns="0" rIns="0" bIns="0">
+            <a:noAutofit/>
+          </a:bodyPr>
+          <a:lstStyle/>
+          <a:p>
+            <a:pPr algn="l" latinLnBrk="0">
+              <a:lnSpc>
+                <a:spcPct val="100000"/>
+              </a:lnSpc>
+              <a:spcBef>
+                <a:spcPts val="0"/>
+              </a:spcBef>
+              <a:spcAft>
+                <a:spcPts val="0"/>
+              </a:spcAft>
+            </a:pPr>
+            <a:r>
+              <a:rPr sz="1300" b="1">
+                <a:solidFill>
+                  <a:srgbClr val="1F2937"/>
+                </a:solidFill>
+                <a:latin typeface="Microsoft YaHei"/>
+                <a:ea typeface="Microsoft YaHei"/>
+                <a:cs typeface="Microsoft YaHei"/>
+              </a:rPr>
+              <a:t>融合算子</a:t>
+            </a:r>
+            <a:r>
+              <a:rPr sz="900" b="0">
+                <a:solidFill>
+                  <a:srgbClr val="6B7280"/>
+                </a:solidFill>
+                <a:latin typeface="Microsoft YaHei"/>
+                <a:ea typeface="Microsoft YaHei"/>
+                <a:cs typeface="Microsoft YaHei"/>
+              </a:rPr>
+              <a:t>　适用：相邻的带宽受限小算子</a:t>
+            </a:r>
+          </a:p>
+        </p:txBody>
+      </p:sp>
+      <p:sp>
+        <p:nvSpPr>
+          <p:cNvPr id="33" name="Rectangle 32"/>
+          <p:cNvSpPr/>
+          <p:nvPr/>
+        </p:nvSpPr>
+        <p:spPr>
+          <a:xfrm>
+            <a:off x="5843016" y="2148840"/>
+            <a:ext cx="600417" cy="173736"/>
+          </a:xfrm>
+          <a:prstGeom prst="rect">
+            <a:avLst/>
+          </a:prstGeom>
+          <a:solidFill>
+            <a:srgbClr val="0D9488"/>
+          </a:solidFill>
+          <a:ln>
+            <a:noFill/>
+          </a:ln>
+        </p:spPr>
+        <p:txBody>
+          <a:bodyPr rtlCol="0" anchor="ctr" wrap="none" lIns="0" tIns="0" rIns="0" bIns="0">
+            <a:noAutofit/>
+          </a:bodyPr>
+          <a:lstStyle/>
+          <a:p>
+            <a:pPr algn="ctr" latinLnBrk="0">
+              <a:lnSpc>
+                <a:spcPct val="100000"/>
+              </a:lnSpc>
+              <a:spcBef>
+                <a:spcPts val="0"/>
+              </a:spcBef>
+              <a:spcAft>
+                <a:spcPts val="0"/>
+              </a:spcAft>
+            </a:pPr>
+            <a:r>
+              <a:rPr sz="800" b="0">
+                <a:solidFill>
+                  <a:srgbClr val="FFFFFF"/>
+                </a:solidFill>
+                <a:latin typeface="Microsoft YaHei"/>
+                <a:ea typeface="Microsoft YaHei"/>
+                <a:cs typeface="Microsoft YaHei"/>
+              </a:rPr>
+              <a:t>Add</a:t>
+            </a:r>
+          </a:p>
+        </p:txBody>
+      </p:sp>
+      <p:sp>
+        <p:nvSpPr>
+          <p:cNvPr id="34" name="Rectangle 33"/>
+          <p:cNvSpPr/>
+          <p:nvPr/>
+        </p:nvSpPr>
+        <p:spPr>
+          <a:xfrm>
+            <a:off x="6643573" y="2148840"/>
+            <a:ext cx="800557" cy="173736"/>
+          </a:xfrm>
+          <a:prstGeom prst="rect">
+            <a:avLst/>
+          </a:prstGeom>
+          <a:solidFill>
+            <a:srgbClr val="0D9488"/>
+          </a:solidFill>
+          <a:ln>
+            <a:noFill/>
+          </a:ln>
+        </p:spPr>
+        <p:txBody>
+          <a:bodyPr rtlCol="0" anchor="ctr" wrap="none" lIns="0" tIns="0" rIns="0" bIns="0">
+            <a:noAutofit/>
+          </a:bodyPr>
+          <a:lstStyle/>
+          <a:p>
+            <a:pPr algn="ctr" latinLnBrk="0">
+              <a:lnSpc>
+                <a:spcPct val="100000"/>
+              </a:lnSpc>
+              <a:spcBef>
+                <a:spcPts val="0"/>
+              </a:spcBef>
+              <a:spcAft>
+                <a:spcPts val="0"/>
+              </a:spcAft>
+            </a:pPr>
+            <a:r>
+              <a:rPr sz="800" b="0">
+                <a:solidFill>
+                  <a:srgbClr val="FFFFFF"/>
+                </a:solidFill>
+                <a:latin typeface="Microsoft YaHei"/>
+                <a:ea typeface="Microsoft YaHei"/>
+                <a:cs typeface="Microsoft YaHei"/>
+              </a:rPr>
+              <a:t>RMSNorm</a:t>
+            </a:r>
+          </a:p>
+        </p:txBody>
+      </p:sp>
+      <p:sp>
+        <p:nvSpPr>
+          <p:cNvPr id="35" name="Rectangle 34"/>
+          <p:cNvSpPr/>
+          <p:nvPr/>
+        </p:nvSpPr>
+        <p:spPr>
+          <a:xfrm>
+            <a:off x="7644269" y="2148840"/>
+            <a:ext cx="600417" cy="173736"/>
+          </a:xfrm>
+          <a:prstGeom prst="rect">
+            <a:avLst/>
+          </a:prstGeom>
+          <a:solidFill>
+            <a:srgbClr val="0D9488"/>
+          </a:solidFill>
+          <a:ln>
+            <a:noFill/>
+          </a:ln>
+        </p:spPr>
+        <p:txBody>
+          <a:bodyPr rtlCol="0" anchor="ctr" wrap="none" lIns="0" tIns="0" rIns="0" bIns="0">
+            <a:noAutofit/>
+          </a:bodyPr>
+          <a:lstStyle/>
+          <a:p>
+            <a:pPr algn="ctr" latinLnBrk="0">
+              <a:lnSpc>
+                <a:spcPct val="100000"/>
+              </a:lnSpc>
+              <a:spcBef>
+                <a:spcPts val="0"/>
+              </a:spcBef>
+              <a:spcAft>
+                <a:spcPts val="0"/>
+              </a:spcAft>
+            </a:pPr>
+            <a:r>
+              <a:rPr sz="800" b="0">
+                <a:solidFill>
+                  <a:srgbClr val="FFFFFF"/>
+                </a:solidFill>
+                <a:latin typeface="Microsoft YaHei"/>
+                <a:ea typeface="Microsoft YaHei"/>
+                <a:cs typeface="Microsoft YaHei"/>
+              </a:rPr>
+              <a:t>Quant</a:t>
+            </a:r>
+          </a:p>
+        </p:txBody>
+      </p:sp>
+      <p:sp>
+        <p:nvSpPr>
+          <p:cNvPr id="36" name="Rectangle 35"/>
+          <p:cNvSpPr/>
+          <p:nvPr/>
+        </p:nvSpPr>
+        <p:spPr>
+          <a:xfrm>
+            <a:off x="5843016" y="2414016"/>
+            <a:ext cx="1200835" cy="173736"/>
+          </a:xfrm>
+          <a:prstGeom prst="rect">
+            <a:avLst/>
+          </a:prstGeom>
+          <a:solidFill>
+            <a:srgbClr val="0D9488"/>
+          </a:solidFill>
+          <a:ln>
+            <a:noFill/>
+          </a:ln>
+        </p:spPr>
+        <p:txBody>
+          <a:bodyPr rtlCol="0" anchor="ctr" wrap="none" lIns="0" tIns="0" rIns="0" bIns="0">
+            <a:noAutofit/>
+          </a:bodyPr>
+          <a:lstStyle/>
+          <a:p>
+            <a:pPr algn="ctr" latinLnBrk="0">
+              <a:lnSpc>
+                <a:spcPct val="100000"/>
+              </a:lnSpc>
+              <a:spcBef>
+                <a:spcPts val="0"/>
+              </a:spcBef>
+              <a:spcAft>
+                <a:spcPts val="0"/>
+              </a:spcAft>
+            </a:pPr>
+            <a:r>
+              <a:rPr sz="800" b="0">
+                <a:solidFill>
+                  <a:srgbClr val="FFFFFF"/>
+                </a:solidFill>
+                <a:latin typeface="Microsoft YaHei"/>
+                <a:ea typeface="Microsoft YaHei"/>
+                <a:cs typeface="Microsoft YaHei"/>
+              </a:rPr>
+              <a:t>Add+RMSNorm+Quant</a:t>
+            </a:r>
+          </a:p>
+        </p:txBody>
+      </p:sp>
+      <p:sp>
+        <p:nvSpPr>
+          <p:cNvPr id="37" name="TextBox 36"/>
+          <p:cNvSpPr txBox="1"/>
+          <p:nvPr/>
+        </p:nvSpPr>
+        <p:spPr>
+          <a:xfrm>
+            <a:off x="5312664" y="2148840"/>
+            <a:ext cx="502920" cy="173736"/>
+          </a:xfrm>
+          <a:prstGeom prst="rect">
+            <a:avLst/>
+          </a:prstGeom>
+          <a:noFill/>
+        </p:spPr>
+        <p:txBody>
+          <a:bodyPr wrap="square" anchor="ctr" lIns="0" tIns="0" rIns="0" bIns="0">
+            <a:noAutofit/>
+          </a:bodyPr>
+          <a:lstStyle/>
+          <a:p>
+            <a:pPr algn="l" latinLnBrk="0">
+              <a:lnSpc>
+                <a:spcPct val="100000"/>
+              </a:lnSpc>
+              <a:spcBef>
+                <a:spcPts val="0"/>
+              </a:spcBef>
+              <a:spcAft>
+                <a:spcPts val="0"/>
+              </a:spcAft>
+            </a:pPr>
+            <a:r>
+              <a:rPr sz="850" b="0">
+                <a:solidFill>
+                  <a:srgbClr val="6B7280"/>
+                </a:solidFill>
+                <a:latin typeface="Microsoft YaHei"/>
+                <a:ea typeface="Microsoft YaHei"/>
+                <a:cs typeface="Microsoft YaHei"/>
+              </a:rPr>
+              <a:t>优化前</a:t>
+            </a:r>
+          </a:p>
+        </p:txBody>
+      </p:sp>
+      <p:sp>
+        <p:nvSpPr>
+          <p:cNvPr id="38" name="TextBox 37"/>
+          <p:cNvSpPr txBox="1"/>
+          <p:nvPr/>
+        </p:nvSpPr>
+        <p:spPr>
+          <a:xfrm>
+            <a:off x="5312664" y="2414016"/>
+            <a:ext cx="502920" cy="173736"/>
+          </a:xfrm>
+          <a:prstGeom prst="rect">
+            <a:avLst/>
+          </a:prstGeom>
+          <a:noFill/>
+        </p:spPr>
+        <p:txBody>
+          <a:bodyPr wrap="square" anchor="ctr" lIns="0" tIns="0" rIns="0" bIns="0">
+            <a:noAutofit/>
+          </a:bodyPr>
+          <a:lstStyle/>
+          <a:p>
+            <a:pPr algn="l" latinLnBrk="0">
+              <a:lnSpc>
+                <a:spcPct val="100000"/>
+              </a:lnSpc>
+              <a:spcBef>
+                <a:spcPts val="0"/>
+              </a:spcBef>
+              <a:spcAft>
+                <a:spcPts val="0"/>
+              </a:spcAft>
+            </a:pPr>
+            <a:r>
+              <a:rPr sz="850" b="0">
+                <a:solidFill>
+                  <a:srgbClr val="6B7280"/>
+                </a:solidFill>
+                <a:latin typeface="Microsoft YaHei"/>
+                <a:ea typeface="Microsoft YaHei"/>
+                <a:cs typeface="Microsoft YaHei"/>
+              </a:rPr>
+              <a:t>优化后</a:t>
+            </a:r>
+          </a:p>
+        </p:txBody>
+      </p:sp>
+      <p:sp>
+        <p:nvSpPr>
+          <p:cNvPr id="39" name="Rectangle 38"/>
+          <p:cNvSpPr/>
+          <p:nvPr/>
+        </p:nvSpPr>
+        <p:spPr>
+          <a:xfrm>
+            <a:off x="7043851" y="2414016"/>
+            <a:ext cx="1200835" cy="173736"/>
+          </a:xfrm>
+          <a:prstGeom prst="rect">
+            <a:avLst/>
+          </a:prstGeom>
+          <a:solidFill>
+            <a:srgbClr val="F0FDF4"/>
+          </a:solidFill>
+          <a:ln w="12700">
+            <a:solidFill>
+              <a:srgbClr val="15803D"/>
+            </a:solidFill>
+            <a:prstDash val="dash"/>
+          </a:ln>
+        </p:spPr>
+        <p:txBody>
+          <a:bodyPr rtlCol="0" anchor="ctr" wrap="square" lIns="0" tIns="0" rIns="0" bIns="0">
+            <a:noAutofit/>
+          </a:bodyPr>
+          <a:lstStyle/>
+          <a:p>
+            <a:pPr algn="ctr" latinLnBrk="0">
+              <a:lnSpc>
+                <a:spcPct val="100000"/>
+              </a:lnSpc>
+              <a:spcBef>
+                <a:spcPts val="0"/>
+              </a:spcBef>
+              <a:spcAft>
+                <a:spcPts val="0"/>
+              </a:spcAft>
+            </a:pPr>
+            <a:r>
+              <a:rPr sz="850" b="1">
+                <a:solidFill>
+                  <a:srgbClr val="15803D"/>
+                </a:solidFill>
+                <a:latin typeface="Microsoft YaHei"/>
+                <a:ea typeface="Microsoft YaHei"/>
+                <a:cs typeface="Microsoft YaHei"/>
+              </a:rPr>
+              <a:t>节省</a:t>
+            </a:r>
+          </a:p>
+        </p:txBody>
+      </p:sp>
+      <p:sp>
+        <p:nvSpPr>
+          <p:cNvPr id="40" name="TextBox 39"/>
+          <p:cNvSpPr txBox="1"/>
+          <p:nvPr/>
+        </p:nvSpPr>
+        <p:spPr>
+          <a:xfrm>
+            <a:off x="5312664" y="2898648"/>
+            <a:ext cx="2950311" cy="274320"/>
+          </a:xfrm>
+          <a:prstGeom prst="rect">
+            <a:avLst/>
+          </a:prstGeom>
+          <a:noFill/>
+        </p:spPr>
+        <p:txBody>
+          <a:bodyPr wrap="square" anchor="ctr" lIns="0" tIns="0" rIns="0" bIns="0">
+            <a:noAutofit/>
+          </a:bodyPr>
+          <a:lstStyle/>
+          <a:p>
+            <a:pPr algn="l" latinLnBrk="0">
+              <a:lnSpc>
+                <a:spcPct val="100000"/>
+              </a:lnSpc>
+              <a:spcBef>
+                <a:spcPts val="0"/>
+              </a:spcBef>
+              <a:spcAft>
+                <a:spcPts val="0"/>
+              </a:spcAft>
+            </a:pPr>
+            <a:r>
+              <a:rPr sz="900" b="1">
+                <a:solidFill>
+                  <a:srgbClr val="1D4ED8"/>
+                </a:solidFill>
+                <a:latin typeface="Microsoft YaHei"/>
+                <a:ea typeface="Microsoft YaHei"/>
+                <a:cs typeface="Microsoft YaHei"/>
+              </a:rPr>
+              <a:t>芯片特性　</a:t>
+            </a:r>
+            <a:r>
+              <a:rPr sz="900" b="0">
+                <a:solidFill>
+                  <a:srgbClr val="374151"/>
+                </a:solidFill>
+                <a:latin typeface="Microsoft YaHei"/>
+                <a:ea typeface="Microsoft YaHei"/>
+                <a:cs typeface="Microsoft YaHei"/>
+              </a:rPr>
+              <a:t>中间结果留在片上，少读写显存</a:t>
+            </a:r>
+          </a:p>
+        </p:txBody>
+      </p:sp>
+      <p:sp>
+        <p:nvSpPr>
+          <p:cNvPr id="41" name="Rounded Rectangle 40"/>
+          <p:cNvSpPr/>
+          <p:nvPr/>
+        </p:nvSpPr>
+        <p:spPr>
+          <a:xfrm>
+            <a:off x="8555583" y="1691640"/>
+            <a:ext cx="3224631" cy="1554480"/>
+          </a:xfrm>
+          <a:prstGeom prst="roundRect">
+            <a:avLst>
+              <a:gd name="adj" fmla="val 5000"/>
+            </a:avLst>
+          </a:prstGeom>
+          <a:solidFill>
+            <a:srgbClr val="FFFFFF"/>
+          </a:solidFill>
+          <a:ln w="9525">
+            <a:solidFill>
+              <a:srgbClr val="D1D5DB"/>
+            </a:solidFill>
+          </a:ln>
+        </p:spPr>
+        <p:txBody>
+          <a:bodyPr rtlCol="0" anchor="ctr"/>
+          <a:lstStyle/>
+          <a:p>
+            <a:pPr algn="ctr"/>
+          </a:p>
+        </p:txBody>
+      </p:sp>
+      <p:sp>
+        <p:nvSpPr>
+          <p:cNvPr id="42" name="TextBox 41"/>
+          <p:cNvSpPr txBox="1"/>
+          <p:nvPr/>
+        </p:nvSpPr>
+        <p:spPr>
+          <a:xfrm>
+            <a:off x="8701887" y="1764792"/>
+            <a:ext cx="2950311" cy="310896"/>
+          </a:xfrm>
+          <a:prstGeom prst="rect">
+            <a:avLst/>
+          </a:prstGeom>
+          <a:noFill/>
+        </p:spPr>
+        <p:txBody>
+          <a:bodyPr wrap="square" anchor="ctr" lIns="0" tIns="0" rIns="0" bIns="0">
+            <a:noAutofit/>
+          </a:bodyPr>
+          <a:lstStyle/>
+          <a:p>
+            <a:pPr algn="l" latinLnBrk="0">
+              <a:lnSpc>
+                <a:spcPct val="100000"/>
+              </a:lnSpc>
+              <a:spcBef>
+                <a:spcPts val="0"/>
+              </a:spcBef>
+              <a:spcAft>
+                <a:spcPts val="0"/>
+              </a:spcAft>
+            </a:pPr>
+            <a:r>
+              <a:rPr sz="1300" b="1">
+                <a:solidFill>
+                  <a:srgbClr val="1F2937"/>
+                </a:solidFill>
+                <a:latin typeface="Microsoft YaHei"/>
+                <a:ea typeface="Microsoft YaHei"/>
+                <a:cs typeface="Microsoft YaHei"/>
+              </a:rPr>
+              <a:t>通算融合</a:t>
+            </a:r>
+            <a:r>
+              <a:rPr sz="900" b="0">
+                <a:solidFill>
+                  <a:srgbClr val="6B7280"/>
+                </a:solidFill>
+                <a:latin typeface="Microsoft YaHei"/>
+                <a:ea typeface="Microsoft YaHei"/>
+                <a:cs typeface="Microsoft YaHei"/>
+              </a:rPr>
+              <a:t>　适用：TP / EP 通信占比高</a:t>
+            </a:r>
+          </a:p>
+        </p:txBody>
+      </p:sp>
+      <p:sp>
+        <p:nvSpPr>
+          <p:cNvPr id="43" name="Rectangle 42"/>
+          <p:cNvSpPr/>
+          <p:nvPr/>
+        </p:nvSpPr>
+        <p:spPr>
+          <a:xfrm>
+            <a:off x="9232239" y="2148840"/>
+            <a:ext cx="1412748" cy="173736"/>
+          </a:xfrm>
+          <a:prstGeom prst="rect">
+            <a:avLst/>
+          </a:prstGeom>
+          <a:solidFill>
+            <a:srgbClr val="2563EB"/>
+          </a:solidFill>
+          <a:ln>
+            <a:noFill/>
+          </a:ln>
+        </p:spPr>
+        <p:txBody>
+          <a:bodyPr rtlCol="0" anchor="ctr" wrap="none" lIns="0" tIns="0" rIns="0" bIns="0">
+            <a:noAutofit/>
+          </a:bodyPr>
+          <a:lstStyle/>
+          <a:p>
+            <a:pPr algn="ctr" latinLnBrk="0">
+              <a:lnSpc>
+                <a:spcPct val="100000"/>
+              </a:lnSpc>
+              <a:spcBef>
+                <a:spcPts val="0"/>
+              </a:spcBef>
+              <a:spcAft>
+                <a:spcPts val="0"/>
+              </a:spcAft>
+            </a:pPr>
+            <a:r>
+              <a:rPr sz="800" b="0">
+                <a:solidFill>
+                  <a:srgbClr val="FFFFFF"/>
+                </a:solidFill>
+                <a:latin typeface="Microsoft YaHei"/>
+                <a:ea typeface="Microsoft YaHei"/>
+                <a:cs typeface="Microsoft YaHei"/>
+              </a:rPr>
+              <a:t>GEMM</a:t>
+            </a:r>
+          </a:p>
+        </p:txBody>
+      </p:sp>
+      <p:sp>
+        <p:nvSpPr>
+          <p:cNvPr id="44" name="Rectangle 43"/>
+          <p:cNvSpPr/>
+          <p:nvPr/>
+        </p:nvSpPr>
+        <p:spPr>
+          <a:xfrm>
+            <a:off x="10644987" y="2148840"/>
+            <a:ext cx="988923" cy="173736"/>
+          </a:xfrm>
+          <a:prstGeom prst="rect">
+            <a:avLst/>
+          </a:prstGeom>
+          <a:solidFill>
+            <a:srgbClr val="D97706"/>
+          </a:solidFill>
+          <a:ln>
+            <a:noFill/>
+          </a:ln>
+        </p:spPr>
+        <p:txBody>
+          <a:bodyPr rtlCol="0" anchor="ctr" wrap="none" lIns="0" tIns="0" rIns="0" bIns="0">
+            <a:noAutofit/>
+          </a:bodyPr>
+          <a:lstStyle/>
+          <a:p>
+            <a:pPr algn="ctr" latinLnBrk="0">
+              <a:lnSpc>
+                <a:spcPct val="100000"/>
+              </a:lnSpc>
+              <a:spcBef>
+                <a:spcPts val="0"/>
+              </a:spcBef>
+              <a:spcAft>
+                <a:spcPts val="0"/>
+              </a:spcAft>
+            </a:pPr>
+            <a:r>
+              <a:rPr sz="800" b="0">
+                <a:solidFill>
+                  <a:srgbClr val="FFFFFF"/>
+                </a:solidFill>
+                <a:latin typeface="Microsoft YaHei"/>
+                <a:ea typeface="Microsoft YaHei"/>
+                <a:cs typeface="Microsoft YaHei"/>
+              </a:rPr>
+              <a:t>AllReduce</a:t>
+            </a:r>
+          </a:p>
+        </p:txBody>
+      </p:sp>
+      <p:sp>
+        <p:nvSpPr>
+          <p:cNvPr id="45" name="Rectangle 44"/>
+          <p:cNvSpPr/>
+          <p:nvPr/>
+        </p:nvSpPr>
+        <p:spPr>
+          <a:xfrm>
+            <a:off x="9232239" y="2414016"/>
+            <a:ext cx="452079" cy="173736"/>
+          </a:xfrm>
+          <a:prstGeom prst="rect">
+            <a:avLst/>
+          </a:prstGeom>
+          <a:solidFill>
+            <a:srgbClr val="2563EB"/>
+          </a:solidFill>
+          <a:ln>
+            <a:noFill/>
+          </a:ln>
+        </p:spPr>
+        <p:txBody>
+          <a:bodyPr rtlCol="0" anchor="ctr" wrap="none" lIns="0" tIns="0" rIns="0" bIns="0">
+            <a:noAutofit/>
+          </a:bodyPr>
+          <a:lstStyle/>
+          <a:p>
+            <a:pPr algn="ctr" latinLnBrk="0">
+              <a:lnSpc>
+                <a:spcPct val="100000"/>
+              </a:lnSpc>
+              <a:spcBef>
+                <a:spcPts val="0"/>
+              </a:spcBef>
+              <a:spcAft>
+                <a:spcPts val="0"/>
+              </a:spcAft>
+            </a:pPr>
+            <a:r>
+              <a:rPr sz="800" b="0">
+                <a:solidFill>
+                  <a:srgbClr val="FFFFFF"/>
+                </a:solidFill>
+                <a:latin typeface="Microsoft YaHei"/>
+                <a:ea typeface="Microsoft YaHei"/>
+                <a:cs typeface="Microsoft YaHei"/>
+              </a:rPr>
+              <a:t>GEMM 1</a:t>
+            </a:r>
+          </a:p>
+        </p:txBody>
+      </p:sp>
+      <p:sp>
+        <p:nvSpPr>
+          <p:cNvPr id="46" name="Rectangle 45"/>
+          <p:cNvSpPr/>
+          <p:nvPr/>
+        </p:nvSpPr>
+        <p:spPr>
+          <a:xfrm>
+            <a:off x="9712573" y="2414016"/>
+            <a:ext cx="452079" cy="173736"/>
+          </a:xfrm>
+          <a:prstGeom prst="rect">
+            <a:avLst/>
+          </a:prstGeom>
+          <a:solidFill>
+            <a:srgbClr val="2563EB"/>
+          </a:solidFill>
+          <a:ln>
+            <a:noFill/>
+          </a:ln>
+        </p:spPr>
+        <p:txBody>
+          <a:bodyPr rtlCol="0" anchor="ctr" wrap="none" lIns="0" tIns="0" rIns="0" bIns="0">
+            <a:noAutofit/>
+          </a:bodyPr>
+          <a:lstStyle/>
+          <a:p>
+            <a:pPr algn="ctr" latinLnBrk="0">
+              <a:lnSpc>
+                <a:spcPct val="100000"/>
+              </a:lnSpc>
+              <a:spcBef>
+                <a:spcPts val="0"/>
+              </a:spcBef>
+              <a:spcAft>
+                <a:spcPts val="0"/>
+              </a:spcAft>
+            </a:pPr>
+            <a:r>
+              <a:rPr sz="800" b="0">
+                <a:solidFill>
+                  <a:srgbClr val="FFFFFF"/>
+                </a:solidFill>
+                <a:latin typeface="Microsoft YaHei"/>
+                <a:ea typeface="Microsoft YaHei"/>
+                <a:cs typeface="Microsoft YaHei"/>
+              </a:rPr>
+              <a:t>GEMM 2</a:t>
+            </a:r>
+          </a:p>
+        </p:txBody>
+      </p:sp>
+      <p:sp>
+        <p:nvSpPr>
+          <p:cNvPr id="47" name="Rectangle 46"/>
+          <p:cNvSpPr/>
+          <p:nvPr/>
+        </p:nvSpPr>
+        <p:spPr>
+          <a:xfrm>
+            <a:off x="10192908" y="2414016"/>
+            <a:ext cx="452079" cy="173736"/>
+          </a:xfrm>
+          <a:prstGeom prst="rect">
+            <a:avLst/>
+          </a:prstGeom>
+          <a:solidFill>
+            <a:srgbClr val="2563EB"/>
+          </a:solidFill>
+          <a:ln>
+            <a:noFill/>
+          </a:ln>
+        </p:spPr>
+        <p:txBody>
+          <a:bodyPr rtlCol="0" anchor="ctr" wrap="none" lIns="0" tIns="0" rIns="0" bIns="0">
+            <a:noAutofit/>
+          </a:bodyPr>
+          <a:lstStyle/>
+          <a:p>
+            <a:pPr algn="ctr" latinLnBrk="0">
+              <a:lnSpc>
+                <a:spcPct val="100000"/>
+              </a:lnSpc>
+              <a:spcBef>
+                <a:spcPts val="0"/>
+              </a:spcBef>
+              <a:spcAft>
+                <a:spcPts val="0"/>
+              </a:spcAft>
+            </a:pPr>
+            <a:r>
+              <a:rPr sz="800" b="0">
+                <a:solidFill>
+                  <a:srgbClr val="FFFFFF"/>
+                </a:solidFill>
+                <a:latin typeface="Microsoft YaHei"/>
+                <a:ea typeface="Microsoft YaHei"/>
+                <a:cs typeface="Microsoft YaHei"/>
+              </a:rPr>
+              <a:t>GEMM 3</a:t>
+            </a:r>
+          </a:p>
+        </p:txBody>
+      </p:sp>
+      <p:sp>
+        <p:nvSpPr>
+          <p:cNvPr id="48" name="Rectangle 47"/>
+          <p:cNvSpPr/>
+          <p:nvPr/>
+        </p:nvSpPr>
+        <p:spPr>
+          <a:xfrm>
+            <a:off x="9712573" y="2624328"/>
+            <a:ext cx="324932" cy="173736"/>
+          </a:xfrm>
+          <a:prstGeom prst="rect">
+            <a:avLst/>
+          </a:prstGeom>
+          <a:solidFill>
+            <a:srgbClr val="D97706"/>
+          </a:solidFill>
+          <a:ln>
+            <a:noFill/>
+          </a:ln>
+        </p:spPr>
+        <p:txBody>
+          <a:bodyPr rtlCol="0" anchor="ctr" wrap="none" lIns="0" tIns="0" rIns="0" bIns="0">
+            <a:noAutofit/>
+          </a:bodyPr>
+          <a:lstStyle/>
+          <a:p>
+            <a:pPr algn="ctr" latinLnBrk="0">
+              <a:lnSpc>
+                <a:spcPct val="100000"/>
+              </a:lnSpc>
+              <a:spcBef>
+                <a:spcPts val="0"/>
+              </a:spcBef>
+              <a:spcAft>
+                <a:spcPts val="0"/>
+              </a:spcAft>
+            </a:pPr>
+            <a:r>
+              <a:rPr sz="800" b="0">
+                <a:solidFill>
+                  <a:srgbClr val="FFFFFF"/>
+                </a:solidFill>
+                <a:latin typeface="Microsoft YaHei"/>
+                <a:ea typeface="Microsoft YaHei"/>
+                <a:cs typeface="Microsoft YaHei"/>
+              </a:rPr>
+              <a:t>AR 1</a:t>
+            </a:r>
+          </a:p>
+        </p:txBody>
+      </p:sp>
+      <p:sp>
+        <p:nvSpPr>
+          <p:cNvPr id="49" name="Rectangle 48"/>
+          <p:cNvSpPr/>
+          <p:nvPr/>
+        </p:nvSpPr>
+        <p:spPr>
+          <a:xfrm>
+            <a:off x="10192908" y="2624328"/>
+            <a:ext cx="324932" cy="173736"/>
+          </a:xfrm>
+          <a:prstGeom prst="rect">
+            <a:avLst/>
+          </a:prstGeom>
+          <a:solidFill>
+            <a:srgbClr val="D97706"/>
+          </a:solidFill>
+          <a:ln>
+            <a:noFill/>
+          </a:ln>
+        </p:spPr>
+        <p:txBody>
+          <a:bodyPr rtlCol="0" anchor="ctr" wrap="none" lIns="0" tIns="0" rIns="0" bIns="0">
+            <a:noAutofit/>
+          </a:bodyPr>
+          <a:lstStyle/>
+          <a:p>
+            <a:pPr algn="ctr" latinLnBrk="0">
+              <a:lnSpc>
+                <a:spcPct val="100000"/>
+              </a:lnSpc>
+              <a:spcBef>
+                <a:spcPts val="0"/>
+              </a:spcBef>
+              <a:spcAft>
+                <a:spcPts val="0"/>
+              </a:spcAft>
+            </a:pPr>
+            <a:r>
+              <a:rPr sz="800" b="0">
+                <a:solidFill>
+                  <a:srgbClr val="FFFFFF"/>
+                </a:solidFill>
+                <a:latin typeface="Microsoft YaHei"/>
+                <a:ea typeface="Microsoft YaHei"/>
+                <a:cs typeface="Microsoft YaHei"/>
+              </a:rPr>
+              <a:t>AR 2</a:t>
+            </a:r>
+          </a:p>
+        </p:txBody>
+      </p:sp>
+      <p:sp>
+        <p:nvSpPr>
+          <p:cNvPr id="50" name="Rectangle 49"/>
+          <p:cNvSpPr/>
+          <p:nvPr/>
+        </p:nvSpPr>
+        <p:spPr>
+          <a:xfrm>
+            <a:off x="10673242" y="2624328"/>
+            <a:ext cx="324932" cy="173736"/>
+          </a:xfrm>
+          <a:prstGeom prst="rect">
+            <a:avLst/>
+          </a:prstGeom>
+          <a:solidFill>
+            <a:srgbClr val="D97706"/>
+          </a:solidFill>
+          <a:ln>
+            <a:noFill/>
+          </a:ln>
+        </p:spPr>
+        <p:txBody>
+          <a:bodyPr rtlCol="0" anchor="ctr" wrap="none" lIns="0" tIns="0" rIns="0" bIns="0">
+            <a:noAutofit/>
+          </a:bodyPr>
+          <a:lstStyle/>
+          <a:p>
+            <a:pPr algn="ctr" latinLnBrk="0">
+              <a:lnSpc>
+                <a:spcPct val="100000"/>
+              </a:lnSpc>
+              <a:spcBef>
+                <a:spcPts val="0"/>
+              </a:spcBef>
+              <a:spcAft>
+                <a:spcPts val="0"/>
+              </a:spcAft>
+            </a:pPr>
+            <a:r>
+              <a:rPr sz="800" b="0">
+                <a:solidFill>
+                  <a:srgbClr val="FFFFFF"/>
+                </a:solidFill>
+                <a:latin typeface="Microsoft YaHei"/>
+                <a:ea typeface="Microsoft YaHei"/>
+                <a:cs typeface="Microsoft YaHei"/>
+              </a:rPr>
+              <a:t>AR 3</a:t>
+            </a:r>
+          </a:p>
+        </p:txBody>
+      </p:sp>
+      <p:sp>
+        <p:nvSpPr>
+          <p:cNvPr id="51" name="TextBox 50"/>
+          <p:cNvSpPr txBox="1"/>
+          <p:nvPr/>
+        </p:nvSpPr>
+        <p:spPr>
+          <a:xfrm>
+            <a:off x="8701887" y="2148840"/>
+            <a:ext cx="502920" cy="173736"/>
+          </a:xfrm>
+          <a:prstGeom prst="rect">
+            <a:avLst/>
+          </a:prstGeom>
+          <a:noFill/>
+        </p:spPr>
+        <p:txBody>
+          <a:bodyPr wrap="square" anchor="ctr" lIns="0" tIns="0" rIns="0" bIns="0">
+            <a:noAutofit/>
+          </a:bodyPr>
+          <a:lstStyle/>
+          <a:p>
+            <a:pPr algn="l" latinLnBrk="0">
+              <a:lnSpc>
+                <a:spcPct val="100000"/>
+              </a:lnSpc>
+              <a:spcBef>
+                <a:spcPts val="0"/>
+              </a:spcBef>
+              <a:spcAft>
+                <a:spcPts val="0"/>
+              </a:spcAft>
+            </a:pPr>
+            <a:r>
+              <a:rPr sz="850" b="0">
+                <a:solidFill>
+                  <a:srgbClr val="6B7280"/>
+                </a:solidFill>
+                <a:latin typeface="Microsoft YaHei"/>
+                <a:ea typeface="Microsoft YaHei"/>
+                <a:cs typeface="Microsoft YaHei"/>
+              </a:rPr>
+              <a:t>优化前</a:t>
+            </a:r>
+          </a:p>
+        </p:txBody>
+      </p:sp>
+      <p:sp>
+        <p:nvSpPr>
+          <p:cNvPr id="52" name="TextBox 51"/>
+          <p:cNvSpPr txBox="1"/>
+          <p:nvPr/>
+        </p:nvSpPr>
+        <p:spPr>
+          <a:xfrm>
+            <a:off x="8701887" y="2414016"/>
+            <a:ext cx="502920" cy="384048"/>
+          </a:xfrm>
+          <a:prstGeom prst="rect">
+            <a:avLst/>
+          </a:prstGeom>
+          <a:noFill/>
+        </p:spPr>
+        <p:txBody>
+          <a:bodyPr wrap="square" anchor="ctr" lIns="0" tIns="0" rIns="0" bIns="0">
+            <a:noAutofit/>
+          </a:bodyPr>
+          <a:lstStyle/>
+          <a:p>
+            <a:pPr algn="l" latinLnBrk="0">
+              <a:lnSpc>
+                <a:spcPct val="100000"/>
+              </a:lnSpc>
+              <a:spcBef>
+                <a:spcPts val="0"/>
+              </a:spcBef>
+              <a:spcAft>
+                <a:spcPts val="0"/>
+              </a:spcAft>
+            </a:pPr>
+            <a:r>
+              <a:rPr sz="850" b="0">
+                <a:solidFill>
+                  <a:srgbClr val="6B7280"/>
+                </a:solidFill>
+                <a:latin typeface="Microsoft YaHei"/>
+                <a:ea typeface="Microsoft YaHei"/>
+                <a:cs typeface="Microsoft YaHei"/>
+              </a:rPr>
+              <a:t>优化后</a:t>
+            </a:r>
+          </a:p>
+        </p:txBody>
+      </p:sp>
+      <p:sp>
+        <p:nvSpPr>
+          <p:cNvPr id="53" name="Rectangle 52"/>
+          <p:cNvSpPr/>
+          <p:nvPr/>
+        </p:nvSpPr>
+        <p:spPr>
+          <a:xfrm>
+            <a:off x="10998174" y="2414016"/>
+            <a:ext cx="635736" cy="384048"/>
+          </a:xfrm>
+          <a:prstGeom prst="rect">
+            <a:avLst/>
+          </a:prstGeom>
+          <a:solidFill>
+            <a:srgbClr val="F0FDF4"/>
+          </a:solidFill>
+          <a:ln w="12700">
+            <a:solidFill>
+              <a:srgbClr val="15803D"/>
+            </a:solidFill>
+            <a:prstDash val="dash"/>
+          </a:ln>
+        </p:spPr>
+        <p:txBody>
+          <a:bodyPr rtlCol="0" anchor="ctr" wrap="square" lIns="0" tIns="0" rIns="0" bIns="0">
+            <a:noAutofit/>
+          </a:bodyPr>
+          <a:lstStyle/>
+          <a:p>
+            <a:pPr algn="ctr" latinLnBrk="0">
+              <a:lnSpc>
+                <a:spcPct val="100000"/>
+              </a:lnSpc>
+              <a:spcBef>
+                <a:spcPts val="0"/>
+              </a:spcBef>
+              <a:spcAft>
+                <a:spcPts val="0"/>
+              </a:spcAft>
+            </a:pPr>
+            <a:r>
+              <a:rPr sz="850" b="1">
+                <a:solidFill>
+                  <a:srgbClr val="15803D"/>
+                </a:solidFill>
+                <a:latin typeface="Microsoft YaHei"/>
+                <a:ea typeface="Microsoft YaHei"/>
+                <a:cs typeface="Microsoft YaHei"/>
+              </a:rPr>
+              <a:t>节省</a:t>
+            </a:r>
+          </a:p>
+        </p:txBody>
+      </p:sp>
+      <p:sp>
+        <p:nvSpPr>
+          <p:cNvPr id="54" name="TextBox 53"/>
+          <p:cNvSpPr txBox="1"/>
+          <p:nvPr/>
+        </p:nvSpPr>
+        <p:spPr>
+          <a:xfrm>
+            <a:off x="8701887" y="2898648"/>
+            <a:ext cx="2950311" cy="274320"/>
+          </a:xfrm>
+          <a:prstGeom prst="rect">
+            <a:avLst/>
+          </a:prstGeom>
+          <a:noFill/>
+        </p:spPr>
+        <p:txBody>
+          <a:bodyPr wrap="square" anchor="ctr" lIns="0" tIns="0" rIns="0" bIns="0">
+            <a:noAutofit/>
+          </a:bodyPr>
+          <a:lstStyle/>
+          <a:p>
+            <a:pPr algn="l" latinLnBrk="0">
+              <a:lnSpc>
+                <a:spcPct val="100000"/>
+              </a:lnSpc>
+              <a:spcBef>
+                <a:spcPts val="0"/>
+              </a:spcBef>
+              <a:spcAft>
+                <a:spcPts val="0"/>
+              </a:spcAft>
+            </a:pPr>
+            <a:r>
+              <a:rPr sz="900" b="1">
+                <a:solidFill>
+                  <a:srgbClr val="1D4ED8"/>
+                </a:solidFill>
+                <a:latin typeface="Microsoft YaHei"/>
+                <a:ea typeface="Microsoft YaHei"/>
+                <a:cs typeface="Microsoft YaHei"/>
+              </a:rPr>
+              <a:t>芯片特性　</a:t>
+            </a:r>
+            <a:r>
+              <a:rPr sz="900" b="0">
+                <a:solidFill>
+                  <a:srgbClr val="374151"/>
+                </a:solidFill>
+                <a:latin typeface="Microsoft YaHei"/>
+                <a:ea typeface="Microsoft YaHei"/>
+                <a:cs typeface="Microsoft YaHei"/>
+              </a:rPr>
+              <a:t>通信能和计算同时跑；互联越慢越值得做</a:t>
+            </a:r>
+          </a:p>
+        </p:txBody>
+      </p:sp>
+      <p:sp>
+        <p:nvSpPr>
+          <p:cNvPr id="55" name="Rounded Rectangle 54"/>
+          <p:cNvSpPr/>
+          <p:nvPr/>
+        </p:nvSpPr>
+        <p:spPr>
+          <a:xfrm>
+            <a:off x="5166360" y="3374136"/>
+            <a:ext cx="3224631" cy="1554480"/>
+          </a:xfrm>
+          <a:prstGeom prst="roundRect">
+            <a:avLst>
+              <a:gd name="adj" fmla="val 5000"/>
+            </a:avLst>
+          </a:prstGeom>
+          <a:solidFill>
+            <a:srgbClr val="FFFFFF"/>
+          </a:solidFill>
+          <a:ln w="9525">
+            <a:solidFill>
+              <a:srgbClr val="D1D5DB"/>
+            </a:solidFill>
+          </a:ln>
+        </p:spPr>
+        <p:txBody>
+          <a:bodyPr rtlCol="0" anchor="ctr"/>
+          <a:lstStyle/>
+          <a:p>
+            <a:pPr algn="ctr"/>
+          </a:p>
+        </p:txBody>
+      </p:sp>
+      <p:sp>
+        <p:nvSpPr>
+          <p:cNvPr id="56" name="TextBox 55"/>
+          <p:cNvSpPr txBox="1"/>
+          <p:nvPr/>
+        </p:nvSpPr>
+        <p:spPr>
+          <a:xfrm>
+            <a:off x="5312664" y="3447288"/>
+            <a:ext cx="2950311" cy="310896"/>
+          </a:xfrm>
+          <a:prstGeom prst="rect">
+            <a:avLst/>
+          </a:prstGeom>
+          <a:noFill/>
+        </p:spPr>
+        <p:txBody>
+          <a:bodyPr wrap="square" anchor="ctr" lIns="0" tIns="0" rIns="0" bIns="0">
+            <a:noAutofit/>
+          </a:bodyPr>
+          <a:lstStyle/>
+          <a:p>
+            <a:pPr algn="l" latinLnBrk="0">
+              <a:lnSpc>
+                <a:spcPct val="100000"/>
+              </a:lnSpc>
+              <a:spcBef>
+                <a:spcPts val="0"/>
+              </a:spcBef>
+              <a:spcAft>
+                <a:spcPts val="0"/>
+              </a:spcAft>
+            </a:pPr>
+            <a:r>
+              <a:rPr sz="1300" b="1">
+                <a:solidFill>
+                  <a:srgbClr val="1F2937"/>
+                </a:solidFill>
+                <a:latin typeface="Microsoft YaHei"/>
+                <a:ea typeface="Microsoft YaHei"/>
+                <a:cs typeface="Microsoft YaHei"/>
+              </a:rPr>
+              <a:t>多流并行</a:t>
+            </a:r>
+            <a:r>
+              <a:rPr sz="900" b="0">
+                <a:solidFill>
+                  <a:srgbClr val="6B7280"/>
+                </a:solidFill>
+                <a:latin typeface="Microsoft YaHei"/>
+                <a:ea typeface="Microsoft YaHei"/>
+                <a:cs typeface="Microsoft YaHei"/>
+              </a:rPr>
+              <a:t>　适用：单个算子吃不满计算单元</a:t>
+            </a:r>
+          </a:p>
+        </p:txBody>
+      </p:sp>
+      <p:sp>
+        <p:nvSpPr>
+          <p:cNvPr id="57" name="Rectangle 56"/>
+          <p:cNvSpPr/>
+          <p:nvPr/>
+        </p:nvSpPr>
+        <p:spPr>
+          <a:xfrm>
+            <a:off x="5843016" y="3831335"/>
+            <a:ext cx="1569092" cy="173736"/>
+          </a:xfrm>
+          <a:prstGeom prst="rect">
+            <a:avLst/>
+          </a:prstGeom>
+          <a:solidFill>
+            <a:srgbClr val="2563EB"/>
+          </a:solidFill>
+          <a:ln>
+            <a:noFill/>
+          </a:ln>
+        </p:spPr>
+        <p:txBody>
+          <a:bodyPr rtlCol="0" anchor="ctr" wrap="none" lIns="0" tIns="0" rIns="0" bIns="0">
+            <a:noAutofit/>
+          </a:bodyPr>
+          <a:lstStyle/>
+          <a:p>
+            <a:pPr algn="ctr" latinLnBrk="0">
+              <a:lnSpc>
+                <a:spcPct val="100000"/>
+              </a:lnSpc>
+              <a:spcBef>
+                <a:spcPts val="0"/>
+              </a:spcBef>
+              <a:spcAft>
+                <a:spcPts val="0"/>
+              </a:spcAft>
+            </a:pPr>
+            <a:r>
+              <a:rPr sz="800" b="0">
+                <a:solidFill>
+                  <a:srgbClr val="FFFFFF"/>
+                </a:solidFill>
+                <a:latin typeface="Microsoft YaHei"/>
+                <a:ea typeface="Microsoft YaHei"/>
+                <a:cs typeface="Microsoft YaHei"/>
+              </a:rPr>
+              <a:t>路由专家</a:t>
+            </a:r>
+          </a:p>
+        </p:txBody>
+      </p:sp>
+      <p:sp>
+        <p:nvSpPr>
+          <p:cNvPr id="58" name="Rectangle 57"/>
+          <p:cNvSpPr/>
+          <p:nvPr/>
+        </p:nvSpPr>
+        <p:spPr>
+          <a:xfrm>
+            <a:off x="7444130" y="3831335"/>
+            <a:ext cx="800557" cy="173736"/>
+          </a:xfrm>
+          <a:prstGeom prst="rect">
+            <a:avLst/>
+          </a:prstGeom>
+          <a:solidFill>
+            <a:srgbClr val="2563EB"/>
+          </a:solidFill>
+          <a:ln>
+            <a:noFill/>
+          </a:ln>
+        </p:spPr>
+        <p:txBody>
+          <a:bodyPr rtlCol="0" anchor="ctr" wrap="none" lIns="0" tIns="0" rIns="0" bIns="0">
+            <a:noAutofit/>
+          </a:bodyPr>
+          <a:lstStyle/>
+          <a:p>
+            <a:pPr algn="ctr" latinLnBrk="0">
+              <a:lnSpc>
+                <a:spcPct val="100000"/>
+              </a:lnSpc>
+              <a:spcBef>
+                <a:spcPts val="0"/>
+              </a:spcBef>
+              <a:spcAft>
+                <a:spcPts val="0"/>
+              </a:spcAft>
+            </a:pPr>
+            <a:r>
+              <a:rPr sz="800" b="0">
+                <a:solidFill>
+                  <a:srgbClr val="FFFFFF"/>
+                </a:solidFill>
+                <a:latin typeface="Microsoft YaHei"/>
+                <a:ea typeface="Microsoft YaHei"/>
+                <a:cs typeface="Microsoft YaHei"/>
+              </a:rPr>
+              <a:t>共享专家</a:t>
+            </a:r>
+          </a:p>
+        </p:txBody>
+      </p:sp>
+      <p:sp>
+        <p:nvSpPr>
+          <p:cNvPr id="59" name="Rectangle 58"/>
+          <p:cNvSpPr/>
+          <p:nvPr/>
+        </p:nvSpPr>
+        <p:spPr>
+          <a:xfrm>
+            <a:off x="5843016" y="4096511"/>
+            <a:ext cx="1569092" cy="173736"/>
+          </a:xfrm>
+          <a:prstGeom prst="rect">
+            <a:avLst/>
+          </a:prstGeom>
+          <a:solidFill>
+            <a:srgbClr val="2563EB"/>
+          </a:solidFill>
+          <a:ln>
+            <a:noFill/>
+          </a:ln>
+        </p:spPr>
+        <p:txBody>
+          <a:bodyPr rtlCol="0" anchor="ctr" wrap="none" lIns="0" tIns="0" rIns="0" bIns="0">
+            <a:noAutofit/>
+          </a:bodyPr>
+          <a:lstStyle/>
+          <a:p>
+            <a:pPr algn="ctr" latinLnBrk="0">
+              <a:lnSpc>
+                <a:spcPct val="100000"/>
+              </a:lnSpc>
+              <a:spcBef>
+                <a:spcPts val="0"/>
+              </a:spcBef>
+              <a:spcAft>
+                <a:spcPts val="0"/>
+              </a:spcAft>
+            </a:pPr>
+            <a:r>
+              <a:rPr sz="800" b="0">
+                <a:solidFill>
+                  <a:srgbClr val="FFFFFF"/>
+                </a:solidFill>
+                <a:latin typeface="Microsoft YaHei"/>
+                <a:ea typeface="Microsoft YaHei"/>
+                <a:cs typeface="Microsoft YaHei"/>
+              </a:rPr>
+              <a:t>路由专家</a:t>
+            </a:r>
+          </a:p>
+        </p:txBody>
+      </p:sp>
+      <p:sp>
+        <p:nvSpPr>
+          <p:cNvPr id="60" name="Rectangle 59"/>
+          <p:cNvSpPr/>
+          <p:nvPr/>
+        </p:nvSpPr>
+        <p:spPr>
+          <a:xfrm>
+            <a:off x="5843016" y="4306824"/>
+            <a:ext cx="800557" cy="173736"/>
+          </a:xfrm>
+          <a:prstGeom prst="rect">
+            <a:avLst/>
+          </a:prstGeom>
+          <a:solidFill>
+            <a:srgbClr val="2563EB"/>
+          </a:solidFill>
+          <a:ln>
+            <a:noFill/>
+          </a:ln>
+        </p:spPr>
+        <p:txBody>
+          <a:bodyPr rtlCol="0" anchor="ctr" wrap="none" lIns="0" tIns="0" rIns="0" bIns="0">
+            <a:noAutofit/>
+          </a:bodyPr>
+          <a:lstStyle/>
+          <a:p>
+            <a:pPr algn="ctr" latinLnBrk="0">
+              <a:lnSpc>
+                <a:spcPct val="100000"/>
+              </a:lnSpc>
+              <a:spcBef>
+                <a:spcPts val="0"/>
+              </a:spcBef>
+              <a:spcAft>
+                <a:spcPts val="0"/>
+              </a:spcAft>
+            </a:pPr>
+            <a:r>
+              <a:rPr sz="800" b="0">
+                <a:solidFill>
+                  <a:srgbClr val="FFFFFF"/>
+                </a:solidFill>
+                <a:latin typeface="Microsoft YaHei"/>
+                <a:ea typeface="Microsoft YaHei"/>
+                <a:cs typeface="Microsoft YaHei"/>
+              </a:rPr>
+              <a:t>共享专家</a:t>
+            </a:r>
+          </a:p>
+        </p:txBody>
+      </p:sp>
+      <p:sp>
+        <p:nvSpPr>
+          <p:cNvPr id="61" name="TextBox 60"/>
+          <p:cNvSpPr txBox="1"/>
+          <p:nvPr/>
+        </p:nvSpPr>
+        <p:spPr>
+          <a:xfrm>
+            <a:off x="5312664" y="3831335"/>
+            <a:ext cx="502920" cy="173736"/>
+          </a:xfrm>
+          <a:prstGeom prst="rect">
+            <a:avLst/>
+          </a:prstGeom>
+          <a:noFill/>
+        </p:spPr>
+        <p:txBody>
+          <a:bodyPr wrap="square" anchor="ctr" lIns="0" tIns="0" rIns="0" bIns="0">
+            <a:noAutofit/>
+          </a:bodyPr>
+          <a:lstStyle/>
+          <a:p>
+            <a:pPr algn="l" latinLnBrk="0">
+              <a:lnSpc>
+                <a:spcPct val="100000"/>
+              </a:lnSpc>
+              <a:spcBef>
+                <a:spcPts val="0"/>
+              </a:spcBef>
+              <a:spcAft>
+                <a:spcPts val="0"/>
+              </a:spcAft>
+            </a:pPr>
+            <a:r>
+              <a:rPr sz="850" b="0">
+                <a:solidFill>
+                  <a:srgbClr val="6B7280"/>
+                </a:solidFill>
+                <a:latin typeface="Microsoft YaHei"/>
+                <a:ea typeface="Microsoft YaHei"/>
+                <a:cs typeface="Microsoft YaHei"/>
+              </a:rPr>
+              <a:t>优化前</a:t>
+            </a:r>
+          </a:p>
+        </p:txBody>
+      </p:sp>
+      <p:sp>
+        <p:nvSpPr>
+          <p:cNvPr id="62" name="TextBox 61"/>
+          <p:cNvSpPr txBox="1"/>
+          <p:nvPr/>
+        </p:nvSpPr>
+        <p:spPr>
+          <a:xfrm>
+            <a:off x="5312664" y="4096511"/>
+            <a:ext cx="502920" cy="384048"/>
+          </a:xfrm>
+          <a:prstGeom prst="rect">
+            <a:avLst/>
+          </a:prstGeom>
+          <a:noFill/>
+        </p:spPr>
+        <p:txBody>
+          <a:bodyPr wrap="square" anchor="ctr" lIns="0" tIns="0" rIns="0" bIns="0">
+            <a:noAutofit/>
+          </a:bodyPr>
+          <a:lstStyle/>
+          <a:p>
+            <a:pPr algn="l" latinLnBrk="0">
+              <a:lnSpc>
+                <a:spcPct val="100000"/>
+              </a:lnSpc>
+              <a:spcBef>
+                <a:spcPts val="0"/>
+              </a:spcBef>
+              <a:spcAft>
+                <a:spcPts val="0"/>
+              </a:spcAft>
+            </a:pPr>
+            <a:r>
+              <a:rPr sz="850" b="0">
+                <a:solidFill>
+                  <a:srgbClr val="6B7280"/>
+                </a:solidFill>
+                <a:latin typeface="Microsoft YaHei"/>
+                <a:ea typeface="Microsoft YaHei"/>
+                <a:cs typeface="Microsoft YaHei"/>
+              </a:rPr>
+              <a:t>优化后</a:t>
+            </a:r>
+          </a:p>
+        </p:txBody>
+      </p:sp>
+      <p:sp>
+        <p:nvSpPr>
+          <p:cNvPr id="63" name="Rectangle 62"/>
+          <p:cNvSpPr/>
+          <p:nvPr/>
+        </p:nvSpPr>
+        <p:spPr>
+          <a:xfrm>
+            <a:off x="7412108" y="4096511"/>
+            <a:ext cx="832579" cy="384048"/>
+          </a:xfrm>
+          <a:prstGeom prst="rect">
+            <a:avLst/>
+          </a:prstGeom>
+          <a:solidFill>
+            <a:srgbClr val="F0FDF4"/>
+          </a:solidFill>
+          <a:ln w="12700">
+            <a:solidFill>
+              <a:srgbClr val="15803D"/>
+            </a:solidFill>
+            <a:prstDash val="dash"/>
+          </a:ln>
+        </p:spPr>
+        <p:txBody>
+          <a:bodyPr rtlCol="0" anchor="ctr" wrap="square" lIns="0" tIns="0" rIns="0" bIns="0">
+            <a:noAutofit/>
+          </a:bodyPr>
+          <a:lstStyle/>
+          <a:p>
+            <a:pPr algn="ctr" latinLnBrk="0">
+              <a:lnSpc>
+                <a:spcPct val="100000"/>
+              </a:lnSpc>
+              <a:spcBef>
+                <a:spcPts val="0"/>
+              </a:spcBef>
+              <a:spcAft>
+                <a:spcPts val="0"/>
+              </a:spcAft>
+            </a:pPr>
+            <a:r>
+              <a:rPr sz="850" b="1">
+                <a:solidFill>
+                  <a:srgbClr val="15803D"/>
+                </a:solidFill>
+                <a:latin typeface="Microsoft YaHei"/>
+                <a:ea typeface="Microsoft YaHei"/>
+                <a:cs typeface="Microsoft YaHei"/>
+              </a:rPr>
+              <a:t>节省</a:t>
+            </a:r>
+          </a:p>
+        </p:txBody>
+      </p:sp>
+      <p:sp>
+        <p:nvSpPr>
+          <p:cNvPr id="64" name="TextBox 63"/>
+          <p:cNvSpPr txBox="1"/>
+          <p:nvPr/>
+        </p:nvSpPr>
+        <p:spPr>
+          <a:xfrm>
+            <a:off x="5312664" y="4581144"/>
+            <a:ext cx="2950311" cy="274320"/>
+          </a:xfrm>
+          <a:prstGeom prst="rect">
+            <a:avLst/>
+          </a:prstGeom>
+          <a:noFill/>
+        </p:spPr>
+        <p:txBody>
+          <a:bodyPr wrap="square" anchor="ctr" lIns="0" tIns="0" rIns="0" bIns="0">
+            <a:noAutofit/>
+          </a:bodyPr>
+          <a:lstStyle/>
+          <a:p>
+            <a:pPr algn="l" latinLnBrk="0">
+              <a:lnSpc>
+                <a:spcPct val="100000"/>
+              </a:lnSpc>
+              <a:spcBef>
+                <a:spcPts val="0"/>
+              </a:spcBef>
+              <a:spcAft>
+                <a:spcPts val="0"/>
+              </a:spcAft>
+            </a:pPr>
+            <a:r>
+              <a:rPr sz="900" b="1">
+                <a:solidFill>
+                  <a:srgbClr val="1D4ED8"/>
+                </a:solidFill>
+                <a:latin typeface="Microsoft YaHei"/>
+                <a:ea typeface="Microsoft YaHei"/>
+                <a:cs typeface="Microsoft YaHei"/>
+              </a:rPr>
+              <a:t>芯片特性　</a:t>
+            </a:r>
+            <a:r>
+              <a:rPr sz="900" b="0">
+                <a:solidFill>
+                  <a:srgbClr val="374151"/>
+                </a:solidFill>
+                <a:latin typeface="Microsoft YaHei"/>
+                <a:ea typeface="Microsoft YaHei"/>
+                <a:cs typeface="Microsoft YaHei"/>
+              </a:rPr>
+              <a:t>支持多流并发；小 batch 时计算单元有空闲</a:t>
+            </a:r>
+          </a:p>
+        </p:txBody>
+      </p:sp>
+      <p:sp>
+        <p:nvSpPr>
+          <p:cNvPr id="65" name="Rounded Rectangle 64"/>
+          <p:cNvSpPr/>
+          <p:nvPr/>
+        </p:nvSpPr>
+        <p:spPr>
+          <a:xfrm>
+            <a:off x="8555583" y="3374136"/>
+            <a:ext cx="3224631" cy="1554480"/>
+          </a:xfrm>
+          <a:prstGeom prst="roundRect">
+            <a:avLst>
+              <a:gd name="adj" fmla="val 5000"/>
+            </a:avLst>
+          </a:prstGeom>
+          <a:solidFill>
+            <a:srgbClr val="FFFFFF"/>
+          </a:solidFill>
+          <a:ln w="9525">
+            <a:solidFill>
+              <a:srgbClr val="D1D5DB"/>
+            </a:solidFill>
+          </a:ln>
+        </p:spPr>
+        <p:txBody>
+          <a:bodyPr rtlCol="0" anchor="ctr"/>
+          <a:lstStyle/>
+          <a:p>
+            <a:pPr algn="ctr"/>
+          </a:p>
+        </p:txBody>
+      </p:sp>
+      <p:sp>
+        <p:nvSpPr>
+          <p:cNvPr id="66" name="TextBox 65"/>
+          <p:cNvSpPr txBox="1"/>
+          <p:nvPr/>
+        </p:nvSpPr>
+        <p:spPr>
+          <a:xfrm>
+            <a:off x="8701887" y="3447288"/>
+            <a:ext cx="2950311" cy="310896"/>
+          </a:xfrm>
+          <a:prstGeom prst="rect">
+            <a:avLst/>
+          </a:prstGeom>
+          <a:noFill/>
+        </p:spPr>
+        <p:txBody>
+          <a:bodyPr wrap="square" anchor="ctr" lIns="0" tIns="0" rIns="0" bIns="0">
+            <a:noAutofit/>
+          </a:bodyPr>
+          <a:lstStyle/>
+          <a:p>
+            <a:pPr algn="l" latinLnBrk="0">
+              <a:lnSpc>
+                <a:spcPct val="100000"/>
+              </a:lnSpc>
+              <a:spcBef>
+                <a:spcPts val="0"/>
+              </a:spcBef>
+              <a:spcAft>
+                <a:spcPts val="0"/>
+              </a:spcAft>
+            </a:pPr>
+            <a:r>
+              <a:rPr sz="1300" b="1">
+                <a:solidFill>
+                  <a:srgbClr val="1F2937"/>
+                </a:solidFill>
+                <a:latin typeface="Microsoft YaHei"/>
+                <a:ea typeface="Microsoft YaHei"/>
+                <a:cs typeface="Microsoft YaHei"/>
+              </a:rPr>
+              <a:t>权重预取</a:t>
+            </a:r>
+            <a:r>
+              <a:rPr sz="900" b="0">
+                <a:solidFill>
+                  <a:srgbClr val="6B7280"/>
+                </a:solidFill>
+                <a:latin typeface="Microsoft YaHei"/>
+                <a:ea typeface="Microsoft YaHei"/>
+                <a:cs typeface="Microsoft YaHei"/>
+              </a:rPr>
+              <a:t>　适用：前一个算子没用满带宽</a:t>
+            </a:r>
+          </a:p>
+        </p:txBody>
+      </p:sp>
+      <p:sp>
+        <p:nvSpPr>
+          <p:cNvPr id="67" name="Rectangle 66"/>
+          <p:cNvSpPr/>
+          <p:nvPr/>
+        </p:nvSpPr>
+        <p:spPr>
+          <a:xfrm>
+            <a:off x="9232239" y="3831335"/>
+            <a:ext cx="1130198" cy="173736"/>
+          </a:xfrm>
+          <a:prstGeom prst="rect">
+            <a:avLst/>
+          </a:prstGeom>
+          <a:solidFill>
+            <a:srgbClr val="2563EB"/>
+          </a:solidFill>
+          <a:ln>
+            <a:noFill/>
+          </a:ln>
+        </p:spPr>
+        <p:txBody>
+          <a:bodyPr rtlCol="0" anchor="ctr" wrap="none" lIns="0" tIns="0" rIns="0" bIns="0">
+            <a:noAutofit/>
+          </a:bodyPr>
+          <a:lstStyle/>
+          <a:p>
+            <a:pPr algn="ctr" latinLnBrk="0">
+              <a:lnSpc>
+                <a:spcPct val="100000"/>
+              </a:lnSpc>
+              <a:spcBef>
+                <a:spcPts val="0"/>
+              </a:spcBef>
+              <a:spcAft>
+                <a:spcPts val="0"/>
+              </a:spcAft>
+            </a:pPr>
+            <a:r>
+              <a:rPr sz="800" b="0">
+                <a:solidFill>
+                  <a:srgbClr val="FFFFFF"/>
+                </a:solidFill>
+                <a:latin typeface="Microsoft YaHei"/>
+                <a:ea typeface="Microsoft YaHei"/>
+                <a:cs typeface="Microsoft YaHei"/>
+              </a:rPr>
+              <a:t>算子 A</a:t>
+            </a:r>
+          </a:p>
+        </p:txBody>
+      </p:sp>
+      <p:sp>
+        <p:nvSpPr>
+          <p:cNvPr id="68" name="Rectangle 67"/>
+          <p:cNvSpPr/>
+          <p:nvPr/>
+        </p:nvSpPr>
+        <p:spPr>
+          <a:xfrm>
+            <a:off x="10362438" y="3831335"/>
+            <a:ext cx="635736" cy="173736"/>
+          </a:xfrm>
+          <a:prstGeom prst="rect">
+            <a:avLst/>
+          </a:prstGeom>
+          <a:solidFill>
+            <a:srgbClr val="0D9488"/>
+          </a:solidFill>
+          <a:ln>
+            <a:noFill/>
+          </a:ln>
+        </p:spPr>
+        <p:txBody>
+          <a:bodyPr rtlCol="0" anchor="ctr" wrap="none" lIns="0" tIns="0" rIns="0" bIns="0">
+            <a:noAutofit/>
+          </a:bodyPr>
+          <a:lstStyle/>
+          <a:p>
+            <a:pPr algn="ctr" latinLnBrk="0">
+              <a:lnSpc>
+                <a:spcPct val="100000"/>
+              </a:lnSpc>
+              <a:spcBef>
+                <a:spcPts val="0"/>
+              </a:spcBef>
+              <a:spcAft>
+                <a:spcPts val="0"/>
+              </a:spcAft>
+            </a:pPr>
+            <a:r>
+              <a:rPr sz="800" b="0">
+                <a:solidFill>
+                  <a:srgbClr val="FFFFFF"/>
+                </a:solidFill>
+                <a:latin typeface="Microsoft YaHei"/>
+                <a:ea typeface="Microsoft YaHei"/>
+                <a:cs typeface="Microsoft YaHei"/>
+              </a:rPr>
+              <a:t>读 B 权重</a:t>
+            </a:r>
+          </a:p>
+        </p:txBody>
+      </p:sp>
+      <p:sp>
+        <p:nvSpPr>
+          <p:cNvPr id="69" name="Rectangle 68"/>
+          <p:cNvSpPr/>
+          <p:nvPr/>
+        </p:nvSpPr>
+        <p:spPr>
+          <a:xfrm>
+            <a:off x="10998174" y="3831335"/>
+            <a:ext cx="635736" cy="173736"/>
+          </a:xfrm>
+          <a:prstGeom prst="rect">
+            <a:avLst/>
+          </a:prstGeom>
+          <a:solidFill>
+            <a:srgbClr val="2563EB"/>
+          </a:solidFill>
+          <a:ln>
+            <a:noFill/>
+          </a:ln>
+        </p:spPr>
+        <p:txBody>
+          <a:bodyPr rtlCol="0" anchor="ctr" wrap="none" lIns="0" tIns="0" rIns="0" bIns="0">
+            <a:noAutofit/>
+          </a:bodyPr>
+          <a:lstStyle/>
+          <a:p>
+            <a:pPr algn="ctr" latinLnBrk="0">
+              <a:lnSpc>
+                <a:spcPct val="100000"/>
+              </a:lnSpc>
+              <a:spcBef>
+                <a:spcPts val="0"/>
+              </a:spcBef>
+              <a:spcAft>
+                <a:spcPts val="0"/>
+              </a:spcAft>
+            </a:pPr>
+            <a:r>
+              <a:rPr sz="800" b="0">
+                <a:solidFill>
+                  <a:srgbClr val="FFFFFF"/>
+                </a:solidFill>
+                <a:latin typeface="Microsoft YaHei"/>
+                <a:ea typeface="Microsoft YaHei"/>
+                <a:cs typeface="Microsoft YaHei"/>
+              </a:rPr>
+              <a:t>算子 B</a:t>
+            </a:r>
+          </a:p>
+        </p:txBody>
+      </p:sp>
+      <p:sp>
+        <p:nvSpPr>
+          <p:cNvPr id="70" name="Rectangle 69"/>
+          <p:cNvSpPr/>
+          <p:nvPr/>
+        </p:nvSpPr>
+        <p:spPr>
+          <a:xfrm>
+            <a:off x="9232239" y="4096511"/>
+            <a:ext cx="1130198" cy="173736"/>
+          </a:xfrm>
+          <a:prstGeom prst="rect">
+            <a:avLst/>
+          </a:prstGeom>
+          <a:solidFill>
+            <a:srgbClr val="2563EB"/>
+          </a:solidFill>
+          <a:ln>
+            <a:noFill/>
+          </a:ln>
+        </p:spPr>
+        <p:txBody>
+          <a:bodyPr rtlCol="0" anchor="ctr" wrap="none" lIns="0" tIns="0" rIns="0" bIns="0">
+            <a:noAutofit/>
+          </a:bodyPr>
+          <a:lstStyle/>
+          <a:p>
+            <a:pPr algn="ctr" latinLnBrk="0">
+              <a:lnSpc>
+                <a:spcPct val="100000"/>
+              </a:lnSpc>
+              <a:spcBef>
+                <a:spcPts val="0"/>
+              </a:spcBef>
+              <a:spcAft>
+                <a:spcPts val="0"/>
+              </a:spcAft>
+            </a:pPr>
+            <a:r>
+              <a:rPr sz="800" b="0">
+                <a:solidFill>
+                  <a:srgbClr val="FFFFFF"/>
+                </a:solidFill>
+                <a:latin typeface="Microsoft YaHei"/>
+                <a:ea typeface="Microsoft YaHei"/>
+                <a:cs typeface="Microsoft YaHei"/>
+              </a:rPr>
+              <a:t>算子 A</a:t>
+            </a:r>
+          </a:p>
+        </p:txBody>
+      </p:sp>
+      <p:sp>
+        <p:nvSpPr>
+          <p:cNvPr id="71" name="Rectangle 70"/>
+          <p:cNvSpPr/>
+          <p:nvPr/>
+        </p:nvSpPr>
+        <p:spPr>
+          <a:xfrm>
+            <a:off x="10390692" y="4096511"/>
+            <a:ext cx="607481" cy="173736"/>
+          </a:xfrm>
+          <a:prstGeom prst="rect">
+            <a:avLst/>
+          </a:prstGeom>
+          <a:solidFill>
+            <a:srgbClr val="2563EB"/>
+          </a:solidFill>
+          <a:ln>
+            <a:noFill/>
+          </a:ln>
+        </p:spPr>
+        <p:txBody>
+          <a:bodyPr rtlCol="0" anchor="ctr" wrap="none" lIns="0" tIns="0" rIns="0" bIns="0">
+            <a:noAutofit/>
+          </a:bodyPr>
+          <a:lstStyle/>
+          <a:p>
+            <a:pPr algn="ctr" latinLnBrk="0">
+              <a:lnSpc>
+                <a:spcPct val="100000"/>
+              </a:lnSpc>
+              <a:spcBef>
+                <a:spcPts val="0"/>
+              </a:spcBef>
+              <a:spcAft>
+                <a:spcPts val="0"/>
+              </a:spcAft>
+            </a:pPr>
+            <a:r>
+              <a:rPr sz="800" b="0">
+                <a:solidFill>
+                  <a:srgbClr val="FFFFFF"/>
+                </a:solidFill>
+                <a:latin typeface="Microsoft YaHei"/>
+                <a:ea typeface="Microsoft YaHei"/>
+                <a:cs typeface="Microsoft YaHei"/>
+              </a:rPr>
+              <a:t>算子 B</a:t>
+            </a:r>
+          </a:p>
+        </p:txBody>
+      </p:sp>
+      <p:sp>
+        <p:nvSpPr>
+          <p:cNvPr id="72" name="Rectangle 71"/>
+          <p:cNvSpPr/>
+          <p:nvPr/>
+        </p:nvSpPr>
+        <p:spPr>
+          <a:xfrm>
+            <a:off x="9514789" y="4306824"/>
+            <a:ext cx="635736" cy="173736"/>
+          </a:xfrm>
+          <a:prstGeom prst="rect">
+            <a:avLst/>
+          </a:prstGeom>
+          <a:solidFill>
+            <a:srgbClr val="0D9488"/>
+          </a:solidFill>
+          <a:ln>
+            <a:noFill/>
+          </a:ln>
+        </p:spPr>
+        <p:txBody>
+          <a:bodyPr rtlCol="0" anchor="ctr" wrap="none" lIns="0" tIns="0" rIns="0" bIns="0">
+            <a:noAutofit/>
+          </a:bodyPr>
+          <a:lstStyle/>
+          <a:p>
+            <a:pPr algn="ctr" latinLnBrk="0">
+              <a:lnSpc>
+                <a:spcPct val="100000"/>
+              </a:lnSpc>
+              <a:spcBef>
+                <a:spcPts val="0"/>
+              </a:spcBef>
+              <a:spcAft>
+                <a:spcPts val="0"/>
+              </a:spcAft>
+            </a:pPr>
+            <a:r>
+              <a:rPr sz="800" b="0">
+                <a:solidFill>
+                  <a:srgbClr val="FFFFFF"/>
+                </a:solidFill>
+                <a:latin typeface="Microsoft YaHei"/>
+                <a:ea typeface="Microsoft YaHei"/>
+                <a:cs typeface="Microsoft YaHei"/>
+              </a:rPr>
+              <a:t>预取 B 权重</a:t>
+            </a:r>
+          </a:p>
+        </p:txBody>
+      </p:sp>
+      <p:sp>
+        <p:nvSpPr>
+          <p:cNvPr id="73" name="TextBox 72"/>
+          <p:cNvSpPr txBox="1"/>
+          <p:nvPr/>
+        </p:nvSpPr>
+        <p:spPr>
+          <a:xfrm>
+            <a:off x="8701887" y="3831335"/>
+            <a:ext cx="502920" cy="173736"/>
+          </a:xfrm>
+          <a:prstGeom prst="rect">
+            <a:avLst/>
+          </a:prstGeom>
+          <a:noFill/>
+        </p:spPr>
+        <p:txBody>
+          <a:bodyPr wrap="square" anchor="ctr" lIns="0" tIns="0" rIns="0" bIns="0">
+            <a:noAutofit/>
+          </a:bodyPr>
+          <a:lstStyle/>
+          <a:p>
+            <a:pPr algn="l" latinLnBrk="0">
+              <a:lnSpc>
+                <a:spcPct val="100000"/>
+              </a:lnSpc>
+              <a:spcBef>
+                <a:spcPts val="0"/>
+              </a:spcBef>
+              <a:spcAft>
+                <a:spcPts val="0"/>
+              </a:spcAft>
+            </a:pPr>
+            <a:r>
+              <a:rPr sz="850" b="0">
+                <a:solidFill>
+                  <a:srgbClr val="6B7280"/>
+                </a:solidFill>
+                <a:latin typeface="Microsoft YaHei"/>
+                <a:ea typeface="Microsoft YaHei"/>
+                <a:cs typeface="Microsoft YaHei"/>
+              </a:rPr>
+              <a:t>优化前</a:t>
+            </a:r>
+          </a:p>
+        </p:txBody>
+      </p:sp>
+      <p:sp>
+        <p:nvSpPr>
+          <p:cNvPr id="74" name="TextBox 73"/>
+          <p:cNvSpPr txBox="1"/>
+          <p:nvPr/>
+        </p:nvSpPr>
+        <p:spPr>
+          <a:xfrm>
+            <a:off x="8701887" y="4096511"/>
+            <a:ext cx="502920" cy="384048"/>
+          </a:xfrm>
+          <a:prstGeom prst="rect">
+            <a:avLst/>
+          </a:prstGeom>
+          <a:noFill/>
+        </p:spPr>
+        <p:txBody>
+          <a:bodyPr wrap="square" anchor="ctr" lIns="0" tIns="0" rIns="0" bIns="0">
+            <a:noAutofit/>
+          </a:bodyPr>
+          <a:lstStyle/>
+          <a:p>
+            <a:pPr algn="l" latinLnBrk="0">
+              <a:lnSpc>
+                <a:spcPct val="100000"/>
+              </a:lnSpc>
+              <a:spcBef>
+                <a:spcPts val="0"/>
+              </a:spcBef>
+              <a:spcAft>
+                <a:spcPts val="0"/>
+              </a:spcAft>
+            </a:pPr>
+            <a:r>
+              <a:rPr sz="850" b="0">
+                <a:solidFill>
+                  <a:srgbClr val="6B7280"/>
+                </a:solidFill>
+                <a:latin typeface="Microsoft YaHei"/>
+                <a:ea typeface="Microsoft YaHei"/>
+                <a:cs typeface="Microsoft YaHei"/>
+              </a:rPr>
+              <a:t>优化后</a:t>
+            </a:r>
+          </a:p>
+        </p:txBody>
+      </p:sp>
+      <p:sp>
+        <p:nvSpPr>
+          <p:cNvPr id="75" name="Rectangle 74"/>
+          <p:cNvSpPr/>
+          <p:nvPr/>
+        </p:nvSpPr>
+        <p:spPr>
+          <a:xfrm>
+            <a:off x="10998174" y="4096511"/>
+            <a:ext cx="635736" cy="384048"/>
+          </a:xfrm>
+          <a:prstGeom prst="rect">
+            <a:avLst/>
+          </a:prstGeom>
+          <a:solidFill>
+            <a:srgbClr val="F0FDF4"/>
+          </a:solidFill>
+          <a:ln w="12700">
+            <a:solidFill>
+              <a:srgbClr val="15803D"/>
+            </a:solidFill>
+            <a:prstDash val="dash"/>
+          </a:ln>
+        </p:spPr>
+        <p:txBody>
+          <a:bodyPr rtlCol="0" anchor="ctr" wrap="square" lIns="0" tIns="0" rIns="0" bIns="0">
+            <a:noAutofit/>
+          </a:bodyPr>
+          <a:lstStyle/>
+          <a:p>
+            <a:pPr algn="ctr" latinLnBrk="0">
+              <a:lnSpc>
+                <a:spcPct val="100000"/>
+              </a:lnSpc>
+              <a:spcBef>
+                <a:spcPts val="0"/>
+              </a:spcBef>
+              <a:spcAft>
+                <a:spcPts val="0"/>
+              </a:spcAft>
+            </a:pPr>
+            <a:r>
+              <a:rPr sz="850" b="1">
+                <a:solidFill>
+                  <a:srgbClr val="15803D"/>
+                </a:solidFill>
+                <a:latin typeface="Microsoft YaHei"/>
+                <a:ea typeface="Microsoft YaHei"/>
+                <a:cs typeface="Microsoft YaHei"/>
+              </a:rPr>
+              <a:t>节省</a:t>
+            </a:r>
+          </a:p>
+        </p:txBody>
+      </p:sp>
+      <p:sp>
+        <p:nvSpPr>
+          <p:cNvPr id="76" name="TextBox 75"/>
+          <p:cNvSpPr txBox="1"/>
+          <p:nvPr/>
+        </p:nvSpPr>
+        <p:spPr>
+          <a:xfrm>
+            <a:off x="8701887" y="4581144"/>
+            <a:ext cx="2950311" cy="274320"/>
+          </a:xfrm>
+          <a:prstGeom prst="rect">
+            <a:avLst/>
+          </a:prstGeom>
+          <a:noFill/>
+        </p:spPr>
+        <p:txBody>
+          <a:bodyPr wrap="square" anchor="ctr" lIns="0" tIns="0" rIns="0" bIns="0">
+            <a:noAutofit/>
+          </a:bodyPr>
+          <a:lstStyle/>
+          <a:p>
+            <a:pPr algn="l" latinLnBrk="0">
+              <a:lnSpc>
+                <a:spcPct val="100000"/>
+              </a:lnSpc>
+              <a:spcBef>
+                <a:spcPts val="0"/>
+              </a:spcBef>
+              <a:spcAft>
+                <a:spcPts val="0"/>
+              </a:spcAft>
+            </a:pPr>
+            <a:r>
+              <a:rPr sz="900" b="1">
+                <a:solidFill>
+                  <a:srgbClr val="1D4ED8"/>
+                </a:solidFill>
+                <a:latin typeface="Microsoft YaHei"/>
+                <a:ea typeface="Microsoft YaHei"/>
+                <a:cs typeface="Microsoft YaHei"/>
+              </a:rPr>
+              <a:t>芯片特性　</a:t>
+            </a:r>
+            <a:r>
+              <a:rPr sz="900" b="0">
+                <a:solidFill>
+                  <a:srgbClr val="374151"/>
+                </a:solidFill>
+                <a:latin typeface="Microsoft YaHei"/>
+                <a:ea typeface="Microsoft YaHei"/>
+                <a:cs typeface="Microsoft YaHei"/>
+              </a:rPr>
+              <a:t>片上缓存够大，放得下预取的权重块</a:t>
+            </a:r>
+          </a:p>
+        </p:txBody>
+      </p:sp>
+      <p:sp>
+        <p:nvSpPr>
+          <p:cNvPr id="77" name="TextBox 76"/>
+          <p:cNvSpPr txBox="1"/>
+          <p:nvPr/>
+        </p:nvSpPr>
+        <p:spPr>
+          <a:xfrm>
+            <a:off x="5166360" y="5020055"/>
+            <a:ext cx="6613855" cy="274320"/>
+          </a:xfrm>
+          <a:prstGeom prst="rect">
+            <a:avLst/>
+          </a:prstGeom>
+          <a:noFill/>
+        </p:spPr>
+        <p:txBody>
+          <a:bodyPr wrap="square" anchor="ctr" lIns="0" tIns="0" rIns="0" bIns="0">
+            <a:noAutofit/>
+          </a:bodyPr>
+          <a:lstStyle/>
+          <a:p>
+            <a:pPr algn="l" latinLnBrk="0">
+              <a:lnSpc>
+                <a:spcPct val="100000"/>
+              </a:lnSpc>
+              <a:spcBef>
+                <a:spcPts val="0"/>
+              </a:spcBef>
+              <a:spcAft>
+                <a:spcPts val="0"/>
+              </a:spcAft>
+            </a:pPr>
+            <a:r>
+              <a:rPr sz="1100" b="1">
+                <a:solidFill>
+                  <a:srgbClr val="B91C1C"/>
+                </a:solidFill>
+                <a:latin typeface="Microsoft YaHei"/>
+                <a:ea typeface="Microsoft YaHei"/>
+                <a:cs typeface="Microsoft YaHei"/>
+              </a:rPr>
+              <a:t>算子异常</a:t>
+            </a:r>
+            <a:r>
+              <a:rPr sz="1000" b="0">
+                <a:solidFill>
+                  <a:srgbClr val="6B7280"/>
+                </a:solidFill>
+                <a:latin typeface="Microsoft YaHei"/>
+                <a:ea typeface="Microsoft YaHei"/>
+                <a:cs typeface="Microsoft YaHei"/>
+              </a:rPr>
+              <a:t>　诊断环节自动标出，优先排查</a:t>
+            </a:r>
+          </a:p>
+        </p:txBody>
+      </p:sp>
+      <p:sp>
+        <p:nvSpPr>
+          <p:cNvPr id="78" name="Rectangle 77"/>
+          <p:cNvSpPr/>
+          <p:nvPr/>
+        </p:nvSpPr>
+        <p:spPr>
+          <a:xfrm>
+            <a:off x="5166360" y="5349240"/>
+            <a:ext cx="1234988" cy="658368"/>
+          </a:xfrm>
+          <a:prstGeom prst="rect">
+            <a:avLst/>
+          </a:prstGeom>
+          <a:solidFill>
+            <a:srgbClr val="FFFFFF"/>
+          </a:solidFill>
+          <a:ln w="9525">
+            <a:solidFill>
+              <a:srgbClr val="D1D5DB"/>
+            </a:solidFill>
+          </a:ln>
+        </p:spPr>
+        <p:txBody>
+          <a:bodyPr rtlCol="0" anchor="ctr"/>
+          <a:lstStyle/>
+          <a:p>
+            <a:pPr algn="ctr"/>
+          </a:p>
+        </p:txBody>
+      </p:sp>
+      <p:sp>
+        <p:nvSpPr>
+          <p:cNvPr id="79" name="Rectangle 78"/>
+          <p:cNvSpPr/>
+          <p:nvPr/>
+        </p:nvSpPr>
+        <p:spPr>
+          <a:xfrm>
+            <a:off x="5166360" y="5349240"/>
+            <a:ext cx="54864" cy="658368"/>
+          </a:xfrm>
+          <a:prstGeom prst="rect">
+            <a:avLst/>
+          </a:prstGeom>
+          <a:solidFill>
+            <a:srgbClr val="B91C1C"/>
+          </a:solidFill>
+          <a:ln>
+            <a:noFill/>
+          </a:ln>
+        </p:spPr>
+        <p:txBody>
+          <a:bodyPr rtlCol="0" anchor="ctr"/>
+          <a:lstStyle/>
+          <a:p>
+            <a:pPr algn="ctr"/>
+          </a:p>
+        </p:txBody>
+      </p:sp>
+      <p:sp>
+        <p:nvSpPr>
+          <p:cNvPr id="80" name="TextBox 79"/>
+          <p:cNvSpPr txBox="1"/>
+          <p:nvPr/>
+        </p:nvSpPr>
+        <p:spPr>
+          <a:xfrm>
+            <a:off x="5221224" y="5349240"/>
+            <a:ext cx="1180124" cy="658368"/>
+          </a:xfrm>
+          <a:prstGeom prst="rect">
+            <a:avLst/>
+          </a:prstGeom>
+          <a:noFill/>
+        </p:spPr>
+        <p:txBody>
+          <a:bodyPr wrap="square" anchor="ctr" lIns="128016" tIns="18288" rIns="73152" bIns="18288">
+            <a:noAutofit/>
+          </a:bodyPr>
+          <a:lstStyle/>
+          <a:p>
+            <a:pPr algn="l" latinLnBrk="0">
+              <a:lnSpc>
+                <a:spcPct val="100000"/>
+              </a:lnSpc>
+              <a:spcBef>
+                <a:spcPts val="0"/>
+              </a:spcBef>
+              <a:spcAft>
+                <a:spcPts val="200"/>
+              </a:spcAft>
+            </a:pPr>
+            <a:r>
+              <a:rPr sz="1000" b="1">
+                <a:solidFill>
+                  <a:srgbClr val="B91C1C"/>
+                </a:solidFill>
+                <a:latin typeface="Microsoft YaHei"/>
+                <a:ea typeface="Microsoft YaHei"/>
+                <a:cs typeface="Microsoft YaHei"/>
+              </a:rPr>
+              <a:t>远低于屋顶线</a:t>
+            </a:r>
+          </a:p>
+          <a:p>
+            <a:pPr algn="l" latinLnBrk="0">
+              <a:lnSpc>
+                <a:spcPct val="100000"/>
+              </a:lnSpc>
+              <a:spcBef>
+                <a:spcPts val="0"/>
+              </a:spcBef>
+              <a:spcAft>
+                <a:spcPts val="0"/>
+              </a:spcAft>
+            </a:pPr>
+            <a:r>
+              <a:rPr sz="850" b="0">
+                <a:solidFill>
+                  <a:srgbClr val="374151"/>
+                </a:solidFill>
+                <a:latin typeface="Microsoft YaHei"/>
+                <a:ea typeface="Microsoft YaHei"/>
+                <a:cs typeface="Microsoft YaHei"/>
+              </a:rPr>
+              <a:t>效率异常低</a:t>
+            </a:r>
+          </a:p>
+        </p:txBody>
+      </p:sp>
+      <p:sp>
+        <p:nvSpPr>
+          <p:cNvPr id="81" name="Rectangle 80"/>
+          <p:cNvSpPr/>
+          <p:nvPr/>
+        </p:nvSpPr>
+        <p:spPr>
+          <a:xfrm>
+            <a:off x="6511076" y="5349240"/>
+            <a:ext cx="1234988" cy="658368"/>
+          </a:xfrm>
+          <a:prstGeom prst="rect">
+            <a:avLst/>
+          </a:prstGeom>
+          <a:solidFill>
+            <a:srgbClr val="FFFFFF"/>
+          </a:solidFill>
+          <a:ln w="9525">
+            <a:solidFill>
+              <a:srgbClr val="D1D5DB"/>
+            </a:solidFill>
+          </a:ln>
+        </p:spPr>
+        <p:txBody>
+          <a:bodyPr rtlCol="0" anchor="ctr"/>
+          <a:lstStyle/>
+          <a:p>
+            <a:pPr algn="ctr"/>
+          </a:p>
+        </p:txBody>
+      </p:sp>
+      <p:sp>
+        <p:nvSpPr>
+          <p:cNvPr id="82" name="Rectangle 81"/>
+          <p:cNvSpPr/>
+          <p:nvPr/>
+        </p:nvSpPr>
+        <p:spPr>
+          <a:xfrm>
+            <a:off x="6511076" y="5349240"/>
+            <a:ext cx="54864" cy="658368"/>
+          </a:xfrm>
+          <a:prstGeom prst="rect">
+            <a:avLst/>
+          </a:prstGeom>
+          <a:solidFill>
+            <a:srgbClr val="B91C1C"/>
+          </a:solidFill>
+          <a:ln>
+            <a:noFill/>
+          </a:ln>
+        </p:spPr>
+        <p:txBody>
+          <a:bodyPr rtlCol="0" anchor="ctr"/>
+          <a:lstStyle/>
+          <a:p>
+            <a:pPr algn="ctr"/>
+          </a:p>
+        </p:txBody>
+      </p:sp>
+      <p:sp>
+        <p:nvSpPr>
+          <p:cNvPr id="83" name="TextBox 82"/>
+          <p:cNvSpPr txBox="1"/>
+          <p:nvPr/>
+        </p:nvSpPr>
+        <p:spPr>
+          <a:xfrm>
+            <a:off x="6565940" y="5349240"/>
+            <a:ext cx="1180124" cy="658368"/>
+          </a:xfrm>
+          <a:prstGeom prst="rect">
+            <a:avLst/>
+          </a:prstGeom>
+          <a:noFill/>
+        </p:spPr>
+        <p:txBody>
+          <a:bodyPr wrap="square" anchor="ctr" lIns="128016" tIns="18288" rIns="73152" bIns="18288">
+            <a:noAutofit/>
+          </a:bodyPr>
+          <a:lstStyle/>
+          <a:p>
+            <a:pPr algn="l" latinLnBrk="0">
+              <a:lnSpc>
+                <a:spcPct val="100000"/>
+              </a:lnSpc>
+              <a:spcBef>
+                <a:spcPts val="0"/>
+              </a:spcBef>
+              <a:spcAft>
+                <a:spcPts val="200"/>
+              </a:spcAft>
+            </a:pPr>
+            <a:r>
+              <a:rPr sz="1000" b="1">
+                <a:solidFill>
+                  <a:srgbClr val="B91C1C"/>
+                </a:solidFill>
+                <a:latin typeface="Microsoft YaHei"/>
+                <a:ea typeface="Microsoft YaHei"/>
+                <a:cs typeface="Microsoft YaHei"/>
+              </a:rPr>
+              <a:t>kernel 间空隙</a:t>
+            </a:r>
+          </a:p>
+          <a:p>
+            <a:pPr algn="l" latinLnBrk="0">
+              <a:lnSpc>
+                <a:spcPct val="100000"/>
+              </a:lnSpc>
+              <a:spcBef>
+                <a:spcPts val="0"/>
+              </a:spcBef>
+              <a:spcAft>
+                <a:spcPts val="0"/>
+              </a:spcAft>
+            </a:pPr>
+            <a:r>
+              <a:rPr sz="850" b="0">
+                <a:solidFill>
+                  <a:srgbClr val="374151"/>
+                </a:solidFill>
+                <a:latin typeface="Microsoft YaHei"/>
+                <a:ea typeface="Microsoft YaHei"/>
+                <a:cs typeface="Microsoft YaHei"/>
+              </a:rPr>
+              <a:t>主机同步、调度慢</a:t>
+            </a:r>
+          </a:p>
+        </p:txBody>
+      </p:sp>
+      <p:sp>
+        <p:nvSpPr>
+          <p:cNvPr id="84" name="Rectangle 83"/>
+          <p:cNvSpPr/>
+          <p:nvPr/>
+        </p:nvSpPr>
+        <p:spPr>
+          <a:xfrm>
+            <a:off x="7855793" y="5349240"/>
+            <a:ext cx="1234988" cy="658368"/>
+          </a:xfrm>
+          <a:prstGeom prst="rect">
+            <a:avLst/>
+          </a:prstGeom>
+          <a:solidFill>
+            <a:srgbClr val="FFFFFF"/>
+          </a:solidFill>
+          <a:ln w="9525">
+            <a:solidFill>
+              <a:srgbClr val="D1D5DB"/>
+            </a:solidFill>
+          </a:ln>
+        </p:spPr>
+        <p:txBody>
+          <a:bodyPr rtlCol="0" anchor="ctr"/>
+          <a:lstStyle/>
+          <a:p>
+            <a:pPr algn="ctr"/>
+          </a:p>
+        </p:txBody>
+      </p:sp>
+      <p:sp>
+        <p:nvSpPr>
+          <p:cNvPr id="85" name="Rectangle 84"/>
+          <p:cNvSpPr/>
+          <p:nvPr/>
+        </p:nvSpPr>
+        <p:spPr>
+          <a:xfrm>
+            <a:off x="7855793" y="5349240"/>
+            <a:ext cx="54864" cy="658368"/>
+          </a:xfrm>
+          <a:prstGeom prst="rect">
+            <a:avLst/>
+          </a:prstGeom>
+          <a:solidFill>
+            <a:srgbClr val="B91C1C"/>
+          </a:solidFill>
+          <a:ln>
+            <a:noFill/>
+          </a:ln>
+        </p:spPr>
+        <p:txBody>
+          <a:bodyPr rtlCol="0" anchor="ctr"/>
+          <a:lstStyle/>
+          <a:p>
+            <a:pPr algn="ctr"/>
+          </a:p>
+        </p:txBody>
+      </p:sp>
+      <p:sp>
+        <p:nvSpPr>
+          <p:cNvPr id="86" name="TextBox 85"/>
+          <p:cNvSpPr txBox="1"/>
+          <p:nvPr/>
+        </p:nvSpPr>
+        <p:spPr>
+          <a:xfrm>
+            <a:off x="7910657" y="5349240"/>
+            <a:ext cx="1180124" cy="658368"/>
+          </a:xfrm>
+          <a:prstGeom prst="rect">
+            <a:avLst/>
+          </a:prstGeom>
+          <a:noFill/>
+        </p:spPr>
+        <p:txBody>
+          <a:bodyPr wrap="square" anchor="ctr" lIns="128016" tIns="18288" rIns="73152" bIns="18288">
+            <a:noAutofit/>
+          </a:bodyPr>
+          <a:lstStyle/>
+          <a:p>
+            <a:pPr algn="l" latinLnBrk="0">
+              <a:lnSpc>
+                <a:spcPct val="100000"/>
+              </a:lnSpc>
+              <a:spcBef>
+                <a:spcPts val="0"/>
+              </a:spcBef>
+              <a:spcAft>
+                <a:spcPts val="200"/>
+              </a:spcAft>
+            </a:pPr>
+            <a:r>
+              <a:rPr sz="1000" b="1">
+                <a:solidFill>
+                  <a:srgbClr val="B91C1C"/>
+                </a:solidFill>
+                <a:latin typeface="Microsoft YaHei"/>
+                <a:ea typeface="Microsoft YaHei"/>
+                <a:cs typeface="Microsoft YaHei"/>
+              </a:rPr>
+              <a:t>launch 密集</a:t>
+            </a:r>
+          </a:p>
+          <a:p>
+            <a:pPr algn="l" latinLnBrk="0">
+              <a:lnSpc>
+                <a:spcPct val="100000"/>
+              </a:lnSpc>
+              <a:spcBef>
+                <a:spcPts val="0"/>
+              </a:spcBef>
+              <a:spcAft>
+                <a:spcPts val="0"/>
+              </a:spcAft>
+            </a:pPr>
+            <a:r>
+              <a:rPr sz="850" b="0">
+                <a:solidFill>
+                  <a:srgbClr val="374151"/>
+                </a:solidFill>
+                <a:latin typeface="Microsoft YaHei"/>
+                <a:ea typeface="Microsoft YaHei"/>
+                <a:cs typeface="Microsoft YaHei"/>
+              </a:rPr>
+              <a:t>没走图、小算子多</a:t>
+            </a:r>
+          </a:p>
+        </p:txBody>
+      </p:sp>
+      <p:sp>
+        <p:nvSpPr>
+          <p:cNvPr id="87" name="Rectangle 86"/>
+          <p:cNvSpPr/>
+          <p:nvPr/>
+        </p:nvSpPr>
+        <p:spPr>
+          <a:xfrm>
+            <a:off x="9200509" y="5349240"/>
+            <a:ext cx="1234988" cy="658368"/>
+          </a:xfrm>
+          <a:prstGeom prst="rect">
+            <a:avLst/>
+          </a:prstGeom>
+          <a:solidFill>
+            <a:srgbClr val="FFFFFF"/>
+          </a:solidFill>
+          <a:ln w="9525">
+            <a:solidFill>
+              <a:srgbClr val="D1D5DB"/>
+            </a:solidFill>
+          </a:ln>
+        </p:spPr>
+        <p:txBody>
+          <a:bodyPr rtlCol="0" anchor="ctr"/>
+          <a:lstStyle/>
+          <a:p>
+            <a:pPr algn="ctr"/>
+          </a:p>
+        </p:txBody>
+      </p:sp>
+      <p:sp>
+        <p:nvSpPr>
+          <p:cNvPr id="88" name="Rectangle 87"/>
+          <p:cNvSpPr/>
+          <p:nvPr/>
+        </p:nvSpPr>
+        <p:spPr>
+          <a:xfrm>
+            <a:off x="9200509" y="5349240"/>
+            <a:ext cx="54864" cy="658368"/>
+          </a:xfrm>
+          <a:prstGeom prst="rect">
+            <a:avLst/>
+          </a:prstGeom>
+          <a:solidFill>
+            <a:srgbClr val="B91C1C"/>
+          </a:solidFill>
+          <a:ln>
+            <a:noFill/>
+          </a:ln>
+        </p:spPr>
+        <p:txBody>
+          <a:bodyPr rtlCol="0" anchor="ctr"/>
+          <a:lstStyle/>
+          <a:p>
+            <a:pPr algn="ctr"/>
+          </a:p>
+        </p:txBody>
+      </p:sp>
+      <p:sp>
+        <p:nvSpPr>
+          <p:cNvPr id="89" name="TextBox 88"/>
+          <p:cNvSpPr txBox="1"/>
+          <p:nvPr/>
+        </p:nvSpPr>
+        <p:spPr>
+          <a:xfrm>
+            <a:off x="9255373" y="5349240"/>
+            <a:ext cx="1180124" cy="658368"/>
+          </a:xfrm>
+          <a:prstGeom prst="rect">
+            <a:avLst/>
+          </a:prstGeom>
+          <a:noFill/>
+        </p:spPr>
+        <p:txBody>
+          <a:bodyPr wrap="square" anchor="ctr" lIns="128016" tIns="18288" rIns="73152" bIns="18288">
+            <a:noAutofit/>
+          </a:bodyPr>
+          <a:lstStyle/>
+          <a:p>
+            <a:pPr algn="l" latinLnBrk="0">
+              <a:lnSpc>
+                <a:spcPct val="100000"/>
+              </a:lnSpc>
+              <a:spcBef>
+                <a:spcPts val="0"/>
+              </a:spcBef>
+              <a:spcAft>
+                <a:spcPts val="200"/>
+              </a:spcAft>
+            </a:pPr>
+            <a:r>
+              <a:rPr sz="1000" b="1">
+                <a:solidFill>
+                  <a:srgbClr val="B91C1C"/>
+                </a:solidFill>
+                <a:latin typeface="Microsoft YaHei"/>
+                <a:ea typeface="Microsoft YaHei"/>
+                <a:cs typeface="Microsoft YaHei"/>
+              </a:rPr>
+              <a:t>耗时离群</a:t>
+            </a:r>
+          </a:p>
+          <a:p>
+            <a:pPr algn="l" latinLnBrk="0">
+              <a:lnSpc>
+                <a:spcPct val="100000"/>
+              </a:lnSpc>
+              <a:spcBef>
+                <a:spcPts val="0"/>
+              </a:spcBef>
+              <a:spcAft>
+                <a:spcPts val="0"/>
+              </a:spcAft>
+            </a:pPr>
+            <a:r>
+              <a:rPr sz="850" b="0">
+                <a:solidFill>
+                  <a:srgbClr val="374151"/>
+                </a:solidFill>
+                <a:latin typeface="Microsoft YaHei"/>
+                <a:ea typeface="Microsoft YaHei"/>
+                <a:cs typeface="Microsoft YaHei"/>
+              </a:rPr>
+              <a:t>同类算子差异大</a:t>
+            </a:r>
+          </a:p>
+        </p:txBody>
+      </p:sp>
+      <p:sp>
+        <p:nvSpPr>
+          <p:cNvPr id="90" name="Rectangle 89"/>
+          <p:cNvSpPr/>
+          <p:nvPr/>
+        </p:nvSpPr>
+        <p:spPr>
+          <a:xfrm>
+            <a:off x="10545226" y="5349240"/>
+            <a:ext cx="1234988" cy="658368"/>
+          </a:xfrm>
+          <a:prstGeom prst="rect">
+            <a:avLst/>
+          </a:prstGeom>
+          <a:solidFill>
+            <a:srgbClr val="FFFFFF"/>
+          </a:solidFill>
+          <a:ln w="9525">
+            <a:solidFill>
+              <a:srgbClr val="D1D5DB"/>
+            </a:solidFill>
+          </a:ln>
+        </p:spPr>
+        <p:txBody>
+          <a:bodyPr rtlCol="0" anchor="ctr"/>
+          <a:lstStyle/>
+          <a:p>
+            <a:pPr algn="ctr"/>
+          </a:p>
+        </p:txBody>
+      </p:sp>
+      <p:sp>
+        <p:nvSpPr>
+          <p:cNvPr id="91" name="Rectangle 90"/>
+          <p:cNvSpPr/>
+          <p:nvPr/>
+        </p:nvSpPr>
+        <p:spPr>
+          <a:xfrm>
+            <a:off x="10545226" y="5349240"/>
+            <a:ext cx="54864" cy="658368"/>
+          </a:xfrm>
+          <a:prstGeom prst="rect">
+            <a:avLst/>
+          </a:prstGeom>
+          <a:solidFill>
+            <a:srgbClr val="B91C1C"/>
+          </a:solidFill>
+          <a:ln>
+            <a:noFill/>
+          </a:ln>
+        </p:spPr>
+        <p:txBody>
+          <a:bodyPr rtlCol="0" anchor="ctr"/>
+          <a:lstStyle/>
+          <a:p>
+            <a:pPr algn="ctr"/>
+          </a:p>
+        </p:txBody>
+      </p:sp>
+      <p:sp>
+        <p:nvSpPr>
+          <p:cNvPr id="92" name="TextBox 91"/>
+          <p:cNvSpPr txBox="1"/>
+          <p:nvPr/>
+        </p:nvSpPr>
+        <p:spPr>
+          <a:xfrm>
+            <a:off x="10600090" y="5349240"/>
+            <a:ext cx="1180124" cy="658368"/>
+          </a:xfrm>
+          <a:prstGeom prst="rect">
+            <a:avLst/>
+          </a:prstGeom>
+          <a:noFill/>
+        </p:spPr>
+        <p:txBody>
+          <a:bodyPr wrap="square" anchor="ctr" lIns="128016" tIns="18288" rIns="73152" bIns="18288">
+            <a:noAutofit/>
+          </a:bodyPr>
+          <a:lstStyle/>
+          <a:p>
+            <a:pPr algn="l" latinLnBrk="0">
+              <a:lnSpc>
+                <a:spcPct val="100000"/>
+              </a:lnSpc>
+              <a:spcBef>
+                <a:spcPts val="0"/>
+              </a:spcBef>
+              <a:spcAft>
+                <a:spcPts val="200"/>
+              </a:spcAft>
+            </a:pPr>
+            <a:r>
+              <a:rPr sz="1000" b="1">
+                <a:solidFill>
+                  <a:srgbClr val="B91C1C"/>
+                </a:solidFill>
+                <a:latin typeface="Microsoft YaHei"/>
+                <a:ea typeface="Microsoft YaHei"/>
+                <a:cs typeface="Microsoft YaHei"/>
+              </a:rPr>
+              <a:t>走了慢路径</a:t>
+            </a:r>
+          </a:p>
+          <a:p>
+            <a:pPr algn="l" latinLnBrk="0">
+              <a:lnSpc>
+                <a:spcPct val="100000"/>
+              </a:lnSpc>
+              <a:spcBef>
+                <a:spcPts val="0"/>
+              </a:spcBef>
+              <a:spcAft>
+                <a:spcPts val="0"/>
+              </a:spcAft>
+            </a:pPr>
+            <a:r>
+              <a:rPr sz="850" b="0">
+                <a:solidFill>
+                  <a:srgbClr val="374151"/>
+                </a:solidFill>
+                <a:latin typeface="Microsoft YaHei"/>
+                <a:ea typeface="Microsoft YaHei"/>
+                <a:cs typeface="Microsoft YaHei"/>
+              </a:rPr>
+              <a:t>回退到参考实现</a:t>
+            </a:r>
+          </a:p>
+        </p:txBody>
+      </p:sp>
+      <p:sp>
+        <p:nvSpPr>
+          <p:cNvPr id="93" name="TextBox 92"/>
+          <p:cNvSpPr txBox="1"/>
+          <p:nvPr/>
+        </p:nvSpPr>
+        <p:spPr>
+          <a:xfrm>
+            <a:off x="411480" y="6254496"/>
+            <a:ext cx="11368735" cy="292608"/>
+          </a:xfrm>
+          <a:prstGeom prst="rect">
+            <a:avLst/>
+          </a:prstGeom>
+          <a:noFill/>
+        </p:spPr>
+        <p:txBody>
+          <a:bodyPr wrap="square" anchor="ctr" lIns="0" tIns="0" rIns="0" bIns="0">
+            <a:noAutofit/>
+          </a:bodyPr>
+          <a:lstStyle/>
+          <a:p>
+            <a:pPr algn="l" latinLnBrk="0">
+              <a:lnSpc>
+                <a:spcPct val="100000"/>
+              </a:lnSpc>
+              <a:spcBef>
+                <a:spcPts val="0"/>
+              </a:spcBef>
+              <a:spcAft>
+                <a:spcPts val="0"/>
+              </a:spcAft>
+            </a:pPr>
+            <a:r>
+              <a:rPr sz="950" b="0">
+                <a:solidFill>
+                  <a:srgbClr val="6B7280"/>
+                </a:solidFill>
+                <a:latin typeface="Microsoft YaHei"/>
+                <a:ea typeface="Microsoft YaHei"/>
+                <a:cs typeface="Microsoft YaHei"/>
+              </a:rPr>
+              <a:t>原则：每条建议都附 trace 证据和预估收益 · 先估算、再上真机验证 · 精度和收益都达标才保留</a:t>
             </a:r>
           </a:p>
         </p:txBody>

</xml_diff>